<commit_message>
fix(layout,pdf,pptx): implement full AST layout calculation for grid/compare/hero/diagram, fix PDF text contrast & watermark
</commit_message>
<xml_diff>
--- a/presentation.pptx
+++ b/presentation.pptx
@@ -111,6 +111,659 @@
     </a:lvl9pPr>
   </p:defaultTextStyle>
 </p:presentation>
+</file>
+
+<file path=ppt/charts/chart1.xml><?xml version="1.0" encoding="utf-8"?>
+<c:chartSpace xmlns:c="http://schemas.openxmlformats.org/drawingml/2006/chart" xmlns:a="http://schemas.openxmlformats.org/drawingml/2006/main" xmlns:r="http://schemas.openxmlformats.org/officeDocument/2006/relationships">
+  <c:date1904 val="0"/>
+  <c:roundedCorners val="1"/>
+  <c:chart>
+    <c:title>
+      <c:tx>
+        <c:rich>
+          <a:bodyPr/>
+          <a:lstStyle/>
+          <a:p>
+            <a:pPr>
+              <a:defRPr sz="1800" b="0" i="0" u="none" strike="noStrike">
+                <a:solidFill>
+                  <a:srgbClr val="2C2B29"/>
+                </a:solidFill>
+                <a:latin typeface="Georgia"/>
+              </a:defRPr>
+            </a:pPr>
+            <a:r>
+              <a:rPr sz="1800" b="0" i="0" u="none" strike="noStrike">
+                <a:solidFill>
+                  <a:srgbClr val="2C2B29"/>
+                </a:solidFill>
+                <a:latin typeface="Georgia"/>
+              </a:rPr>
+              <a:t>Inference Acceleration (x Baseline)</a:t>
+            </a:r>
+          </a:p>
+        </c:rich>
+      </c:tx>
+      <c:layout/>
+      <c:overlay val="0"/>
+    </c:title>
+    <c:autoTitleDeleted val="0"/>
+    <c:plotArea>
+      <c:layout/>
+      <c:barChart>
+        <c:barDir val="col"/>
+        <c:grouping val="clustered"/>
+        <c:varyColors val="0"/>
+        <c:ser>
+          <c:idx val="0"/>
+          <c:order val="0"/>
+          <c:tx>
+            <c:strRef>
+              <c:f>Sheet1!$B$1</c:f>
+              <c:strCache>
+                <c:ptCount val="1"/>
+                <c:pt idx="0">
+                  <c:v>Inference Acceleration (x Baseline)</c:v>
+                </c:pt>
+              </c:strCache>
+            </c:strRef>
+          </c:tx>
+          <c:spPr>
+            <a:solidFill>
+              <a:srgbClr val="8B0000"/>
+            </a:solidFill>
+            <a:effectLst/>
+          </c:spPr>
+          <c:invertIfNegative val="0"/>
+          <c:dLbls>
+            <c:numFmt formatCode="#,##0" sourceLinked="0"/>
+            <c:txPr>
+              <a:bodyPr/>
+              <a:lstStyle/>
+              <a:p>
+                <a:pPr>
+                  <a:defRPr b="0" i="0" strike="noStrike" sz="1200" u="none">
+                    <a:solidFill>
+                      <a:srgbClr val="000000"/>
+                    </a:solidFill>
+                    <a:latin typeface="Arial"/>
+                  </a:defRPr>
+                </a:pPr>
+              </a:p>
+            </c:txPr>
+            <c:showLegendKey val="0"/>
+            <c:showVal val="0"/>
+            <c:showCatName val="0"/>
+            <c:showSerName val="0"/>
+            <c:showPercent val="0"/>
+            <c:showBubbleSize val="0"/>
+            <c:showLeaderLines val="0"/>
+          </c:dLbls>
+          <c:dPt>
+            <c:idx val="0"/>
+            <c:invertIfNegative val="0"/>
+            <c:bubble3D val="0"/>
+            <c:spPr>
+              <a:solidFill>
+                <a:srgbClr val="8b0000"/>
+              </a:solidFill>
+              <a:effectLst/>
+            </c:spPr>
+          </c:dPt>
+          <c:dPt>
+            <c:idx val="1"/>
+            <c:invertIfNegative val="0"/>
+            <c:bubble3D val="0"/>
+            <c:spPr>
+              <a:solidFill>
+                <a:srgbClr val="c29b38"/>
+              </a:solidFill>
+              <a:effectLst/>
+            </c:spPr>
+          </c:dPt>
+          <c:dPt>
+            <c:idx val="2"/>
+            <c:invertIfNegative val="0"/>
+            <c:bubble3D val="0"/>
+            <c:spPr>
+              <a:solidFill>
+                <a:srgbClr val="1c3f60"/>
+              </a:solidFill>
+              <a:effectLst/>
+            </c:spPr>
+          </c:dPt>
+          <c:dPt>
+            <c:idx val="3"/>
+            <c:invertIfNegative val="0"/>
+            <c:bubble3D val="0"/>
+            <c:spPr>
+              <a:solidFill>
+                <a:srgbClr val="2e7d32"/>
+              </a:solidFill>
+              <a:effectLst/>
+            </c:spPr>
+          </c:dPt>
+          <c:cat>
+            <c:multiLvlStrRef>
+              <c:f>Sheet1!$A$2:$A$5</c:f>
+              <c:multiLvlStrCache>
+                <c:ptCount val="4"/>
+                <c:lvl>
+                  <c:pt idx="0">
+                    <c:v>ResNet-50</c:v>
+                  </c:pt>
+                  <c:pt idx="1">
+                    <c:v>BERT-Large</c:v>
+                  </c:pt>
+                  <c:pt idx="2">
+                    <c:v>LLaMA-7B</c:v>
+                  </c:pt>
+                  <c:pt idx="3">
+                    <c:v>QuantumNet</c:v>
+                  </c:pt>
+                </c:lvl>
+              </c:multiLvlStrCache>
+            </c:multiLvlStrRef>
+          </c:cat>
+          <c:val>
+            <c:numRef>
+              <c:f>Sheet1!$B$2:$B$5</c:f>
+              <c:numCache>
+                <c:formatCode>General</c:formatCode>
+                <c:ptCount val="4"/>
+                <c:pt idx="0">
+                  <c:v>3.2</c:v>
+                </c:pt>
+                <c:pt idx="1">
+                  <c:v>5.8</c:v>
+                </c:pt>
+                <c:pt idx="2">
+                  <c:v>8.4</c:v>
+                </c:pt>
+                <c:pt idx="3">
+                  <c:v>14.1</c:v>
+                </c:pt>
+              </c:numCache>
+            </c:numRef>
+          </c:val>
+        </c:ser>
+        <c:dLbls>
+          <c:numFmt formatCode="#,##0" sourceLinked="0"/>
+          <c:txPr>
+            <a:bodyPr/>
+            <a:lstStyle/>
+            <a:p>
+              <a:pPr>
+                <a:defRPr b="0" i="0" strike="noStrike" sz="1200" u="none">
+                  <a:solidFill>
+                    <a:srgbClr val="000000"/>
+                  </a:solidFill>
+                  <a:latin typeface="Arial"/>
+                </a:defRPr>
+              </a:pPr>
+            </a:p>
+          </c:txPr>
+          <c:showLegendKey val="0"/>
+          <c:showVal val="0"/>
+          <c:showCatName val="0"/>
+          <c:showSerName val="0"/>
+          <c:showPercent val="0"/>
+          <c:showBubbleSize val="0"/>
+          <c:showLeaderLines val="0"/>
+        </c:dLbls>
+        <c:gapWidth val="150"/>
+        <c:overlap val="0"/>
+        <c:axId val="2094734554"/>
+        <c:axId val="2094734552"/>
+        <c:axId val="2094734556"/>
+      </c:barChart>
+      <c:catAx>
+        <c:axId val="2094734554"/>
+        <c:scaling>
+          <c:orientation val="minMax"/>
+        </c:scaling>
+        <c:delete val="0"/>
+        <c:axPos val="b"/>
+        <c:numFmt formatCode="General" sourceLinked="1"/>
+        <c:majorTickMark val="out"/>
+        <c:minorTickMark val="none"/>
+        <c:tickLblPos val="low"/>
+        <c:spPr>
+          <a:ln w="12700" cap="flat">
+            <a:solidFill>
+              <a:srgbClr val="888888"/>
+            </a:solidFill>
+            <a:prstDash val="solid"/>
+            <a:round/>
+          </a:ln>
+        </c:spPr>
+        <c:txPr>
+          <a:bodyPr/>
+          <a:lstStyle/>
+          <a:p>
+            <a:pPr>
+              <a:defRPr sz="1200" b="0" i="0" u="none" strike="noStrike">
+                <a:solidFill>
+                  <a:srgbClr val="000000"/>
+                </a:solidFill>
+                <a:latin typeface="Arial"/>
+              </a:defRPr>
+            </a:pPr>
+            <a:endParaRPr lang="en-US"/>
+          </a:p>
+        </c:txPr>
+        <c:crossAx val="2094734552"/>
+        <c:crosses val="autoZero"/>
+        <c:auto val="1"/>
+        <c:lblAlgn val="ctr"/>
+        <c:noMultiLvlLbl val="1"/>
+      </c:catAx>
+      <c:valAx>
+        <c:axId val="2094734552"/>
+        <c:scaling>
+          <c:orientation val="minMax"/>
+        </c:scaling>
+        <c:delete val="0"/>
+        <c:axPos val="l"/>
+        <c:majorGridlines>
+          <c:spPr>
+            <a:ln w="12700" cap="flat">
+              <a:solidFill>
+                <a:srgbClr val="888888"/>
+              </a:solidFill>
+              <a:prstDash val="solid"/>
+              <a:round/>
+            </a:ln>
+          </c:spPr>
+        </c:majorGridlines>
+        <c:numFmt formatCode="General" sourceLinked="0"/>
+        <c:majorTickMark val="out"/>
+        <c:minorTickMark val="none"/>
+        <c:tickLblPos val="nextTo"/>
+        <c:spPr>
+          <a:ln w="12700" cap="flat">
+            <a:solidFill>
+              <a:srgbClr val="888888"/>
+            </a:solidFill>
+            <a:prstDash val="solid"/>
+            <a:round/>
+          </a:ln>
+        </c:spPr>
+        <c:txPr>
+          <a:bodyPr/>
+          <a:lstStyle/>
+          <a:p>
+            <a:pPr>
+              <a:defRPr sz="1200" b="0" i="0" u="none" strike="noStrike">
+                <a:solidFill>
+                  <a:srgbClr val="000000"/>
+                </a:solidFill>
+                <a:latin typeface="Arial"/>
+              </a:defRPr>
+            </a:pPr>
+            <a:endParaRPr lang="en-US"/>
+          </a:p>
+        </c:txPr>
+        <c:crossAx val="2094734554"/>
+        <c:crosses val="autoZero"/>
+        <c:crossBetween val="between"/>
+      </c:valAx>
+      <c:spPr>
+        <a:noFill/>
+        <a:ln>
+          <a:noFill/>
+        </a:ln>
+        <a:effectLst/>
+      </c:spPr>
+    </c:plotArea>
+    <c:legend>
+      <c:legendPos val="b"/>
+      <c:overlay val="0"/>
+      <c:txPr>
+        <a:bodyPr/>
+        <a:lstStyle/>
+        <a:p>
+          <a:pPr>
+            <a:defRPr>
+              <a:solidFill>
+                <a:srgbClr val="6B6862"/>
+              </a:solidFill>
+            </a:defRPr>
+          </a:pPr>
+          <a:endParaRPr lang="en-US"/>
+        </a:p>
+      </c:txPr>
+    </c:legend>
+    <c:plotVisOnly val="1"/>
+    <c:dispBlanksAs val="span"/>
+  </c:chart>
+  <c:spPr>
+    <a:noFill/>
+    <a:ln>
+      <a:noFill/>
+    </a:ln>
+    <a:effectLst/>
+  </c:spPr>
+  <c:externalData r:id="rId1">
+    <c:autoUpdate val="0"/>
+  </c:externalData>
+</c:chartSpace>
+</file>
+
+<file path=ppt/charts/chart2.xml><?xml version="1.0" encoding="utf-8"?>
+<c:chartSpace xmlns:c="http://schemas.openxmlformats.org/drawingml/2006/chart" xmlns:a="http://schemas.openxmlformats.org/drawingml/2006/main" xmlns:r="http://schemas.openxmlformats.org/officeDocument/2006/relationships">
+  <c:date1904 val="0"/>
+  <c:roundedCorners val="1"/>
+  <c:chart>
+    <c:title>
+      <c:tx>
+        <c:rich>
+          <a:bodyPr/>
+          <a:lstStyle/>
+          <a:p>
+            <a:pPr>
+              <a:defRPr sz="1800" b="0" i="0" u="none" strike="noStrike">
+                <a:solidFill>
+                  <a:srgbClr val="2C2B29"/>
+                </a:solidFill>
+                <a:latin typeface="Georgia"/>
+              </a:defRPr>
+            </a:pPr>
+            <a:r>
+              <a:rPr sz="1800" b="0" i="0" u="none" strike="noStrike">
+                <a:solidFill>
+                  <a:srgbClr val="2C2B29"/>
+                </a:solidFill>
+                <a:latin typeface="Georgia"/>
+              </a:rPr>
+              <a:t>Cluster Resource Utilization</a:t>
+            </a:r>
+          </a:p>
+        </c:rich>
+      </c:tx>
+      <c:layout/>
+      <c:overlay val="0"/>
+    </c:title>
+    <c:autoTitleDeleted val="0"/>
+    <c:plotArea>
+      <c:layout/>
+      <c:doughnutChart>
+        <c:varyColors val="1"/>
+        <c:ser>
+          <c:idx val="0"/>
+          <c:order val="0"/>
+          <c:tx>
+            <c:strRef>
+              <c:f>Sheet1!$B$1</c:f>
+              <c:strCache>
+                <c:ptCount val="1"/>
+                <c:pt idx="0">
+                  <c:v>Cluster Resource Utilization</c:v>
+                </c:pt>
+              </c:strCache>
+            </c:strRef>
+          </c:tx>
+          <c:spPr>
+            <a:solidFill>
+              <a:schemeClr val="accent1"/>
+            </a:solidFill>
+            <a:ln w="9525" cap="flat">
+              <a:solidFill>
+                <a:srgbClr val="F9F9F9"/>
+              </a:solidFill>
+              <a:prstDash val="solid"/>
+              <a:round/>
+            </a:ln>
+            <a:effectLst/>
+          </c:spPr>
+          <c:dPt>
+            <c:idx val="0"/>
+            <c:bubble3D val="0"/>
+            <c:spPr>
+              <a:solidFill>
+                <a:srgbClr val="8B0000"/>
+              </a:solidFill>
+              <a:effectLst/>
+            </c:spPr>
+          </c:dPt>
+          <c:dPt>
+            <c:idx val="1"/>
+            <c:bubble3D val="0"/>
+            <c:spPr>
+              <a:solidFill>
+                <a:srgbClr val="C29B38"/>
+              </a:solidFill>
+              <a:effectLst/>
+            </c:spPr>
+          </c:dPt>
+          <c:dPt>
+            <c:idx val="2"/>
+            <c:bubble3D val="0"/>
+            <c:spPr>
+              <a:solidFill>
+                <a:srgbClr val="1C3F60"/>
+              </a:solidFill>
+              <a:effectLst/>
+            </c:spPr>
+          </c:dPt>
+          <c:dPt>
+            <c:idx val="3"/>
+            <c:bubble3D val="0"/>
+            <c:spPr>
+              <a:solidFill>
+                <a:srgbClr val="2E7D32"/>
+              </a:solidFill>
+              <a:effectLst/>
+            </c:spPr>
+          </c:dPt>
+          <c:dLbls>
+            <c:dLbl>
+              <c:idx val="0"/>
+              <c:numFmt formatCode="General" sourceLinked="0"/>
+              <c:spPr/>
+              <c:txPr>
+                <a:bodyPr/>
+                <a:lstStyle/>
+                <a:p>
+                  <a:pPr>
+                    <a:defRPr sz="1200" b="0" i="0" u="none" strike="noStrike">
+                      <a:solidFill>
+                        <a:srgbClr val="000000"/>
+                      </a:solidFill>
+                      <a:latin typeface="Arial"/>
+                    </a:defRPr>
+                  </a:pPr>
+                </a:p>
+              </c:txPr>
+              <c:showLegendKey val="0"/>
+              <c:showVal val="0"/>
+              <c:showCatName val="0"/>
+              <c:showSerName val="0"/>
+              <c:showPercent val="0"/>
+              <c:showBubbleSize val="0"/>
+            </c:dLbl>
+            <c:dLbl>
+              <c:idx val="1"/>
+              <c:numFmt formatCode="General" sourceLinked="0"/>
+              <c:spPr/>
+              <c:txPr>
+                <a:bodyPr/>
+                <a:lstStyle/>
+                <a:p>
+                  <a:pPr>
+                    <a:defRPr sz="1200" b="0" i="0" u="none" strike="noStrike">
+                      <a:solidFill>
+                        <a:srgbClr val="000000"/>
+                      </a:solidFill>
+                      <a:latin typeface="Arial"/>
+                    </a:defRPr>
+                  </a:pPr>
+                </a:p>
+              </c:txPr>
+              <c:showLegendKey val="0"/>
+              <c:showVal val="0"/>
+              <c:showCatName val="0"/>
+              <c:showSerName val="0"/>
+              <c:showPercent val="0"/>
+              <c:showBubbleSize val="0"/>
+            </c:dLbl>
+            <c:dLbl>
+              <c:idx val="2"/>
+              <c:numFmt formatCode="General" sourceLinked="0"/>
+              <c:spPr/>
+              <c:txPr>
+                <a:bodyPr/>
+                <a:lstStyle/>
+                <a:p>
+                  <a:pPr>
+                    <a:defRPr sz="1200" b="0" i="0" u="none" strike="noStrike">
+                      <a:solidFill>
+                        <a:srgbClr val="000000"/>
+                      </a:solidFill>
+                      <a:latin typeface="Arial"/>
+                    </a:defRPr>
+                  </a:pPr>
+                </a:p>
+              </c:txPr>
+              <c:showLegendKey val="0"/>
+              <c:showVal val="0"/>
+              <c:showCatName val="0"/>
+              <c:showSerName val="0"/>
+              <c:showPercent val="0"/>
+              <c:showBubbleSize val="0"/>
+            </c:dLbl>
+            <c:dLbl>
+              <c:idx val="3"/>
+              <c:numFmt formatCode="General" sourceLinked="0"/>
+              <c:spPr/>
+              <c:txPr>
+                <a:bodyPr/>
+                <a:lstStyle/>
+                <a:p>
+                  <a:pPr>
+                    <a:defRPr sz="1200" b="0" i="0" u="none" strike="noStrike">
+                      <a:solidFill>
+                        <a:srgbClr val="000000"/>
+                      </a:solidFill>
+                      <a:latin typeface="Arial"/>
+                    </a:defRPr>
+                  </a:pPr>
+                </a:p>
+              </c:txPr>
+              <c:showLegendKey val="0"/>
+              <c:showVal val="0"/>
+              <c:showCatName val="0"/>
+              <c:showSerName val="0"/>
+              <c:showPercent val="0"/>
+              <c:showBubbleSize val="0"/>
+            </c:dLbl>
+            <c:numFmt formatCode="General" sourceLinked="0"/>
+            <c:txPr>
+              <a:bodyPr/>
+              <a:lstStyle/>
+              <a:p>
+                <a:pPr>
+                  <a:defRPr sz="1800" b="0" i="0" u="none" strike="noStrike">
+                    <a:solidFill>
+                      <a:srgbClr val="000000"/>
+                    </a:solidFill>
+                    <a:latin typeface="Arial"/>
+                  </a:defRPr>
+                </a:pPr>
+              </a:p>
+            </c:txPr>
+            <c:showLegendKey val="0"/>
+            <c:showVal val="0"/>
+            <c:showCatName val="1"/>
+            <c:showSerName val="0"/>
+            <c:showPercent val="1"/>
+            <c:showBubbleSize val="0"/>
+            <c:showLeaderLines val="0"/>
+          </c:dLbls>
+          <c:cat>
+            <c:strRef>
+              <c:f>Sheet1!$A$2:$A$5</c:f>
+              <c:strCache>
+                <c:ptCount val="4"/>
+                <c:pt idx="0">
+                  <c:v>Tensor Cores</c:v>
+                </c:pt>
+                <c:pt idx="1">
+                  <c:v>Ingestion Mesh</c:v>
+                </c:pt>
+                <c:pt idx="2">
+                  <c:v>Vector DB</c:v>
+                </c:pt>
+                <c:pt idx="3">
+                  <c:v>Reserve</c:v>
+                </c:pt>
+              </c:strCache>
+            </c:strRef>
+          </c:cat>
+          <c:val>
+            <c:numRef>
+              <c:f>Sheet1!$B$2:$B$5</c:f>
+              <c:numCache>
+                <c:ptCount val="4"/>
+                <c:pt idx="0">
+                  <c:v>50</c:v>
+                </c:pt>
+                <c:pt idx="1">
+                  <c:v>25</c:v>
+                </c:pt>
+                <c:pt idx="2">
+                  <c:v>15</c:v>
+                </c:pt>
+                <c:pt idx="3">
+                  <c:v>10</c:v>
+                </c:pt>
+              </c:numCache>
+            </c:numRef>
+          </c:val>
+        </c:ser>
+        <c:firstSliceAng val="0"/>
+        <c:holeSize val="50"/>
+      </c:doughnutChart>
+      <c:spPr>
+        <a:noFill/>
+        <a:ln>
+          <a:noFill/>
+        </a:ln>
+        <a:effectLst/>
+      </c:spPr>
+    </c:plotArea>
+    <c:legend>
+      <c:legendPos val="b"/>
+      <c:overlay val="0"/>
+      <c:txPr>
+        <a:bodyPr/>
+        <a:lstStyle/>
+        <a:p>
+          <a:pPr>
+            <a:defRPr>
+              <a:solidFill>
+                <a:srgbClr val="6B6862"/>
+              </a:solidFill>
+            </a:defRPr>
+          </a:pPr>
+          <a:endParaRPr lang="en-US"/>
+        </a:p>
+      </c:txPr>
+    </c:legend>
+    <c:plotVisOnly val="1"/>
+    <c:dispBlanksAs val="span"/>
+  </c:chart>
+  <c:spPr>
+    <a:noFill/>
+    <a:ln>
+      <a:noFill/>
+    </a:ln>
+    <a:effectLst/>
+  </c:spPr>
+  <c:externalData r:id="rId1">
+    <c:autoUpdate val="0"/>
+  </c:externalData>
+</c:chartSpace>
 </file>
 
 <file path=ppt/notesMasters/notesMaster1.xml><?xml version="1.0" encoding="utf-8"?>
@@ -1456,7 +2109,7 @@
         </p:nvSpPr>
         <p:spPr>
           <a:xfrm>
-            <a:off x="406390" y="1181100"/>
+            <a:off x="406390" y="1155700"/>
             <a:ext cx="11378916" cy="320040"/>
           </a:xfrm>
           <a:prstGeom prst="rect">
@@ -1495,7 +2148,7 @@
         </p:nvSpPr>
         <p:spPr>
           <a:xfrm>
-            <a:off x="406390" y="1546860"/>
+            <a:off x="406390" y="1521460"/>
             <a:ext cx="11378916" cy="822960"/>
           </a:xfrm>
           <a:prstGeom prst="rect">
@@ -1534,7 +2187,7 @@
         </p:nvSpPr>
         <p:spPr>
           <a:xfrm>
-            <a:off x="406390" y="2415540"/>
+            <a:off x="406390" y="2390140"/>
             <a:ext cx="11378916" cy="548640"/>
           </a:xfrm>
           <a:prstGeom prst="rect">
@@ -1573,12 +2226,12 @@
         </p:nvSpPr>
         <p:spPr>
           <a:xfrm>
-            <a:off x="406390" y="1765300"/>
-            <a:ext cx="2286000" cy="347472"/>
+            <a:off x="406390" y="2508250"/>
+            <a:ext cx="2286000" cy="285750"/>
           </a:xfrm>
           <a:prstGeom prst="roundRect">
             <a:avLst>
-              <a:gd name="adj" fmla="val 39474"/>
+              <a:gd name="adj" fmla="val 48000"/>
             </a:avLst>
           </a:prstGeom>
           <a:solidFill>
@@ -1600,8 +2253,8 @@
         </p:nvSpPr>
         <p:spPr>
           <a:xfrm>
-            <a:off x="406390" y="1765300"/>
-            <a:ext cx="2286000" cy="347472"/>
+            <a:off x="406390" y="2508250"/>
+            <a:ext cx="2286000" cy="285750"/>
           </a:xfrm>
           <a:prstGeom prst="rect">
             <a:avLst/>
@@ -1628,6 +2281,45 @@
               <a:t>V2.4 PRODUCTION SPECIFICATION</a:t>
             </a:r>
             <a:endParaRPr lang="en-US" sz="1000" dirty="0"/>
+          </a:p>
+        </p:txBody>
+      </p:sp>
+      <p:sp>
+        <p:nvSpPr>
+          <p:cNvPr id="8" name="Text 6"/>
+          <p:cNvSpPr/>
+          <p:nvPr/>
+        </p:nvSpPr>
+        <p:spPr>
+          <a:xfrm>
+            <a:off x="457200" y="6492240"/>
+            <a:ext cx="11277295" cy="228600"/>
+          </a:xfrm>
+          <a:prstGeom prst="rect">
+            <a:avLst/>
+          </a:prstGeom>
+          <a:noFill/>
+          <a:ln/>
+        </p:spPr>
+        <p:txBody>
+          <a:bodyPr wrap="square" rtlCol="0" anchor="ctr"/>
+          <a:lstStyle/>
+          <a:p>
+            <a:pPr indent="0" marL="0">
+              <a:buNone/>
+            </a:pPr>
+            <a:r>
+              <a:rPr lang="en-US" sz="900" b="1" dirty="0">
+                <a:solidFill>
+                  <a:srgbClr val="6B6862"/>
+                </a:solidFill>
+                <a:latin typeface="Georgia" pitchFamily="34" charset="0"/>
+                <a:ea typeface="Georgia" pitchFamily="34" charset="-122"/>
+                <a:cs typeface="Georgia" pitchFamily="34" charset="-120"/>
+              </a:rPr>
+              <a:t>YUMIA V0.1.26 • CONFIDENTIAL</a:t>
+            </a:r>
+            <a:endParaRPr lang="en-US" sz="900" dirty="0"/>
           </a:p>
         </p:txBody>
       </p:sp>
@@ -1710,7 +2402,7 @@
         </p:nvSpPr>
         <p:spPr>
           <a:xfrm>
-            <a:off x="406390" y="1181100"/>
+            <a:off x="406390" y="1155700"/>
             <a:ext cx="11378916" cy="457200"/>
           </a:xfrm>
           <a:prstGeom prst="rect">
@@ -1749,12 +2441,12 @@
         </p:nvSpPr>
         <p:spPr>
           <a:xfrm>
-            <a:off x="406390" y="1775460"/>
-            <a:ext cx="5552298" cy="277114"/>
+            <a:off x="406390" y="1750060"/>
+            <a:ext cx="5552298" cy="308864"/>
           </a:xfrm>
           <a:prstGeom prst="roundRect">
             <a:avLst>
-              <a:gd name="adj" fmla="val 26398"/>
+              <a:gd name="adj" fmla="val 23684"/>
             </a:avLst>
           </a:prstGeom>
           <a:solidFill>
@@ -1776,7 +2468,7 @@
         </p:nvSpPr>
         <p:spPr>
           <a:xfrm>
-            <a:off x="516118" y="1749425"/>
+            <a:off x="516118" y="1739900"/>
             <a:ext cx="329184" cy="329184"/>
           </a:xfrm>
           <a:prstGeom prst="roundRect">
@@ -1798,7 +2490,7 @@
         </p:nvSpPr>
         <p:spPr>
           <a:xfrm>
-            <a:off x="516118" y="1749425"/>
+            <a:off x="516118" y="1739900"/>
             <a:ext cx="329184" cy="329184"/>
           </a:xfrm>
           <a:prstGeom prst="rect">
@@ -1837,8 +2529,8 @@
         </p:nvSpPr>
         <p:spPr>
           <a:xfrm>
-            <a:off x="909310" y="1830324"/>
-            <a:ext cx="4957938" cy="167386"/>
+            <a:off x="909310" y="1804924"/>
+            <a:ext cx="4957938" cy="199136"/>
           </a:xfrm>
           <a:prstGeom prst="rect">
             <a:avLst/>
@@ -1876,12 +2568,12 @@
         </p:nvSpPr>
         <p:spPr>
           <a:xfrm>
-            <a:off x="6233008" y="1775460"/>
-            <a:ext cx="5552298" cy="277114"/>
+            <a:off x="6233008" y="1750060"/>
+            <a:ext cx="5552298" cy="308864"/>
           </a:xfrm>
           <a:prstGeom prst="roundRect">
             <a:avLst>
-              <a:gd name="adj" fmla="val 26398"/>
+              <a:gd name="adj" fmla="val 23684"/>
             </a:avLst>
           </a:prstGeom>
           <a:solidFill>
@@ -1903,7 +2595,7 @@
         </p:nvSpPr>
         <p:spPr>
           <a:xfrm>
-            <a:off x="6342736" y="1749425"/>
+            <a:off x="6342736" y="1739900"/>
             <a:ext cx="329184" cy="329184"/>
           </a:xfrm>
           <a:prstGeom prst="roundRect">
@@ -1925,7 +2617,7 @@
         </p:nvSpPr>
         <p:spPr>
           <a:xfrm>
-            <a:off x="6342736" y="1749425"/>
+            <a:off x="6342736" y="1739900"/>
             <a:ext cx="329184" cy="329184"/>
           </a:xfrm>
           <a:prstGeom prst="rect">
@@ -1964,8 +2656,8 @@
         </p:nvSpPr>
         <p:spPr>
           <a:xfrm>
-            <a:off x="6735928" y="1830324"/>
-            <a:ext cx="4957938" cy="167386"/>
+            <a:off x="6735928" y="1804924"/>
+            <a:ext cx="4957938" cy="199136"/>
           </a:xfrm>
           <a:prstGeom prst="rect">
             <a:avLst/>
@@ -2003,12 +2695,12 @@
         </p:nvSpPr>
         <p:spPr>
           <a:xfrm>
-            <a:off x="406390" y="2162302"/>
-            <a:ext cx="5552298" cy="277114"/>
+            <a:off x="406390" y="2168652"/>
+            <a:ext cx="5552298" cy="308864"/>
           </a:xfrm>
           <a:prstGeom prst="roundRect">
             <a:avLst>
-              <a:gd name="adj" fmla="val 26398"/>
+              <a:gd name="adj" fmla="val 23684"/>
             </a:avLst>
           </a:prstGeom>
           <a:solidFill>
@@ -2030,7 +2722,7 @@
         </p:nvSpPr>
         <p:spPr>
           <a:xfrm>
-            <a:off x="516118" y="2136267"/>
+            <a:off x="516118" y="2158492"/>
             <a:ext cx="329184" cy="329184"/>
           </a:xfrm>
           <a:prstGeom prst="roundRect">
@@ -2052,7 +2744,7 @@
         </p:nvSpPr>
         <p:spPr>
           <a:xfrm>
-            <a:off x="516118" y="2136267"/>
+            <a:off x="516118" y="2158492"/>
             <a:ext cx="329184" cy="329184"/>
           </a:xfrm>
           <a:prstGeom prst="rect">
@@ -2091,8 +2783,8 @@
         </p:nvSpPr>
         <p:spPr>
           <a:xfrm>
-            <a:off x="909310" y="2217166"/>
-            <a:ext cx="4957938" cy="167386"/>
+            <a:off x="909310" y="2223516"/>
+            <a:ext cx="4957938" cy="199136"/>
           </a:xfrm>
           <a:prstGeom prst="rect">
             <a:avLst/>
@@ -2130,12 +2822,12 @@
         </p:nvSpPr>
         <p:spPr>
           <a:xfrm>
-            <a:off x="6233008" y="2162302"/>
-            <a:ext cx="5552298" cy="277114"/>
+            <a:off x="6233008" y="2168652"/>
+            <a:ext cx="5552298" cy="308864"/>
           </a:xfrm>
           <a:prstGeom prst="roundRect">
             <a:avLst>
-              <a:gd name="adj" fmla="val 26398"/>
+              <a:gd name="adj" fmla="val 23684"/>
             </a:avLst>
           </a:prstGeom>
           <a:solidFill>
@@ -2157,7 +2849,7 @@
         </p:nvSpPr>
         <p:spPr>
           <a:xfrm>
-            <a:off x="6342736" y="2136267"/>
+            <a:off x="6342736" y="2158492"/>
             <a:ext cx="329184" cy="329184"/>
           </a:xfrm>
           <a:prstGeom prst="roundRect">
@@ -2179,7 +2871,7 @@
         </p:nvSpPr>
         <p:spPr>
           <a:xfrm>
-            <a:off x="6342736" y="2136267"/>
+            <a:off x="6342736" y="2158492"/>
             <a:ext cx="329184" cy="329184"/>
           </a:xfrm>
           <a:prstGeom prst="rect">
@@ -2218,8 +2910,8 @@
         </p:nvSpPr>
         <p:spPr>
           <a:xfrm>
-            <a:off x="6735928" y="2217166"/>
-            <a:ext cx="4957938" cy="167386"/>
+            <a:off x="6735928" y="2223516"/>
+            <a:ext cx="4957938" cy="199136"/>
           </a:xfrm>
           <a:prstGeom prst="rect">
             <a:avLst/>
@@ -2257,12 +2949,12 @@
         </p:nvSpPr>
         <p:spPr>
           <a:xfrm>
-            <a:off x="406390" y="2549144"/>
-            <a:ext cx="5552298" cy="277114"/>
+            <a:off x="406390" y="2587244"/>
+            <a:ext cx="5552298" cy="308864"/>
           </a:xfrm>
           <a:prstGeom prst="roundRect">
             <a:avLst>
-              <a:gd name="adj" fmla="val 26398"/>
+              <a:gd name="adj" fmla="val 23684"/>
             </a:avLst>
           </a:prstGeom>
           <a:solidFill>
@@ -2284,7 +2976,7 @@
         </p:nvSpPr>
         <p:spPr>
           <a:xfrm>
-            <a:off x="516118" y="2523109"/>
+            <a:off x="516118" y="2577084"/>
             <a:ext cx="329184" cy="329184"/>
           </a:xfrm>
           <a:prstGeom prst="roundRect">
@@ -2306,7 +2998,7 @@
         </p:nvSpPr>
         <p:spPr>
           <a:xfrm>
-            <a:off x="516118" y="2523109"/>
+            <a:off x="516118" y="2577084"/>
             <a:ext cx="329184" cy="329184"/>
           </a:xfrm>
           <a:prstGeom prst="rect">
@@ -2345,8 +3037,8 @@
         </p:nvSpPr>
         <p:spPr>
           <a:xfrm>
-            <a:off x="909310" y="2604008"/>
-            <a:ext cx="4957938" cy="167386"/>
+            <a:off x="909310" y="2642108"/>
+            <a:ext cx="4957938" cy="199136"/>
           </a:xfrm>
           <a:prstGeom prst="rect">
             <a:avLst/>
@@ -2384,12 +3076,12 @@
         </p:nvSpPr>
         <p:spPr>
           <a:xfrm>
-            <a:off x="6233008" y="2549144"/>
-            <a:ext cx="5552298" cy="277114"/>
+            <a:off x="6233008" y="2587244"/>
+            <a:ext cx="5552298" cy="308864"/>
           </a:xfrm>
           <a:prstGeom prst="roundRect">
             <a:avLst>
-              <a:gd name="adj" fmla="val 26398"/>
+              <a:gd name="adj" fmla="val 23684"/>
             </a:avLst>
           </a:prstGeom>
           <a:solidFill>
@@ -2411,7 +3103,7 @@
         </p:nvSpPr>
         <p:spPr>
           <a:xfrm>
-            <a:off x="6342736" y="2523109"/>
+            <a:off x="6342736" y="2577084"/>
             <a:ext cx="329184" cy="329184"/>
           </a:xfrm>
           <a:prstGeom prst="roundRect">
@@ -2433,7 +3125,7 @@
         </p:nvSpPr>
         <p:spPr>
           <a:xfrm>
-            <a:off x="6342736" y="2523109"/>
+            <a:off x="6342736" y="2577084"/>
             <a:ext cx="329184" cy="329184"/>
           </a:xfrm>
           <a:prstGeom prst="rect">
@@ -2472,8 +3164,8 @@
         </p:nvSpPr>
         <p:spPr>
           <a:xfrm>
-            <a:off x="6735928" y="2604008"/>
-            <a:ext cx="4957938" cy="167386"/>
+            <a:off x="6735928" y="2642108"/>
+            <a:ext cx="4957938" cy="199136"/>
           </a:xfrm>
           <a:prstGeom prst="rect">
             <a:avLst/>
@@ -2511,12 +3203,12 @@
         </p:nvSpPr>
         <p:spPr>
           <a:xfrm>
-            <a:off x="406390" y="2935986"/>
-            <a:ext cx="5552298" cy="277114"/>
+            <a:off x="406390" y="3005836"/>
+            <a:ext cx="5552298" cy="308864"/>
           </a:xfrm>
           <a:prstGeom prst="roundRect">
             <a:avLst>
-              <a:gd name="adj" fmla="val 26398"/>
+              <a:gd name="adj" fmla="val 23684"/>
             </a:avLst>
           </a:prstGeom>
           <a:solidFill>
@@ -2538,7 +3230,7 @@
         </p:nvSpPr>
         <p:spPr>
           <a:xfrm>
-            <a:off x="516118" y="2909951"/>
+            <a:off x="516118" y="2995676"/>
             <a:ext cx="329184" cy="329184"/>
           </a:xfrm>
           <a:prstGeom prst="roundRect">
@@ -2560,7 +3252,7 @@
         </p:nvSpPr>
         <p:spPr>
           <a:xfrm>
-            <a:off x="516118" y="2909951"/>
+            <a:off x="516118" y="2995676"/>
             <a:ext cx="329184" cy="329184"/>
           </a:xfrm>
           <a:prstGeom prst="rect">
@@ -2599,8 +3291,8 @@
         </p:nvSpPr>
         <p:spPr>
           <a:xfrm>
-            <a:off x="909310" y="2990850"/>
-            <a:ext cx="4957938" cy="167386"/>
+            <a:off x="909310" y="3060700"/>
+            <a:ext cx="4957938" cy="199136"/>
           </a:xfrm>
           <a:prstGeom prst="rect">
             <a:avLst/>
@@ -2627,6 +3319,45 @@
               <a:t>Implementation &amp; Runtime Kernel</a:t>
             </a:r>
             <a:endParaRPr lang="en-US" sz="1300" dirty="0"/>
+          </a:p>
+        </p:txBody>
+      </p:sp>
+      <p:sp>
+        <p:nvSpPr>
+          <p:cNvPr id="32" name="Text 30"/>
+          <p:cNvSpPr/>
+          <p:nvPr/>
+        </p:nvSpPr>
+        <p:spPr>
+          <a:xfrm>
+            <a:off x="457200" y="6492240"/>
+            <a:ext cx="11277295" cy="228600"/>
+          </a:xfrm>
+          <a:prstGeom prst="rect">
+            <a:avLst/>
+          </a:prstGeom>
+          <a:noFill/>
+          <a:ln/>
+        </p:spPr>
+        <p:txBody>
+          <a:bodyPr wrap="square" rtlCol="0" anchor="ctr"/>
+          <a:lstStyle/>
+          <a:p>
+            <a:pPr indent="0" marL="0">
+              <a:buNone/>
+            </a:pPr>
+            <a:r>
+              <a:rPr lang="en-US" sz="900" b="1" dirty="0">
+                <a:solidFill>
+                  <a:srgbClr val="6B6862"/>
+                </a:solidFill>
+                <a:latin typeface="Georgia" pitchFamily="34" charset="0"/>
+                <a:ea typeface="Georgia" pitchFamily="34" charset="-122"/>
+                <a:cs typeface="Georgia" pitchFamily="34" charset="-120"/>
+              </a:rPr>
+              <a:t>YUMIA V0.1.26 • CONFIDENTIAL</a:t>
+            </a:r>
+            <a:endParaRPr lang="en-US" sz="900" dirty="0"/>
           </a:p>
         </p:txBody>
       </p:sp>
@@ -2709,7 +3440,7 @@
         </p:nvSpPr>
         <p:spPr>
           <a:xfrm>
-            <a:off x="406390" y="1181100"/>
+            <a:off x="406390" y="1155700"/>
             <a:ext cx="11378916" cy="444500"/>
           </a:xfrm>
           <a:prstGeom prst="rect">
@@ -2748,7 +3479,7 @@
         </p:nvSpPr>
         <p:spPr>
           <a:xfrm>
-            <a:off x="1862619" y="2019300"/>
+            <a:off x="1862619" y="2794000"/>
             <a:ext cx="1024443" cy="9144"/>
           </a:xfrm>
           <a:prstGeom prst="line">
@@ -2772,7 +3503,7 @@
         </p:nvSpPr>
         <p:spPr>
           <a:xfrm>
-            <a:off x="4343290" y="2019300"/>
+            <a:off x="4343290" y="2794000"/>
             <a:ext cx="1024443" cy="9144"/>
           </a:xfrm>
           <a:prstGeom prst="line">
@@ -2796,7 +3527,7 @@
         </p:nvSpPr>
         <p:spPr>
           <a:xfrm>
-            <a:off x="4489752" y="1882140"/>
+            <a:off x="4489752" y="2656840"/>
             <a:ext cx="731520" cy="274320"/>
           </a:xfrm>
           <a:prstGeom prst="rect">
@@ -2832,7 +3563,7 @@
         </p:nvSpPr>
         <p:spPr>
           <a:xfrm>
-            <a:off x="6823962" y="2019300"/>
+            <a:off x="6823962" y="2794000"/>
             <a:ext cx="1024443" cy="9144"/>
           </a:xfrm>
           <a:prstGeom prst="line">
@@ -2856,7 +3587,7 @@
         </p:nvSpPr>
         <p:spPr>
           <a:xfrm>
-            <a:off x="6970423" y="1882140"/>
+            <a:off x="6970423" y="2656840"/>
             <a:ext cx="731520" cy="274320"/>
           </a:xfrm>
           <a:prstGeom prst="rect">
@@ -2892,8 +3623,8 @@
         </p:nvSpPr>
         <p:spPr>
           <a:xfrm flipV="1">
-            <a:off x="9304634" y="1809750"/>
-            <a:ext cx="1024443" cy="209550"/>
+            <a:off x="9304634" y="2075180"/>
+            <a:ext cx="1024443" cy="718820"/>
           </a:xfrm>
           <a:prstGeom prst="line">
             <a:avLst/>
@@ -2916,8 +3647,8 @@
         </p:nvSpPr>
         <p:spPr>
           <a:xfrm>
-            <a:off x="9304634" y="2019300"/>
-            <a:ext cx="1024443" cy="209550"/>
+            <a:off x="9304634" y="2794000"/>
+            <a:ext cx="1024443" cy="718820"/>
           </a:xfrm>
           <a:prstGeom prst="line">
             <a:avLst/>
@@ -2940,7 +3671,7 @@
         </p:nvSpPr>
         <p:spPr>
           <a:xfrm>
-            <a:off x="9451095" y="1986915"/>
+            <a:off x="9451095" y="3016250"/>
             <a:ext cx="731520" cy="274320"/>
           </a:xfrm>
           <a:prstGeom prst="rect">
@@ -2976,12 +3707,12 @@
         </p:nvSpPr>
         <p:spPr>
           <a:xfrm>
-            <a:off x="406390" y="2038350"/>
-            <a:ext cx="1456229" cy="-38100"/>
+            <a:off x="406390" y="2496820"/>
+            <a:ext cx="1456229" cy="594360"/>
           </a:xfrm>
           <a:prstGeom prst="roundRect">
             <a:avLst>
-              <a:gd name="adj" fmla="val -192000"/>
+              <a:gd name="adj" fmla="val 12308"/>
             </a:avLst>
           </a:prstGeom>
           <a:solidFill>
@@ -3003,8 +3734,8 @@
         </p:nvSpPr>
         <p:spPr>
           <a:xfrm>
-            <a:off x="452110" y="2084070"/>
-            <a:ext cx="1364789" cy="91440"/>
+            <a:off x="452110" y="2542540"/>
+            <a:ext cx="1364789" cy="502920"/>
           </a:xfrm>
           <a:prstGeom prst="rect">
             <a:avLst/>
@@ -3042,12 +3773,12 @@
         </p:nvSpPr>
         <p:spPr>
           <a:xfrm>
-            <a:off x="2887062" y="2038350"/>
-            <a:ext cx="1456229" cy="-38100"/>
+            <a:off x="2887062" y="2496820"/>
+            <a:ext cx="1456229" cy="594360"/>
           </a:xfrm>
           <a:prstGeom prst="roundRect">
             <a:avLst>
-              <a:gd name="adj" fmla="val -192000"/>
+              <a:gd name="adj" fmla="val 12308"/>
             </a:avLst>
           </a:prstGeom>
           <a:solidFill>
@@ -3069,8 +3800,8 @@
         </p:nvSpPr>
         <p:spPr>
           <a:xfrm>
-            <a:off x="2932782" y="2084070"/>
-            <a:ext cx="1364789" cy="91440"/>
+            <a:off x="2932782" y="2542540"/>
+            <a:ext cx="1364789" cy="502920"/>
           </a:xfrm>
           <a:prstGeom prst="rect">
             <a:avLst/>
@@ -3108,12 +3839,12 @@
         </p:nvSpPr>
         <p:spPr>
           <a:xfrm>
-            <a:off x="5367733" y="2038350"/>
-            <a:ext cx="1456229" cy="-38100"/>
+            <a:off x="5367733" y="2496820"/>
+            <a:ext cx="1456229" cy="594360"/>
           </a:xfrm>
           <a:prstGeom prst="roundRect">
             <a:avLst>
-              <a:gd name="adj" fmla="val -192000"/>
+              <a:gd name="adj" fmla="val 12308"/>
             </a:avLst>
           </a:prstGeom>
           <a:solidFill>
@@ -3135,8 +3866,8 @@
         </p:nvSpPr>
         <p:spPr>
           <a:xfrm>
-            <a:off x="5413453" y="2084070"/>
-            <a:ext cx="1364789" cy="91440"/>
+            <a:off x="5413453" y="2542540"/>
+            <a:ext cx="1364789" cy="502920"/>
           </a:xfrm>
           <a:prstGeom prst="rect">
             <a:avLst/>
@@ -3174,12 +3905,12 @@
         </p:nvSpPr>
         <p:spPr>
           <a:xfrm>
-            <a:off x="7848405" y="2038350"/>
-            <a:ext cx="1456229" cy="-38100"/>
+            <a:off x="7848405" y="2496820"/>
+            <a:ext cx="1456229" cy="594360"/>
           </a:xfrm>
           <a:prstGeom prst="roundRect">
             <a:avLst>
-              <a:gd name="adj" fmla="val -192000"/>
+              <a:gd name="adj" fmla="val 12308"/>
             </a:avLst>
           </a:prstGeom>
           <a:solidFill>
@@ -3201,8 +3932,8 @@
         </p:nvSpPr>
         <p:spPr>
           <a:xfrm>
-            <a:off x="7894125" y="2084070"/>
-            <a:ext cx="1364789" cy="91440"/>
+            <a:off x="7894125" y="2542540"/>
+            <a:ext cx="1364789" cy="502920"/>
           </a:xfrm>
           <a:prstGeom prst="rect">
             <a:avLst/>
@@ -3240,12 +3971,12 @@
         </p:nvSpPr>
         <p:spPr>
           <a:xfrm>
-            <a:off x="10329077" y="1828800"/>
-            <a:ext cx="1456229" cy="-38100"/>
+            <a:off x="10329077" y="1778000"/>
+            <a:ext cx="1456229" cy="594360"/>
           </a:xfrm>
           <a:prstGeom prst="can">
             <a:avLst>
-              <a:gd name="adj" fmla="val -192000"/>
+              <a:gd name="adj" fmla="val 12308"/>
             </a:avLst>
           </a:prstGeom>
           <a:solidFill>
@@ -3267,8 +3998,8 @@
         </p:nvSpPr>
         <p:spPr>
           <a:xfrm>
-            <a:off x="10374797" y="1874520"/>
-            <a:ext cx="1364789" cy="91440"/>
+            <a:off x="10374797" y="1823720"/>
+            <a:ext cx="1364789" cy="502920"/>
           </a:xfrm>
           <a:prstGeom prst="rect">
             <a:avLst/>
@@ -3306,12 +4037,12 @@
         </p:nvSpPr>
         <p:spPr>
           <a:xfrm>
-            <a:off x="10329077" y="2247900"/>
-            <a:ext cx="1456229" cy="-38100"/>
+            <a:off x="10329077" y="3215640"/>
+            <a:ext cx="1456229" cy="594360"/>
           </a:xfrm>
           <a:prstGeom prst="can">
             <a:avLst>
-              <a:gd name="adj" fmla="val -192000"/>
+              <a:gd name="adj" fmla="val 12308"/>
             </a:avLst>
           </a:prstGeom>
           <a:solidFill>
@@ -3333,8 +4064,8 @@
         </p:nvSpPr>
         <p:spPr>
           <a:xfrm>
-            <a:off x="10374797" y="2293620"/>
-            <a:ext cx="1364789" cy="91440"/>
+            <a:off x="10374797" y="3261360"/>
+            <a:ext cx="1364789" cy="502920"/>
           </a:xfrm>
           <a:prstGeom prst="rect">
             <a:avLst/>
@@ -3361,6 +4092,45 @@
               <a:t>Redis Semantic Cache</a:t>
             </a:r>
             <a:endParaRPr lang="en-US" sz="1100" dirty="0"/>
+          </a:p>
+        </p:txBody>
+      </p:sp>
+      <p:sp>
+        <p:nvSpPr>
+          <p:cNvPr id="24" name="Text 22"/>
+          <p:cNvSpPr/>
+          <p:nvPr/>
+        </p:nvSpPr>
+        <p:spPr>
+          <a:xfrm>
+            <a:off x="457200" y="6492240"/>
+            <a:ext cx="11277295" cy="228600"/>
+          </a:xfrm>
+          <a:prstGeom prst="rect">
+            <a:avLst/>
+          </a:prstGeom>
+          <a:noFill/>
+          <a:ln/>
+        </p:spPr>
+        <p:txBody>
+          <a:bodyPr wrap="square" rtlCol="0" anchor="ctr"/>
+          <a:lstStyle/>
+          <a:p>
+            <a:pPr indent="0" marL="0">
+              <a:buNone/>
+            </a:pPr>
+            <a:r>
+              <a:rPr lang="en-US" sz="900" b="1" dirty="0">
+                <a:solidFill>
+                  <a:srgbClr val="6B6862"/>
+                </a:solidFill>
+                <a:latin typeface="Georgia" pitchFamily="34" charset="0"/>
+                <a:ea typeface="Georgia" pitchFamily="34" charset="-122"/>
+                <a:cs typeface="Georgia" pitchFamily="34" charset="-120"/>
+              </a:rPr>
+              <a:t>YUMIA V0.1.26 • CONFIDENTIAL</a:t>
+            </a:r>
+            <a:endParaRPr lang="en-US" sz="900" dirty="0"/>
           </a:p>
         </p:txBody>
       </p:sp>
@@ -3443,7 +4213,7 @@
         </p:nvSpPr>
         <p:spPr>
           <a:xfrm>
-            <a:off x="406390" y="1181100"/>
+            <a:off x="406390" y="1155700"/>
             <a:ext cx="11378916" cy="444500"/>
           </a:xfrm>
           <a:prstGeom prst="rect">
@@ -3471,6 +4241,509 @@
               <a:t>Measured Benchmarks Across Compute Clusters</a:t>
             </a:r>
             <a:endParaRPr lang="en-US" sz="3400" dirty="0"/>
+          </a:p>
+        </p:txBody>
+      </p:sp>
+      <p:sp>
+        <p:nvSpPr>
+          <p:cNvPr id="4" name="Shape 2"/>
+          <p:cNvSpPr/>
+          <p:nvPr/>
+        </p:nvSpPr>
+        <p:spPr>
+          <a:xfrm>
+            <a:off x="406390" y="1778000"/>
+            <a:ext cx="5600560" cy="2120900"/>
+          </a:xfrm>
+          <a:prstGeom prst="roundRect">
+            <a:avLst>
+              <a:gd name="adj" fmla="val 3449"/>
+            </a:avLst>
+          </a:prstGeom>
+          <a:solidFill>
+            <a:srgbClr val="F5F2EB"/>
+          </a:solidFill>
+          <a:ln w="19050">
+            <a:solidFill>
+              <a:srgbClr val="2E7D32"/>
+            </a:solidFill>
+            <a:prstDash val="solid"/>
+          </a:ln>
+        </p:spPr>
+      </p:sp>
+      <p:sp>
+        <p:nvSpPr>
+          <p:cNvPr id="5" name="Shape 3"/>
+          <p:cNvSpPr/>
+          <p:nvPr/>
+        </p:nvSpPr>
+        <p:spPr>
+          <a:xfrm>
+            <a:off x="424678" y="1814576"/>
+            <a:ext cx="54864" cy="2047748"/>
+          </a:xfrm>
+          <a:prstGeom prst="roundRect">
+            <a:avLst>
+              <a:gd name="adj" fmla="val 50000"/>
+            </a:avLst>
+          </a:prstGeom>
+          <a:solidFill>
+            <a:srgbClr val="2E7D32"/>
+          </a:solidFill>
+          <a:ln/>
+        </p:spPr>
+      </p:sp>
+      <p:sp>
+        <p:nvSpPr>
+          <p:cNvPr id="6" name="Text 4"/>
+          <p:cNvSpPr/>
+          <p:nvPr/>
+        </p:nvSpPr>
+        <p:spPr>
+          <a:xfrm>
+            <a:off x="634990" y="1942592"/>
+            <a:ext cx="5143360" cy="320040"/>
+          </a:xfrm>
+          <a:prstGeom prst="rect">
+            <a:avLst/>
+          </a:prstGeom>
+          <a:noFill/>
+          <a:ln/>
+        </p:spPr>
+        <p:txBody>
+          <a:bodyPr wrap="square" rtlCol="0" anchor="ctr"/>
+          <a:lstStyle/>
+          <a:p>
+            <a:pPr indent="0" marL="0">
+              <a:buNone/>
+            </a:pPr>
+            <a:r>
+              <a:rPr lang="en-US" sz="2000" b="1" dirty="0">
+                <a:solidFill>
+                  <a:srgbClr val="2E7D32"/>
+                </a:solidFill>
+                <a:latin typeface="Georgia" pitchFamily="34" charset="0"/>
+                <a:ea typeface="Georgia" pitchFamily="34" charset="-122"/>
+                <a:cs typeface="Georgia" pitchFamily="34" charset="-120"/>
+              </a:rPr>
+              <a:t>Inference Latency</a:t>
+            </a:r>
+            <a:endParaRPr lang="en-US" sz="2000" dirty="0"/>
+          </a:p>
+        </p:txBody>
+      </p:sp>
+      <p:sp>
+        <p:nvSpPr>
+          <p:cNvPr id="7" name="Shape 5"/>
+          <p:cNvSpPr/>
+          <p:nvPr/>
+        </p:nvSpPr>
+        <p:spPr>
+          <a:xfrm>
+            <a:off x="609585" y="2362200"/>
+            <a:ext cx="5194170" cy="825500"/>
+          </a:xfrm>
+          <a:prstGeom prst="roundRect">
+            <a:avLst>
+              <a:gd name="adj" fmla="val 8862"/>
+            </a:avLst>
+          </a:prstGeom>
+          <a:solidFill>
+            <a:srgbClr val="F5F2EB"/>
+          </a:solidFill>
+          <a:ln w="19050">
+            <a:solidFill>
+              <a:srgbClr val="2E7D32"/>
+            </a:solidFill>
+            <a:prstDash val="solid"/>
+          </a:ln>
+        </p:spPr>
+      </p:sp>
+      <p:sp>
+        <p:nvSpPr>
+          <p:cNvPr id="8" name="Text 6"/>
+          <p:cNvSpPr/>
+          <p:nvPr/>
+        </p:nvSpPr>
+        <p:spPr>
+          <a:xfrm>
+            <a:off x="701025" y="2453640"/>
+            <a:ext cx="5011290" cy="201168"/>
+          </a:xfrm>
+          <a:prstGeom prst="rect">
+            <a:avLst/>
+          </a:prstGeom>
+          <a:noFill/>
+          <a:ln/>
+        </p:spPr>
+        <p:txBody>
+          <a:bodyPr wrap="square" rtlCol="0" anchor="ctr"/>
+          <a:lstStyle/>
+          <a:p>
+            <a:pPr algn="ctr" indent="0" marL="0">
+              <a:buNone/>
+            </a:pPr>
+            <a:r>
+              <a:rPr lang="en-US" sz="1000" b="1" dirty="0">
+                <a:solidFill>
+                  <a:srgbClr val="6B6862"/>
+                </a:solidFill>
+                <a:latin typeface="Georgia" pitchFamily="34" charset="0"/>
+                <a:ea typeface="Georgia" pitchFamily="34" charset="-122"/>
+                <a:cs typeface="Georgia" pitchFamily="34" charset="-120"/>
+              </a:rPr>
+              <a:t>BENCHMARKED SPEEDUP</a:t>
+            </a:r>
+            <a:endParaRPr lang="en-US" sz="1000" dirty="0"/>
+          </a:p>
+        </p:txBody>
+      </p:sp>
+      <p:sp>
+        <p:nvSpPr>
+          <p:cNvPr id="9" name="Text 7"/>
+          <p:cNvSpPr/>
+          <p:nvPr/>
+        </p:nvSpPr>
+        <p:spPr>
+          <a:xfrm>
+            <a:off x="701025" y="2673096"/>
+            <a:ext cx="5011290" cy="402336"/>
+          </a:xfrm>
+          <a:prstGeom prst="rect">
+            <a:avLst/>
+          </a:prstGeom>
+          <a:noFill/>
+          <a:ln/>
+        </p:spPr>
+        <p:txBody>
+          <a:bodyPr wrap="square" rtlCol="0" anchor="ctr"/>
+          <a:lstStyle/>
+          <a:p>
+            <a:pPr algn="ctr" indent="0" marL="0">
+              <a:buNone/>
+            </a:pPr>
+            <a:r>
+              <a:rPr lang="en-US" sz="2600" b="1" dirty="0">
+                <a:solidFill>
+                  <a:srgbClr val="2E7D32"/>
+                </a:solidFill>
+                <a:latin typeface="Georgia" pitchFamily="34" charset="0"/>
+                <a:ea typeface="Georgia" pitchFamily="34" charset="-122"/>
+                <a:cs typeface="Georgia" pitchFamily="34" charset="-120"/>
+              </a:rPr>
+              <a:t>1.42ms</a:t>
+            </a:r>
+            <a:endParaRPr lang="en-US" sz="2600" dirty="0"/>
+          </a:p>
+        </p:txBody>
+      </p:sp>
+      <p:sp>
+        <p:nvSpPr>
+          <p:cNvPr id="10" name="Text 8"/>
+          <p:cNvSpPr/>
+          <p:nvPr/>
+        </p:nvSpPr>
+        <p:spPr>
+          <a:xfrm>
+            <a:off x="609585" y="3365500"/>
+            <a:ext cx="5194170" cy="254000"/>
+          </a:xfrm>
+          <a:prstGeom prst="rect">
+            <a:avLst/>
+          </a:prstGeom>
+          <a:noFill/>
+          <a:ln/>
+        </p:spPr>
+        <p:txBody>
+          <a:bodyPr wrap="square" lIns="0" tIns="0" rIns="0" bIns="0" rtlCol="0" anchor="t"/>
+          <a:lstStyle/>
+          <a:p>
+            <a:pPr algn="l" indent="0" marL="0">
+              <a:buNone/>
+            </a:pPr>
+            <a:r>
+              <a:rPr lang="en-US" sz="1800" dirty="0">
+                <a:solidFill>
+                  <a:srgbClr val="2C2B29"/>
+                </a:solidFill>
+                <a:latin typeface="Georgia" pitchFamily="34" charset="0"/>
+                <a:ea typeface="Georgia" pitchFamily="34" charset="-122"/>
+                <a:cs typeface="Georgia" pitchFamily="34" charset="-120"/>
+              </a:rPr>
+              <a:t>End-to-end latency reduction under heavy concurrent load.</a:t>
+            </a:r>
+            <a:endParaRPr lang="en-US" sz="1800" dirty="0"/>
+          </a:p>
+        </p:txBody>
+      </p:sp>
+      <p:sp>
+        <p:nvSpPr>
+          <p:cNvPr id="11" name="Shape 9"/>
+          <p:cNvSpPr/>
+          <p:nvPr/>
+        </p:nvSpPr>
+        <p:spPr>
+          <a:xfrm>
+            <a:off x="6184745" y="1778000"/>
+            <a:ext cx="5600560" cy="2324100"/>
+          </a:xfrm>
+          <a:prstGeom prst="roundRect">
+            <a:avLst>
+              <a:gd name="adj" fmla="val 3148"/>
+            </a:avLst>
+          </a:prstGeom>
+          <a:solidFill>
+            <a:srgbClr val="F5F2EB"/>
+          </a:solidFill>
+          <a:ln w="19050">
+            <a:solidFill>
+              <a:srgbClr val="C29B38"/>
+            </a:solidFill>
+            <a:prstDash val="solid"/>
+          </a:ln>
+        </p:spPr>
+      </p:sp>
+      <p:sp>
+        <p:nvSpPr>
+          <p:cNvPr id="12" name="Shape 10"/>
+          <p:cNvSpPr/>
+          <p:nvPr/>
+        </p:nvSpPr>
+        <p:spPr>
+          <a:xfrm>
+            <a:off x="6203033" y="1814576"/>
+            <a:ext cx="54864" cy="2250948"/>
+          </a:xfrm>
+          <a:prstGeom prst="roundRect">
+            <a:avLst>
+              <a:gd name="adj" fmla="val 50000"/>
+            </a:avLst>
+          </a:prstGeom>
+          <a:solidFill>
+            <a:srgbClr val="C29B38"/>
+          </a:solidFill>
+          <a:ln/>
+        </p:spPr>
+      </p:sp>
+      <p:sp>
+        <p:nvSpPr>
+          <p:cNvPr id="13" name="Text 11"/>
+          <p:cNvSpPr/>
+          <p:nvPr/>
+        </p:nvSpPr>
+        <p:spPr>
+          <a:xfrm>
+            <a:off x="6413345" y="1942592"/>
+            <a:ext cx="5143360" cy="320040"/>
+          </a:xfrm>
+          <a:prstGeom prst="rect">
+            <a:avLst/>
+          </a:prstGeom>
+          <a:noFill/>
+          <a:ln/>
+        </p:spPr>
+        <p:txBody>
+          <a:bodyPr wrap="square" rtlCol="0" anchor="ctr"/>
+          <a:lstStyle/>
+          <a:p>
+            <a:pPr indent="0" marL="0">
+              <a:buNone/>
+            </a:pPr>
+            <a:r>
+              <a:rPr lang="en-US" sz="2000" b="1" dirty="0">
+                <a:solidFill>
+                  <a:srgbClr val="C29B38"/>
+                </a:solidFill>
+                <a:latin typeface="Georgia" pitchFamily="34" charset="0"/>
+                <a:ea typeface="Georgia" pitchFamily="34" charset="-122"/>
+                <a:cs typeface="Georgia" pitchFamily="34" charset="-120"/>
+              </a:rPr>
+              <a:t>Throughput Capacity</a:t>
+            </a:r>
+            <a:endParaRPr lang="en-US" sz="2000" dirty="0"/>
+          </a:p>
+        </p:txBody>
+      </p:sp>
+      <p:sp>
+        <p:nvSpPr>
+          <p:cNvPr id="14" name="Shape 12"/>
+          <p:cNvSpPr/>
+          <p:nvPr/>
+        </p:nvSpPr>
+        <p:spPr>
+          <a:xfrm>
+            <a:off x="6387940" y="2362200"/>
+            <a:ext cx="5194170" cy="825500"/>
+          </a:xfrm>
+          <a:prstGeom prst="roundRect">
+            <a:avLst>
+              <a:gd name="adj" fmla="val 8862"/>
+            </a:avLst>
+          </a:prstGeom>
+          <a:solidFill>
+            <a:srgbClr val="F5F2EB"/>
+          </a:solidFill>
+          <a:ln w="19050">
+            <a:solidFill>
+              <a:srgbClr val="C29B38"/>
+            </a:solidFill>
+            <a:prstDash val="solid"/>
+          </a:ln>
+        </p:spPr>
+      </p:sp>
+      <p:sp>
+        <p:nvSpPr>
+          <p:cNvPr id="15" name="Text 13"/>
+          <p:cNvSpPr/>
+          <p:nvPr/>
+        </p:nvSpPr>
+        <p:spPr>
+          <a:xfrm>
+            <a:off x="6479380" y="2453640"/>
+            <a:ext cx="5011290" cy="201168"/>
+          </a:xfrm>
+          <a:prstGeom prst="rect">
+            <a:avLst/>
+          </a:prstGeom>
+          <a:noFill/>
+          <a:ln/>
+        </p:spPr>
+        <p:txBody>
+          <a:bodyPr wrap="square" rtlCol="0" anchor="ctr"/>
+          <a:lstStyle/>
+          <a:p>
+            <a:pPr algn="ctr" indent="0" marL="0">
+              <a:buNone/>
+            </a:pPr>
+            <a:r>
+              <a:rPr lang="en-US" sz="1000" b="1" dirty="0">
+                <a:solidFill>
+                  <a:srgbClr val="6B6862"/>
+                </a:solidFill>
+                <a:latin typeface="Georgia" pitchFamily="34" charset="0"/>
+                <a:ea typeface="Georgia" pitchFamily="34" charset="-122"/>
+                <a:cs typeface="Georgia" pitchFamily="34" charset="-120"/>
+              </a:rPr>
+              <a:t>BENCHMARKED SPEEDUP</a:t>
+            </a:r>
+            <a:endParaRPr lang="en-US" sz="1000" dirty="0"/>
+          </a:p>
+        </p:txBody>
+      </p:sp>
+      <p:sp>
+        <p:nvSpPr>
+          <p:cNvPr id="16" name="Text 14"/>
+          <p:cNvSpPr/>
+          <p:nvPr/>
+        </p:nvSpPr>
+        <p:spPr>
+          <a:xfrm>
+            <a:off x="6479380" y="2673096"/>
+            <a:ext cx="5011290" cy="402336"/>
+          </a:xfrm>
+          <a:prstGeom prst="rect">
+            <a:avLst/>
+          </a:prstGeom>
+          <a:noFill/>
+          <a:ln/>
+        </p:spPr>
+        <p:txBody>
+          <a:bodyPr wrap="square" rtlCol="0" anchor="ctr"/>
+          <a:lstStyle/>
+          <a:p>
+            <a:pPr algn="ctr" indent="0" marL="0">
+              <a:buNone/>
+            </a:pPr>
+            <a:r>
+              <a:rPr lang="en-US" sz="2600" b="1" dirty="0">
+                <a:solidFill>
+                  <a:srgbClr val="C29B38"/>
+                </a:solidFill>
+                <a:latin typeface="Georgia" pitchFamily="34" charset="0"/>
+                <a:ea typeface="Georgia" pitchFamily="34" charset="-122"/>
+                <a:cs typeface="Georgia" pitchFamily="34" charset="-120"/>
+              </a:rPr>
+              <a:t>450k op/s</a:t>
+            </a:r>
+            <a:endParaRPr lang="en-US" sz="2600" dirty="0"/>
+          </a:p>
+        </p:txBody>
+      </p:sp>
+      <p:sp>
+        <p:nvSpPr>
+          <p:cNvPr id="17" name="Text 15"/>
+          <p:cNvSpPr/>
+          <p:nvPr/>
+        </p:nvSpPr>
+        <p:spPr>
+          <a:xfrm>
+            <a:off x="6387940" y="3365500"/>
+            <a:ext cx="5194170" cy="457200"/>
+          </a:xfrm>
+          <a:prstGeom prst="rect">
+            <a:avLst/>
+          </a:prstGeom>
+          <a:noFill/>
+          <a:ln/>
+        </p:spPr>
+        <p:txBody>
+          <a:bodyPr wrap="square" lIns="0" tIns="0" rIns="0" bIns="0" rtlCol="0" anchor="t"/>
+          <a:lstStyle/>
+          <a:p>
+            <a:pPr algn="l" indent="0" marL="0">
+              <a:buNone/>
+            </a:pPr>
+            <a:r>
+              <a:rPr lang="en-US" sz="1800" dirty="0">
+                <a:solidFill>
+                  <a:srgbClr val="2C2B29"/>
+                </a:solidFill>
+                <a:latin typeface="Georgia" pitchFamily="34" charset="0"/>
+                <a:ea typeface="Georgia" pitchFamily="34" charset="-122"/>
+                <a:cs typeface="Georgia" pitchFamily="34" charset="-120"/>
+              </a:rPr>
+              <a:t>Peak distributed operations sustained without buffer degradation.</a:t>
+            </a:r>
+            <a:endParaRPr lang="en-US" sz="1800" dirty="0"/>
+          </a:p>
+        </p:txBody>
+      </p:sp>
+      <p:sp>
+        <p:nvSpPr>
+          <p:cNvPr id="18" name="Text 16"/>
+          <p:cNvSpPr/>
+          <p:nvPr/>
+        </p:nvSpPr>
+        <p:spPr>
+          <a:xfrm>
+            <a:off x="457200" y="6492240"/>
+            <a:ext cx="11277295" cy="228600"/>
+          </a:xfrm>
+          <a:prstGeom prst="rect">
+            <a:avLst/>
+          </a:prstGeom>
+          <a:noFill/>
+          <a:ln/>
+        </p:spPr>
+        <p:txBody>
+          <a:bodyPr wrap="square" rtlCol="0" anchor="ctr"/>
+          <a:lstStyle/>
+          <a:p>
+            <a:pPr indent="0" marL="0">
+              <a:buNone/>
+            </a:pPr>
+            <a:r>
+              <a:rPr lang="en-US" sz="900" b="1" dirty="0">
+                <a:solidFill>
+                  <a:srgbClr val="6B6862"/>
+                </a:solidFill>
+                <a:latin typeface="Georgia" pitchFamily="34" charset="0"/>
+                <a:ea typeface="Georgia" pitchFamily="34" charset="-122"/>
+                <a:cs typeface="Georgia" pitchFamily="34" charset="-120"/>
+              </a:rPr>
+              <a:t>YUMIA V0.1.26 • CONFIDENTIAL</a:t>
+            </a:r>
+            <a:endParaRPr lang="en-US" sz="900" dirty="0"/>
           </a:p>
         </p:txBody>
       </p:sp>
@@ -3553,7 +4826,7 @@
         </p:nvSpPr>
         <p:spPr>
           <a:xfrm>
-            <a:off x="406390" y="1181100"/>
+            <a:off x="406390" y="1155700"/>
             <a:ext cx="11378916" cy="444500"/>
           </a:xfrm>
           <a:prstGeom prst="rect">
@@ -3592,12 +4865,12 @@
         </p:nvSpPr>
         <p:spPr>
           <a:xfrm>
-            <a:off x="406390" y="1828800"/>
-            <a:ext cx="5506578" cy="381000"/>
+            <a:off x="406390" y="1778000"/>
+            <a:ext cx="5506578" cy="2336800"/>
           </a:xfrm>
           <a:prstGeom prst="roundRect">
             <a:avLst>
-              <a:gd name="adj" fmla="val 24000"/>
+              <a:gd name="adj" fmla="val 3913"/>
             </a:avLst>
           </a:prstGeom>
           <a:solidFill>
@@ -3619,7 +4892,7 @@
         </p:nvSpPr>
         <p:spPr>
           <a:xfrm>
-            <a:off x="543550" y="1965960"/>
+            <a:off x="543550" y="1915160"/>
             <a:ext cx="5232258" cy="365760"/>
           </a:xfrm>
           <a:prstGeom prst="rect">
@@ -3658,12 +4931,12 @@
         </p:nvSpPr>
         <p:spPr>
           <a:xfrm>
-            <a:off x="6278728" y="1828800"/>
-            <a:ext cx="5506578" cy="381000"/>
+            <a:off x="6278728" y="1778000"/>
+            <a:ext cx="5506578" cy="2336800"/>
           </a:xfrm>
           <a:prstGeom prst="roundRect">
             <a:avLst>
-              <a:gd name="adj" fmla="val 24000"/>
+              <a:gd name="adj" fmla="val 3913"/>
             </a:avLst>
           </a:prstGeom>
           <a:solidFill>
@@ -3685,7 +4958,7 @@
         </p:nvSpPr>
         <p:spPr>
           <a:xfrm>
-            <a:off x="6415888" y="1965960"/>
+            <a:off x="6415888" y="1915160"/>
             <a:ext cx="5232258" cy="365760"/>
           </a:xfrm>
           <a:prstGeom prst="rect">
@@ -3724,7 +4997,7 @@
         </p:nvSpPr>
         <p:spPr>
           <a:xfrm>
-            <a:off x="5958688" y="1854708"/>
+            <a:off x="5958688" y="2781808"/>
             <a:ext cx="274320" cy="274320"/>
           </a:xfrm>
           <a:prstGeom prst="roundRect">
@@ -3746,7 +5019,7 @@
         </p:nvSpPr>
         <p:spPr>
           <a:xfrm>
-            <a:off x="5958688" y="1854708"/>
+            <a:off x="5958688" y="2781808"/>
             <a:ext cx="274320" cy="274320"/>
           </a:xfrm>
           <a:prstGeom prst="rect">
@@ -3785,7 +5058,427 @@
         </p:nvSpPr>
         <p:spPr>
           <a:xfrm>
-            <a:off x="406390" y="2413000"/>
+            <a:off x="558786" y="2216150"/>
+            <a:ext cx="2286000" cy="285750"/>
+          </a:xfrm>
+          <a:prstGeom prst="roundRect">
+            <a:avLst>
+              <a:gd name="adj" fmla="val 48000"/>
+            </a:avLst>
+          </a:prstGeom>
+          <a:solidFill>
+            <a:srgbClr val="F5F2EB"/>
+          </a:solidFill>
+          <a:ln w="19050">
+            <a:solidFill>
+              <a:srgbClr val="E65100"/>
+            </a:solidFill>
+            <a:prstDash val="solid"/>
+          </a:ln>
+        </p:spPr>
+      </p:sp>
+      <p:sp>
+        <p:nvSpPr>
+          <p:cNvPr id="11" name="Text 9"/>
+          <p:cNvSpPr/>
+          <p:nvPr/>
+        </p:nvSpPr>
+        <p:spPr>
+          <a:xfrm>
+            <a:off x="558786" y="2216150"/>
+            <a:ext cx="2286000" cy="285750"/>
+          </a:xfrm>
+          <a:prstGeom prst="rect">
+            <a:avLst/>
+          </a:prstGeom>
+          <a:noFill/>
+          <a:ln/>
+        </p:spPr>
+        <p:txBody>
+          <a:bodyPr wrap="square" rtlCol="0" anchor="ctr"/>
+          <a:lstStyle/>
+          <a:p>
+            <a:pPr algn="ctr" indent="0" marL="0">
+              <a:buNone/>
+            </a:pPr>
+            <a:r>
+              <a:rPr lang="en-US" sz="1000" b="1" dirty="0">
+                <a:solidFill>
+                  <a:srgbClr val="E65100"/>
+                </a:solidFill>
+                <a:latin typeface="Georgia" pitchFamily="34" charset="0"/>
+                <a:ea typeface="Georgia" pitchFamily="34" charset="-122"/>
+                <a:cs typeface="Georgia" pitchFamily="34" charset="-120"/>
+              </a:rPr>
+              <a:t>LEGACY INFRASTRUCTURE</a:t>
+            </a:r>
+            <a:endParaRPr lang="en-US" sz="1000" dirty="0"/>
+          </a:p>
+        </p:txBody>
+      </p:sp>
+      <p:sp>
+        <p:nvSpPr>
+          <p:cNvPr id="12" name="Text 10"/>
+          <p:cNvSpPr/>
+          <p:nvPr/>
+        </p:nvSpPr>
+        <p:spPr>
+          <a:xfrm>
+            <a:off x="558786" y="2590800"/>
+            <a:ext cx="5295768" cy="457200"/>
+          </a:xfrm>
+          <a:prstGeom prst="rect">
+            <a:avLst/>
+          </a:prstGeom>
+          <a:noFill/>
+          <a:ln/>
+        </p:spPr>
+        <p:txBody>
+          <a:bodyPr wrap="square" lIns="0" tIns="0" rIns="0" bIns="0" rtlCol="0" anchor="t"/>
+          <a:lstStyle/>
+          <a:p>
+            <a:pPr algn="l" indent="0" marL="0">
+              <a:buNone/>
+            </a:pPr>
+            <a:r>
+              <a:rPr lang="en-US" sz="1800" dirty="0">
+                <a:solidFill>
+                  <a:srgbClr val="2C2B29"/>
+                </a:solidFill>
+                <a:latin typeface="Georgia" pitchFamily="34" charset="0"/>
+                <a:ea typeface="Georgia" pitchFamily="34" charset="-122"/>
+                <a:cs typeface="Georgia" pitchFamily="34" charset="-120"/>
+              </a:rPr>
+              <a:t>Linear memory scaling with quadratic communication overhead during multi-node synchronization.</a:t>
+            </a:r>
+            <a:endParaRPr lang="en-US" sz="1800" dirty="0"/>
+          </a:p>
+        </p:txBody>
+      </p:sp>
+      <p:sp>
+        <p:nvSpPr>
+          <p:cNvPr id="13" name="Shape 11"/>
+          <p:cNvSpPr/>
+          <p:nvPr/>
+        </p:nvSpPr>
+        <p:spPr>
+          <a:xfrm>
+            <a:off x="558786" y="3136900"/>
+            <a:ext cx="5295768" cy="825500"/>
+          </a:xfrm>
+          <a:prstGeom prst="roundRect">
+            <a:avLst>
+              <a:gd name="adj" fmla="val 8862"/>
+            </a:avLst>
+          </a:prstGeom>
+          <a:solidFill>
+            <a:srgbClr val="F5F2EB"/>
+          </a:solidFill>
+          <a:ln w="19050">
+            <a:solidFill>
+              <a:srgbClr val="E65100"/>
+            </a:solidFill>
+            <a:prstDash val="solid"/>
+          </a:ln>
+        </p:spPr>
+      </p:sp>
+      <p:sp>
+        <p:nvSpPr>
+          <p:cNvPr id="14" name="Text 12"/>
+          <p:cNvSpPr/>
+          <p:nvPr/>
+        </p:nvSpPr>
+        <p:spPr>
+          <a:xfrm>
+            <a:off x="650226" y="3228340"/>
+            <a:ext cx="5112888" cy="201168"/>
+          </a:xfrm>
+          <a:prstGeom prst="rect">
+            <a:avLst/>
+          </a:prstGeom>
+          <a:noFill/>
+          <a:ln/>
+        </p:spPr>
+        <p:txBody>
+          <a:bodyPr wrap="square" rtlCol="0" anchor="ctr"/>
+          <a:lstStyle/>
+          <a:p>
+            <a:pPr algn="ctr" indent="0" marL="0">
+              <a:buNone/>
+            </a:pPr>
+            <a:r>
+              <a:rPr lang="en-US" sz="1000" b="1" dirty="0">
+                <a:solidFill>
+                  <a:srgbClr val="6B6862"/>
+                </a:solidFill>
+                <a:latin typeface="Georgia" pitchFamily="34" charset="0"/>
+                <a:ea typeface="Georgia" pitchFamily="34" charset="-122"/>
+                <a:cs typeface="Georgia" pitchFamily="34" charset="-120"/>
+              </a:rPr>
+              <a:t>AVG CONVERGENCE TIME</a:t>
+            </a:r>
+            <a:endParaRPr lang="en-US" sz="1000" dirty="0"/>
+          </a:p>
+        </p:txBody>
+      </p:sp>
+      <p:sp>
+        <p:nvSpPr>
+          <p:cNvPr id="15" name="Text 13"/>
+          <p:cNvSpPr/>
+          <p:nvPr/>
+        </p:nvSpPr>
+        <p:spPr>
+          <a:xfrm>
+            <a:off x="650226" y="3447796"/>
+            <a:ext cx="5112888" cy="402336"/>
+          </a:xfrm>
+          <a:prstGeom prst="rect">
+            <a:avLst/>
+          </a:prstGeom>
+          <a:noFill/>
+          <a:ln/>
+        </p:spPr>
+        <p:txBody>
+          <a:bodyPr wrap="square" rtlCol="0" anchor="ctr"/>
+          <a:lstStyle/>
+          <a:p>
+            <a:pPr algn="ctr" indent="0" marL="0">
+              <a:buNone/>
+            </a:pPr>
+            <a:r>
+              <a:rPr lang="en-US" sz="2600" b="1" dirty="0">
+                <a:solidFill>
+                  <a:srgbClr val="E65100"/>
+                </a:solidFill>
+                <a:latin typeface="Georgia" pitchFamily="34" charset="0"/>
+                <a:ea typeface="Georgia" pitchFamily="34" charset="-122"/>
+                <a:cs typeface="Georgia" pitchFamily="34" charset="-120"/>
+              </a:rPr>
+              <a:t>68ms</a:t>
+            </a:r>
+            <a:endParaRPr lang="en-US" sz="2600" dirty="0"/>
+          </a:p>
+        </p:txBody>
+      </p:sp>
+      <p:sp>
+        <p:nvSpPr>
+          <p:cNvPr id="16" name="Shape 14"/>
+          <p:cNvSpPr/>
+          <p:nvPr/>
+        </p:nvSpPr>
+        <p:spPr>
+          <a:xfrm>
+            <a:off x="6337142" y="2216150"/>
+            <a:ext cx="2286000" cy="285750"/>
+          </a:xfrm>
+          <a:prstGeom prst="roundRect">
+            <a:avLst>
+              <a:gd name="adj" fmla="val 48000"/>
+            </a:avLst>
+          </a:prstGeom>
+          <a:solidFill>
+            <a:srgbClr val="F5F2EB"/>
+          </a:solidFill>
+          <a:ln w="19050">
+            <a:solidFill>
+              <a:srgbClr val="2E7D32"/>
+            </a:solidFill>
+            <a:prstDash val="solid"/>
+          </a:ln>
+        </p:spPr>
+      </p:sp>
+      <p:sp>
+        <p:nvSpPr>
+          <p:cNvPr id="17" name="Text 15"/>
+          <p:cNvSpPr/>
+          <p:nvPr/>
+        </p:nvSpPr>
+        <p:spPr>
+          <a:xfrm>
+            <a:off x="6337142" y="2216150"/>
+            <a:ext cx="2286000" cy="285750"/>
+          </a:xfrm>
+          <a:prstGeom prst="rect">
+            <a:avLst/>
+          </a:prstGeom>
+          <a:noFill/>
+          <a:ln/>
+        </p:spPr>
+        <p:txBody>
+          <a:bodyPr wrap="square" rtlCol="0" anchor="ctr"/>
+          <a:lstStyle/>
+          <a:p>
+            <a:pPr algn="ctr" indent="0" marL="0">
+              <a:buNone/>
+            </a:pPr>
+            <a:r>
+              <a:rPr lang="en-US" sz="1000" b="1" dirty="0">
+                <a:solidFill>
+                  <a:srgbClr val="2E7D32"/>
+                </a:solidFill>
+                <a:latin typeface="Georgia" pitchFamily="34" charset="0"/>
+                <a:ea typeface="Georgia" pitchFamily="34" charset="-122"/>
+                <a:cs typeface="Georgia" pitchFamily="34" charset="-120"/>
+              </a:rPr>
+              <a:t>DISTRIBUTED TENSOR CORE</a:t>
+            </a:r>
+            <a:endParaRPr lang="en-US" sz="1000" dirty="0"/>
+          </a:p>
+        </p:txBody>
+      </p:sp>
+      <p:sp>
+        <p:nvSpPr>
+          <p:cNvPr id="18" name="Text 16"/>
+          <p:cNvSpPr/>
+          <p:nvPr/>
+        </p:nvSpPr>
+        <p:spPr>
+          <a:xfrm>
+            <a:off x="6337142" y="2590800"/>
+            <a:ext cx="5295768" cy="457200"/>
+          </a:xfrm>
+          <a:prstGeom prst="rect">
+            <a:avLst/>
+          </a:prstGeom>
+          <a:noFill/>
+          <a:ln/>
+        </p:spPr>
+        <p:txBody>
+          <a:bodyPr wrap="square" lIns="0" tIns="0" rIns="0" bIns="0" rtlCol="0" anchor="t"/>
+          <a:lstStyle/>
+          <a:p>
+            <a:pPr algn="l" indent="0" marL="0">
+              <a:buNone/>
+            </a:pPr>
+            <a:r>
+              <a:rPr lang="en-US" sz="1800" dirty="0">
+                <a:solidFill>
+                  <a:srgbClr val="2C2B29"/>
+                </a:solidFill>
+                <a:latin typeface="Georgia" pitchFamily="34" charset="0"/>
+                <a:ea typeface="Georgia" pitchFamily="34" charset="-122"/>
+                <a:cs typeface="Georgia" pitchFamily="34" charset="-120"/>
+              </a:rPr>
+              <a:t>Logarithmic latency scaling leveraging quantum sparse tensor compression.</a:t>
+            </a:r>
+            <a:endParaRPr lang="en-US" sz="1800" dirty="0"/>
+          </a:p>
+        </p:txBody>
+      </p:sp>
+      <p:sp>
+        <p:nvSpPr>
+          <p:cNvPr id="19" name="Shape 17"/>
+          <p:cNvSpPr/>
+          <p:nvPr/>
+        </p:nvSpPr>
+        <p:spPr>
+          <a:xfrm>
+            <a:off x="6337142" y="3136900"/>
+            <a:ext cx="5295768" cy="825500"/>
+          </a:xfrm>
+          <a:prstGeom prst="roundRect">
+            <a:avLst>
+              <a:gd name="adj" fmla="val 8862"/>
+            </a:avLst>
+          </a:prstGeom>
+          <a:solidFill>
+            <a:srgbClr val="F5F2EB"/>
+          </a:solidFill>
+          <a:ln w="19050">
+            <a:solidFill>
+              <a:srgbClr val="2E7D32"/>
+            </a:solidFill>
+            <a:prstDash val="solid"/>
+          </a:ln>
+        </p:spPr>
+      </p:sp>
+      <p:sp>
+        <p:nvSpPr>
+          <p:cNvPr id="20" name="Text 18"/>
+          <p:cNvSpPr/>
+          <p:nvPr/>
+        </p:nvSpPr>
+        <p:spPr>
+          <a:xfrm>
+            <a:off x="6428582" y="3228340"/>
+            <a:ext cx="5112888" cy="201168"/>
+          </a:xfrm>
+          <a:prstGeom prst="rect">
+            <a:avLst/>
+          </a:prstGeom>
+          <a:noFill/>
+          <a:ln/>
+        </p:spPr>
+        <p:txBody>
+          <a:bodyPr wrap="square" rtlCol="0" anchor="ctr"/>
+          <a:lstStyle/>
+          <a:p>
+            <a:pPr algn="ctr" indent="0" marL="0">
+              <a:buNone/>
+            </a:pPr>
+            <a:r>
+              <a:rPr lang="en-US" sz="1000" b="1" dirty="0">
+                <a:solidFill>
+                  <a:srgbClr val="6B6862"/>
+                </a:solidFill>
+                <a:latin typeface="Georgia" pitchFamily="34" charset="0"/>
+                <a:ea typeface="Georgia" pitchFamily="34" charset="-122"/>
+                <a:cs typeface="Georgia" pitchFamily="34" charset="-120"/>
+              </a:rPr>
+              <a:t>AVG CONVERGENCE TIME</a:t>
+            </a:r>
+            <a:endParaRPr lang="en-US" sz="1000" dirty="0"/>
+          </a:p>
+        </p:txBody>
+      </p:sp>
+      <p:sp>
+        <p:nvSpPr>
+          <p:cNvPr id="21" name="Text 19"/>
+          <p:cNvSpPr/>
+          <p:nvPr/>
+        </p:nvSpPr>
+        <p:spPr>
+          <a:xfrm>
+            <a:off x="6428582" y="3447796"/>
+            <a:ext cx="5112888" cy="402336"/>
+          </a:xfrm>
+          <a:prstGeom prst="rect">
+            <a:avLst/>
+          </a:prstGeom>
+          <a:noFill/>
+          <a:ln/>
+        </p:spPr>
+        <p:txBody>
+          <a:bodyPr wrap="square" rtlCol="0" anchor="ctr"/>
+          <a:lstStyle/>
+          <a:p>
+            <a:pPr algn="ctr" indent="0" marL="0">
+              <a:buNone/>
+            </a:pPr>
+            <a:r>
+              <a:rPr lang="en-US" sz="2600" b="1" dirty="0">
+                <a:solidFill>
+                  <a:srgbClr val="2E7D32"/>
+                </a:solidFill>
+                <a:latin typeface="Georgia" pitchFamily="34" charset="0"/>
+                <a:ea typeface="Georgia" pitchFamily="34" charset="-122"/>
+                <a:cs typeface="Georgia" pitchFamily="34" charset="-120"/>
+              </a:rPr>
+              <a:t>4.1ms</a:t>
+            </a:r>
+            <a:endParaRPr lang="en-US" sz="2600" dirty="0"/>
+          </a:p>
+        </p:txBody>
+      </p:sp>
+      <p:sp>
+        <p:nvSpPr>
+          <p:cNvPr id="22" name="Shape 20"/>
+          <p:cNvSpPr/>
+          <p:nvPr/>
+        </p:nvSpPr>
+        <p:spPr>
+          <a:xfrm>
+            <a:off x="406390" y="4292600"/>
             <a:ext cx="11378916" cy="571500"/>
           </a:xfrm>
           <a:prstGeom prst="roundRect">
@@ -3806,13 +5499,13 @@
       </p:sp>
       <p:sp>
         <p:nvSpPr>
-          <p:cNvPr id="11" name="Shape 9"/>
-          <p:cNvSpPr/>
-          <p:nvPr/>
-        </p:nvSpPr>
-        <p:spPr>
-          <a:xfrm>
-            <a:off x="406390" y="2413000"/>
+          <p:cNvPr id="23" name="Shape 21"/>
+          <p:cNvSpPr/>
+          <p:nvPr/>
+        </p:nvSpPr>
+        <p:spPr>
+          <a:xfrm>
+            <a:off x="406390" y="4292600"/>
             <a:ext cx="54864" cy="571500"/>
           </a:xfrm>
           <a:prstGeom prst="rect">
@@ -3831,13 +5524,13 @@
       </p:sp>
       <p:sp>
         <p:nvSpPr>
-          <p:cNvPr id="12" name="Text 10"/>
-          <p:cNvSpPr/>
-          <p:nvPr/>
-        </p:nvSpPr>
-        <p:spPr>
-          <a:xfrm>
-            <a:off x="543550" y="2413000"/>
+          <p:cNvPr id="24" name="Text 22"/>
+          <p:cNvSpPr/>
+          <p:nvPr/>
+        </p:nvSpPr>
+        <p:spPr>
+          <a:xfrm>
+            <a:off x="543550" y="4292600"/>
             <a:ext cx="11104596" cy="571500"/>
           </a:xfrm>
           <a:prstGeom prst="rect">
@@ -3865,6 +5558,45 @@
               <a:t>\mathcal{L}(\theta) = \mathbb{E}_{x \sim \mathcal{D}} \left[ \| f_\theta(x) - y \|_2^2 \right] + \lambda \sum_{i=1}^N \Omega(W_i)</a:t>
             </a:r>
             <a:endParaRPr lang="en-US" sz="2000" dirty="0"/>
+          </a:p>
+        </p:txBody>
+      </p:sp>
+      <p:sp>
+        <p:nvSpPr>
+          <p:cNvPr id="25" name="Text 23"/>
+          <p:cNvSpPr/>
+          <p:nvPr/>
+        </p:nvSpPr>
+        <p:spPr>
+          <a:xfrm>
+            <a:off x="457200" y="6492240"/>
+            <a:ext cx="11277295" cy="228600"/>
+          </a:xfrm>
+          <a:prstGeom prst="rect">
+            <a:avLst/>
+          </a:prstGeom>
+          <a:noFill/>
+          <a:ln/>
+        </p:spPr>
+        <p:txBody>
+          <a:bodyPr wrap="square" rtlCol="0" anchor="ctr"/>
+          <a:lstStyle/>
+          <a:p>
+            <a:pPr indent="0" marL="0">
+              <a:buNone/>
+            </a:pPr>
+            <a:r>
+              <a:rPr lang="en-US" sz="900" b="1" dirty="0">
+                <a:solidFill>
+                  <a:srgbClr val="6B6862"/>
+                </a:solidFill>
+                <a:latin typeface="Georgia" pitchFamily="34" charset="0"/>
+                <a:ea typeface="Georgia" pitchFamily="34" charset="-122"/>
+                <a:cs typeface="Georgia" pitchFamily="34" charset="-120"/>
+              </a:rPr>
+              <a:t>YUMIA V0.1.26 • CONFIDENTIAL</a:t>
+            </a:r>
+            <a:endParaRPr lang="en-US" sz="900" dirty="0"/>
           </a:p>
         </p:txBody>
       </p:sp>
@@ -3947,7 +5679,7 @@
         </p:nvSpPr>
         <p:spPr>
           <a:xfrm>
-            <a:off x="406390" y="1181100"/>
+            <a:off x="406390" y="1155700"/>
             <a:ext cx="11378916" cy="444500"/>
           </a:xfrm>
           <a:prstGeom prst="rect">
@@ -3975,6 +5707,77 @@
               <a:t>Resource Allocation &amp; Workload Distribution</a:t>
             </a:r>
             <a:endParaRPr lang="en-US" sz="3400" dirty="0"/>
+          </a:p>
+        </p:txBody>
+      </p:sp>
+      <p:graphicFrame>
+        <p:nvGraphicFramePr>
+          <p:cNvPr id="4" name="Chart 0" descr=""/>
+          <p:cNvGraphicFramePr/>
+          <p:nvPr/>
+        </p:nvGraphicFramePr>
+        <p:xfrm>
+          <a:off x="406390" y="1778000"/>
+          <a:ext cx="5600560" cy="1778000"/>
+        </p:xfrm>
+        <a:graphic xmlns:a="http://schemas.openxmlformats.org/drawingml/2006/main">
+          <a:graphicData uri="http://schemas.openxmlformats.org/drawingml/2006/chart">
+            <c:chart xmlns:c="http://schemas.openxmlformats.org/drawingml/2006/chart" r:id="rId1"/>
+          </a:graphicData>
+        </a:graphic>
+      </p:graphicFrame>
+      <p:graphicFrame>
+        <p:nvGraphicFramePr>
+          <p:cNvPr id="5" name="Chart 1" descr=""/>
+          <p:cNvGraphicFramePr/>
+          <p:nvPr/>
+        </p:nvGraphicFramePr>
+        <p:xfrm>
+          <a:off x="6184745" y="1778000"/>
+          <a:ext cx="5600560" cy="1778000"/>
+        </p:xfrm>
+        <a:graphic xmlns:a="http://schemas.openxmlformats.org/drawingml/2006/main">
+          <a:graphicData uri="http://schemas.openxmlformats.org/drawingml/2006/chart">
+            <c:chart xmlns:c="http://schemas.openxmlformats.org/drawingml/2006/chart" r:id="rId2"/>
+          </a:graphicData>
+        </a:graphic>
+      </p:graphicFrame>
+      <p:sp>
+        <p:nvSpPr>
+          <p:cNvPr id="6" name="Text 2"/>
+          <p:cNvSpPr/>
+          <p:nvPr/>
+        </p:nvSpPr>
+        <p:spPr>
+          <a:xfrm>
+            <a:off x="457200" y="6492240"/>
+            <a:ext cx="11277295" cy="228600"/>
+          </a:xfrm>
+          <a:prstGeom prst="rect">
+            <a:avLst/>
+          </a:prstGeom>
+          <a:noFill/>
+          <a:ln/>
+        </p:spPr>
+        <p:txBody>
+          <a:bodyPr wrap="square" rtlCol="0" anchor="ctr"/>
+          <a:lstStyle/>
+          <a:p>
+            <a:pPr indent="0" marL="0">
+              <a:buNone/>
+            </a:pPr>
+            <a:r>
+              <a:rPr lang="en-US" sz="900" b="1" dirty="0">
+                <a:solidFill>
+                  <a:srgbClr val="6B6862"/>
+                </a:solidFill>
+                <a:latin typeface="Georgia" pitchFamily="34" charset="0"/>
+                <a:ea typeface="Georgia" pitchFamily="34" charset="-122"/>
+                <a:cs typeface="Georgia" pitchFamily="34" charset="-120"/>
+              </a:rPr>
+              <a:t>YUMIA V0.1.26 • CONFIDENTIAL</a:t>
+            </a:r>
+            <a:endParaRPr lang="en-US" sz="900" dirty="0"/>
           </a:p>
         </p:txBody>
       </p:sp>
@@ -4057,7 +5860,7 @@
         </p:nvSpPr>
         <p:spPr>
           <a:xfrm>
-            <a:off x="406390" y="1181100"/>
+            <a:off x="406390" y="1155700"/>
             <a:ext cx="11378916" cy="444500"/>
           </a:xfrm>
           <a:prstGeom prst="rect">
@@ -4096,8 +5899,8 @@
         </p:nvSpPr>
         <p:spPr>
           <a:xfrm>
-            <a:off x="406390" y="1828800"/>
-            <a:ext cx="6705432" cy="838200"/>
+            <a:off x="406390" y="1778000"/>
+            <a:ext cx="6720672" cy="838200"/>
           </a:xfrm>
           <a:prstGeom prst="roundRect">
             <a:avLst>
@@ -4123,8 +5926,8 @@
         </p:nvSpPr>
         <p:spPr>
           <a:xfrm>
-            <a:off x="589270" y="1965960"/>
-            <a:ext cx="6339672" cy="563880"/>
+            <a:off x="589270" y="1915160"/>
+            <a:ext cx="6354912" cy="563880"/>
           </a:xfrm>
           <a:prstGeom prst="rect">
             <a:avLst/>
@@ -4196,12 +5999,12 @@
         </p:nvSpPr>
         <p:spPr>
           <a:xfrm>
-            <a:off x="7315017" y="1828800"/>
-            <a:ext cx="4470288" cy="381000"/>
+            <a:off x="7304857" y="1778000"/>
+            <a:ext cx="4480448" cy="831850"/>
           </a:xfrm>
           <a:prstGeom prst="roundRect">
             <a:avLst>
-              <a:gd name="adj" fmla="val 19200"/>
+              <a:gd name="adj" fmla="val 8794"/>
             </a:avLst>
           </a:prstGeom>
           <a:solidFill>
@@ -4223,8 +6026,8 @@
         </p:nvSpPr>
         <p:spPr>
           <a:xfrm>
-            <a:off x="7452177" y="1901952"/>
-            <a:ext cx="4195968" cy="274320"/>
+            <a:off x="7442017" y="1851152"/>
+            <a:ext cx="4206128" cy="274320"/>
           </a:xfrm>
           <a:prstGeom prst="rect">
             <a:avLst/>
@@ -4262,8 +6065,8 @@
         </p:nvSpPr>
         <p:spPr>
           <a:xfrm>
-            <a:off x="7452177" y="2221992"/>
-            <a:ext cx="4195968" cy="-85344"/>
+            <a:off x="7442017" y="2171192"/>
+            <a:ext cx="4206128" cy="365506"/>
           </a:xfrm>
           <a:prstGeom prst="rect">
             <a:avLst/>
@@ -4301,12 +6104,12 @@
         </p:nvSpPr>
         <p:spPr>
           <a:xfrm>
-            <a:off x="7315017" y="2413000"/>
-            <a:ext cx="2011680" cy="347472"/>
+            <a:off x="7304857" y="2787650"/>
+            <a:ext cx="2011680" cy="285750"/>
           </a:xfrm>
           <a:prstGeom prst="roundRect">
             <a:avLst>
-              <a:gd name="adj" fmla="val 39474"/>
+              <a:gd name="adj" fmla="val 48000"/>
             </a:avLst>
           </a:prstGeom>
           <a:solidFill>
@@ -4328,8 +6131,8 @@
         </p:nvSpPr>
         <p:spPr>
           <a:xfrm>
-            <a:off x="7315017" y="2413000"/>
-            <a:ext cx="2011680" cy="347472"/>
+            <a:off x="7304857" y="2787650"/>
+            <a:ext cx="2011680" cy="285750"/>
           </a:xfrm>
           <a:prstGeom prst="rect">
             <a:avLst/>
@@ -4367,12 +6170,12 @@
         </p:nvSpPr>
         <p:spPr>
           <a:xfrm>
-            <a:off x="7315017" y="2997200"/>
-            <a:ext cx="2231136" cy="347472"/>
+            <a:off x="7304857" y="3251200"/>
+            <a:ext cx="2231136" cy="285750"/>
           </a:xfrm>
           <a:prstGeom prst="roundRect">
             <a:avLst>
-              <a:gd name="adj" fmla="val 39474"/>
+              <a:gd name="adj" fmla="val 48000"/>
             </a:avLst>
           </a:prstGeom>
           <a:solidFill>
@@ -4394,8 +6197,8 @@
         </p:nvSpPr>
         <p:spPr>
           <a:xfrm>
-            <a:off x="7315017" y="2997200"/>
-            <a:ext cx="2231136" cy="347472"/>
+            <a:off x="7304857" y="3251200"/>
+            <a:ext cx="2231136" cy="285750"/>
           </a:xfrm>
           <a:prstGeom prst="rect">
             <a:avLst/>
@@ -4422,6 +6225,45 @@
               <a:t>WCAG AAA VERIFIED</a:t>
             </a:r>
             <a:endParaRPr lang="en-US" sz="1000" dirty="0"/>
+          </a:p>
+        </p:txBody>
+      </p:sp>
+      <p:sp>
+        <p:nvSpPr>
+          <p:cNvPr id="13" name="Text 11"/>
+          <p:cNvSpPr/>
+          <p:nvPr/>
+        </p:nvSpPr>
+        <p:spPr>
+          <a:xfrm>
+            <a:off x="457200" y="6492240"/>
+            <a:ext cx="11277295" cy="228600"/>
+          </a:xfrm>
+          <a:prstGeom prst="rect">
+            <a:avLst/>
+          </a:prstGeom>
+          <a:noFill/>
+          <a:ln/>
+        </p:spPr>
+        <p:txBody>
+          <a:bodyPr wrap="square" rtlCol="0" anchor="ctr"/>
+          <a:lstStyle/>
+          <a:p>
+            <a:pPr indent="0" marL="0">
+              <a:buNone/>
+            </a:pPr>
+            <a:r>
+              <a:rPr lang="en-US" sz="900" b="1" dirty="0">
+                <a:solidFill>
+                  <a:srgbClr val="6B6862"/>
+                </a:solidFill>
+                <a:latin typeface="Georgia" pitchFamily="34" charset="0"/>
+                <a:ea typeface="Georgia" pitchFamily="34" charset="-122"/>
+                <a:cs typeface="Georgia" pitchFamily="34" charset="-120"/>
+              </a:rPr>
+              <a:t>YUMIA V0.1.26 • CONFIDENTIAL</a:t>
+            </a:r>
+            <a:endParaRPr lang="en-US" sz="900" dirty="0"/>
           </a:p>
         </p:txBody>
       </p:sp>

</xml_diff>

<commit_message>
feat(pptx,pdf): luxury visual upgrade for PPTX and PDF with mac terminal code headers, pill edge labels, and refined geometry
</commit_message>
<xml_diff>
--- a/presentation.pptx
+++ b/presentation.pptx
@@ -3521,14 +3521,41 @@
       </p:sp>
       <p:sp>
         <p:nvSpPr>
-          <p:cNvPr id="6" name="Text 4"/>
-          <p:cNvSpPr/>
-          <p:nvPr/>
-        </p:nvSpPr>
-        <p:spPr>
-          <a:xfrm>
-            <a:off x="4489752" y="2656840"/>
-            <a:ext cx="731520" cy="274320"/>
+          <p:cNvPr id="6" name="Shape 4"/>
+          <p:cNvSpPr/>
+          <p:nvPr/>
+        </p:nvSpPr>
+        <p:spPr>
+          <a:xfrm>
+            <a:off x="4485180" y="2675128"/>
+            <a:ext cx="740664" cy="237744"/>
+          </a:xfrm>
+          <a:prstGeom prst="roundRect">
+            <a:avLst>
+              <a:gd name="adj" fmla="val 23077"/>
+            </a:avLst>
+          </a:prstGeom>
+          <a:solidFill>
+            <a:srgbClr val="F5F2EB"/>
+          </a:solidFill>
+          <a:ln w="12700">
+            <a:solidFill>
+              <a:srgbClr val="E0DACD"/>
+            </a:solidFill>
+            <a:prstDash val="solid"/>
+          </a:ln>
+        </p:spPr>
+      </p:sp>
+      <p:sp>
+        <p:nvSpPr>
+          <p:cNvPr id="7" name="Text 5"/>
+          <p:cNvSpPr/>
+          <p:nvPr/>
+        </p:nvSpPr>
+        <p:spPr>
+          <a:xfrm>
+            <a:off x="4485180" y="2675128"/>
+            <a:ext cx="740664" cy="237744"/>
           </a:xfrm>
           <a:prstGeom prst="rect">
             <a:avLst/>
@@ -3544,10 +3571,13 @@
               <a:buNone/>
             </a:pPr>
             <a:r>
-              <a:rPr lang="en-US" sz="900" dirty="0">
+              <a:rPr lang="en-US" sz="900" b="1" dirty="0">
                 <a:solidFill>
                   <a:srgbClr val="6B6862"/>
                 </a:solidFill>
+                <a:latin typeface="Georgia" pitchFamily="34" charset="0"/>
+                <a:ea typeface="Georgia" pitchFamily="34" charset="-122"/>
+                <a:cs typeface="Georgia" pitchFamily="34" charset="-120"/>
               </a:rPr>
               <a:t>TLS 1.3</a:t>
             </a:r>
@@ -3557,7 +3587,7 @@
       </p:sp>
       <p:sp>
         <p:nvSpPr>
-          <p:cNvPr id="7" name="Shape 5"/>
+          <p:cNvPr id="8" name="Shape 6"/>
           <p:cNvSpPr/>
           <p:nvPr/>
         </p:nvSpPr>
@@ -3581,14 +3611,41 @@
       </p:sp>
       <p:sp>
         <p:nvSpPr>
-          <p:cNvPr id="8" name="Text 6"/>
-          <p:cNvSpPr/>
-          <p:nvPr/>
-        </p:nvSpPr>
-        <p:spPr>
-          <a:xfrm>
-            <a:off x="6970423" y="2656840"/>
-            <a:ext cx="731520" cy="274320"/>
+          <p:cNvPr id="9" name="Shape 7"/>
+          <p:cNvSpPr/>
+          <p:nvPr/>
+        </p:nvSpPr>
+        <p:spPr>
+          <a:xfrm>
+            <a:off x="6709819" y="2675128"/>
+            <a:ext cx="1252728" cy="237744"/>
+          </a:xfrm>
+          <a:prstGeom prst="roundRect">
+            <a:avLst>
+              <a:gd name="adj" fmla="val 23077"/>
+            </a:avLst>
+          </a:prstGeom>
+          <a:solidFill>
+            <a:srgbClr val="F5F2EB"/>
+          </a:solidFill>
+          <a:ln w="12700">
+            <a:solidFill>
+              <a:srgbClr val="E0DACD"/>
+            </a:solidFill>
+            <a:prstDash val="solid"/>
+          </a:ln>
+        </p:spPr>
+      </p:sp>
+      <p:sp>
+        <p:nvSpPr>
+          <p:cNvPr id="10" name="Text 8"/>
+          <p:cNvSpPr/>
+          <p:nvPr/>
+        </p:nvSpPr>
+        <p:spPr>
+          <a:xfrm>
+            <a:off x="6709819" y="2675128"/>
+            <a:ext cx="1252728" cy="237744"/>
           </a:xfrm>
           <a:prstGeom prst="rect">
             <a:avLst/>
@@ -3604,10 +3661,13 @@
               <a:buNone/>
             </a:pPr>
             <a:r>
-              <a:rPr lang="en-US" sz="900" dirty="0">
+              <a:rPr lang="en-US" sz="900" b="1" dirty="0">
                 <a:solidFill>
                   <a:srgbClr val="6B6862"/>
                 </a:solidFill>
+                <a:latin typeface="Georgia" pitchFamily="34" charset="0"/>
+                <a:ea typeface="Georgia" pitchFamily="34" charset="-122"/>
+                <a:cs typeface="Georgia" pitchFamily="34" charset="-120"/>
               </a:rPr>
               <a:t>gRPC Streaming</a:t>
             </a:r>
@@ -3617,7 +3677,7 @@
       </p:sp>
       <p:sp>
         <p:nvSpPr>
-          <p:cNvPr id="9" name="Shape 7"/>
+          <p:cNvPr id="11" name="Shape 9"/>
           <p:cNvSpPr/>
           <p:nvPr/>
         </p:nvSpPr>
@@ -3641,7 +3701,7 @@
       </p:sp>
       <p:sp>
         <p:nvSpPr>
-          <p:cNvPr id="10" name="Shape 8"/>
+          <p:cNvPr id="12" name="Shape 10"/>
           <p:cNvSpPr/>
           <p:nvPr/>
         </p:nvSpPr>
@@ -3665,14 +3725,41 @@
       </p:sp>
       <p:sp>
         <p:nvSpPr>
-          <p:cNvPr id="11" name="Text 9"/>
-          <p:cNvSpPr/>
-          <p:nvPr/>
-        </p:nvSpPr>
-        <p:spPr>
-          <a:xfrm>
-            <a:off x="9451095" y="3016250"/>
-            <a:ext cx="731520" cy="274320"/>
+          <p:cNvPr id="13" name="Shape 11"/>
+          <p:cNvSpPr/>
+          <p:nvPr/>
+        </p:nvSpPr>
+        <p:spPr>
+          <a:xfrm>
+            <a:off x="9373371" y="3034538"/>
+            <a:ext cx="886968" cy="237744"/>
+          </a:xfrm>
+          <a:prstGeom prst="roundRect">
+            <a:avLst>
+              <a:gd name="adj" fmla="val 23077"/>
+            </a:avLst>
+          </a:prstGeom>
+          <a:solidFill>
+            <a:srgbClr val="F5F2EB"/>
+          </a:solidFill>
+          <a:ln w="12700">
+            <a:solidFill>
+              <a:srgbClr val="E0DACD"/>
+            </a:solidFill>
+            <a:prstDash val="solid"/>
+          </a:ln>
+        </p:spPr>
+      </p:sp>
+      <p:sp>
+        <p:nvSpPr>
+          <p:cNvPr id="14" name="Text 12"/>
+          <p:cNvSpPr/>
+          <p:nvPr/>
+        </p:nvSpPr>
+        <p:spPr>
+          <a:xfrm>
+            <a:off x="9373371" y="3034538"/>
+            <a:ext cx="886968" cy="237744"/>
           </a:xfrm>
           <a:prstGeom prst="rect">
             <a:avLst/>
@@ -3688,10 +3775,13 @@
               <a:buNone/>
             </a:pPr>
             <a:r>
-              <a:rPr lang="en-US" sz="900" dirty="0">
+              <a:rPr lang="en-US" sz="900" b="1" dirty="0">
                 <a:solidFill>
                   <a:srgbClr val="6B6862"/>
                 </a:solidFill>
+                <a:latin typeface="Georgia" pitchFamily="34" charset="0"/>
+                <a:ea typeface="Georgia" pitchFamily="34" charset="-122"/>
+                <a:cs typeface="Georgia" pitchFamily="34" charset="-120"/>
               </a:rPr>
               <a:t>Hot Cache</a:t>
             </a:r>
@@ -3701,7 +3791,7 @@
       </p:sp>
       <p:sp>
         <p:nvSpPr>
-          <p:cNvPr id="12" name="Shape 10"/>
+          <p:cNvPr id="15" name="Shape 13"/>
           <p:cNvSpPr/>
           <p:nvPr/>
         </p:nvSpPr>
@@ -3728,14 +3818,14 @@
       </p:sp>
       <p:sp>
         <p:nvSpPr>
-          <p:cNvPr id="13" name="Text 11"/>
-          <p:cNvSpPr/>
-          <p:nvPr/>
-        </p:nvSpPr>
-        <p:spPr>
-          <a:xfrm>
-            <a:off x="452110" y="2542540"/>
-            <a:ext cx="1364789" cy="502920"/>
+          <p:cNvPr id="16" name="Text 14"/>
+          <p:cNvSpPr/>
+          <p:nvPr/>
+        </p:nvSpPr>
+        <p:spPr>
+          <a:xfrm>
+            <a:off x="461254" y="2551684"/>
+            <a:ext cx="1346501" cy="484632"/>
           </a:xfrm>
           <a:prstGeom prst="rect">
             <a:avLst/>
@@ -3767,7 +3857,7 @@
       </p:sp>
       <p:sp>
         <p:nvSpPr>
-          <p:cNvPr id="14" name="Shape 12"/>
+          <p:cNvPr id="17" name="Shape 15"/>
           <p:cNvSpPr/>
           <p:nvPr/>
         </p:nvSpPr>
@@ -3794,14 +3884,14 @@
       </p:sp>
       <p:sp>
         <p:nvSpPr>
-          <p:cNvPr id="15" name="Text 13"/>
-          <p:cNvSpPr/>
-          <p:nvPr/>
-        </p:nvSpPr>
-        <p:spPr>
-          <a:xfrm>
-            <a:off x="2932782" y="2542540"/>
-            <a:ext cx="1364789" cy="502920"/>
+          <p:cNvPr id="18" name="Text 16"/>
+          <p:cNvSpPr/>
+          <p:nvPr/>
+        </p:nvSpPr>
+        <p:spPr>
+          <a:xfrm>
+            <a:off x="2941926" y="2551684"/>
+            <a:ext cx="1346501" cy="484632"/>
           </a:xfrm>
           <a:prstGeom prst="rect">
             <a:avLst/>
@@ -3833,7 +3923,7 @@
       </p:sp>
       <p:sp>
         <p:nvSpPr>
-          <p:cNvPr id="16" name="Shape 14"/>
+          <p:cNvPr id="19" name="Shape 17"/>
           <p:cNvSpPr/>
           <p:nvPr/>
         </p:nvSpPr>
@@ -3860,14 +3950,14 @@
       </p:sp>
       <p:sp>
         <p:nvSpPr>
-          <p:cNvPr id="17" name="Text 15"/>
-          <p:cNvSpPr/>
-          <p:nvPr/>
-        </p:nvSpPr>
-        <p:spPr>
-          <a:xfrm>
-            <a:off x="5413453" y="2542540"/>
-            <a:ext cx="1364789" cy="502920"/>
+          <p:cNvPr id="20" name="Text 18"/>
+          <p:cNvSpPr/>
+          <p:nvPr/>
+        </p:nvSpPr>
+        <p:spPr>
+          <a:xfrm>
+            <a:off x="5422597" y="2551684"/>
+            <a:ext cx="1346501" cy="484632"/>
           </a:xfrm>
           <a:prstGeom prst="rect">
             <a:avLst/>
@@ -3899,7 +3989,7 @@
       </p:sp>
       <p:sp>
         <p:nvSpPr>
-          <p:cNvPr id="18" name="Shape 16"/>
+          <p:cNvPr id="21" name="Shape 19"/>
           <p:cNvSpPr/>
           <p:nvPr/>
         </p:nvSpPr>
@@ -3926,14 +4016,14 @@
       </p:sp>
       <p:sp>
         <p:nvSpPr>
-          <p:cNvPr id="19" name="Text 17"/>
-          <p:cNvSpPr/>
-          <p:nvPr/>
-        </p:nvSpPr>
-        <p:spPr>
-          <a:xfrm>
-            <a:off x="7894125" y="2542540"/>
-            <a:ext cx="1364789" cy="502920"/>
+          <p:cNvPr id="22" name="Text 20"/>
+          <p:cNvSpPr/>
+          <p:nvPr/>
+        </p:nvSpPr>
+        <p:spPr>
+          <a:xfrm>
+            <a:off x="7903269" y="2551684"/>
+            <a:ext cx="1346501" cy="484632"/>
           </a:xfrm>
           <a:prstGeom prst="rect">
             <a:avLst/>
@@ -3949,7 +4039,7 @@
               <a:buNone/>
             </a:pPr>
             <a:r>
-              <a:rPr lang="en-US" sz="1100" b="1" dirty="0">
+              <a:rPr lang="en-US" sz="1000" b="1" dirty="0">
                 <a:solidFill>
                   <a:srgbClr val="2C2B29"/>
                 </a:solidFill>
@@ -3959,13 +4049,13 @@
               </a:rPr>
               <a:t>Quantum Tensor Cores</a:t>
             </a:r>
-            <a:endParaRPr lang="en-US" sz="1100" dirty="0"/>
-          </a:p>
-        </p:txBody>
-      </p:sp>
-      <p:sp>
-        <p:nvSpPr>
-          <p:cNvPr id="20" name="Shape 18"/>
+            <a:endParaRPr lang="en-US" sz="1000" dirty="0"/>
+          </a:p>
+        </p:txBody>
+      </p:sp>
+      <p:sp>
+        <p:nvSpPr>
+          <p:cNvPr id="23" name="Shape 21"/>
           <p:cNvSpPr/>
           <p:nvPr/>
         </p:nvSpPr>
@@ -3992,14 +4082,39 @@
       </p:sp>
       <p:sp>
         <p:nvSpPr>
-          <p:cNvPr id="21" name="Text 19"/>
-          <p:cNvSpPr/>
-          <p:nvPr/>
-        </p:nvSpPr>
-        <p:spPr>
-          <a:xfrm>
-            <a:off x="10374797" y="1823720"/>
-            <a:ext cx="1364789" cy="502920"/>
+          <p:cNvPr id="24" name="Shape 22"/>
+          <p:cNvSpPr/>
+          <p:nvPr/>
+        </p:nvSpPr>
+        <p:spPr>
+          <a:xfrm>
+            <a:off x="10466237" y="1869440"/>
+            <a:ext cx="1181909" cy="18288"/>
+          </a:xfrm>
+          <a:prstGeom prst="rect">
+            <a:avLst/>
+          </a:prstGeom>
+          <a:solidFill>
+            <a:srgbClr val="8B0000"/>
+          </a:solidFill>
+          <a:ln w="12700">
+            <a:solidFill>
+              <a:srgbClr val="8B0000"/>
+            </a:solidFill>
+            <a:prstDash val="solid"/>
+          </a:ln>
+        </p:spPr>
+      </p:sp>
+      <p:sp>
+        <p:nvSpPr>
+          <p:cNvPr id="25" name="Text 23"/>
+          <p:cNvSpPr/>
+          <p:nvPr/>
+        </p:nvSpPr>
+        <p:spPr>
+          <a:xfrm>
+            <a:off x="10383941" y="1832864"/>
+            <a:ext cx="1346501" cy="484632"/>
           </a:xfrm>
           <a:prstGeom prst="rect">
             <a:avLst/>
@@ -4015,7 +4130,7 @@
               <a:buNone/>
             </a:pPr>
             <a:r>
-              <a:rPr lang="en-US" sz="1100" b="1" dirty="0">
+              <a:rPr lang="en-US" sz="1000" b="1" dirty="0">
                 <a:solidFill>
                   <a:srgbClr val="2C2B29"/>
                 </a:solidFill>
@@ -4025,13 +4140,13 @@
               </a:rPr>
               <a:t>Vector Knowledge Base</a:t>
             </a:r>
-            <a:endParaRPr lang="en-US" sz="1100" dirty="0"/>
-          </a:p>
-        </p:txBody>
-      </p:sp>
-      <p:sp>
-        <p:nvSpPr>
-          <p:cNvPr id="22" name="Shape 20"/>
+            <a:endParaRPr lang="en-US" sz="1000" dirty="0"/>
+          </a:p>
+        </p:txBody>
+      </p:sp>
+      <p:sp>
+        <p:nvSpPr>
+          <p:cNvPr id="26" name="Shape 24"/>
           <p:cNvSpPr/>
           <p:nvPr/>
         </p:nvSpPr>
@@ -4058,14 +4173,39 @@
       </p:sp>
       <p:sp>
         <p:nvSpPr>
-          <p:cNvPr id="23" name="Text 21"/>
-          <p:cNvSpPr/>
-          <p:nvPr/>
-        </p:nvSpPr>
-        <p:spPr>
-          <a:xfrm>
-            <a:off x="10374797" y="3261360"/>
-            <a:ext cx="1364789" cy="502920"/>
+          <p:cNvPr id="27" name="Shape 25"/>
+          <p:cNvSpPr/>
+          <p:nvPr/>
+        </p:nvSpPr>
+        <p:spPr>
+          <a:xfrm>
+            <a:off x="10466237" y="3307080"/>
+            <a:ext cx="1181909" cy="18288"/>
+          </a:xfrm>
+          <a:prstGeom prst="rect">
+            <a:avLst/>
+          </a:prstGeom>
+          <a:solidFill>
+            <a:srgbClr val="2E7D32"/>
+          </a:solidFill>
+          <a:ln w="12700">
+            <a:solidFill>
+              <a:srgbClr val="2E7D32"/>
+            </a:solidFill>
+            <a:prstDash val="solid"/>
+          </a:ln>
+        </p:spPr>
+      </p:sp>
+      <p:sp>
+        <p:nvSpPr>
+          <p:cNvPr id="28" name="Text 26"/>
+          <p:cNvSpPr/>
+          <p:nvPr/>
+        </p:nvSpPr>
+        <p:spPr>
+          <a:xfrm>
+            <a:off x="10383941" y="3270504"/>
+            <a:ext cx="1346501" cy="484632"/>
           </a:xfrm>
           <a:prstGeom prst="rect">
             <a:avLst/>
@@ -4081,7 +4221,7 @@
               <a:buNone/>
             </a:pPr>
             <a:r>
-              <a:rPr lang="en-US" sz="1100" b="1" dirty="0">
+              <a:rPr lang="en-US" sz="1000" b="1" dirty="0">
                 <a:solidFill>
                   <a:srgbClr val="2C2B29"/>
                 </a:solidFill>
@@ -4091,13 +4231,13 @@
               </a:rPr>
               <a:t>Redis Semantic Cache</a:t>
             </a:r>
-            <a:endParaRPr lang="en-US" sz="1100" dirty="0"/>
-          </a:p>
-        </p:txBody>
-      </p:sp>
-      <p:sp>
-        <p:nvSpPr>
-          <p:cNvPr id="24" name="Text 22"/>
+            <a:endParaRPr lang="en-US" sz="1000" dirty="0"/>
+          </a:p>
+        </p:txBody>
+      </p:sp>
+      <p:sp>
+        <p:nvSpPr>
+          <p:cNvPr id="29" name="Text 27"/>
           <p:cNvSpPr/>
           <p:nvPr/>
         </p:nvSpPr>
@@ -5904,13 +6044,13 @@
           </a:xfrm>
           <a:prstGeom prst="roundRect">
             <a:avLst>
-              <a:gd name="adj" fmla="val 5455"/>
+              <a:gd name="adj" fmla="val 8727"/>
             </a:avLst>
           </a:prstGeom>
           <a:solidFill>
             <a:srgbClr val="2C2B29"/>
           </a:solidFill>
-          <a:ln w="12700">
+          <a:ln w="19050">
             <a:solidFill>
               <a:srgbClr val="E0DACD"/>
             </a:solidFill>
@@ -5920,14 +6060,89 @@
       </p:sp>
       <p:sp>
         <p:nvSpPr>
-          <p:cNvPr id="5" name="Text 3"/>
-          <p:cNvSpPr/>
-          <p:nvPr/>
-        </p:nvSpPr>
-        <p:spPr>
-          <a:xfrm>
-            <a:off x="589270" y="1915160"/>
-            <a:ext cx="6354912" cy="563880"/>
+          <p:cNvPr id="5" name="Shape 3"/>
+          <p:cNvSpPr/>
+          <p:nvPr/>
+        </p:nvSpPr>
+        <p:spPr>
+          <a:xfrm>
+            <a:off x="543550" y="1887728"/>
+            <a:ext cx="91440" cy="91440"/>
+          </a:xfrm>
+          <a:prstGeom prst="ellipse">
+            <a:avLst/>
+          </a:prstGeom>
+          <a:solidFill>
+            <a:srgbClr val="EF4444"/>
+          </a:solidFill>
+          <a:ln w="12700">
+            <a:solidFill>
+              <a:srgbClr val="EF4444"/>
+            </a:solidFill>
+            <a:prstDash val="solid"/>
+          </a:ln>
+        </p:spPr>
+      </p:sp>
+      <p:sp>
+        <p:nvSpPr>
+          <p:cNvPr id="6" name="Shape 4"/>
+          <p:cNvSpPr/>
+          <p:nvPr/>
+        </p:nvSpPr>
+        <p:spPr>
+          <a:xfrm>
+            <a:off x="680710" y="1887728"/>
+            <a:ext cx="91440" cy="91440"/>
+          </a:xfrm>
+          <a:prstGeom prst="ellipse">
+            <a:avLst/>
+          </a:prstGeom>
+          <a:solidFill>
+            <a:srgbClr val="F59E0B"/>
+          </a:solidFill>
+          <a:ln w="12700">
+            <a:solidFill>
+              <a:srgbClr val="F59E0B"/>
+            </a:solidFill>
+            <a:prstDash val="solid"/>
+          </a:ln>
+        </p:spPr>
+      </p:sp>
+      <p:sp>
+        <p:nvSpPr>
+          <p:cNvPr id="7" name="Shape 5"/>
+          <p:cNvSpPr/>
+          <p:nvPr/>
+        </p:nvSpPr>
+        <p:spPr>
+          <a:xfrm>
+            <a:off x="817870" y="1887728"/>
+            <a:ext cx="91440" cy="91440"/>
+          </a:xfrm>
+          <a:prstGeom prst="ellipse">
+            <a:avLst/>
+          </a:prstGeom>
+          <a:solidFill>
+            <a:srgbClr val="10B981"/>
+          </a:solidFill>
+          <a:ln w="12700">
+            <a:solidFill>
+              <a:srgbClr val="10B981"/>
+            </a:solidFill>
+            <a:prstDash val="solid"/>
+          </a:ln>
+        </p:spPr>
+      </p:sp>
+      <p:sp>
+        <p:nvSpPr>
+          <p:cNvPr id="8" name="Text 6"/>
+          <p:cNvSpPr/>
+          <p:nvPr/>
+        </p:nvSpPr>
+        <p:spPr>
+          <a:xfrm>
+            <a:off x="589270" y="2070608"/>
+            <a:ext cx="6354912" cy="472440"/>
           </a:xfrm>
           <a:prstGeom prst="rect">
             <a:avLst/>
@@ -5943,7 +6158,7 @@
               <a:buNone/>
             </a:pPr>
             <a:r>
-              <a:rPr lang="en-US" sz="1300" dirty="0">
+              <a:rPr lang="en-US" sz="1150" dirty="0">
                 <a:solidFill>
                   <a:srgbClr val="F5F2EB"/>
                 </a:solidFill>
@@ -5953,14 +6168,14 @@
               </a:rPr>
               <a:t>import { YumiaCompiler, createEngine } from '@yumiamd/core';</a:t>
             </a:r>
-            <a:endParaRPr lang="en-US" sz="1300" dirty="0"/>
+            <a:endParaRPr lang="en-US" sz="1150" dirty="0"/>
           </a:p>
           <a:p>
             <a:pPr indent="0" marL="0">
               <a:buNone/>
             </a:pPr>
             <a:r>
-              <a:rPr lang="en-US" sz="1300" dirty="0">
+              <a:rPr lang="en-US" sz="1150" dirty="0">
                 <a:solidFill>
                   <a:srgbClr val="F5F2EB"/>
                 </a:solidFill>
@@ -5970,14 +6185,14 @@
               </a:rPr>
               <a:t>const engine = createEngine({ target: 'multi-target' });</a:t>
             </a:r>
-            <a:endParaRPr lang="en-US" sz="1300" dirty="0"/>
+            <a:endParaRPr lang="en-US" sz="1150" dirty="0"/>
           </a:p>
           <a:p>
             <a:pPr indent="0" marL="0">
               <a:buNone/>
             </a:pPr>
             <a:r>
-              <a:rPr lang="en-US" sz="1300" dirty="0">
+              <a:rPr lang="en-US" sz="1150" dirty="0">
                 <a:solidFill>
                   <a:srgbClr val="F5F2EB"/>
                 </a:solidFill>
@@ -5987,13 +6202,13 @@
               </a:rPr>
               <a:t>const result = await engine.compile('presentation.yumia');</a:t>
             </a:r>
-            <a:endParaRPr lang="en-US" sz="1300" dirty="0"/>
-          </a:p>
-        </p:txBody>
-      </p:sp>
-      <p:sp>
-        <p:nvSpPr>
-          <p:cNvPr id="6" name="Shape 4"/>
+            <a:endParaRPr lang="en-US" sz="1150" dirty="0"/>
+          </a:p>
+        </p:txBody>
+      </p:sp>
+      <p:sp>
+        <p:nvSpPr>
+          <p:cNvPr id="9" name="Shape 7"/>
           <p:cNvSpPr/>
           <p:nvPr/>
         </p:nvSpPr>
@@ -6020,7 +6235,7 @@
       </p:sp>
       <p:sp>
         <p:nvSpPr>
-          <p:cNvPr id="7" name="Text 5"/>
+          <p:cNvPr id="10" name="Text 8"/>
           <p:cNvSpPr/>
           <p:nvPr/>
         </p:nvSpPr>
@@ -6059,7 +6274,7 @@
       </p:sp>
       <p:sp>
         <p:nvSpPr>
-          <p:cNvPr id="8" name="Text 6"/>
+          <p:cNvPr id="11" name="Text 9"/>
           <p:cNvSpPr/>
           <p:nvPr/>
         </p:nvSpPr>
@@ -6098,7 +6313,7 @@
       </p:sp>
       <p:sp>
         <p:nvSpPr>
-          <p:cNvPr id="9" name="Shape 7"/>
+          <p:cNvPr id="12" name="Shape 10"/>
           <p:cNvSpPr/>
           <p:nvPr/>
         </p:nvSpPr>
@@ -6125,7 +6340,7 @@
       </p:sp>
       <p:sp>
         <p:nvSpPr>
-          <p:cNvPr id="10" name="Text 8"/>
+          <p:cNvPr id="13" name="Text 11"/>
           <p:cNvSpPr/>
           <p:nvPr/>
         </p:nvSpPr>
@@ -6164,7 +6379,7 @@
       </p:sp>
       <p:sp>
         <p:nvSpPr>
-          <p:cNvPr id="11" name="Shape 9"/>
+          <p:cNvPr id="14" name="Shape 12"/>
           <p:cNvSpPr/>
           <p:nvPr/>
         </p:nvSpPr>
@@ -6191,7 +6406,7 @@
       </p:sp>
       <p:sp>
         <p:nvSpPr>
-          <p:cNvPr id="12" name="Text 10"/>
+          <p:cNvPr id="15" name="Text 13"/>
           <p:cNvSpPr/>
           <p:nvPr/>
         </p:nvSpPr>
@@ -6230,7 +6445,7 @@
       </p:sp>
       <p:sp>
         <p:nvSpPr>
-          <p:cNvPr id="13" name="Text 11"/>
+          <p:cNvPr id="16" name="Text 14"/>
           <p:cNvSpPr/>
           <p:nvPr/>
         </p:nvSpPr>

</xml_diff>

<commit_message>
fix(layout,pdf,pptx): shared diagram layout, PDF layout roots, and icon rasterization
Prevent cyclic-diagram hangs, wire PDF roots to the layout engine, fit branching labels, and embed IconResolver SVGs as PNG in PPTX/PDF.
</commit_message>
<xml_diff>
--- a/presentation.pptx
+++ b/presentation.pptx
@@ -9044,14 +9044,53 @@
       </p:sp>
       <p:sp>
         <p:nvSpPr>
-          <p:cNvPr id="4" name="Shape 2"/>
-          <p:cNvSpPr/>
-          <p:nvPr/>
-        </p:nvSpPr>
-        <p:spPr>
-          <a:xfrm>
-            <a:off x="2052310" y="1890486"/>
-            <a:ext cx="1598412" cy="903514"/>
+          <p:cNvPr id="4" name="Text 2"/>
+          <p:cNvSpPr/>
+          <p:nvPr/>
+        </p:nvSpPr>
+        <p:spPr>
+          <a:xfrm>
+            <a:off x="406390" y="1778000"/>
+            <a:ext cx="11378916" cy="256032"/>
+          </a:xfrm>
+          <a:prstGeom prst="rect">
+            <a:avLst/>
+          </a:prstGeom>
+          <a:noFill/>
+          <a:ln/>
+        </p:spPr>
+        <p:txBody>
+          <a:bodyPr wrap="square" rtlCol="0" anchor="ctr"/>
+          <a:lstStyle/>
+          <a:p>
+            <a:pPr algn="ctr" indent="0" marL="0">
+              <a:buNone/>
+            </a:pPr>
+            <a:r>
+              <a:rPr lang="en-US" sz="1200" b="1" dirty="0">
+                <a:solidFill>
+                  <a:srgbClr val="FF2E88"/>
+                </a:solidFill>
+                <a:latin typeface="Trebuchet MS" pitchFamily="34" charset="0"/>
+                <a:ea typeface="Trebuchet MS" pitchFamily="34" charset="-122"/>
+                <a:cs typeface="Trebuchet MS" pitchFamily="34" charset="-120"/>
+              </a:rPr>
+              <a:t>Flusso di Trasformazione Multi-Target</a:t>
+            </a:r>
+            <a:endParaRPr lang="en-US" sz="1200" dirty="0"/>
+          </a:p>
+        </p:txBody>
+      </p:sp>
+      <p:sp>
+        <p:nvSpPr>
+          <p:cNvPr id="5" name="Shape 3"/>
+          <p:cNvSpPr/>
+          <p:nvPr/>
+        </p:nvSpPr>
+        <p:spPr>
+          <a:xfrm>
+            <a:off x="4869778" y="2191868"/>
+            <a:ext cx="188626" cy="1091336"/>
           </a:xfrm>
           <a:prstGeom prst="line">
             <a:avLst/>
@@ -9068,14 +9107,14 @@
       </p:sp>
       <p:sp>
         <p:nvSpPr>
-          <p:cNvPr id="5" name="Shape 3"/>
-          <p:cNvSpPr/>
-          <p:nvPr/>
-        </p:nvSpPr>
-        <p:spPr>
-          <a:xfrm>
-            <a:off x="5296642" y="2794000"/>
-            <a:ext cx="1598412" cy="9144"/>
+          <p:cNvPr id="6" name="Shape 4"/>
+          <p:cNvSpPr/>
+          <p:nvPr/>
+        </p:nvSpPr>
+        <p:spPr>
+          <a:xfrm>
+            <a:off x="6001535" y="3283204"/>
+            <a:ext cx="188626" cy="9144"/>
           </a:xfrm>
           <a:prstGeom prst="line">
             <a:avLst/>
@@ -9092,14 +9131,14 @@
       </p:sp>
       <p:sp>
         <p:nvSpPr>
-          <p:cNvPr id="6" name="Shape 4"/>
+          <p:cNvPr id="7" name="Shape 5"/>
           <p:cNvSpPr/>
           <p:nvPr/>
         </p:nvSpPr>
         <p:spPr>
           <a:xfrm flipV="1">
-            <a:off x="8540974" y="2492829"/>
-            <a:ext cx="1598412" cy="301171"/>
+            <a:off x="7133291" y="2919425"/>
+            <a:ext cx="188626" cy="363779"/>
           </a:xfrm>
           <a:prstGeom prst="line">
             <a:avLst/>
@@ -9116,14 +9155,14 @@
       </p:sp>
       <p:sp>
         <p:nvSpPr>
-          <p:cNvPr id="7" name="Shape 5"/>
-          <p:cNvSpPr/>
-          <p:nvPr/>
-        </p:nvSpPr>
-        <p:spPr>
-          <a:xfrm>
-            <a:off x="8540974" y="2794000"/>
-            <a:ext cx="1598412" cy="9144"/>
+          <p:cNvPr id="8" name="Shape 6"/>
+          <p:cNvSpPr/>
+          <p:nvPr/>
+        </p:nvSpPr>
+        <p:spPr>
+          <a:xfrm>
+            <a:off x="7133291" y="3283204"/>
+            <a:ext cx="188626" cy="9144"/>
           </a:xfrm>
           <a:prstGeom prst="line">
             <a:avLst/>
@@ -9140,14 +9179,14 @@
       </p:sp>
       <p:sp>
         <p:nvSpPr>
-          <p:cNvPr id="8" name="Shape 6"/>
-          <p:cNvSpPr/>
-          <p:nvPr/>
-        </p:nvSpPr>
-        <p:spPr>
-          <a:xfrm>
-            <a:off x="8540974" y="2794000"/>
-            <a:ext cx="1598412" cy="301171"/>
+          <p:cNvPr id="9" name="Shape 7"/>
+          <p:cNvSpPr/>
+          <p:nvPr/>
+        </p:nvSpPr>
+        <p:spPr>
+          <a:xfrm>
+            <a:off x="7133291" y="3283204"/>
+            <a:ext cx="188626" cy="363779"/>
           </a:xfrm>
           <a:prstGeom prst="line">
             <a:avLst/>
@@ -9164,18 +9203,18 @@
       </p:sp>
       <p:sp>
         <p:nvSpPr>
-          <p:cNvPr id="9" name="Shape 7"/>
-          <p:cNvSpPr/>
-          <p:nvPr/>
-        </p:nvSpPr>
-        <p:spPr>
-          <a:xfrm>
-            <a:off x="406390" y="1778000"/>
-            <a:ext cx="1645920" cy="224971"/>
+          <p:cNvPr id="10" name="Shape 8"/>
+          <p:cNvSpPr/>
+          <p:nvPr/>
+        </p:nvSpPr>
+        <p:spPr>
+          <a:xfrm>
+            <a:off x="3926648" y="2070608"/>
+            <a:ext cx="943130" cy="242519"/>
           </a:xfrm>
           <a:prstGeom prst="roundRect">
             <a:avLst>
-              <a:gd name="adj" fmla="val 32516"/>
+              <a:gd name="adj" fmla="val 30163"/>
             </a:avLst>
           </a:prstGeom>
           <a:solidFill>
@@ -9191,14 +9230,14 @@
       </p:sp>
       <p:sp>
         <p:nvSpPr>
-          <p:cNvPr id="10" name="Text 8"/>
-          <p:cNvSpPr/>
-          <p:nvPr/>
-        </p:nvSpPr>
-        <p:spPr>
-          <a:xfrm>
-            <a:off x="461254" y="1832864"/>
-            <a:ext cx="1536192" cy="115243"/>
+          <p:cNvPr id="11" name="Text 9"/>
+          <p:cNvSpPr/>
+          <p:nvPr/>
+        </p:nvSpPr>
+        <p:spPr>
+          <a:xfrm>
+            <a:off x="3981512" y="2125472"/>
+            <a:ext cx="833402" cy="132791"/>
           </a:xfrm>
           <a:prstGeom prst="rect">
             <a:avLst/>
@@ -9222,7 +9261,7 @@
                 <a:ea typeface="Trebuchet MS" pitchFamily="34" charset="-122"/>
                 <a:cs typeface="Trebuchet MS" pitchFamily="34" charset="-120"/>
               </a:rPr>
-              <a:t>Sorgente Yumia</a:t>
+              <a:t>Sorgente Yu…</a:t>
             </a:r>
             <a:endParaRPr lang="en-US" sz="1100" dirty="0"/>
           </a:p>
@@ -9230,18 +9269,18 @@
       </p:sp>
       <p:sp>
         <p:nvSpPr>
-          <p:cNvPr id="11" name="Shape 9"/>
-          <p:cNvSpPr/>
-          <p:nvPr/>
-        </p:nvSpPr>
-        <p:spPr>
-          <a:xfrm>
-            <a:off x="3650722" y="2681514"/>
-            <a:ext cx="1645920" cy="224971"/>
+          <p:cNvPr id="12" name="Shape 10"/>
+          <p:cNvSpPr/>
+          <p:nvPr/>
+        </p:nvSpPr>
+        <p:spPr>
+          <a:xfrm>
+            <a:off x="5058404" y="3161944"/>
+            <a:ext cx="943130" cy="242519"/>
           </a:xfrm>
           <a:prstGeom prst="roundRect">
             <a:avLst>
-              <a:gd name="adj" fmla="val 32516"/>
+              <a:gd name="adj" fmla="val 30163"/>
             </a:avLst>
           </a:prstGeom>
           <a:solidFill>
@@ -9257,14 +9296,14 @@
       </p:sp>
       <p:sp>
         <p:nvSpPr>
-          <p:cNvPr id="12" name="Text 10"/>
-          <p:cNvSpPr/>
-          <p:nvPr/>
-        </p:nvSpPr>
-        <p:spPr>
-          <a:xfrm>
-            <a:off x="3705586" y="2736378"/>
-            <a:ext cx="1536192" cy="115243"/>
+          <p:cNvPr id="13" name="Text 11"/>
+          <p:cNvSpPr/>
+          <p:nvPr/>
+        </p:nvSpPr>
+        <p:spPr>
+          <a:xfrm>
+            <a:off x="5113268" y="3216808"/>
+            <a:ext cx="833402" cy="132791"/>
           </a:xfrm>
           <a:prstGeom prst="rect">
             <a:avLst/>
@@ -9288,7 +9327,7 @@
                 <a:ea typeface="Trebuchet MS" pitchFamily="34" charset="-122"/>
                 <a:cs typeface="Trebuchet MS" pitchFamily="34" charset="-120"/>
               </a:rPr>
-              <a:t>AST Semantico</a:t>
+              <a:t>AST Semanti…</a:t>
             </a:r>
             <a:endParaRPr lang="en-US" sz="1100" dirty="0"/>
           </a:p>
@@ -9296,18 +9335,18 @@
       </p:sp>
       <p:sp>
         <p:nvSpPr>
-          <p:cNvPr id="13" name="Shape 11"/>
-          <p:cNvSpPr/>
-          <p:nvPr/>
-        </p:nvSpPr>
-        <p:spPr>
-          <a:xfrm>
-            <a:off x="6895054" y="2681514"/>
-            <a:ext cx="1645920" cy="224971"/>
+          <p:cNvPr id="14" name="Shape 12"/>
+          <p:cNvSpPr/>
+          <p:nvPr/>
+        </p:nvSpPr>
+        <p:spPr>
+          <a:xfrm>
+            <a:off x="6190161" y="3161944"/>
+            <a:ext cx="943130" cy="242519"/>
           </a:xfrm>
           <a:prstGeom prst="roundRect">
             <a:avLst>
-              <a:gd name="adj" fmla="val 32516"/>
+              <a:gd name="adj" fmla="val 30163"/>
             </a:avLst>
           </a:prstGeom>
           <a:solidFill>
@@ -9323,14 +9362,14 @@
       </p:sp>
       <p:sp>
         <p:nvSpPr>
-          <p:cNvPr id="14" name="Text 12"/>
-          <p:cNvSpPr/>
-          <p:nvPr/>
-        </p:nvSpPr>
-        <p:spPr>
-          <a:xfrm>
-            <a:off x="6949918" y="2736378"/>
-            <a:ext cx="1536192" cy="115243"/>
+          <p:cNvPr id="15" name="Text 13"/>
+          <p:cNvSpPr/>
+          <p:nvPr/>
+        </p:nvSpPr>
+        <p:spPr>
+          <a:xfrm>
+            <a:off x="6245025" y="3216808"/>
+            <a:ext cx="833402" cy="132791"/>
           </a:xfrm>
           <a:prstGeom prst="rect">
             <a:avLst/>
@@ -9354,7 +9393,7 @@
                 <a:ea typeface="Trebuchet MS" pitchFamily="34" charset="-122"/>
                 <a:cs typeface="Trebuchet MS" pitchFamily="34" charset="-120"/>
               </a:rPr>
-              <a:t>Design System</a:t>
+              <a:t>Design Syst…</a:t>
             </a:r>
             <a:endParaRPr lang="en-US" sz="1100" dirty="0"/>
           </a:p>
@@ -9362,18 +9401,18 @@
       </p:sp>
       <p:sp>
         <p:nvSpPr>
-          <p:cNvPr id="15" name="Shape 13"/>
-          <p:cNvSpPr/>
-          <p:nvPr/>
-        </p:nvSpPr>
-        <p:spPr>
-          <a:xfrm>
-            <a:off x="10139385" y="2380343"/>
-            <a:ext cx="1645920" cy="224971"/>
+          <p:cNvPr id="16" name="Shape 14"/>
+          <p:cNvSpPr/>
+          <p:nvPr/>
+        </p:nvSpPr>
+        <p:spPr>
+          <a:xfrm>
+            <a:off x="7321917" y="2798166"/>
+            <a:ext cx="943130" cy="242519"/>
           </a:xfrm>
           <a:prstGeom prst="roundRect">
             <a:avLst>
-              <a:gd name="adj" fmla="val 32516"/>
+              <a:gd name="adj" fmla="val 30163"/>
             </a:avLst>
           </a:prstGeom>
           <a:solidFill>
@@ -9389,14 +9428,14 @@
       </p:sp>
       <p:sp>
         <p:nvSpPr>
-          <p:cNvPr id="16" name="Text 14"/>
-          <p:cNvSpPr/>
-          <p:nvPr/>
-        </p:nvSpPr>
-        <p:spPr>
-          <a:xfrm>
-            <a:off x="10194249" y="2435207"/>
-            <a:ext cx="1536192" cy="115243"/>
+          <p:cNvPr id="17" name="Text 15"/>
+          <p:cNvSpPr/>
+          <p:nvPr/>
+        </p:nvSpPr>
+        <p:spPr>
+          <a:xfrm>
+            <a:off x="7376781" y="2853030"/>
+            <a:ext cx="833402" cy="132791"/>
           </a:xfrm>
           <a:prstGeom prst="rect">
             <a:avLst/>
@@ -9420,7 +9459,7 @@
                 <a:ea typeface="Trebuchet MS" pitchFamily="34" charset="-122"/>
                 <a:cs typeface="Trebuchet MS" pitchFamily="34" charset="-120"/>
               </a:rPr>
-              <a:t>HTML Interattivo</a:t>
+              <a:t>HTML Intera…</a:t>
             </a:r>
             <a:endParaRPr lang="en-US" sz="1100" dirty="0"/>
           </a:p>
@@ -9428,18 +9467,18 @@
       </p:sp>
       <p:sp>
         <p:nvSpPr>
-          <p:cNvPr id="17" name="Shape 15"/>
-          <p:cNvSpPr/>
-          <p:nvPr/>
-        </p:nvSpPr>
-        <p:spPr>
-          <a:xfrm>
-            <a:off x="10139385" y="2681514"/>
-            <a:ext cx="1645920" cy="224971"/>
+          <p:cNvPr id="18" name="Shape 16"/>
+          <p:cNvSpPr/>
+          <p:nvPr/>
+        </p:nvSpPr>
+        <p:spPr>
+          <a:xfrm>
+            <a:off x="7321917" y="3161944"/>
+            <a:ext cx="943130" cy="242519"/>
           </a:xfrm>
           <a:prstGeom prst="roundRect">
             <a:avLst>
-              <a:gd name="adj" fmla="val 32516"/>
+              <a:gd name="adj" fmla="val 30163"/>
             </a:avLst>
           </a:prstGeom>
           <a:solidFill>
@@ -9455,14 +9494,14 @@
       </p:sp>
       <p:sp>
         <p:nvSpPr>
-          <p:cNvPr id="18" name="Text 16"/>
-          <p:cNvSpPr/>
-          <p:nvPr/>
-        </p:nvSpPr>
-        <p:spPr>
-          <a:xfrm>
-            <a:off x="10194249" y="2736378"/>
-            <a:ext cx="1536192" cy="115243"/>
+          <p:cNvPr id="19" name="Text 17"/>
+          <p:cNvSpPr/>
+          <p:nvPr/>
+        </p:nvSpPr>
+        <p:spPr>
+          <a:xfrm>
+            <a:off x="7376781" y="3216808"/>
+            <a:ext cx="833402" cy="132791"/>
           </a:xfrm>
           <a:prstGeom prst="rect">
             <a:avLst/>
@@ -9486,7 +9525,7 @@
                 <a:ea typeface="Trebuchet MS" pitchFamily="34" charset="-122"/>
                 <a:cs typeface="Trebuchet MS" pitchFamily="34" charset="-120"/>
               </a:rPr>
-              <a:t>PowerPoint PPTX</a:t>
+              <a:t>PowerPoint …</a:t>
             </a:r>
             <a:endParaRPr lang="en-US" sz="1100" dirty="0"/>
           </a:p>
@@ -9494,18 +9533,18 @@
       </p:sp>
       <p:sp>
         <p:nvSpPr>
-          <p:cNvPr id="19" name="Shape 17"/>
-          <p:cNvSpPr/>
-          <p:nvPr/>
-        </p:nvSpPr>
-        <p:spPr>
-          <a:xfrm>
-            <a:off x="10139385" y="2982686"/>
-            <a:ext cx="1645920" cy="224971"/>
+          <p:cNvPr id="20" name="Shape 18"/>
+          <p:cNvSpPr/>
+          <p:nvPr/>
+        </p:nvSpPr>
+        <p:spPr>
+          <a:xfrm>
+            <a:off x="7321917" y="3525723"/>
+            <a:ext cx="943130" cy="242519"/>
           </a:xfrm>
           <a:prstGeom prst="roundRect">
             <a:avLst>
-              <a:gd name="adj" fmla="val 32516"/>
+              <a:gd name="adj" fmla="val 30163"/>
             </a:avLst>
           </a:prstGeom>
           <a:solidFill>
@@ -9521,14 +9560,14 @@
       </p:sp>
       <p:sp>
         <p:nvSpPr>
-          <p:cNvPr id="20" name="Text 18"/>
-          <p:cNvSpPr/>
-          <p:nvPr/>
-        </p:nvSpPr>
-        <p:spPr>
-          <a:xfrm>
-            <a:off x="10194249" y="3037550"/>
-            <a:ext cx="1536192" cy="115243"/>
+          <p:cNvPr id="21" name="Text 19"/>
+          <p:cNvSpPr/>
+          <p:nvPr/>
+        </p:nvSpPr>
+        <p:spPr>
+          <a:xfrm>
+            <a:off x="7376781" y="3580587"/>
+            <a:ext cx="833402" cy="132791"/>
           </a:xfrm>
           <a:prstGeom prst="rect">
             <a:avLst/>
@@ -9552,7 +9591,7 @@
                 <a:ea typeface="Trebuchet MS" pitchFamily="34" charset="-122"/>
                 <a:cs typeface="Trebuchet MS" pitchFamily="34" charset="-120"/>
               </a:rPr>
-              <a:t>PDF Vettoriale</a:t>
+              <a:t>PDF Vettori…</a:t>
             </a:r>
             <a:endParaRPr lang="en-US" sz="1100" dirty="0"/>
           </a:p>
@@ -9560,18 +9599,18 @@
       </p:sp>
       <p:sp>
         <p:nvSpPr>
-          <p:cNvPr id="21" name="Shape 19"/>
-          <p:cNvSpPr/>
-          <p:nvPr/>
-        </p:nvSpPr>
-        <p:spPr>
-          <a:xfrm>
-            <a:off x="406390" y="2079171"/>
-            <a:ext cx="1645920" cy="224971"/>
+          <p:cNvPr id="22" name="Shape 20"/>
+          <p:cNvSpPr/>
+          <p:nvPr/>
+        </p:nvSpPr>
+        <p:spPr>
+          <a:xfrm>
+            <a:off x="3926648" y="2434387"/>
+            <a:ext cx="943130" cy="242519"/>
           </a:xfrm>
           <a:prstGeom prst="roundRect">
             <a:avLst>
-              <a:gd name="adj" fmla="val 32516"/>
+              <a:gd name="adj" fmla="val 30163"/>
             </a:avLst>
           </a:prstGeom>
           <a:solidFill>
@@ -9587,14 +9626,14 @@
       </p:sp>
       <p:sp>
         <p:nvSpPr>
-          <p:cNvPr id="22" name="Text 20"/>
-          <p:cNvSpPr/>
-          <p:nvPr/>
-        </p:nvSpPr>
-        <p:spPr>
-          <a:xfrm>
-            <a:off x="461254" y="2134035"/>
-            <a:ext cx="1536192" cy="115243"/>
+          <p:cNvPr id="23" name="Text 21"/>
+          <p:cNvSpPr/>
+          <p:nvPr/>
+        </p:nvSpPr>
+        <p:spPr>
+          <a:xfrm>
+            <a:off x="3981512" y="2489251"/>
+            <a:ext cx="833402" cy="132791"/>
           </a:xfrm>
           <a:prstGeom prst="rect">
             <a:avLst/>
@@ -9626,18 +9665,18 @@
       </p:sp>
       <p:sp>
         <p:nvSpPr>
-          <p:cNvPr id="23" name="Shape 21"/>
-          <p:cNvSpPr/>
-          <p:nvPr/>
-        </p:nvSpPr>
-        <p:spPr>
-          <a:xfrm>
-            <a:off x="406390" y="2380343"/>
-            <a:ext cx="1645920" cy="224971"/>
+          <p:cNvPr id="24" name="Shape 22"/>
+          <p:cNvSpPr/>
+          <p:nvPr/>
+        </p:nvSpPr>
+        <p:spPr>
+          <a:xfrm>
+            <a:off x="3926648" y="2798166"/>
+            <a:ext cx="943130" cy="242519"/>
           </a:xfrm>
           <a:prstGeom prst="roundRect">
             <a:avLst>
-              <a:gd name="adj" fmla="val 32516"/>
+              <a:gd name="adj" fmla="val 30163"/>
             </a:avLst>
           </a:prstGeom>
           <a:solidFill>
@@ -9653,14 +9692,14 @@
       </p:sp>
       <p:sp>
         <p:nvSpPr>
-          <p:cNvPr id="24" name="Text 22"/>
-          <p:cNvSpPr/>
-          <p:nvPr/>
-        </p:nvSpPr>
-        <p:spPr>
-          <a:xfrm>
-            <a:off x="461254" y="2435207"/>
-            <a:ext cx="1536192" cy="115243"/>
+          <p:cNvPr id="25" name="Text 23"/>
+          <p:cNvSpPr/>
+          <p:nvPr/>
+        </p:nvSpPr>
+        <p:spPr>
+          <a:xfrm>
+            <a:off x="3981512" y="2853030"/>
+            <a:ext cx="833402" cy="132791"/>
           </a:xfrm>
           <a:prstGeom prst="rect">
             <a:avLst/>
@@ -9692,18 +9731,18 @@
       </p:sp>
       <p:sp>
         <p:nvSpPr>
-          <p:cNvPr id="25" name="Shape 23"/>
-          <p:cNvSpPr/>
-          <p:nvPr/>
-        </p:nvSpPr>
-        <p:spPr>
-          <a:xfrm>
-            <a:off x="406390" y="2681514"/>
-            <a:ext cx="1645920" cy="224971"/>
+          <p:cNvPr id="26" name="Shape 24"/>
+          <p:cNvSpPr/>
+          <p:nvPr/>
+        </p:nvSpPr>
+        <p:spPr>
+          <a:xfrm>
+            <a:off x="3926648" y="3161944"/>
+            <a:ext cx="943130" cy="242519"/>
           </a:xfrm>
           <a:prstGeom prst="roundRect">
             <a:avLst>
-              <a:gd name="adj" fmla="val 32516"/>
+              <a:gd name="adj" fmla="val 30163"/>
             </a:avLst>
           </a:prstGeom>
           <a:solidFill>
@@ -9719,14 +9758,14 @@
       </p:sp>
       <p:sp>
         <p:nvSpPr>
-          <p:cNvPr id="26" name="Text 24"/>
-          <p:cNvSpPr/>
-          <p:nvPr/>
-        </p:nvSpPr>
-        <p:spPr>
-          <a:xfrm>
-            <a:off x="461254" y="2736378"/>
-            <a:ext cx="1536192" cy="115243"/>
+          <p:cNvPr id="27" name="Text 25"/>
+          <p:cNvSpPr/>
+          <p:nvPr/>
+        </p:nvSpPr>
+        <p:spPr>
+          <a:xfrm>
+            <a:off x="3981512" y="3216808"/>
+            <a:ext cx="833402" cy="132791"/>
           </a:xfrm>
           <a:prstGeom prst="rect">
             <a:avLst/>
@@ -9758,18 +9797,18 @@
       </p:sp>
       <p:sp>
         <p:nvSpPr>
-          <p:cNvPr id="27" name="Shape 25"/>
-          <p:cNvSpPr/>
-          <p:nvPr/>
-        </p:nvSpPr>
-        <p:spPr>
-          <a:xfrm>
-            <a:off x="406390" y="2982686"/>
-            <a:ext cx="1645920" cy="224971"/>
+          <p:cNvPr id="28" name="Shape 26"/>
+          <p:cNvSpPr/>
+          <p:nvPr/>
+        </p:nvSpPr>
+        <p:spPr>
+          <a:xfrm>
+            <a:off x="3926648" y="3525723"/>
+            <a:ext cx="943130" cy="242519"/>
           </a:xfrm>
           <a:prstGeom prst="roundRect">
             <a:avLst>
-              <a:gd name="adj" fmla="val 32516"/>
+              <a:gd name="adj" fmla="val 30163"/>
             </a:avLst>
           </a:prstGeom>
           <a:solidFill>
@@ -9785,14 +9824,14 @@
       </p:sp>
       <p:sp>
         <p:nvSpPr>
-          <p:cNvPr id="28" name="Text 26"/>
-          <p:cNvSpPr/>
-          <p:nvPr/>
-        </p:nvSpPr>
-        <p:spPr>
-          <a:xfrm>
-            <a:off x="461254" y="3037550"/>
-            <a:ext cx="1536192" cy="115243"/>
+          <p:cNvPr id="29" name="Text 27"/>
+          <p:cNvSpPr/>
+          <p:nvPr/>
+        </p:nvSpPr>
+        <p:spPr>
+          <a:xfrm>
+            <a:off x="3981512" y="3580587"/>
+            <a:ext cx="833402" cy="132791"/>
           </a:xfrm>
           <a:prstGeom prst="rect">
             <a:avLst/>
@@ -9824,18 +9863,18 @@
       </p:sp>
       <p:sp>
         <p:nvSpPr>
-          <p:cNvPr id="29" name="Shape 27"/>
-          <p:cNvSpPr/>
-          <p:nvPr/>
-        </p:nvSpPr>
-        <p:spPr>
-          <a:xfrm>
-            <a:off x="406390" y="3283857"/>
-            <a:ext cx="1645920" cy="224971"/>
+          <p:cNvPr id="30" name="Shape 28"/>
+          <p:cNvSpPr/>
+          <p:nvPr/>
+        </p:nvSpPr>
+        <p:spPr>
+          <a:xfrm>
+            <a:off x="3926648" y="3889502"/>
+            <a:ext cx="943130" cy="242519"/>
           </a:xfrm>
           <a:prstGeom prst="roundRect">
             <a:avLst>
-              <a:gd name="adj" fmla="val 32516"/>
+              <a:gd name="adj" fmla="val 30163"/>
             </a:avLst>
           </a:prstGeom>
           <a:solidFill>
@@ -9851,14 +9890,14 @@
       </p:sp>
       <p:sp>
         <p:nvSpPr>
-          <p:cNvPr id="30" name="Text 28"/>
-          <p:cNvSpPr/>
-          <p:nvPr/>
-        </p:nvSpPr>
-        <p:spPr>
-          <a:xfrm>
-            <a:off x="461254" y="3338721"/>
-            <a:ext cx="1536192" cy="115243"/>
+          <p:cNvPr id="31" name="Text 29"/>
+          <p:cNvSpPr/>
+          <p:nvPr/>
+        </p:nvSpPr>
+        <p:spPr>
+          <a:xfrm>
+            <a:off x="3981512" y="3944366"/>
+            <a:ext cx="833402" cy="132791"/>
           </a:xfrm>
           <a:prstGeom prst="rect">
             <a:avLst/>
@@ -9890,18 +9929,18 @@
       </p:sp>
       <p:sp>
         <p:nvSpPr>
-          <p:cNvPr id="31" name="Shape 29"/>
-          <p:cNvSpPr/>
-          <p:nvPr/>
-        </p:nvSpPr>
-        <p:spPr>
-          <a:xfrm>
-            <a:off x="406390" y="3585029"/>
-            <a:ext cx="1645920" cy="224971"/>
+          <p:cNvPr id="32" name="Shape 30"/>
+          <p:cNvSpPr/>
+          <p:nvPr/>
+        </p:nvSpPr>
+        <p:spPr>
+          <a:xfrm>
+            <a:off x="3926648" y="4253281"/>
+            <a:ext cx="943130" cy="242519"/>
           </a:xfrm>
           <a:prstGeom prst="roundRect">
             <a:avLst>
-              <a:gd name="adj" fmla="val 32516"/>
+              <a:gd name="adj" fmla="val 30163"/>
             </a:avLst>
           </a:prstGeom>
           <a:solidFill>
@@ -9917,14 +9956,14 @@
       </p:sp>
       <p:sp>
         <p:nvSpPr>
-          <p:cNvPr id="32" name="Text 30"/>
-          <p:cNvSpPr/>
-          <p:nvPr/>
-        </p:nvSpPr>
-        <p:spPr>
-          <a:xfrm>
-            <a:off x="461254" y="3639893"/>
-            <a:ext cx="1536192" cy="115243"/>
+          <p:cNvPr id="33" name="Text 31"/>
+          <p:cNvSpPr/>
+          <p:nvPr/>
+        </p:nvSpPr>
+        <p:spPr>
+          <a:xfrm>
+            <a:off x="3981512" y="4308145"/>
+            <a:ext cx="833402" cy="132791"/>
           </a:xfrm>
           <a:prstGeom prst="rect">
             <a:avLst/>
@@ -9956,13 +9995,13 @@
       </p:sp>
       <p:sp>
         <p:nvSpPr>
-          <p:cNvPr id="33" name="Shape 31"/>
-          <p:cNvSpPr/>
-          <p:nvPr/>
-        </p:nvSpPr>
-        <p:spPr>
-          <a:xfrm>
-            <a:off x="406390" y="3987800"/>
+          <p:cNvPr id="34" name="Shape 32"/>
+          <p:cNvSpPr/>
+          <p:nvPr/>
+        </p:nvSpPr>
+        <p:spPr>
+          <a:xfrm>
+            <a:off x="406390" y="4673600"/>
             <a:ext cx="11378916" cy="831850"/>
           </a:xfrm>
           <a:prstGeom prst="roundRect">
@@ -9983,13 +10022,13 @@
       </p:sp>
       <p:sp>
         <p:nvSpPr>
-          <p:cNvPr id="34" name="Text 32"/>
-          <p:cNvSpPr/>
-          <p:nvPr/>
-        </p:nvSpPr>
-        <p:spPr>
-          <a:xfrm>
-            <a:off x="543550" y="4060952"/>
+          <p:cNvPr id="35" name="Text 33"/>
+          <p:cNvSpPr/>
+          <p:nvPr/>
+        </p:nvSpPr>
+        <p:spPr>
+          <a:xfrm>
+            <a:off x="543550" y="4746752"/>
             <a:ext cx="11104596" cy="274320"/>
           </a:xfrm>
           <a:prstGeom prst="rect">
@@ -10022,13 +10061,13 @@
       </p:sp>
       <p:sp>
         <p:nvSpPr>
-          <p:cNvPr id="35" name="Text 33"/>
-          <p:cNvSpPr/>
-          <p:nvPr/>
-        </p:nvSpPr>
-        <p:spPr>
-          <a:xfrm>
-            <a:off x="543550" y="4380992"/>
+          <p:cNvPr id="36" name="Text 34"/>
+          <p:cNvSpPr/>
+          <p:nvPr/>
+        </p:nvSpPr>
+        <p:spPr>
+          <a:xfrm>
+            <a:off x="543550" y="5066792"/>
             <a:ext cx="11104596" cy="365506"/>
           </a:xfrm>
           <a:prstGeom prst="rect">
@@ -10061,7 +10100,7 @@
       </p:sp>
       <p:sp>
         <p:nvSpPr>
-          <p:cNvPr id="36" name="Text 34"/>
+          <p:cNvPr id="37" name="Text 35"/>
           <p:cNvSpPr/>
           <p:nvPr/>
         </p:nvSpPr>
@@ -10210,14 +10249,53 @@
       </p:sp>
       <p:sp>
         <p:nvSpPr>
-          <p:cNvPr id="4" name="Shape 2"/>
-          <p:cNvSpPr/>
-          <p:nvPr/>
-        </p:nvSpPr>
-        <p:spPr>
-          <a:xfrm>
-            <a:off x="1619914" y="1890486"/>
-            <a:ext cx="819554" cy="903514"/>
+          <p:cNvPr id="4" name="Text 2"/>
+          <p:cNvSpPr/>
+          <p:nvPr/>
+        </p:nvSpPr>
+        <p:spPr>
+          <a:xfrm>
+            <a:off x="406390" y="1778000"/>
+            <a:ext cx="11378916" cy="256032"/>
+          </a:xfrm>
+          <a:prstGeom prst="rect">
+            <a:avLst/>
+          </a:prstGeom>
+          <a:noFill/>
+          <a:ln/>
+        </p:spPr>
+        <p:txBody>
+          <a:bodyPr wrap="square" rtlCol="0" anchor="ctr"/>
+          <a:lstStyle/>
+          <a:p>
+            <a:pPr algn="ctr" indent="0" marL="0">
+              <a:buNone/>
+            </a:pPr>
+            <a:r>
+              <a:rPr lang="en-US" sz="1200" b="1" dirty="0">
+                <a:solidFill>
+                  <a:srgbClr val="FF2E88"/>
+                </a:solidFill>
+                <a:latin typeface="Trebuchet MS" pitchFamily="34" charset="0"/>
+                <a:ea typeface="Trebuchet MS" pitchFamily="34" charset="-122"/>
+                <a:cs typeface="Trebuchet MS" pitchFamily="34" charset="-120"/>
+              </a:rPr>
+              <a:t>Pipeline di Compilazione Deterministica</a:t>
+            </a:r>
+            <a:endParaRPr lang="en-US" sz="1200" dirty="0"/>
+          </a:p>
+        </p:txBody>
+      </p:sp>
+      <p:sp>
+        <p:nvSpPr>
+          <p:cNvPr id="5" name="Shape 3"/>
+          <p:cNvSpPr/>
+          <p:nvPr/>
+        </p:nvSpPr>
+        <p:spPr>
+          <a:xfrm>
+            <a:off x="3782933" y="2191868"/>
+            <a:ext cx="188626" cy="1091336"/>
           </a:xfrm>
           <a:prstGeom prst="line">
             <a:avLst/>
@@ -10234,14 +10312,14 @@
       </p:sp>
       <p:sp>
         <p:nvSpPr>
-          <p:cNvPr id="5" name="Shape 3"/>
-          <p:cNvSpPr/>
-          <p:nvPr/>
-        </p:nvSpPr>
-        <p:spPr>
-          <a:xfrm>
-            <a:off x="3652992" y="2794000"/>
-            <a:ext cx="819554" cy="9144"/>
+          <p:cNvPr id="6" name="Shape 4"/>
+          <p:cNvSpPr/>
+          <p:nvPr/>
+        </p:nvSpPr>
+        <p:spPr>
+          <a:xfrm>
+            <a:off x="4892234" y="3283204"/>
+            <a:ext cx="188626" cy="9144"/>
           </a:xfrm>
           <a:prstGeom prst="line">
             <a:avLst/>
@@ -10258,14 +10336,14 @@
       </p:sp>
       <p:sp>
         <p:nvSpPr>
-          <p:cNvPr id="6" name="Shape 4"/>
-          <p:cNvSpPr/>
-          <p:nvPr/>
-        </p:nvSpPr>
-        <p:spPr>
-          <a:xfrm>
-            <a:off x="5686070" y="2794000"/>
-            <a:ext cx="819554" cy="9144"/>
+          <p:cNvPr id="7" name="Shape 5"/>
+          <p:cNvSpPr/>
+          <p:nvPr/>
+        </p:nvSpPr>
+        <p:spPr>
+          <a:xfrm>
+            <a:off x="6001535" y="3283204"/>
+            <a:ext cx="188626" cy="9144"/>
           </a:xfrm>
           <a:prstGeom prst="line">
             <a:avLst/>
@@ -10282,14 +10360,14 @@
       </p:sp>
       <p:sp>
         <p:nvSpPr>
-          <p:cNvPr id="7" name="Shape 5"/>
-          <p:cNvSpPr/>
-          <p:nvPr/>
-        </p:nvSpPr>
-        <p:spPr>
-          <a:xfrm>
-            <a:off x="7719149" y="2794000"/>
-            <a:ext cx="819554" cy="9144"/>
+          <p:cNvPr id="8" name="Shape 6"/>
+          <p:cNvSpPr/>
+          <p:nvPr/>
+        </p:nvSpPr>
+        <p:spPr>
+          <a:xfrm>
+            <a:off x="7110835" y="3283204"/>
+            <a:ext cx="188626" cy="9144"/>
           </a:xfrm>
           <a:prstGeom prst="line">
             <a:avLst/>
@@ -10306,14 +10384,14 @@
       </p:sp>
       <p:sp>
         <p:nvSpPr>
-          <p:cNvPr id="8" name="Shape 6"/>
-          <p:cNvSpPr/>
-          <p:nvPr/>
-        </p:nvSpPr>
-        <p:spPr>
-          <a:xfrm>
-            <a:off x="9752227" y="2794000"/>
-            <a:ext cx="819554" cy="9144"/>
+          <p:cNvPr id="9" name="Shape 7"/>
+          <p:cNvSpPr/>
+          <p:nvPr/>
+        </p:nvSpPr>
+        <p:spPr>
+          <a:xfrm>
+            <a:off x="8220136" y="3283204"/>
+            <a:ext cx="188626" cy="9144"/>
           </a:xfrm>
           <a:prstGeom prst="line">
             <a:avLst/>
@@ -10330,18 +10408,18 @@
       </p:sp>
       <p:sp>
         <p:nvSpPr>
-          <p:cNvPr id="9" name="Shape 7"/>
-          <p:cNvSpPr/>
-          <p:nvPr/>
-        </p:nvSpPr>
-        <p:spPr>
-          <a:xfrm>
-            <a:off x="406390" y="1778000"/>
-            <a:ext cx="1213524" cy="224971"/>
+          <p:cNvPr id="10" name="Shape 8"/>
+          <p:cNvSpPr/>
+          <p:nvPr/>
+        </p:nvSpPr>
+        <p:spPr>
+          <a:xfrm>
+            <a:off x="2862258" y="2070608"/>
+            <a:ext cx="920675" cy="242519"/>
           </a:xfrm>
           <a:prstGeom prst="roundRect">
             <a:avLst>
-              <a:gd name="adj" fmla="val 32516"/>
+              <a:gd name="adj" fmla="val 30163"/>
             </a:avLst>
           </a:prstGeom>
           <a:solidFill>
@@ -10357,14 +10435,14 @@
       </p:sp>
       <p:sp>
         <p:nvSpPr>
-          <p:cNvPr id="10" name="Text 8"/>
-          <p:cNvSpPr/>
-          <p:nvPr/>
-        </p:nvSpPr>
-        <p:spPr>
-          <a:xfrm>
-            <a:off x="461254" y="1832864"/>
-            <a:ext cx="1103796" cy="115243"/>
+          <p:cNvPr id="11" name="Text 9"/>
+          <p:cNvSpPr/>
+          <p:nvPr/>
+        </p:nvSpPr>
+        <p:spPr>
+          <a:xfrm>
+            <a:off x="2917122" y="2125472"/>
+            <a:ext cx="810947" cy="132791"/>
           </a:xfrm>
           <a:prstGeom prst="rect">
             <a:avLst/>
@@ -10396,18 +10474,18 @@
       </p:sp>
       <p:sp>
         <p:nvSpPr>
-          <p:cNvPr id="11" name="Shape 9"/>
-          <p:cNvSpPr/>
-          <p:nvPr/>
-        </p:nvSpPr>
-        <p:spPr>
-          <a:xfrm>
-            <a:off x="2439468" y="2681514"/>
-            <a:ext cx="1213524" cy="224971"/>
+          <p:cNvPr id="12" name="Shape 10"/>
+          <p:cNvSpPr/>
+          <p:nvPr/>
+        </p:nvSpPr>
+        <p:spPr>
+          <a:xfrm>
+            <a:off x="3971559" y="3161944"/>
+            <a:ext cx="920675" cy="242519"/>
           </a:xfrm>
           <a:prstGeom prst="roundRect">
             <a:avLst>
-              <a:gd name="adj" fmla="val 32516"/>
+              <a:gd name="adj" fmla="val 30163"/>
             </a:avLst>
           </a:prstGeom>
           <a:solidFill>
@@ -10423,14 +10501,14 @@
       </p:sp>
       <p:sp>
         <p:nvSpPr>
-          <p:cNvPr id="12" name="Text 10"/>
-          <p:cNvSpPr/>
-          <p:nvPr/>
-        </p:nvSpPr>
-        <p:spPr>
-          <a:xfrm>
-            <a:off x="2494332" y="2736378"/>
-            <a:ext cx="1103796" cy="115243"/>
+          <p:cNvPr id="13" name="Text 11"/>
+          <p:cNvSpPr/>
+          <p:nvPr/>
+        </p:nvSpPr>
+        <p:spPr>
+          <a:xfrm>
+            <a:off x="4026423" y="3216808"/>
+            <a:ext cx="810947" cy="132791"/>
           </a:xfrm>
           <a:prstGeom prst="rect">
             <a:avLst/>
@@ -10462,18 +10540,18 @@
       </p:sp>
       <p:sp>
         <p:nvSpPr>
-          <p:cNvPr id="13" name="Shape 11"/>
-          <p:cNvSpPr/>
-          <p:nvPr/>
-        </p:nvSpPr>
-        <p:spPr>
-          <a:xfrm>
-            <a:off x="4472546" y="2681514"/>
-            <a:ext cx="1213524" cy="224971"/>
+          <p:cNvPr id="14" name="Shape 12"/>
+          <p:cNvSpPr/>
+          <p:nvPr/>
+        </p:nvSpPr>
+        <p:spPr>
+          <a:xfrm>
+            <a:off x="5080860" y="3161944"/>
+            <a:ext cx="920675" cy="242519"/>
           </a:xfrm>
           <a:prstGeom prst="roundRect">
             <a:avLst>
-              <a:gd name="adj" fmla="val 32516"/>
+              <a:gd name="adj" fmla="val 30163"/>
             </a:avLst>
           </a:prstGeom>
           <a:solidFill>
@@ -10489,14 +10567,14 @@
       </p:sp>
       <p:sp>
         <p:nvSpPr>
-          <p:cNvPr id="14" name="Text 12"/>
-          <p:cNvSpPr/>
-          <p:nvPr/>
-        </p:nvSpPr>
-        <p:spPr>
-          <a:xfrm>
-            <a:off x="4527410" y="2736378"/>
-            <a:ext cx="1103796" cy="115243"/>
+          <p:cNvPr id="15" name="Text 13"/>
+          <p:cNvSpPr/>
+          <p:nvPr/>
+        </p:nvSpPr>
+        <p:spPr>
+          <a:xfrm>
+            <a:off x="5135724" y="3216808"/>
+            <a:ext cx="810947" cy="132791"/>
           </a:xfrm>
           <a:prstGeom prst="rect">
             <a:avLst/>
@@ -10520,7 +10598,7 @@
                 <a:ea typeface="Trebuchet MS" pitchFamily="34" charset="-122"/>
                 <a:cs typeface="Trebuchet MS" pitchFamily="34" charset="-120"/>
               </a:rPr>
-              <a:t>Design Linter</a:t>
+              <a:t>Design Lint…</a:t>
             </a:r>
             <a:endParaRPr lang="en-US" sz="1100" dirty="0"/>
           </a:p>
@@ -10528,18 +10606,18 @@
       </p:sp>
       <p:sp>
         <p:nvSpPr>
-          <p:cNvPr id="15" name="Shape 13"/>
-          <p:cNvSpPr/>
-          <p:nvPr/>
-        </p:nvSpPr>
-        <p:spPr>
-          <a:xfrm>
-            <a:off x="6505625" y="2681514"/>
-            <a:ext cx="1213524" cy="224971"/>
+          <p:cNvPr id="16" name="Shape 14"/>
+          <p:cNvSpPr/>
+          <p:nvPr/>
+        </p:nvSpPr>
+        <p:spPr>
+          <a:xfrm>
+            <a:off x="6190161" y="3161944"/>
+            <a:ext cx="920675" cy="242519"/>
           </a:xfrm>
           <a:prstGeom prst="roundRect">
             <a:avLst>
-              <a:gd name="adj" fmla="val 32516"/>
+              <a:gd name="adj" fmla="val 30163"/>
             </a:avLst>
           </a:prstGeom>
           <a:solidFill>
@@ -10555,14 +10633,14 @@
       </p:sp>
       <p:sp>
         <p:nvSpPr>
-          <p:cNvPr id="16" name="Text 14"/>
-          <p:cNvSpPr/>
-          <p:nvPr/>
-        </p:nvSpPr>
-        <p:spPr>
-          <a:xfrm>
-            <a:off x="6560489" y="2736378"/>
-            <a:ext cx="1103796" cy="115243"/>
+          <p:cNvPr id="17" name="Text 15"/>
+          <p:cNvSpPr/>
+          <p:nvPr/>
+        </p:nvSpPr>
+        <p:spPr>
+          <a:xfrm>
+            <a:off x="6245025" y="3216808"/>
+            <a:ext cx="810947" cy="132791"/>
           </a:xfrm>
           <a:prstGeom prst="rect">
             <a:avLst/>
@@ -10594,18 +10672,18 @@
       </p:sp>
       <p:sp>
         <p:nvSpPr>
-          <p:cNvPr id="17" name="Shape 15"/>
-          <p:cNvSpPr/>
-          <p:nvPr/>
-        </p:nvSpPr>
-        <p:spPr>
-          <a:xfrm>
-            <a:off x="8538703" y="2681514"/>
-            <a:ext cx="1213524" cy="224971"/>
+          <p:cNvPr id="18" name="Shape 16"/>
+          <p:cNvSpPr/>
+          <p:nvPr/>
+        </p:nvSpPr>
+        <p:spPr>
+          <a:xfrm>
+            <a:off x="7299461" y="3161944"/>
+            <a:ext cx="920675" cy="242519"/>
           </a:xfrm>
           <a:prstGeom prst="roundRect">
             <a:avLst>
-              <a:gd name="adj" fmla="val 32516"/>
+              <a:gd name="adj" fmla="val 30163"/>
             </a:avLst>
           </a:prstGeom>
           <a:solidFill>
@@ -10621,14 +10699,14 @@
       </p:sp>
       <p:sp>
         <p:nvSpPr>
-          <p:cNvPr id="18" name="Text 16"/>
-          <p:cNvSpPr/>
-          <p:nvPr/>
-        </p:nvSpPr>
-        <p:spPr>
-          <a:xfrm>
-            <a:off x="8593567" y="2736378"/>
-            <a:ext cx="1103796" cy="115243"/>
+          <p:cNvPr id="19" name="Text 17"/>
+          <p:cNvSpPr/>
+          <p:nvPr/>
+        </p:nvSpPr>
+        <p:spPr>
+          <a:xfrm>
+            <a:off x="7354325" y="3216808"/>
+            <a:ext cx="810947" cy="132791"/>
           </a:xfrm>
           <a:prstGeom prst="rect">
             <a:avLst/>
@@ -10652,7 +10730,7 @@
                 <a:ea typeface="Trebuchet MS" pitchFamily="34" charset="-122"/>
                 <a:cs typeface="Trebuchet MS" pitchFamily="34" charset="-120"/>
               </a:rPr>
-              <a:t>Layout Engine</a:t>
+              <a:t>Layout Engi…</a:t>
             </a:r>
             <a:endParaRPr lang="en-US" sz="1100" dirty="0"/>
           </a:p>
@@ -10660,18 +10738,18 @@
       </p:sp>
       <p:sp>
         <p:nvSpPr>
-          <p:cNvPr id="19" name="Shape 17"/>
-          <p:cNvSpPr/>
-          <p:nvPr/>
-        </p:nvSpPr>
-        <p:spPr>
-          <a:xfrm>
-            <a:off x="10571781" y="2681514"/>
-            <a:ext cx="1213524" cy="224971"/>
+          <p:cNvPr id="20" name="Shape 18"/>
+          <p:cNvSpPr/>
+          <p:nvPr/>
+        </p:nvSpPr>
+        <p:spPr>
+          <a:xfrm>
+            <a:off x="8408762" y="3161944"/>
+            <a:ext cx="920675" cy="242519"/>
           </a:xfrm>
           <a:prstGeom prst="roundRect">
             <a:avLst>
-              <a:gd name="adj" fmla="val 32516"/>
+              <a:gd name="adj" fmla="val 30163"/>
             </a:avLst>
           </a:prstGeom>
           <a:solidFill>
@@ -10687,14 +10765,14 @@
       </p:sp>
       <p:sp>
         <p:nvSpPr>
-          <p:cNvPr id="20" name="Text 18"/>
-          <p:cNvSpPr/>
-          <p:nvPr/>
-        </p:nvSpPr>
-        <p:spPr>
-          <a:xfrm>
-            <a:off x="10626645" y="2736378"/>
-            <a:ext cx="1103796" cy="115243"/>
+          <p:cNvPr id="21" name="Text 19"/>
+          <p:cNvSpPr/>
+          <p:nvPr/>
+        </p:nvSpPr>
+        <p:spPr>
+          <a:xfrm>
+            <a:off x="8463626" y="3216808"/>
+            <a:ext cx="810947" cy="132791"/>
           </a:xfrm>
           <a:prstGeom prst="rect">
             <a:avLst/>
@@ -10718,7 +10796,7 @@
                 <a:ea typeface="Trebuchet MS" pitchFamily="34" charset="-122"/>
                 <a:cs typeface="Trebuchet MS" pitchFamily="34" charset="-120"/>
               </a:rPr>
-              <a:t>Renderer Multipli</a:t>
+              <a:t>Renderer Mu…</a:t>
             </a:r>
             <a:endParaRPr lang="en-US" sz="1100" dirty="0"/>
           </a:p>
@@ -10726,18 +10804,18 @@
       </p:sp>
       <p:sp>
         <p:nvSpPr>
-          <p:cNvPr id="21" name="Shape 19"/>
-          <p:cNvSpPr/>
-          <p:nvPr/>
-        </p:nvSpPr>
-        <p:spPr>
-          <a:xfrm>
-            <a:off x="406390" y="2079171"/>
-            <a:ext cx="1213524" cy="224971"/>
+          <p:cNvPr id="22" name="Shape 20"/>
+          <p:cNvSpPr/>
+          <p:nvPr/>
+        </p:nvSpPr>
+        <p:spPr>
+          <a:xfrm>
+            <a:off x="2862258" y="2434387"/>
+            <a:ext cx="920675" cy="242519"/>
           </a:xfrm>
           <a:prstGeom prst="roundRect">
             <a:avLst>
-              <a:gd name="adj" fmla="val 32516"/>
+              <a:gd name="adj" fmla="val 30163"/>
             </a:avLst>
           </a:prstGeom>
           <a:solidFill>
@@ -10753,14 +10831,14 @@
       </p:sp>
       <p:sp>
         <p:nvSpPr>
-          <p:cNvPr id="22" name="Text 20"/>
-          <p:cNvSpPr/>
-          <p:nvPr/>
-        </p:nvSpPr>
-        <p:spPr>
-          <a:xfrm>
-            <a:off x="461254" y="2134035"/>
-            <a:ext cx="1103796" cy="115243"/>
+          <p:cNvPr id="23" name="Text 21"/>
+          <p:cNvSpPr/>
+          <p:nvPr/>
+        </p:nvSpPr>
+        <p:spPr>
+          <a:xfrm>
+            <a:off x="2917122" y="2489251"/>
+            <a:ext cx="810947" cy="132791"/>
           </a:xfrm>
           <a:prstGeom prst="rect">
             <a:avLst/>
@@ -10792,18 +10870,18 @@
       </p:sp>
       <p:sp>
         <p:nvSpPr>
-          <p:cNvPr id="23" name="Shape 21"/>
-          <p:cNvSpPr/>
-          <p:nvPr/>
-        </p:nvSpPr>
-        <p:spPr>
-          <a:xfrm>
-            <a:off x="406390" y="2380343"/>
-            <a:ext cx="1213524" cy="224971"/>
+          <p:cNvPr id="24" name="Shape 22"/>
+          <p:cNvSpPr/>
+          <p:nvPr/>
+        </p:nvSpPr>
+        <p:spPr>
+          <a:xfrm>
+            <a:off x="2862258" y="2798166"/>
+            <a:ext cx="920675" cy="242519"/>
           </a:xfrm>
           <a:prstGeom prst="roundRect">
             <a:avLst>
-              <a:gd name="adj" fmla="val 32516"/>
+              <a:gd name="adj" fmla="val 30163"/>
             </a:avLst>
           </a:prstGeom>
           <a:solidFill>
@@ -10819,14 +10897,14 @@
       </p:sp>
       <p:sp>
         <p:nvSpPr>
-          <p:cNvPr id="24" name="Text 22"/>
-          <p:cNvSpPr/>
-          <p:nvPr/>
-        </p:nvSpPr>
-        <p:spPr>
-          <a:xfrm>
-            <a:off x="461254" y="2435207"/>
-            <a:ext cx="1103796" cy="115243"/>
+          <p:cNvPr id="25" name="Text 23"/>
+          <p:cNvSpPr/>
+          <p:nvPr/>
+        </p:nvSpPr>
+        <p:spPr>
+          <a:xfrm>
+            <a:off x="2917122" y="2853030"/>
+            <a:ext cx="810947" cy="132791"/>
           </a:xfrm>
           <a:prstGeom prst="rect">
             <a:avLst/>
@@ -10858,18 +10936,18 @@
       </p:sp>
       <p:sp>
         <p:nvSpPr>
-          <p:cNvPr id="25" name="Shape 23"/>
-          <p:cNvSpPr/>
-          <p:nvPr/>
-        </p:nvSpPr>
-        <p:spPr>
-          <a:xfrm>
-            <a:off x="406390" y="2681514"/>
-            <a:ext cx="1213524" cy="224971"/>
+          <p:cNvPr id="26" name="Shape 24"/>
+          <p:cNvSpPr/>
+          <p:nvPr/>
+        </p:nvSpPr>
+        <p:spPr>
+          <a:xfrm>
+            <a:off x="2862258" y="3161944"/>
+            <a:ext cx="920675" cy="242519"/>
           </a:xfrm>
           <a:prstGeom prst="roundRect">
             <a:avLst>
-              <a:gd name="adj" fmla="val 32516"/>
+              <a:gd name="adj" fmla="val 30163"/>
             </a:avLst>
           </a:prstGeom>
           <a:solidFill>
@@ -10885,14 +10963,14 @@
       </p:sp>
       <p:sp>
         <p:nvSpPr>
-          <p:cNvPr id="26" name="Text 24"/>
-          <p:cNvSpPr/>
-          <p:nvPr/>
-        </p:nvSpPr>
-        <p:spPr>
-          <a:xfrm>
-            <a:off x="461254" y="2736378"/>
-            <a:ext cx="1103796" cy="115243"/>
+          <p:cNvPr id="27" name="Text 25"/>
+          <p:cNvSpPr/>
+          <p:nvPr/>
+        </p:nvSpPr>
+        <p:spPr>
+          <a:xfrm>
+            <a:off x="2917122" y="3216808"/>
+            <a:ext cx="810947" cy="132791"/>
           </a:xfrm>
           <a:prstGeom prst="rect">
             <a:avLst/>
@@ -10924,18 +11002,18 @@
       </p:sp>
       <p:sp>
         <p:nvSpPr>
-          <p:cNvPr id="27" name="Shape 25"/>
-          <p:cNvSpPr/>
-          <p:nvPr/>
-        </p:nvSpPr>
-        <p:spPr>
-          <a:xfrm>
-            <a:off x="406390" y="2982686"/>
-            <a:ext cx="1213524" cy="224971"/>
+          <p:cNvPr id="28" name="Shape 26"/>
+          <p:cNvSpPr/>
+          <p:nvPr/>
+        </p:nvSpPr>
+        <p:spPr>
+          <a:xfrm>
+            <a:off x="2862258" y="3525723"/>
+            <a:ext cx="920675" cy="242519"/>
           </a:xfrm>
           <a:prstGeom prst="roundRect">
             <a:avLst>
-              <a:gd name="adj" fmla="val 32516"/>
+              <a:gd name="adj" fmla="val 30163"/>
             </a:avLst>
           </a:prstGeom>
           <a:solidFill>
@@ -10951,14 +11029,14 @@
       </p:sp>
       <p:sp>
         <p:nvSpPr>
-          <p:cNvPr id="28" name="Text 26"/>
-          <p:cNvSpPr/>
-          <p:nvPr/>
-        </p:nvSpPr>
-        <p:spPr>
-          <a:xfrm>
-            <a:off x="461254" y="3037550"/>
-            <a:ext cx="1103796" cy="115243"/>
+          <p:cNvPr id="29" name="Text 27"/>
+          <p:cNvSpPr/>
+          <p:nvPr/>
+        </p:nvSpPr>
+        <p:spPr>
+          <a:xfrm>
+            <a:off x="2917122" y="3580587"/>
+            <a:ext cx="810947" cy="132791"/>
           </a:xfrm>
           <a:prstGeom prst="rect">
             <a:avLst/>
@@ -10990,18 +11068,18 @@
       </p:sp>
       <p:sp>
         <p:nvSpPr>
-          <p:cNvPr id="29" name="Shape 27"/>
-          <p:cNvSpPr/>
-          <p:nvPr/>
-        </p:nvSpPr>
-        <p:spPr>
-          <a:xfrm>
-            <a:off x="406390" y="3283857"/>
-            <a:ext cx="1213524" cy="224971"/>
+          <p:cNvPr id="30" name="Shape 28"/>
+          <p:cNvSpPr/>
+          <p:nvPr/>
+        </p:nvSpPr>
+        <p:spPr>
+          <a:xfrm>
+            <a:off x="2862258" y="3889502"/>
+            <a:ext cx="920675" cy="242519"/>
           </a:xfrm>
           <a:prstGeom prst="roundRect">
             <a:avLst>
-              <a:gd name="adj" fmla="val 32516"/>
+              <a:gd name="adj" fmla="val 30163"/>
             </a:avLst>
           </a:prstGeom>
           <a:solidFill>
@@ -11017,14 +11095,14 @@
       </p:sp>
       <p:sp>
         <p:nvSpPr>
-          <p:cNvPr id="30" name="Text 28"/>
-          <p:cNvSpPr/>
-          <p:nvPr/>
-        </p:nvSpPr>
-        <p:spPr>
-          <a:xfrm>
-            <a:off x="461254" y="3338721"/>
-            <a:ext cx="1103796" cy="115243"/>
+          <p:cNvPr id="31" name="Text 29"/>
+          <p:cNvSpPr/>
+          <p:nvPr/>
+        </p:nvSpPr>
+        <p:spPr>
+          <a:xfrm>
+            <a:off x="2917122" y="3944366"/>
+            <a:ext cx="810947" cy="132791"/>
           </a:xfrm>
           <a:prstGeom prst="rect">
             <a:avLst/>
@@ -11056,18 +11134,18 @@
       </p:sp>
       <p:sp>
         <p:nvSpPr>
-          <p:cNvPr id="31" name="Shape 29"/>
-          <p:cNvSpPr/>
-          <p:nvPr/>
-        </p:nvSpPr>
-        <p:spPr>
-          <a:xfrm>
-            <a:off x="406390" y="3585029"/>
-            <a:ext cx="1213524" cy="224971"/>
+          <p:cNvPr id="32" name="Shape 30"/>
+          <p:cNvSpPr/>
+          <p:nvPr/>
+        </p:nvSpPr>
+        <p:spPr>
+          <a:xfrm>
+            <a:off x="2862258" y="4253281"/>
+            <a:ext cx="920675" cy="242519"/>
           </a:xfrm>
           <a:prstGeom prst="roundRect">
             <a:avLst>
-              <a:gd name="adj" fmla="val 32516"/>
+              <a:gd name="adj" fmla="val 30163"/>
             </a:avLst>
           </a:prstGeom>
           <a:solidFill>
@@ -11083,14 +11161,14 @@
       </p:sp>
       <p:sp>
         <p:nvSpPr>
-          <p:cNvPr id="32" name="Text 30"/>
-          <p:cNvSpPr/>
-          <p:nvPr/>
-        </p:nvSpPr>
-        <p:spPr>
-          <a:xfrm>
-            <a:off x="461254" y="3639893"/>
-            <a:ext cx="1103796" cy="115243"/>
+          <p:cNvPr id="33" name="Text 31"/>
+          <p:cNvSpPr/>
+          <p:nvPr/>
+        </p:nvSpPr>
+        <p:spPr>
+          <a:xfrm>
+            <a:off x="2917122" y="4308145"/>
+            <a:ext cx="810947" cy="132791"/>
           </a:xfrm>
           <a:prstGeom prst="rect">
             <a:avLst/>
@@ -11122,13 +11200,13 @@
       </p:sp>
       <p:sp>
         <p:nvSpPr>
-          <p:cNvPr id="33" name="Shape 31"/>
-          <p:cNvSpPr/>
-          <p:nvPr/>
-        </p:nvSpPr>
-        <p:spPr>
-          <a:xfrm>
-            <a:off x="406390" y="3987800"/>
+          <p:cNvPr id="34" name="Shape 32"/>
+          <p:cNvSpPr/>
+          <p:nvPr/>
+        </p:nvSpPr>
+        <p:spPr>
+          <a:xfrm>
+            <a:off x="406390" y="4673600"/>
             <a:ext cx="11378916" cy="831850"/>
           </a:xfrm>
           <a:prstGeom prst="roundRect">
@@ -11149,13 +11227,13 @@
       </p:sp>
       <p:sp>
         <p:nvSpPr>
-          <p:cNvPr id="34" name="Text 32"/>
-          <p:cNvSpPr/>
-          <p:nvPr/>
-        </p:nvSpPr>
-        <p:spPr>
-          <a:xfrm>
-            <a:off x="543550" y="4060952"/>
+          <p:cNvPr id="35" name="Text 33"/>
+          <p:cNvSpPr/>
+          <p:nvPr/>
+        </p:nvSpPr>
+        <p:spPr>
+          <a:xfrm>
+            <a:off x="543550" y="4746752"/>
             <a:ext cx="11104596" cy="274320"/>
           </a:xfrm>
           <a:prstGeom prst="rect">
@@ -11188,13 +11266,13 @@
       </p:sp>
       <p:sp>
         <p:nvSpPr>
-          <p:cNvPr id="35" name="Text 33"/>
-          <p:cNvSpPr/>
-          <p:nvPr/>
-        </p:nvSpPr>
-        <p:spPr>
-          <a:xfrm>
-            <a:off x="543550" y="4380992"/>
+          <p:cNvPr id="36" name="Text 34"/>
+          <p:cNvSpPr/>
+          <p:nvPr/>
+        </p:nvSpPr>
+        <p:spPr>
+          <a:xfrm>
+            <a:off x="543550" y="5066792"/>
             <a:ext cx="11104596" cy="365506"/>
           </a:xfrm>
           <a:prstGeom prst="rect">
@@ -11227,7 +11305,7 @@
       </p:sp>
       <p:sp>
         <p:nvSpPr>
-          <p:cNvPr id="36" name="Text 34"/>
+          <p:cNvPr id="37" name="Text 35"/>
           <p:cNvSpPr/>
           <p:nvPr/>
         </p:nvSpPr>

</xml_diff>

<commit_message>
fix(parser,layout,pptx): stop diagram ghost nodes, code overflow, and VS wrap
Parse full bracket labels in node directives, ignore orphan diagram aliases, size code blocks for wrapped lines, and widen compare VS badges.
</commit_message>
<xml_diff>
--- a/presentation.pptx
+++ b/presentation.pptx
@@ -2491,11 +2491,11 @@
         <p:spPr>
           <a:xfrm>
             <a:off x="406390" y="2019300"/>
-            <a:ext cx="3674441" cy="1701800"/>
+            <a:ext cx="3674441" cy="2006600"/>
           </a:xfrm>
           <a:prstGeom prst="roundRect">
             <a:avLst>
-              <a:gd name="adj" fmla="val 4299"/>
+              <a:gd name="adj" fmla="val 3646"/>
             </a:avLst>
           </a:prstGeom>
           <a:solidFill>
@@ -2518,7 +2518,7 @@
         <p:spPr>
           <a:xfrm>
             <a:off x="424678" y="2055876"/>
-            <a:ext cx="54864" cy="1628648"/>
+            <a:ext cx="54864" cy="1933448"/>
           </a:xfrm>
           <a:prstGeom prst="roundRect">
             <a:avLst>
@@ -2579,11 +2579,11 @@
         <p:spPr>
           <a:xfrm>
             <a:off x="634984" y="2705100"/>
-            <a:ext cx="3217253" cy="660400"/>
+            <a:ext cx="3217253" cy="965200"/>
           </a:xfrm>
           <a:prstGeom prst="roundRect">
             <a:avLst>
-              <a:gd name="adj" fmla="val 11077"/>
+              <a:gd name="adj" fmla="val 7579"/>
             </a:avLst>
           </a:prstGeom>
           <a:solidFill>
@@ -2680,24 +2680,24 @@
         </p:nvSpPr>
         <p:spPr>
           <a:xfrm>
-            <a:off x="817864" y="2997708"/>
-            <a:ext cx="2851493" cy="294640"/>
-          </a:xfrm>
-          <a:prstGeom prst="rect">
-            <a:avLst/>
-          </a:prstGeom>
-          <a:noFill/>
-          <a:ln/>
-        </p:spPr>
-        <p:txBody>
-          <a:bodyPr wrap="square" rtlCol="0" anchor="t"/>
+            <a:off x="836152" y="3034284"/>
+            <a:ext cx="2814917" cy="526288"/>
+          </a:xfrm>
+          <a:prstGeom prst="rect">
+            <a:avLst/>
+          </a:prstGeom>
+          <a:noFill/>
+          <a:ln/>
+        </p:spPr>
+        <p:txBody>
+          <a:bodyPr wrap="square" lIns="0" tIns="0" rIns="0" bIns="0" rtlCol="0" anchor="t"/>
           <a:lstStyle/>
           <a:p>
             <a:pPr indent="0" marL="0">
               <a:buNone/>
             </a:pPr>
             <a:r>
-              <a:rPr lang="en-US" sz="1150" dirty="0">
+              <a:rPr lang="en-US" sz="1000" dirty="0">
                 <a:solidFill>
                   <a:srgbClr val="00F0FF"/>
                 </a:solidFill>
@@ -2707,14 +2707,14 @@
               </a:rPr>
               <a:t>yumia validate pres.yumia</a:t>
             </a:r>
-            <a:endParaRPr lang="en-US" sz="1150" dirty="0"/>
+            <a:endParaRPr lang="en-US" sz="1000" dirty="0"/>
           </a:p>
           <a:p>
             <a:pPr indent="0" marL="0">
               <a:buNone/>
             </a:pPr>
             <a:r>
-              <a:rPr lang="en-US" sz="1150" dirty="0">
+              <a:rPr lang="en-US" sz="1000" dirty="0">
                 <a:solidFill>
                   <a:srgbClr val="00F0FF"/>
                 </a:solidFill>
@@ -2724,7 +2724,7 @@
               </a:rPr>
               <a:t>yumia explain pres.yumia</a:t>
             </a:r>
-            <a:endParaRPr lang="en-US" sz="1150" dirty="0"/>
+            <a:endParaRPr lang="en-US" sz="1000" dirty="0"/>
           </a:p>
         </p:txBody>
       </p:sp>
@@ -2737,11 +2737,11 @@
         <p:spPr>
           <a:xfrm>
             <a:off x="4258627" y="2019300"/>
-            <a:ext cx="3674441" cy="1701800"/>
+            <a:ext cx="3674441" cy="2006600"/>
           </a:xfrm>
           <a:prstGeom prst="roundRect">
             <a:avLst>
-              <a:gd name="adj" fmla="val 4299"/>
+              <a:gd name="adj" fmla="val 3646"/>
             </a:avLst>
           </a:prstGeom>
           <a:solidFill>
@@ -2764,7 +2764,7 @@
         <p:spPr>
           <a:xfrm>
             <a:off x="4276915" y="2055876"/>
-            <a:ext cx="54864" cy="1628648"/>
+            <a:ext cx="54864" cy="1933448"/>
           </a:xfrm>
           <a:prstGeom prst="roundRect">
             <a:avLst>
@@ -2825,11 +2825,11 @@
         <p:spPr>
           <a:xfrm>
             <a:off x="4487221" y="2705100"/>
-            <a:ext cx="3217253" cy="660400"/>
+            <a:ext cx="3217253" cy="965200"/>
           </a:xfrm>
           <a:prstGeom prst="roundRect">
             <a:avLst>
-              <a:gd name="adj" fmla="val 11077"/>
+              <a:gd name="adj" fmla="val 7579"/>
             </a:avLst>
           </a:prstGeom>
           <a:solidFill>
@@ -2926,24 +2926,24 @@
         </p:nvSpPr>
         <p:spPr>
           <a:xfrm>
-            <a:off x="4670101" y="2997708"/>
-            <a:ext cx="2851493" cy="294640"/>
-          </a:xfrm>
-          <a:prstGeom prst="rect">
-            <a:avLst/>
-          </a:prstGeom>
-          <a:noFill/>
-          <a:ln/>
-        </p:spPr>
-        <p:txBody>
-          <a:bodyPr wrap="square" rtlCol="0" anchor="t"/>
+            <a:off x="4688389" y="3034284"/>
+            <a:ext cx="2814917" cy="526288"/>
+          </a:xfrm>
+          <a:prstGeom prst="rect">
+            <a:avLst/>
+          </a:prstGeom>
+          <a:noFill/>
+          <a:ln/>
+        </p:spPr>
+        <p:txBody>
+          <a:bodyPr wrap="square" lIns="0" tIns="0" rIns="0" bIns="0" rtlCol="0" anchor="t"/>
           <a:lstStyle/>
           <a:p>
             <a:pPr indent="0" marL="0">
               <a:buNone/>
             </a:pPr>
             <a:r>
-              <a:rPr lang="en-US" sz="1150" dirty="0">
+              <a:rPr lang="en-US" sz="1000" dirty="0">
                 <a:solidFill>
                   <a:srgbClr val="00F0FF"/>
                 </a:solidFill>
@@ -2953,14 +2953,14 @@
               </a:rPr>
               <a:t>yumia dev pres.yumia --open</a:t>
             </a:r>
-            <a:endParaRPr lang="en-US" sz="1150" dirty="0"/>
+            <a:endParaRPr lang="en-US" sz="1000" dirty="0"/>
           </a:p>
           <a:p>
             <a:pPr indent="0" marL="0">
               <a:buNone/>
             </a:pPr>
             <a:r>
-              <a:rPr lang="en-US" sz="1150" dirty="0">
+              <a:rPr lang="en-US" sz="1000" dirty="0">
                 <a:solidFill>
                   <a:srgbClr val="00F0FF"/>
                 </a:solidFill>
@@ -2970,7 +2970,7 @@
               </a:rPr>
               <a:t>yumia check --optimize</a:t>
             </a:r>
-            <a:endParaRPr lang="en-US" sz="1150" dirty="0"/>
+            <a:endParaRPr lang="en-US" sz="1000" dirty="0"/>
           </a:p>
         </p:txBody>
       </p:sp>
@@ -2983,11 +2983,11 @@
         <p:spPr>
           <a:xfrm>
             <a:off x="8110864" y="2019300"/>
-            <a:ext cx="3674441" cy="1701800"/>
+            <a:ext cx="3674441" cy="2006600"/>
           </a:xfrm>
           <a:prstGeom prst="roundRect">
             <a:avLst>
-              <a:gd name="adj" fmla="val 4299"/>
+              <a:gd name="adj" fmla="val 3646"/>
             </a:avLst>
           </a:prstGeom>
           <a:solidFill>
@@ -3010,7 +3010,7 @@
         <p:spPr>
           <a:xfrm>
             <a:off x="8129152" y="2055876"/>
-            <a:ext cx="54864" cy="1628648"/>
+            <a:ext cx="54864" cy="1933448"/>
           </a:xfrm>
           <a:prstGeom prst="roundRect">
             <a:avLst>
@@ -3071,11 +3071,11 @@
         <p:spPr>
           <a:xfrm>
             <a:off x="8339458" y="2705100"/>
-            <a:ext cx="3217253" cy="660400"/>
+            <a:ext cx="3217253" cy="965200"/>
           </a:xfrm>
           <a:prstGeom prst="roundRect">
             <a:avLst>
-              <a:gd name="adj" fmla="val 11077"/>
+              <a:gd name="adj" fmla="val 7579"/>
             </a:avLst>
           </a:prstGeom>
           <a:solidFill>
@@ -3172,24 +3172,24 @@
         </p:nvSpPr>
         <p:spPr>
           <a:xfrm>
-            <a:off x="8522338" y="2997708"/>
-            <a:ext cx="2851493" cy="294640"/>
-          </a:xfrm>
-          <a:prstGeom prst="rect">
-            <a:avLst/>
-          </a:prstGeom>
-          <a:noFill/>
-          <a:ln/>
-        </p:spPr>
-        <p:txBody>
-          <a:bodyPr wrap="square" rtlCol="0" anchor="t"/>
+            <a:off x="8540626" y="3034284"/>
+            <a:ext cx="2814917" cy="526288"/>
+          </a:xfrm>
+          <a:prstGeom prst="rect">
+            <a:avLst/>
+          </a:prstGeom>
+          <a:noFill/>
+          <a:ln/>
+        </p:spPr>
+        <p:txBody>
+          <a:bodyPr wrap="square" lIns="0" tIns="0" rIns="0" bIns="0" rtlCol="0" anchor="t"/>
           <a:lstStyle/>
           <a:p>
             <a:pPr indent="0" marL="0">
               <a:buNone/>
             </a:pPr>
             <a:r>
-              <a:rPr lang="en-US" sz="1150" dirty="0">
+              <a:rPr lang="en-US" sz="1000" dirty="0">
                 <a:solidFill>
                   <a:srgbClr val="00F0FF"/>
                 </a:solidFill>
@@ -3199,14 +3199,14 @@
               </a:rPr>
               <a:t>yumia build --format pptx</a:t>
             </a:r>
-            <a:endParaRPr lang="en-US" sz="1150" dirty="0"/>
+            <a:endParaRPr lang="en-US" sz="1000" dirty="0"/>
           </a:p>
           <a:p>
             <a:pPr indent="0" marL="0">
               <a:buNone/>
             </a:pPr>
             <a:r>
-              <a:rPr lang="en-US" sz="1150" dirty="0">
+              <a:rPr lang="en-US" sz="1000" dirty="0">
                 <a:solidFill>
                   <a:srgbClr val="00F0FF"/>
                 </a:solidFill>
@@ -3216,7 +3216,7 @@
               </a:rPr>
               <a:t>yumia deploy --provider gh-pages</a:t>
             </a:r>
-            <a:endParaRPr lang="en-US" sz="1150" dirty="0"/>
+            <a:endParaRPr lang="en-US" sz="1000" dirty="0"/>
           </a:p>
         </p:txBody>
       </p:sp>
@@ -3228,12 +3228,12 @@
         </p:nvSpPr>
         <p:spPr>
           <a:xfrm>
-            <a:off x="406390" y="4076700"/>
-            <a:ext cx="11378916" cy="654050"/>
+            <a:off x="406390" y="4381500"/>
+            <a:ext cx="11378916" cy="774700"/>
           </a:xfrm>
           <a:prstGeom prst="roundRect">
             <a:avLst>
-              <a:gd name="adj" fmla="val 11184"/>
+              <a:gd name="adj" fmla="val 9443"/>
             </a:avLst>
           </a:prstGeom>
           <a:solidFill>
@@ -3255,8 +3255,8 @@
         </p:nvSpPr>
         <p:spPr>
           <a:xfrm>
-            <a:off x="543550" y="4149852"/>
-            <a:ext cx="11104596" cy="274320"/>
+            <a:off x="589270" y="4527804"/>
+            <a:ext cx="11013156" cy="274320"/>
           </a:xfrm>
           <a:prstGeom prst="rect">
             <a:avLst/>
@@ -3294,8 +3294,8 @@
         </p:nvSpPr>
         <p:spPr>
           <a:xfrm>
-            <a:off x="543550" y="4469892"/>
-            <a:ext cx="11104596" cy="187706"/>
+            <a:off x="589270" y="4856988"/>
+            <a:ext cx="11013156" cy="182880"/>
           </a:xfrm>
           <a:prstGeom prst="rect">
             <a:avLst/>
@@ -3483,7 +3483,7 @@
         <p:spPr>
           <a:xfrm>
             <a:off x="406390" y="2019300"/>
-            <a:ext cx="5506578" cy="4089400"/>
+            <a:ext cx="5460858" cy="4089400"/>
           </a:xfrm>
           <a:prstGeom prst="roundRect">
             <a:avLst>
@@ -3510,7 +3510,7 @@
         <p:spPr>
           <a:xfrm>
             <a:off x="543550" y="2156460"/>
-            <a:ext cx="5232258" cy="365760"/>
+            <a:ext cx="5186538" cy="365760"/>
           </a:xfrm>
           <a:prstGeom prst="rect">
             <a:avLst/>
@@ -3548,8 +3548,8 @@
         </p:nvSpPr>
         <p:spPr>
           <a:xfrm>
-            <a:off x="6278728" y="2019300"/>
-            <a:ext cx="5506578" cy="4089400"/>
+            <a:off x="6324448" y="2019300"/>
+            <a:ext cx="5460858" cy="4089400"/>
           </a:xfrm>
           <a:prstGeom prst="roundRect">
             <a:avLst>
@@ -3575,8 +3575,8 @@
         </p:nvSpPr>
         <p:spPr>
           <a:xfrm>
-            <a:off x="6415888" y="2156460"/>
-            <a:ext cx="5232258" cy="365760"/>
+            <a:off x="6461608" y="2156460"/>
+            <a:ext cx="5186538" cy="365760"/>
           </a:xfrm>
           <a:prstGeom prst="rect">
             <a:avLst/>
@@ -3614,18 +3614,21 @@
         </p:nvSpPr>
         <p:spPr>
           <a:xfrm>
-            <a:off x="5958688" y="3899408"/>
-            <a:ext cx="274320" cy="274320"/>
-          </a:xfrm>
-          <a:prstGeom prst="roundRect">
-            <a:avLst>
-              <a:gd name="adj" fmla="val 50000"/>
-            </a:avLst>
+            <a:off x="5903824" y="3871976"/>
+            <a:ext cx="384048" cy="384048"/>
+          </a:xfrm>
+          <a:prstGeom prst="ellipse">
+            <a:avLst/>
           </a:prstGeom>
           <a:solidFill>
-            <a:srgbClr val="2E2E48"/>
+            <a:srgbClr val="151522"/>
           </a:solidFill>
-          <a:ln/>
+          <a:ln w="19050">
+            <a:solidFill>
+              <a:srgbClr val="FF2E88"/>
+            </a:solidFill>
+            <a:prstDash val="solid"/>
+          </a:ln>
         </p:spPr>
       </p:sp>
       <p:sp>
@@ -3636,26 +3639,26 @@
         </p:nvSpPr>
         <p:spPr>
           <a:xfrm>
-            <a:off x="5958688" y="3899408"/>
-            <a:ext cx="274320" cy="274320"/>
-          </a:xfrm>
-          <a:prstGeom prst="rect">
-            <a:avLst/>
-          </a:prstGeom>
-          <a:noFill/>
-          <a:ln/>
-        </p:spPr>
-        <p:txBody>
-          <a:bodyPr wrap="square" rtlCol="0" anchor="ctr"/>
+            <a:off x="5903824" y="3871976"/>
+            <a:ext cx="384048" cy="384048"/>
+          </a:xfrm>
+          <a:prstGeom prst="rect">
+            <a:avLst/>
+          </a:prstGeom>
+          <a:noFill/>
+          <a:ln/>
+        </p:spPr>
+        <p:txBody>
+          <a:bodyPr wrap="square" lIns="0" tIns="0" rIns="0" bIns="0" rtlCol="0" anchor="ctr"/>
           <a:lstStyle/>
           <a:p>
             <a:pPr algn="ctr" indent="0" marL="0">
               <a:buNone/>
             </a:pPr>
             <a:r>
-              <a:rPr lang="en-US" sz="1000" b="1" dirty="0">
-                <a:solidFill>
-                  <a:srgbClr val="A7A7B5"/>
+              <a:rPr lang="en-US" sz="1100" b="1" dirty="0">
+                <a:solidFill>
+                  <a:srgbClr val="FFFFFF"/>
                 </a:solidFill>
                 <a:latin typeface="Trebuchet MS" pitchFamily="34" charset="0"/>
                 <a:ea typeface="Trebuchet MS" pitchFamily="34" charset="-122"/>
@@ -3663,7 +3666,7 @@
               </a:rPr>
               <a:t>VS</a:t>
             </a:r>
-            <a:endParaRPr lang="en-US" sz="1000" dirty="0"/>
+            <a:endParaRPr lang="en-US" sz="1100" dirty="0"/>
           </a:p>
         </p:txBody>
       </p:sp>
@@ -3675,7 +3678,7 @@
         </p:nvSpPr>
         <p:spPr>
           <a:xfrm>
-            <a:off x="1775634" y="2552700"/>
+            <a:off x="1731185" y="2552700"/>
             <a:ext cx="2862072" cy="330200"/>
           </a:xfrm>
           <a:prstGeom prst="roundRect">
@@ -3702,7 +3705,7 @@
         </p:nvSpPr>
         <p:spPr>
           <a:xfrm>
-            <a:off x="1775634" y="2552700"/>
+            <a:off x="1731185" y="2552700"/>
             <a:ext cx="2862072" cy="330200"/>
           </a:xfrm>
           <a:prstGeom prst="rect">
@@ -3742,7 +3745,7 @@
         <p:spPr>
           <a:xfrm>
             <a:off x="584185" y="2971800"/>
-            <a:ext cx="5244969" cy="673100"/>
+            <a:ext cx="5156071" cy="673100"/>
           </a:xfrm>
           <a:prstGeom prst="rect">
             <a:avLst/>
@@ -3781,7 +3784,7 @@
         <p:spPr>
           <a:xfrm>
             <a:off x="584185" y="3733800"/>
-            <a:ext cx="5244969" cy="673100"/>
+            <a:ext cx="5156071" cy="673100"/>
           </a:xfrm>
           <a:prstGeom prst="rect">
             <a:avLst/>
@@ -3820,7 +3823,7 @@
         <p:spPr>
           <a:xfrm>
             <a:off x="584185" y="4495800"/>
-            <a:ext cx="5244969" cy="673100"/>
+            <a:ext cx="5156071" cy="673100"/>
           </a:xfrm>
           <a:prstGeom prst="rect">
             <a:avLst/>
@@ -3859,7 +3862,7 @@
         <p:spPr>
           <a:xfrm>
             <a:off x="584185" y="5257800"/>
-            <a:ext cx="5244969" cy="368300"/>
+            <a:ext cx="5156071" cy="368300"/>
           </a:xfrm>
           <a:prstGeom prst="rect">
             <a:avLst/>
@@ -3897,7 +3900,7 @@
         </p:nvSpPr>
         <p:spPr>
           <a:xfrm>
-            <a:off x="7654573" y="2552700"/>
+            <a:off x="7699022" y="2552700"/>
             <a:ext cx="2660904" cy="330200"/>
           </a:xfrm>
           <a:prstGeom prst="roundRect">
@@ -3924,7 +3927,7 @@
         </p:nvSpPr>
         <p:spPr>
           <a:xfrm>
-            <a:off x="7654573" y="2552700"/>
+            <a:off x="7699022" y="2552700"/>
             <a:ext cx="2660904" cy="330200"/>
           </a:xfrm>
           <a:prstGeom prst="rect">
@@ -3963,8 +3966,8 @@
         </p:nvSpPr>
         <p:spPr>
           <a:xfrm>
-            <a:off x="6362541" y="2971800"/>
-            <a:ext cx="5244969" cy="673100"/>
+            <a:off x="6451439" y="2971800"/>
+            <a:ext cx="5156071" cy="673100"/>
           </a:xfrm>
           <a:prstGeom prst="rect">
             <a:avLst/>
@@ -4002,8 +4005,8 @@
         </p:nvSpPr>
         <p:spPr>
           <a:xfrm>
-            <a:off x="6362541" y="3733800"/>
-            <a:ext cx="5244969" cy="673100"/>
+            <a:off x="6451439" y="3733800"/>
+            <a:ext cx="5156071" cy="673100"/>
           </a:xfrm>
           <a:prstGeom prst="rect">
             <a:avLst/>
@@ -4041,8 +4044,8 @@
         </p:nvSpPr>
         <p:spPr>
           <a:xfrm>
-            <a:off x="6362541" y="4495800"/>
-            <a:ext cx="5244969" cy="673100"/>
+            <a:off x="6451439" y="4495800"/>
+            <a:ext cx="5156071" cy="673100"/>
           </a:xfrm>
           <a:prstGeom prst="rect">
             <a:avLst/>
@@ -4080,8 +4083,8 @@
         </p:nvSpPr>
         <p:spPr>
           <a:xfrm>
-            <a:off x="6362541" y="5257800"/>
-            <a:ext cx="5244969" cy="673100"/>
+            <a:off x="6451439" y="5257800"/>
+            <a:ext cx="5156071" cy="673100"/>
           </a:xfrm>
           <a:prstGeom prst="rect">
             <a:avLst/>
@@ -5180,11 +5183,11 @@
         <p:spPr>
           <a:xfrm>
             <a:off x="406390" y="2019300"/>
-            <a:ext cx="5600560" cy="1524000"/>
+            <a:ext cx="5600560" cy="1803400"/>
           </a:xfrm>
           <a:prstGeom prst="roundRect">
             <a:avLst>
-              <a:gd name="adj" fmla="val 4800"/>
+              <a:gd name="adj" fmla="val 4056"/>
             </a:avLst>
           </a:prstGeom>
           <a:solidFill>
@@ -5207,7 +5210,7 @@
         <p:spPr>
           <a:xfrm>
             <a:off x="424678" y="2055876"/>
-            <a:ext cx="54864" cy="1450848"/>
+            <a:ext cx="54864" cy="1730248"/>
           </a:xfrm>
           <a:prstGeom prst="roundRect">
             <a:avLst>
@@ -5268,11 +5271,11 @@
         <p:spPr>
           <a:xfrm>
             <a:off x="634984" y="2705100"/>
-            <a:ext cx="5143371" cy="482600"/>
+            <a:ext cx="5143371" cy="762000"/>
           </a:xfrm>
           <a:prstGeom prst="roundRect">
             <a:avLst>
-              <a:gd name="adj" fmla="val 15158"/>
+              <a:gd name="adj" fmla="val 9600"/>
             </a:avLst>
           </a:prstGeom>
           <a:solidFill>
@@ -5369,24 +5372,24 @@
         </p:nvSpPr>
         <p:spPr>
           <a:xfrm>
-            <a:off x="817864" y="2997708"/>
-            <a:ext cx="4777611" cy="116840"/>
-          </a:xfrm>
-          <a:prstGeom prst="rect">
-            <a:avLst/>
-          </a:prstGeom>
-          <a:noFill/>
-          <a:ln/>
-        </p:spPr>
-        <p:txBody>
-          <a:bodyPr wrap="square" rtlCol="0" anchor="t"/>
+            <a:off x="836152" y="3034284"/>
+            <a:ext cx="4741035" cy="323088"/>
+          </a:xfrm>
+          <a:prstGeom prst="rect">
+            <a:avLst/>
+          </a:prstGeom>
+          <a:noFill/>
+          <a:ln/>
+        </p:spPr>
+        <p:txBody>
+          <a:bodyPr wrap="square" lIns="0" tIns="0" rIns="0" bIns="0" rtlCol="0" anchor="t"/>
           <a:lstStyle/>
           <a:p>
             <a:pPr indent="0" marL="0">
               <a:buNone/>
             </a:pPr>
             <a:r>
-              <a:rPr lang="en-US" sz="1150" dirty="0">
+              <a:rPr lang="en-US" sz="1000" dirty="0">
                 <a:solidFill>
                   <a:srgbClr val="00F0FF"/>
                 </a:solidFill>
@@ -5396,7 +5399,7 @@
               </a:rPr>
               <a:t>:::metric value="99%" label="Uptime" change="+1%" :::</a:t>
             </a:r>
-            <a:endParaRPr lang="en-US" sz="1150" dirty="0"/>
+            <a:endParaRPr lang="en-US" sz="1000" dirty="0"/>
           </a:p>
         </p:txBody>
       </p:sp>
@@ -5408,7 +5411,7 @@
         </p:nvSpPr>
         <p:spPr>
           <a:xfrm>
-            <a:off x="406390" y="3721100"/>
+            <a:off x="406390" y="4000500"/>
             <a:ext cx="5600560" cy="673100"/>
           </a:xfrm>
           <a:prstGeom prst="rect">
@@ -5448,11 +5451,11 @@
         <p:spPr>
           <a:xfrm>
             <a:off x="6184745" y="2019300"/>
-            <a:ext cx="5600560" cy="1524000"/>
+            <a:ext cx="5600560" cy="1803400"/>
           </a:xfrm>
           <a:prstGeom prst="roundRect">
             <a:avLst>
-              <a:gd name="adj" fmla="val 4800"/>
+              <a:gd name="adj" fmla="val 4056"/>
             </a:avLst>
           </a:prstGeom>
           <a:solidFill>
@@ -5475,7 +5478,7 @@
         <p:spPr>
           <a:xfrm>
             <a:off x="6203033" y="2055876"/>
-            <a:ext cx="54864" cy="1450848"/>
+            <a:ext cx="54864" cy="1730248"/>
           </a:xfrm>
           <a:prstGeom prst="roundRect">
             <a:avLst>
@@ -5536,11 +5539,11 @@
         <p:spPr>
           <a:xfrm>
             <a:off x="6413340" y="2705100"/>
-            <a:ext cx="5143371" cy="482600"/>
+            <a:ext cx="5143371" cy="762000"/>
           </a:xfrm>
           <a:prstGeom prst="roundRect">
             <a:avLst>
-              <a:gd name="adj" fmla="val 15158"/>
+              <a:gd name="adj" fmla="val 9600"/>
             </a:avLst>
           </a:prstGeom>
           <a:solidFill>
@@ -5637,24 +5640,24 @@
         </p:nvSpPr>
         <p:spPr>
           <a:xfrm>
-            <a:off x="6596220" y="2997708"/>
-            <a:ext cx="4777611" cy="116840"/>
-          </a:xfrm>
-          <a:prstGeom prst="rect">
-            <a:avLst/>
-          </a:prstGeom>
-          <a:noFill/>
-          <a:ln/>
-        </p:spPr>
-        <p:txBody>
-          <a:bodyPr wrap="square" rtlCol="0" anchor="t"/>
+            <a:off x="6614508" y="3034284"/>
+            <a:ext cx="4741035" cy="323088"/>
+          </a:xfrm>
+          <a:prstGeom prst="rect">
+            <a:avLst/>
+          </a:prstGeom>
+          <a:noFill/>
+          <a:ln/>
+        </p:spPr>
+        <p:txBody>
+          <a:bodyPr wrap="square" lIns="0" tIns="0" rIns="0" bIns="0" rtlCol="0" anchor="t"/>
           <a:lstStyle/>
           <a:p>
             <a:pPr indent="0" marL="0">
               <a:buNone/>
             </a:pPr>
             <a:r>
-              <a:rPr lang="en-US" sz="1150" dirty="0">
+              <a:rPr lang="en-US" sz="1000" dirty="0">
                 <a:solidFill>
                   <a:srgbClr val="00F0FF"/>
                 </a:solidFill>
@@ -5664,7 +5667,7 @@
               </a:rPr>
               <a:t>metric "99%" label="Uptime" diff="+1%"</a:t>
             </a:r>
-            <a:endParaRPr lang="en-US" sz="1150" dirty="0"/>
+            <a:endParaRPr lang="en-US" sz="1000" dirty="0"/>
           </a:p>
         </p:txBody>
       </p:sp>
@@ -5676,7 +5679,7 @@
         </p:nvSpPr>
         <p:spPr>
           <a:xfrm>
-            <a:off x="6184745" y="3721100"/>
+            <a:off x="6184745" y="4000500"/>
             <a:ext cx="5600560" cy="673100"/>
           </a:xfrm>
           <a:prstGeom prst="rect">
@@ -5715,12 +5718,12 @@
         </p:nvSpPr>
         <p:spPr>
           <a:xfrm>
-            <a:off x="406390" y="4572000"/>
-            <a:ext cx="11378916" cy="831850"/>
+            <a:off x="406390" y="4851400"/>
+            <a:ext cx="11378916" cy="965200"/>
           </a:xfrm>
           <a:prstGeom prst="roundRect">
             <a:avLst>
-              <a:gd name="adj" fmla="val 8794"/>
+              <a:gd name="adj" fmla="val 7579"/>
             </a:avLst>
           </a:prstGeom>
           <a:solidFill>
@@ -5742,8 +5745,8 @@
         </p:nvSpPr>
         <p:spPr>
           <a:xfrm>
-            <a:off x="543550" y="4645152"/>
-            <a:ext cx="11104596" cy="274320"/>
+            <a:off x="589270" y="4997704"/>
+            <a:ext cx="11013156" cy="274320"/>
           </a:xfrm>
           <a:prstGeom prst="rect">
             <a:avLst/>
@@ -5781,8 +5784,8 @@
         </p:nvSpPr>
         <p:spPr>
           <a:xfrm>
-            <a:off x="543550" y="4965192"/>
-            <a:ext cx="11104596" cy="365506"/>
+            <a:off x="589270" y="5326888"/>
+            <a:ext cx="11013156" cy="361696"/>
           </a:xfrm>
           <a:prstGeom prst="rect">
             <a:avLst/>
@@ -7337,11 +7340,11 @@
         <p:spPr>
           <a:xfrm>
             <a:off x="406390" y="4076700"/>
-            <a:ext cx="11378916" cy="654050"/>
+            <a:ext cx="11378916" cy="774700"/>
           </a:xfrm>
           <a:prstGeom prst="roundRect">
             <a:avLst>
-              <a:gd name="adj" fmla="val 11184"/>
+              <a:gd name="adj" fmla="val 9443"/>
             </a:avLst>
           </a:prstGeom>
           <a:solidFill>
@@ -7363,8 +7366,8 @@
         </p:nvSpPr>
         <p:spPr>
           <a:xfrm>
-            <a:off x="543550" y="4149852"/>
-            <a:ext cx="11104596" cy="274320"/>
+            <a:off x="589270" y="4223004"/>
+            <a:ext cx="11013156" cy="274320"/>
           </a:xfrm>
           <a:prstGeom prst="rect">
             <a:avLst/>
@@ -7402,8 +7405,8 @@
         </p:nvSpPr>
         <p:spPr>
           <a:xfrm>
-            <a:off x="543550" y="4469892"/>
-            <a:ext cx="11104596" cy="187706"/>
+            <a:off x="589270" y="4552188"/>
+            <a:ext cx="11013156" cy="182880"/>
           </a:xfrm>
           <a:prstGeom prst="rect">
             <a:avLst/>
@@ -7591,7 +7594,7 @@
         <p:spPr>
           <a:xfrm>
             <a:off x="406390" y="2019300"/>
-            <a:ext cx="5506578" cy="3479800"/>
+            <a:ext cx="5460858" cy="3479800"/>
           </a:xfrm>
           <a:prstGeom prst="roundRect">
             <a:avLst>
@@ -7618,7 +7621,7 @@
         <p:spPr>
           <a:xfrm>
             <a:off x="543550" y="2156460"/>
-            <a:ext cx="5232258" cy="365760"/>
+            <a:ext cx="5186538" cy="365760"/>
           </a:xfrm>
           <a:prstGeom prst="rect">
             <a:avLst/>
@@ -7656,8 +7659,8 @@
         </p:nvSpPr>
         <p:spPr>
           <a:xfrm>
-            <a:off x="6278728" y="2019300"/>
-            <a:ext cx="5506578" cy="3479800"/>
+            <a:off x="6324448" y="2019300"/>
+            <a:ext cx="5460858" cy="3479800"/>
           </a:xfrm>
           <a:prstGeom prst="roundRect">
             <a:avLst>
@@ -7683,8 +7686,8 @@
         </p:nvSpPr>
         <p:spPr>
           <a:xfrm>
-            <a:off x="6415888" y="2156460"/>
-            <a:ext cx="5232258" cy="365760"/>
+            <a:off x="6461608" y="2156460"/>
+            <a:ext cx="5186538" cy="365760"/>
           </a:xfrm>
           <a:prstGeom prst="rect">
             <a:avLst/>
@@ -7722,18 +7725,21 @@
         </p:nvSpPr>
         <p:spPr>
           <a:xfrm>
-            <a:off x="5958688" y="3594608"/>
-            <a:ext cx="274320" cy="274320"/>
-          </a:xfrm>
-          <a:prstGeom prst="roundRect">
-            <a:avLst>
-              <a:gd name="adj" fmla="val 50000"/>
-            </a:avLst>
+            <a:off x="5903824" y="3567176"/>
+            <a:ext cx="384048" cy="384048"/>
+          </a:xfrm>
+          <a:prstGeom prst="ellipse">
+            <a:avLst/>
           </a:prstGeom>
           <a:solidFill>
-            <a:srgbClr val="2E2E48"/>
+            <a:srgbClr val="151522"/>
           </a:solidFill>
-          <a:ln/>
+          <a:ln w="19050">
+            <a:solidFill>
+              <a:srgbClr val="FF2E88"/>
+            </a:solidFill>
+            <a:prstDash val="solid"/>
+          </a:ln>
         </p:spPr>
       </p:sp>
       <p:sp>
@@ -7744,26 +7750,26 @@
         </p:nvSpPr>
         <p:spPr>
           <a:xfrm>
-            <a:off x="5958688" y="3594608"/>
-            <a:ext cx="274320" cy="274320"/>
-          </a:xfrm>
-          <a:prstGeom prst="rect">
-            <a:avLst/>
-          </a:prstGeom>
-          <a:noFill/>
-          <a:ln/>
-        </p:spPr>
-        <p:txBody>
-          <a:bodyPr wrap="square" rtlCol="0" anchor="ctr"/>
+            <a:off x="5903824" y="3567176"/>
+            <a:ext cx="384048" cy="384048"/>
+          </a:xfrm>
+          <a:prstGeom prst="rect">
+            <a:avLst/>
+          </a:prstGeom>
+          <a:noFill/>
+          <a:ln/>
+        </p:spPr>
+        <p:txBody>
+          <a:bodyPr wrap="square" lIns="0" tIns="0" rIns="0" bIns="0" rtlCol="0" anchor="ctr"/>
           <a:lstStyle/>
           <a:p>
             <a:pPr algn="ctr" indent="0" marL="0">
               <a:buNone/>
             </a:pPr>
             <a:r>
-              <a:rPr lang="en-US" sz="1000" b="1" dirty="0">
-                <a:solidFill>
-                  <a:srgbClr val="A7A7B5"/>
+              <a:rPr lang="en-US" sz="1100" b="1" dirty="0">
+                <a:solidFill>
+                  <a:srgbClr val="FFFFFF"/>
                 </a:solidFill>
                 <a:latin typeface="Trebuchet MS" pitchFamily="34" charset="0"/>
                 <a:ea typeface="Trebuchet MS" pitchFamily="34" charset="-122"/>
@@ -7771,7 +7777,7 @@
               </a:rPr>
               <a:t>VS</a:t>
             </a:r>
-            <a:endParaRPr lang="en-US" sz="1000" dirty="0"/>
+            <a:endParaRPr lang="en-US" sz="1100" dirty="0"/>
           </a:p>
         </p:txBody>
       </p:sp>
@@ -7783,7 +7789,7 @@
         </p:nvSpPr>
         <p:spPr>
           <a:xfrm>
-            <a:off x="1606470" y="2552700"/>
+            <a:off x="1562021" y="2552700"/>
             <a:ext cx="3200400" cy="330200"/>
           </a:xfrm>
           <a:prstGeom prst="roundRect">
@@ -7810,7 +7816,7 @@
         </p:nvSpPr>
         <p:spPr>
           <a:xfrm>
-            <a:off x="1606470" y="2552700"/>
+            <a:off x="1562021" y="2552700"/>
             <a:ext cx="3200400" cy="330200"/>
           </a:xfrm>
           <a:prstGeom prst="rect">
@@ -7850,7 +7856,7 @@
         <p:spPr>
           <a:xfrm>
             <a:off x="584185" y="2971800"/>
-            <a:ext cx="5244969" cy="368300"/>
+            <a:ext cx="5156071" cy="368300"/>
           </a:xfrm>
           <a:prstGeom prst="rect">
             <a:avLst/>
@@ -7889,7 +7895,7 @@
         <p:spPr>
           <a:xfrm>
             <a:off x="584185" y="3429000"/>
-            <a:ext cx="5244969" cy="368300"/>
+            <a:ext cx="5156071" cy="673100"/>
           </a:xfrm>
           <a:prstGeom prst="rect">
             <a:avLst/>
@@ -7927,8 +7933,8 @@
         </p:nvSpPr>
         <p:spPr>
           <a:xfrm>
-            <a:off x="584185" y="3886200"/>
-            <a:ext cx="5244969" cy="368300"/>
+            <a:off x="584185" y="4191000"/>
+            <a:ext cx="5156071" cy="368300"/>
           </a:xfrm>
           <a:prstGeom prst="rect">
             <a:avLst/>
@@ -7966,8 +7972,8 @@
         </p:nvSpPr>
         <p:spPr>
           <a:xfrm>
-            <a:off x="584185" y="4343400"/>
-            <a:ext cx="5244969" cy="673100"/>
+            <a:off x="584185" y="4648200"/>
+            <a:ext cx="5156071" cy="673100"/>
           </a:xfrm>
           <a:prstGeom prst="rect">
             <a:avLst/>
@@ -8005,7 +8011,7 @@
         </p:nvSpPr>
         <p:spPr>
           <a:xfrm>
-            <a:off x="7503697" y="2552700"/>
+            <a:off x="7548146" y="2552700"/>
             <a:ext cx="2962656" cy="330200"/>
           </a:xfrm>
           <a:prstGeom prst="roundRect">
@@ -8032,7 +8038,7 @@
         </p:nvSpPr>
         <p:spPr>
           <a:xfrm>
-            <a:off x="7503697" y="2552700"/>
+            <a:off x="7548146" y="2552700"/>
             <a:ext cx="2962656" cy="330200"/>
           </a:xfrm>
           <a:prstGeom prst="rect">
@@ -8071,8 +8077,8 @@
         </p:nvSpPr>
         <p:spPr>
           <a:xfrm>
-            <a:off x="6362541" y="2971800"/>
-            <a:ext cx="5244969" cy="673100"/>
+            <a:off x="6451439" y="2971800"/>
+            <a:ext cx="5156071" cy="673100"/>
           </a:xfrm>
           <a:prstGeom prst="rect">
             <a:avLst/>
@@ -8110,8 +8116,8 @@
         </p:nvSpPr>
         <p:spPr>
           <a:xfrm>
-            <a:off x="6362541" y="3733800"/>
-            <a:ext cx="5244969" cy="368300"/>
+            <a:off x="6451439" y="3733800"/>
+            <a:ext cx="5156071" cy="368300"/>
           </a:xfrm>
           <a:prstGeom prst="rect">
             <a:avLst/>
@@ -8149,8 +8155,8 @@
         </p:nvSpPr>
         <p:spPr>
           <a:xfrm>
-            <a:off x="6362541" y="4191000"/>
-            <a:ext cx="5244969" cy="673100"/>
+            <a:off x="6451439" y="4191000"/>
+            <a:ext cx="5156071" cy="673100"/>
           </a:xfrm>
           <a:prstGeom prst="rect">
             <a:avLst/>
@@ -8188,8 +8194,8 @@
         </p:nvSpPr>
         <p:spPr>
           <a:xfrm>
-            <a:off x="6362541" y="4953000"/>
-            <a:ext cx="5244969" cy="368300"/>
+            <a:off x="6451439" y="4953000"/>
+            <a:ext cx="5156071" cy="368300"/>
           </a:xfrm>
           <a:prstGeom prst="rect">
             <a:avLst/>
@@ -8758,11 +8764,11 @@
         <p:spPr>
           <a:xfrm>
             <a:off x="406390" y="5003800"/>
-            <a:ext cx="11378916" cy="831850"/>
+            <a:ext cx="11378916" cy="965200"/>
           </a:xfrm>
           <a:prstGeom prst="roundRect">
             <a:avLst>
-              <a:gd name="adj" fmla="val 8794"/>
+              <a:gd name="adj" fmla="val 7579"/>
             </a:avLst>
           </a:prstGeom>
           <a:solidFill>
@@ -8784,8 +8790,8 @@
         </p:nvSpPr>
         <p:spPr>
           <a:xfrm>
-            <a:off x="543550" y="5076952"/>
-            <a:ext cx="11104596" cy="274320"/>
+            <a:off x="589270" y="5150104"/>
+            <a:ext cx="11013156" cy="274320"/>
           </a:xfrm>
           <a:prstGeom prst="rect">
             <a:avLst/>
@@ -8823,8 +8829,8 @@
         </p:nvSpPr>
         <p:spPr>
           <a:xfrm>
-            <a:off x="543550" y="5396992"/>
-            <a:ext cx="11104596" cy="365506"/>
+            <a:off x="589270" y="5479288"/>
+            <a:ext cx="11013156" cy="361696"/>
           </a:xfrm>
           <a:prstGeom prst="rect">
             <a:avLst/>
@@ -9050,8 +9056,8 @@
         </p:nvSpPr>
         <p:spPr>
           <a:xfrm>
-            <a:off x="4869778" y="2433168"/>
-            <a:ext cx="94313" cy="9144"/>
+            <a:off x="4188184" y="2902204"/>
+            <a:ext cx="129577" cy="9144"/>
           </a:xfrm>
           <a:prstGeom prst="line">
             <a:avLst/>
@@ -9073,8 +9079,8 @@
         </p:nvSpPr>
         <p:spPr>
           <a:xfrm>
-            <a:off x="4964091" y="2433168"/>
-            <a:ext cx="9144" cy="1091336"/>
+            <a:off x="4317761" y="2902204"/>
+            <a:ext cx="9144" cy="9144"/>
           </a:xfrm>
           <a:prstGeom prst="line">
             <a:avLst/>
@@ -9096,8 +9102,8 @@
         </p:nvSpPr>
         <p:spPr>
           <a:xfrm>
-            <a:off x="4964091" y="3524504"/>
-            <a:ext cx="94313" cy="9144"/>
+            <a:off x="4317761" y="2902204"/>
+            <a:ext cx="129577" cy="9144"/>
           </a:xfrm>
           <a:prstGeom prst="line">
             <a:avLst/>
@@ -9120,8 +9126,8 @@
         </p:nvSpPr>
         <p:spPr>
           <a:xfrm>
-            <a:off x="6001535" y="3524504"/>
-            <a:ext cx="94313" cy="9144"/>
+            <a:off x="5966270" y="2902204"/>
+            <a:ext cx="129577" cy="9144"/>
           </a:xfrm>
           <a:prstGeom prst="line">
             <a:avLst/>
@@ -9143,7 +9149,7 @@
         </p:nvSpPr>
         <p:spPr>
           <a:xfrm>
-            <a:off x="6095848" y="3524504"/>
+            <a:off x="6095848" y="2902204"/>
             <a:ext cx="9144" cy="9144"/>
           </a:xfrm>
           <a:prstGeom prst="line">
@@ -9166,8 +9172,8 @@
         </p:nvSpPr>
         <p:spPr>
           <a:xfrm>
-            <a:off x="6095848" y="3524504"/>
-            <a:ext cx="94313" cy="9144"/>
+            <a:off x="6095848" y="2902204"/>
+            <a:ext cx="129577" cy="9144"/>
           </a:xfrm>
           <a:prstGeom prst="line">
             <a:avLst/>
@@ -9190,8 +9196,8 @@
         </p:nvSpPr>
         <p:spPr>
           <a:xfrm>
-            <a:off x="7133291" y="3524504"/>
-            <a:ext cx="94313" cy="9144"/>
+            <a:off x="7744357" y="2902204"/>
+            <a:ext cx="129577" cy="9144"/>
           </a:xfrm>
           <a:prstGeom prst="line">
             <a:avLst/>
@@ -9213,8 +9219,8 @@
         </p:nvSpPr>
         <p:spPr>
           <a:xfrm flipV="1">
-            <a:off x="7227604" y="3160725"/>
-            <a:ext cx="9144" cy="363779"/>
+            <a:off x="7873934" y="2455883"/>
+            <a:ext cx="9144" cy="446321"/>
           </a:xfrm>
           <a:prstGeom prst="line">
             <a:avLst/>
@@ -9236,8 +9242,8 @@
         </p:nvSpPr>
         <p:spPr>
           <a:xfrm>
-            <a:off x="7227604" y="3160725"/>
-            <a:ext cx="94313" cy="9144"/>
+            <a:off x="7873934" y="2455883"/>
+            <a:ext cx="129577" cy="9144"/>
           </a:xfrm>
           <a:prstGeom prst="line">
             <a:avLst/>
@@ -9260,8 +9266,8 @@
         </p:nvSpPr>
         <p:spPr>
           <a:xfrm>
-            <a:off x="7133291" y="3524504"/>
-            <a:ext cx="94313" cy="9144"/>
+            <a:off x="7744357" y="2902204"/>
+            <a:ext cx="129577" cy="9144"/>
           </a:xfrm>
           <a:prstGeom prst="line">
             <a:avLst/>
@@ -9283,7 +9289,7 @@
         </p:nvSpPr>
         <p:spPr>
           <a:xfrm>
-            <a:off x="7227604" y="3524504"/>
+            <a:off x="7873934" y="2902204"/>
             <a:ext cx="9144" cy="9144"/>
           </a:xfrm>
           <a:prstGeom prst="line">
@@ -9306,8 +9312,8 @@
         </p:nvSpPr>
         <p:spPr>
           <a:xfrm>
-            <a:off x="7227604" y="3524504"/>
-            <a:ext cx="94313" cy="9144"/>
+            <a:off x="7873934" y="2902204"/>
+            <a:ext cx="129577" cy="9144"/>
           </a:xfrm>
           <a:prstGeom prst="line">
             <a:avLst/>
@@ -9330,8 +9336,8 @@
         </p:nvSpPr>
         <p:spPr>
           <a:xfrm>
-            <a:off x="7133291" y="3524504"/>
-            <a:ext cx="94313" cy="9144"/>
+            <a:off x="7744357" y="2902204"/>
+            <a:ext cx="129577" cy="9144"/>
           </a:xfrm>
           <a:prstGeom prst="line">
             <a:avLst/>
@@ -9353,8 +9359,8 @@
         </p:nvSpPr>
         <p:spPr>
           <a:xfrm>
-            <a:off x="7227604" y="3524504"/>
-            <a:ext cx="9144" cy="363779"/>
+            <a:off x="7873934" y="2902204"/>
+            <a:ext cx="9144" cy="446321"/>
           </a:xfrm>
           <a:prstGeom prst="line">
             <a:avLst/>
@@ -9376,8 +9382,8 @@
         </p:nvSpPr>
         <p:spPr>
           <a:xfrm>
-            <a:off x="7227604" y="3888283"/>
-            <a:ext cx="94313" cy="9144"/>
+            <a:off x="7873934" y="3348525"/>
+            <a:ext cx="129577" cy="9144"/>
           </a:xfrm>
           <a:prstGeom prst="line">
             <a:avLst/>
@@ -9400,12 +9406,12 @@
         </p:nvSpPr>
         <p:spPr>
           <a:xfrm>
-            <a:off x="3926648" y="2311908"/>
-            <a:ext cx="943130" cy="242519"/>
+            <a:off x="2669251" y="2758229"/>
+            <a:ext cx="1518932" cy="287949"/>
           </a:xfrm>
           <a:prstGeom prst="roundRect">
             <a:avLst>
-              <a:gd name="adj" fmla="val 30163"/>
+              <a:gd name="adj" fmla="val 25404"/>
             </a:avLst>
           </a:prstGeom>
           <a:solidFill>
@@ -9427,24 +9433,24 @@
         </p:nvSpPr>
         <p:spPr>
           <a:xfrm>
-            <a:off x="3981512" y="2366772"/>
-            <a:ext cx="833402" cy="132791"/>
-          </a:xfrm>
-          <a:prstGeom prst="rect">
-            <a:avLst/>
-          </a:prstGeom>
-          <a:noFill/>
-          <a:ln/>
-        </p:spPr>
-        <p:txBody>
-          <a:bodyPr wrap="square" rtlCol="0" anchor="ctr"/>
+            <a:off x="2742403" y="2813093"/>
+            <a:ext cx="1372628" cy="178221"/>
+          </a:xfrm>
+          <a:prstGeom prst="rect">
+            <a:avLst/>
+          </a:prstGeom>
+          <a:noFill/>
+          <a:ln/>
+        </p:spPr>
+        <p:txBody>
+          <a:bodyPr wrap="square" lIns="0" tIns="0" rIns="0" bIns="0" rtlCol="0" anchor="ctr"/>
           <a:lstStyle/>
           <a:p>
             <a:pPr algn="ctr" indent="0" marL="0">
               <a:buNone/>
             </a:pPr>
             <a:r>
-              <a:rPr lang="en-US" sz="1100" b="1" dirty="0">
+              <a:rPr lang="en-US" sz="1200" b="1" dirty="0">
                 <a:solidFill>
                   <a:srgbClr val="FFFFFF"/>
                 </a:solidFill>
@@ -9452,9 +9458,9 @@
                 <a:ea typeface="Trebuchet MS" pitchFamily="34" charset="-122"/>
                 <a:cs typeface="Trebuchet MS" pitchFamily="34" charset="-120"/>
               </a:rPr>
-              <a:t>Sorgente Yu…</a:t>
-            </a:r>
-            <a:endParaRPr lang="en-US" sz="1100" dirty="0"/>
+              <a:t>Sorgente Yumia</a:t>
+            </a:r>
+            <a:endParaRPr lang="en-US" sz="1200" dirty="0"/>
           </a:p>
         </p:txBody>
       </p:sp>
@@ -9466,12 +9472,12 @@
         </p:nvSpPr>
         <p:spPr>
           <a:xfrm>
-            <a:off x="5058404" y="3403244"/>
-            <a:ext cx="943130" cy="242519"/>
+            <a:off x="4447338" y="2758229"/>
+            <a:ext cx="1518932" cy="287949"/>
           </a:xfrm>
           <a:prstGeom prst="roundRect">
             <a:avLst>
-              <a:gd name="adj" fmla="val 30163"/>
+              <a:gd name="adj" fmla="val 25404"/>
             </a:avLst>
           </a:prstGeom>
           <a:solidFill>
@@ -9493,24 +9499,24 @@
         </p:nvSpPr>
         <p:spPr>
           <a:xfrm>
-            <a:off x="5113268" y="3458108"/>
-            <a:ext cx="833402" cy="132791"/>
-          </a:xfrm>
-          <a:prstGeom prst="rect">
-            <a:avLst/>
-          </a:prstGeom>
-          <a:noFill/>
-          <a:ln/>
-        </p:spPr>
-        <p:txBody>
-          <a:bodyPr wrap="square" rtlCol="0" anchor="ctr"/>
+            <a:off x="4520490" y="2813093"/>
+            <a:ext cx="1372628" cy="178221"/>
+          </a:xfrm>
+          <a:prstGeom prst="rect">
+            <a:avLst/>
+          </a:prstGeom>
+          <a:noFill/>
+          <a:ln/>
+        </p:spPr>
+        <p:txBody>
+          <a:bodyPr wrap="square" lIns="0" tIns="0" rIns="0" bIns="0" rtlCol="0" anchor="ctr"/>
           <a:lstStyle/>
           <a:p>
             <a:pPr algn="ctr" indent="0" marL="0">
               <a:buNone/>
             </a:pPr>
             <a:r>
-              <a:rPr lang="en-US" sz="1100" b="1" dirty="0">
+              <a:rPr lang="en-US" sz="1200" b="1" dirty="0">
                 <a:solidFill>
                   <a:srgbClr val="FFFFFF"/>
                 </a:solidFill>
@@ -9518,9 +9524,9 @@
                 <a:ea typeface="Trebuchet MS" pitchFamily="34" charset="-122"/>
                 <a:cs typeface="Trebuchet MS" pitchFamily="34" charset="-120"/>
               </a:rPr>
-              <a:t>AST Semanti…</a:t>
-            </a:r>
-            <a:endParaRPr lang="en-US" sz="1100" dirty="0"/>
+              <a:t>AST Semantico</a:t>
+            </a:r>
+            <a:endParaRPr lang="en-US" sz="1200" dirty="0"/>
           </a:p>
         </p:txBody>
       </p:sp>
@@ -9532,12 +9538,12 @@
         </p:nvSpPr>
         <p:spPr>
           <a:xfrm>
-            <a:off x="6190161" y="3403244"/>
-            <a:ext cx="943130" cy="242519"/>
+            <a:off x="6225425" y="2758229"/>
+            <a:ext cx="1518932" cy="287949"/>
           </a:xfrm>
           <a:prstGeom prst="roundRect">
             <a:avLst>
-              <a:gd name="adj" fmla="val 30163"/>
+              <a:gd name="adj" fmla="val 25404"/>
             </a:avLst>
           </a:prstGeom>
           <a:solidFill>
@@ -9545,7 +9551,7 @@
           </a:solidFill>
           <a:ln w="25400">
             <a:solidFill>
-              <a:srgbClr val="7B61FF"/>
+              <a:srgbClr val="FFE600"/>
             </a:solidFill>
             <a:prstDash val="solid"/>
           </a:ln>
@@ -9559,24 +9565,24 @@
         </p:nvSpPr>
         <p:spPr>
           <a:xfrm>
-            <a:off x="6245025" y="3458108"/>
-            <a:ext cx="833402" cy="132791"/>
-          </a:xfrm>
-          <a:prstGeom prst="rect">
-            <a:avLst/>
-          </a:prstGeom>
-          <a:noFill/>
-          <a:ln/>
-        </p:spPr>
-        <p:txBody>
-          <a:bodyPr wrap="square" rtlCol="0" anchor="ctr"/>
+            <a:off x="6298577" y="2813093"/>
+            <a:ext cx="1372628" cy="178221"/>
+          </a:xfrm>
+          <a:prstGeom prst="rect">
+            <a:avLst/>
+          </a:prstGeom>
+          <a:noFill/>
+          <a:ln/>
+        </p:spPr>
+        <p:txBody>
+          <a:bodyPr wrap="square" lIns="0" tIns="0" rIns="0" bIns="0" rtlCol="0" anchor="ctr"/>
           <a:lstStyle/>
           <a:p>
             <a:pPr algn="ctr" indent="0" marL="0">
               <a:buNone/>
             </a:pPr>
             <a:r>
-              <a:rPr lang="en-US" sz="1100" b="1" dirty="0">
+              <a:rPr lang="en-US" sz="1200" b="1" dirty="0">
                 <a:solidFill>
                   <a:srgbClr val="FFFFFF"/>
                 </a:solidFill>
@@ -9584,9 +9590,9 @@
                 <a:ea typeface="Trebuchet MS" pitchFamily="34" charset="-122"/>
                 <a:cs typeface="Trebuchet MS" pitchFamily="34" charset="-120"/>
               </a:rPr>
-              <a:t>Design Syst…</a:t>
-            </a:r>
-            <a:endParaRPr lang="en-US" sz="1100" dirty="0"/>
+              <a:t>Design System</a:t>
+            </a:r>
+            <a:endParaRPr lang="en-US" sz="1200" dirty="0"/>
           </a:p>
         </p:txBody>
       </p:sp>
@@ -9598,12 +9604,12 @@
         </p:nvSpPr>
         <p:spPr>
           <a:xfrm>
-            <a:off x="7321917" y="3039466"/>
-            <a:ext cx="943130" cy="242519"/>
+            <a:off x="8003512" y="2311908"/>
+            <a:ext cx="1518932" cy="287949"/>
           </a:xfrm>
           <a:prstGeom prst="roundRect">
             <a:avLst>
-              <a:gd name="adj" fmla="val 30163"/>
+              <a:gd name="adj" fmla="val 25404"/>
             </a:avLst>
           </a:prstGeom>
           <a:solidFill>
@@ -9611,7 +9617,7 @@
           </a:solidFill>
           <a:ln w="25400">
             <a:solidFill>
-              <a:srgbClr val="7B61FF"/>
+              <a:srgbClr val="00FF9F"/>
             </a:solidFill>
             <a:prstDash val="solid"/>
           </a:ln>
@@ -9625,24 +9631,24 @@
         </p:nvSpPr>
         <p:spPr>
           <a:xfrm>
-            <a:off x="7376781" y="3094330"/>
-            <a:ext cx="833402" cy="132791"/>
-          </a:xfrm>
-          <a:prstGeom prst="rect">
-            <a:avLst/>
-          </a:prstGeom>
-          <a:noFill/>
-          <a:ln/>
-        </p:spPr>
-        <p:txBody>
-          <a:bodyPr wrap="square" rtlCol="0" anchor="ctr"/>
+            <a:off x="8076664" y="2366772"/>
+            <a:ext cx="1372628" cy="178221"/>
+          </a:xfrm>
+          <a:prstGeom prst="rect">
+            <a:avLst/>
+          </a:prstGeom>
+          <a:noFill/>
+          <a:ln/>
+        </p:spPr>
+        <p:txBody>
+          <a:bodyPr wrap="square" lIns="0" tIns="0" rIns="0" bIns="0" rtlCol="0" anchor="ctr"/>
           <a:lstStyle/>
           <a:p>
             <a:pPr algn="ctr" indent="0" marL="0">
               <a:buNone/>
             </a:pPr>
             <a:r>
-              <a:rPr lang="en-US" sz="1100" b="1" dirty="0">
+              <a:rPr lang="en-US" sz="1200" b="1" dirty="0">
                 <a:solidFill>
                   <a:srgbClr val="FFFFFF"/>
                 </a:solidFill>
@@ -9650,9 +9656,9 @@
                 <a:ea typeface="Trebuchet MS" pitchFamily="34" charset="-122"/>
                 <a:cs typeface="Trebuchet MS" pitchFamily="34" charset="-120"/>
               </a:rPr>
-              <a:t>HTML Intera…</a:t>
-            </a:r>
-            <a:endParaRPr lang="en-US" sz="1100" dirty="0"/>
+              <a:t>HTML Interattivo</a:t>
+            </a:r>
+            <a:endParaRPr lang="en-US" sz="1200" dirty="0"/>
           </a:p>
         </p:txBody>
       </p:sp>
@@ -9664,144 +9670,12 @@
         </p:nvSpPr>
         <p:spPr>
           <a:xfrm>
-            <a:off x="7321917" y="3403244"/>
-            <a:ext cx="943130" cy="242519"/>
+            <a:off x="8003512" y="2758229"/>
+            <a:ext cx="1518932" cy="287949"/>
           </a:xfrm>
           <a:prstGeom prst="roundRect">
             <a:avLst>
-              <a:gd name="adj" fmla="val 30163"/>
-            </a:avLst>
-          </a:prstGeom>
-          <a:solidFill>
-            <a:srgbClr val="151522"/>
-          </a:solidFill>
-          <a:ln w="25400">
-            <a:solidFill>
-              <a:srgbClr val="7B61FF"/>
-            </a:solidFill>
-            <a:prstDash val="solid"/>
-          </a:ln>
-        </p:spPr>
-      </p:sp>
-      <p:sp>
-        <p:nvSpPr>
-          <p:cNvPr id="29" name="Text 27"/>
-          <p:cNvSpPr/>
-          <p:nvPr/>
-        </p:nvSpPr>
-        <p:spPr>
-          <a:xfrm>
-            <a:off x="7376781" y="3458108"/>
-            <a:ext cx="833402" cy="132791"/>
-          </a:xfrm>
-          <a:prstGeom prst="rect">
-            <a:avLst/>
-          </a:prstGeom>
-          <a:noFill/>
-          <a:ln/>
-        </p:spPr>
-        <p:txBody>
-          <a:bodyPr wrap="square" rtlCol="0" anchor="ctr"/>
-          <a:lstStyle/>
-          <a:p>
-            <a:pPr algn="ctr" indent="0" marL="0">
-              <a:buNone/>
-            </a:pPr>
-            <a:r>
-              <a:rPr lang="en-US" sz="1100" b="1" dirty="0">
-                <a:solidFill>
-                  <a:srgbClr val="FFFFFF"/>
-                </a:solidFill>
-                <a:latin typeface="Trebuchet MS" pitchFamily="34" charset="0"/>
-                <a:ea typeface="Trebuchet MS" pitchFamily="34" charset="-122"/>
-                <a:cs typeface="Trebuchet MS" pitchFamily="34" charset="-120"/>
-              </a:rPr>
-              <a:t>PowerPoint …</a:t>
-            </a:r>
-            <a:endParaRPr lang="en-US" sz="1100" dirty="0"/>
-          </a:p>
-        </p:txBody>
-      </p:sp>
-      <p:sp>
-        <p:nvSpPr>
-          <p:cNvPr id="30" name="Shape 28"/>
-          <p:cNvSpPr/>
-          <p:nvPr/>
-        </p:nvSpPr>
-        <p:spPr>
-          <a:xfrm>
-            <a:off x="7321917" y="3767023"/>
-            <a:ext cx="943130" cy="242519"/>
-          </a:xfrm>
-          <a:prstGeom prst="roundRect">
-            <a:avLst>
-              <a:gd name="adj" fmla="val 30163"/>
-            </a:avLst>
-          </a:prstGeom>
-          <a:solidFill>
-            <a:srgbClr val="151522"/>
-          </a:solidFill>
-          <a:ln w="25400">
-            <a:solidFill>
-              <a:srgbClr val="7B61FF"/>
-            </a:solidFill>
-            <a:prstDash val="solid"/>
-          </a:ln>
-        </p:spPr>
-      </p:sp>
-      <p:sp>
-        <p:nvSpPr>
-          <p:cNvPr id="31" name="Text 29"/>
-          <p:cNvSpPr/>
-          <p:nvPr/>
-        </p:nvSpPr>
-        <p:spPr>
-          <a:xfrm>
-            <a:off x="7376781" y="3821887"/>
-            <a:ext cx="833402" cy="132791"/>
-          </a:xfrm>
-          <a:prstGeom prst="rect">
-            <a:avLst/>
-          </a:prstGeom>
-          <a:noFill/>
-          <a:ln/>
-        </p:spPr>
-        <p:txBody>
-          <a:bodyPr wrap="square" rtlCol="0" anchor="ctr"/>
-          <a:lstStyle/>
-          <a:p>
-            <a:pPr algn="ctr" indent="0" marL="0">
-              <a:buNone/>
-            </a:pPr>
-            <a:r>
-              <a:rPr lang="en-US" sz="1100" b="1" dirty="0">
-                <a:solidFill>
-                  <a:srgbClr val="FFFFFF"/>
-                </a:solidFill>
-                <a:latin typeface="Trebuchet MS" pitchFamily="34" charset="0"/>
-                <a:ea typeface="Trebuchet MS" pitchFamily="34" charset="-122"/>
-                <a:cs typeface="Trebuchet MS" pitchFamily="34" charset="-120"/>
-              </a:rPr>
-              <a:t>PDF Vettori…</a:t>
-            </a:r>
-            <a:endParaRPr lang="en-US" sz="1100" dirty="0"/>
-          </a:p>
-        </p:txBody>
-      </p:sp>
-      <p:sp>
-        <p:nvSpPr>
-          <p:cNvPr id="32" name="Shape 30"/>
-          <p:cNvSpPr/>
-          <p:nvPr/>
-        </p:nvSpPr>
-        <p:spPr>
-          <a:xfrm>
-            <a:off x="3926648" y="2675687"/>
-            <a:ext cx="943130" cy="242519"/>
-          </a:xfrm>
-          <a:prstGeom prst="roundRect">
-            <a:avLst>
-              <a:gd name="adj" fmla="val 30163"/>
+              <a:gd name="adj" fmla="val 25404"/>
             </a:avLst>
           </a:prstGeom>
           <a:solidFill>
@@ -9817,30 +9691,30 @@
       </p:sp>
       <p:sp>
         <p:nvSpPr>
-          <p:cNvPr id="33" name="Text 31"/>
-          <p:cNvSpPr/>
-          <p:nvPr/>
-        </p:nvSpPr>
-        <p:spPr>
-          <a:xfrm>
-            <a:off x="3981512" y="2730551"/>
-            <a:ext cx="833402" cy="132791"/>
-          </a:xfrm>
-          <a:prstGeom prst="rect">
-            <a:avLst/>
-          </a:prstGeom>
-          <a:noFill/>
-          <a:ln/>
-        </p:spPr>
-        <p:txBody>
-          <a:bodyPr wrap="square" rtlCol="0" anchor="ctr"/>
+          <p:cNvPr id="29" name="Text 27"/>
+          <p:cNvSpPr/>
+          <p:nvPr/>
+        </p:nvSpPr>
+        <p:spPr>
+          <a:xfrm>
+            <a:off x="8076664" y="2813093"/>
+            <a:ext cx="1372628" cy="178221"/>
+          </a:xfrm>
+          <a:prstGeom prst="rect">
+            <a:avLst/>
+          </a:prstGeom>
+          <a:noFill/>
+          <a:ln/>
+        </p:spPr>
+        <p:txBody>
+          <a:bodyPr wrap="square" lIns="0" tIns="0" rIns="0" bIns="0" rtlCol="0" anchor="ctr"/>
           <a:lstStyle/>
           <a:p>
             <a:pPr algn="ctr" indent="0" marL="0">
               <a:buNone/>
             </a:pPr>
             <a:r>
-              <a:rPr lang="en-US" sz="1100" b="1" dirty="0">
+              <a:rPr lang="en-US" sz="1200" b="1" dirty="0">
                 <a:solidFill>
                   <a:srgbClr val="FFFFFF"/>
                 </a:solidFill>
@@ -9848,26 +9722,26 @@
                 <a:ea typeface="Trebuchet MS" pitchFamily="34" charset="-122"/>
                 <a:cs typeface="Trebuchet MS" pitchFamily="34" charset="-120"/>
               </a:rPr>
-              <a:t>Sorgente</a:t>
-            </a:r>
-            <a:endParaRPr lang="en-US" sz="1100" dirty="0"/>
-          </a:p>
-        </p:txBody>
-      </p:sp>
-      <p:sp>
-        <p:nvSpPr>
-          <p:cNvPr id="34" name="Shape 32"/>
-          <p:cNvSpPr/>
-          <p:nvPr/>
-        </p:nvSpPr>
-        <p:spPr>
-          <a:xfrm>
-            <a:off x="3926648" y="3039466"/>
-            <a:ext cx="943130" cy="242519"/>
+              <a:t>PowerPoint PPTX</a:t>
+            </a:r>
+            <a:endParaRPr lang="en-US" sz="1200" dirty="0"/>
+          </a:p>
+        </p:txBody>
+      </p:sp>
+      <p:sp>
+        <p:nvSpPr>
+          <p:cNvPr id="30" name="Shape 28"/>
+          <p:cNvSpPr/>
+          <p:nvPr/>
+        </p:nvSpPr>
+        <p:spPr>
+          <a:xfrm>
+            <a:off x="8003512" y="3204551"/>
+            <a:ext cx="1518932" cy="287949"/>
           </a:xfrm>
           <a:prstGeom prst="roundRect">
             <a:avLst>
-              <a:gd name="adj" fmla="val 30163"/>
+              <a:gd name="adj" fmla="val 25404"/>
             </a:avLst>
           </a:prstGeom>
           <a:solidFill>
@@ -9875,7 +9749,7 @@
           </a:solidFill>
           <a:ln w="25400">
             <a:solidFill>
-              <a:srgbClr val="7B61FF"/>
+              <a:srgbClr val="FF0055"/>
             </a:solidFill>
             <a:prstDash val="solid"/>
           </a:ln>
@@ -9883,30 +9757,30 @@
       </p:sp>
       <p:sp>
         <p:nvSpPr>
-          <p:cNvPr id="35" name="Text 33"/>
-          <p:cNvSpPr/>
-          <p:nvPr/>
-        </p:nvSpPr>
-        <p:spPr>
-          <a:xfrm>
-            <a:off x="3981512" y="3094330"/>
-            <a:ext cx="833402" cy="132791"/>
-          </a:xfrm>
-          <a:prstGeom prst="rect">
-            <a:avLst/>
-          </a:prstGeom>
-          <a:noFill/>
-          <a:ln/>
-        </p:spPr>
-        <p:txBody>
-          <a:bodyPr wrap="square" rtlCol="0" anchor="ctr"/>
+          <p:cNvPr id="31" name="Text 29"/>
+          <p:cNvSpPr/>
+          <p:nvPr/>
+        </p:nvSpPr>
+        <p:spPr>
+          <a:xfrm>
+            <a:off x="8076664" y="3259415"/>
+            <a:ext cx="1372628" cy="178221"/>
+          </a:xfrm>
+          <a:prstGeom prst="rect">
+            <a:avLst/>
+          </a:prstGeom>
+          <a:noFill/>
+          <a:ln/>
+        </p:spPr>
+        <p:txBody>
+          <a:bodyPr wrap="square" lIns="0" tIns="0" rIns="0" bIns="0" rtlCol="0" anchor="ctr"/>
           <a:lstStyle/>
           <a:p>
             <a:pPr algn="ctr" indent="0" marL="0">
               <a:buNone/>
             </a:pPr>
             <a:r>
-              <a:rPr lang="en-US" sz="1100" b="1" dirty="0">
+              <a:rPr lang="en-US" sz="1200" b="1" dirty="0">
                 <a:solidFill>
                   <a:srgbClr val="FFFFFF"/>
                 </a:solidFill>
@@ -9914,92 +9788,26 @@
                 <a:ea typeface="Trebuchet MS" pitchFamily="34" charset="-122"/>
                 <a:cs typeface="Trebuchet MS" pitchFamily="34" charset="-120"/>
               </a:rPr>
-              <a:t>AST</a:t>
-            </a:r>
-            <a:endParaRPr lang="en-US" sz="1100" dirty="0"/>
-          </a:p>
-        </p:txBody>
-      </p:sp>
-      <p:sp>
-        <p:nvSpPr>
-          <p:cNvPr id="36" name="Shape 34"/>
-          <p:cNvSpPr/>
-          <p:nvPr/>
-        </p:nvSpPr>
-        <p:spPr>
-          <a:xfrm>
-            <a:off x="3926648" y="3403244"/>
-            <a:ext cx="943130" cy="242519"/>
+              <a:t>PDF Vettoriale</a:t>
+            </a:r>
+            <a:endParaRPr lang="en-US" sz="1200" dirty="0"/>
+          </a:p>
+        </p:txBody>
+      </p:sp>
+      <p:sp>
+        <p:nvSpPr>
+          <p:cNvPr id="32" name="Shape 30"/>
+          <p:cNvSpPr/>
+          <p:nvPr/>
+        </p:nvSpPr>
+        <p:spPr>
+          <a:xfrm>
+            <a:off x="406390" y="3670300"/>
+            <a:ext cx="11378916" cy="965200"/>
           </a:xfrm>
           <a:prstGeom prst="roundRect">
             <a:avLst>
-              <a:gd name="adj" fmla="val 30163"/>
-            </a:avLst>
-          </a:prstGeom>
-          <a:solidFill>
-            <a:srgbClr val="151522"/>
-          </a:solidFill>
-          <a:ln w="25400">
-            <a:solidFill>
-              <a:srgbClr val="FFE600"/>
-            </a:solidFill>
-            <a:prstDash val="solid"/>
-          </a:ln>
-        </p:spPr>
-      </p:sp>
-      <p:sp>
-        <p:nvSpPr>
-          <p:cNvPr id="37" name="Text 35"/>
-          <p:cNvSpPr/>
-          <p:nvPr/>
-        </p:nvSpPr>
-        <p:spPr>
-          <a:xfrm>
-            <a:off x="3981512" y="3458108"/>
-            <a:ext cx="833402" cy="132791"/>
-          </a:xfrm>
-          <a:prstGeom prst="rect">
-            <a:avLst/>
-          </a:prstGeom>
-          <a:noFill/>
-          <a:ln/>
-        </p:spPr>
-        <p:txBody>
-          <a:bodyPr wrap="square" rtlCol="0" anchor="ctr"/>
-          <a:lstStyle/>
-          <a:p>
-            <a:pPr algn="ctr" indent="0" marL="0">
-              <a:buNone/>
-            </a:pPr>
-            <a:r>
-              <a:rPr lang="en-US" sz="1100" b="1" dirty="0">
-                <a:solidFill>
-                  <a:srgbClr val="FFFFFF"/>
-                </a:solidFill>
-                <a:latin typeface="Trebuchet MS" pitchFamily="34" charset="0"/>
-                <a:ea typeface="Trebuchet MS" pitchFamily="34" charset="-122"/>
-                <a:cs typeface="Trebuchet MS" pitchFamily="34" charset="-120"/>
-              </a:rPr>
-              <a:t>Design</a:t>
-            </a:r>
-            <a:endParaRPr lang="en-US" sz="1100" dirty="0"/>
-          </a:p>
-        </p:txBody>
-      </p:sp>
-      <p:sp>
-        <p:nvSpPr>
-          <p:cNvPr id="38" name="Shape 36"/>
-          <p:cNvSpPr/>
-          <p:nvPr/>
-        </p:nvSpPr>
-        <p:spPr>
-          <a:xfrm>
-            <a:off x="3926648" y="3767023"/>
-            <a:ext cx="943130" cy="242519"/>
-          </a:xfrm>
-          <a:prstGeom prst="roundRect">
-            <a:avLst>
-              <a:gd name="adj" fmla="val 30163"/>
+              <a:gd name="adj" fmla="val 7579"/>
             </a:avLst>
           </a:prstGeom>
           <a:solidFill>
@@ -10015,14 +9823,14 @@
       </p:sp>
       <p:sp>
         <p:nvSpPr>
-          <p:cNvPr id="39" name="Text 37"/>
-          <p:cNvSpPr/>
-          <p:nvPr/>
-        </p:nvSpPr>
-        <p:spPr>
-          <a:xfrm>
-            <a:off x="3981512" y="3821887"/>
-            <a:ext cx="833402" cy="132791"/>
+          <p:cNvPr id="33" name="Text 31"/>
+          <p:cNvSpPr/>
+          <p:nvPr/>
+        </p:nvSpPr>
+        <p:spPr>
+          <a:xfrm>
+            <a:off x="589270" y="3816604"/>
+            <a:ext cx="11013156" cy="274320"/>
           </a:xfrm>
           <a:prstGeom prst="rect">
             <a:avLst/>
@@ -10034,216 +9842,18 @@
           <a:bodyPr wrap="square" rtlCol="0" anchor="ctr"/>
           <a:lstStyle/>
           <a:p>
-            <a:pPr algn="ctr" indent="0" marL="0">
-              <a:buNone/>
-            </a:pPr>
-            <a:r>
-              <a:rPr lang="en-US" sz="1100" b="1" dirty="0">
-                <a:solidFill>
-                  <a:srgbClr val="FFFFFF"/>
+            <a:pPr indent="0" marL="0">
+              <a:buNone/>
+            </a:pPr>
+            <a:r>
+              <a:rPr lang="en-US" sz="1300" b="1" dirty="0">
+                <a:solidFill>
+                  <a:srgbClr val="00FF9F"/>
                 </a:solidFill>
                 <a:latin typeface="Trebuchet MS" pitchFamily="34" charset="0"/>
                 <a:ea typeface="Trebuchet MS" pitchFamily="34" charset="-122"/>
                 <a:cs typeface="Trebuchet MS" pitchFamily="34" charset="-120"/>
               </a:rPr>
-              <a:t>HTML</a:t>
-            </a:r>
-            <a:endParaRPr lang="en-US" sz="1100" dirty="0"/>
-          </a:p>
-        </p:txBody>
-      </p:sp>
-      <p:sp>
-        <p:nvSpPr>
-          <p:cNvPr id="40" name="Shape 38"/>
-          <p:cNvSpPr/>
-          <p:nvPr/>
-        </p:nvSpPr>
-        <p:spPr>
-          <a:xfrm>
-            <a:off x="3926648" y="4130802"/>
-            <a:ext cx="943130" cy="242519"/>
-          </a:xfrm>
-          <a:prstGeom prst="roundRect">
-            <a:avLst>
-              <a:gd name="adj" fmla="val 30163"/>
-            </a:avLst>
-          </a:prstGeom>
-          <a:solidFill>
-            <a:srgbClr val="151522"/>
-          </a:solidFill>
-          <a:ln w="25400">
-            <a:solidFill>
-              <a:srgbClr val="FF2E88"/>
-            </a:solidFill>
-            <a:prstDash val="solid"/>
-          </a:ln>
-        </p:spPr>
-      </p:sp>
-      <p:sp>
-        <p:nvSpPr>
-          <p:cNvPr id="41" name="Text 39"/>
-          <p:cNvSpPr/>
-          <p:nvPr/>
-        </p:nvSpPr>
-        <p:spPr>
-          <a:xfrm>
-            <a:off x="3981512" y="4185666"/>
-            <a:ext cx="833402" cy="132791"/>
-          </a:xfrm>
-          <a:prstGeom prst="rect">
-            <a:avLst/>
-          </a:prstGeom>
-          <a:noFill/>
-          <a:ln/>
-        </p:spPr>
-        <p:txBody>
-          <a:bodyPr wrap="square" rtlCol="0" anchor="ctr"/>
-          <a:lstStyle/>
-          <a:p>
-            <a:pPr algn="ctr" indent="0" marL="0">
-              <a:buNone/>
-            </a:pPr>
-            <a:r>
-              <a:rPr lang="en-US" sz="1100" b="1" dirty="0">
-                <a:solidFill>
-                  <a:srgbClr val="FFFFFF"/>
-                </a:solidFill>
-                <a:latin typeface="Trebuchet MS" pitchFamily="34" charset="0"/>
-                <a:ea typeface="Trebuchet MS" pitchFamily="34" charset="-122"/>
-                <a:cs typeface="Trebuchet MS" pitchFamily="34" charset="-120"/>
-              </a:rPr>
-              <a:t>PowerPoint</a:t>
-            </a:r>
-            <a:endParaRPr lang="en-US" sz="1100" dirty="0"/>
-          </a:p>
-        </p:txBody>
-      </p:sp>
-      <p:sp>
-        <p:nvSpPr>
-          <p:cNvPr id="42" name="Shape 40"/>
-          <p:cNvSpPr/>
-          <p:nvPr/>
-        </p:nvSpPr>
-        <p:spPr>
-          <a:xfrm>
-            <a:off x="3926648" y="4494581"/>
-            <a:ext cx="943130" cy="242519"/>
-          </a:xfrm>
-          <a:prstGeom prst="roundRect">
-            <a:avLst>
-              <a:gd name="adj" fmla="val 30163"/>
-            </a:avLst>
-          </a:prstGeom>
-          <a:solidFill>
-            <a:srgbClr val="151522"/>
-          </a:solidFill>
-          <a:ln w="25400">
-            <a:solidFill>
-              <a:srgbClr val="FF0055"/>
-            </a:solidFill>
-            <a:prstDash val="solid"/>
-          </a:ln>
-        </p:spPr>
-      </p:sp>
-      <p:sp>
-        <p:nvSpPr>
-          <p:cNvPr id="43" name="Text 41"/>
-          <p:cNvSpPr/>
-          <p:nvPr/>
-        </p:nvSpPr>
-        <p:spPr>
-          <a:xfrm>
-            <a:off x="3981512" y="4549445"/>
-            <a:ext cx="833402" cy="132791"/>
-          </a:xfrm>
-          <a:prstGeom prst="rect">
-            <a:avLst/>
-          </a:prstGeom>
-          <a:noFill/>
-          <a:ln/>
-        </p:spPr>
-        <p:txBody>
-          <a:bodyPr wrap="square" rtlCol="0" anchor="ctr"/>
-          <a:lstStyle/>
-          <a:p>
-            <a:pPr algn="ctr" indent="0" marL="0">
-              <a:buNone/>
-            </a:pPr>
-            <a:r>
-              <a:rPr lang="en-US" sz="1100" b="1" dirty="0">
-                <a:solidFill>
-                  <a:srgbClr val="FFFFFF"/>
-                </a:solidFill>
-                <a:latin typeface="Trebuchet MS" pitchFamily="34" charset="0"/>
-                <a:ea typeface="Trebuchet MS" pitchFamily="34" charset="-122"/>
-                <a:cs typeface="Trebuchet MS" pitchFamily="34" charset="-120"/>
-              </a:rPr>
-              <a:t>PDF</a:t>
-            </a:r>
-            <a:endParaRPr lang="en-US" sz="1100" dirty="0"/>
-          </a:p>
-        </p:txBody>
-      </p:sp>
-      <p:sp>
-        <p:nvSpPr>
-          <p:cNvPr id="44" name="Shape 42"/>
-          <p:cNvSpPr/>
-          <p:nvPr/>
-        </p:nvSpPr>
-        <p:spPr>
-          <a:xfrm>
-            <a:off x="406390" y="4914900"/>
-            <a:ext cx="11378916" cy="831850"/>
-          </a:xfrm>
-          <a:prstGeom prst="roundRect">
-            <a:avLst>
-              <a:gd name="adj" fmla="val 8794"/>
-            </a:avLst>
-          </a:prstGeom>
-          <a:solidFill>
-            <a:srgbClr val="151522"/>
-          </a:solidFill>
-          <a:ln w="25400">
-            <a:solidFill>
-              <a:srgbClr val="00FF9F"/>
-            </a:solidFill>
-            <a:prstDash val="solid"/>
-          </a:ln>
-        </p:spPr>
-      </p:sp>
-      <p:sp>
-        <p:nvSpPr>
-          <p:cNvPr id="45" name="Text 43"/>
-          <p:cNvSpPr/>
-          <p:nvPr/>
-        </p:nvSpPr>
-        <p:spPr>
-          <a:xfrm>
-            <a:off x="543550" y="4988052"/>
-            <a:ext cx="11104596" cy="274320"/>
-          </a:xfrm>
-          <a:prstGeom prst="rect">
-            <a:avLst/>
-          </a:prstGeom>
-          <a:noFill/>
-          <a:ln/>
-        </p:spPr>
-        <p:txBody>
-          <a:bodyPr wrap="square" rtlCol="0" anchor="ctr"/>
-          <a:lstStyle/>
-          <a:p>
-            <a:pPr indent="0" marL="0">
-              <a:buNone/>
-            </a:pPr>
-            <a:r>
-              <a:rPr lang="en-US" sz="1300" b="1" dirty="0">
-                <a:solidFill>
-                  <a:srgbClr val="00FF9F"/>
-                </a:solidFill>
-                <a:latin typeface="Trebuchet MS" pitchFamily="34" charset="0"/>
-                <a:ea typeface="Trebuchet MS" pitchFamily="34" charset="-122"/>
-                <a:cs typeface="Trebuchet MS" pitchFamily="34" charset="-120"/>
-              </a:rPr>
               <a:t>Principio Single Source of Truth</a:t>
             </a:r>
             <a:endParaRPr lang="en-US" sz="1300" dirty="0"/>
@@ -10252,14 +9862,14 @@
       </p:sp>
       <p:sp>
         <p:nvSpPr>
-          <p:cNvPr id="46" name="Text 44"/>
-          <p:cNvSpPr/>
-          <p:nvPr/>
-        </p:nvSpPr>
-        <p:spPr>
-          <a:xfrm>
-            <a:off x="543550" y="5308092"/>
-            <a:ext cx="11104596" cy="365506"/>
+          <p:cNvPr id="34" name="Text 32"/>
+          <p:cNvSpPr/>
+          <p:nvPr/>
+        </p:nvSpPr>
+        <p:spPr>
+          <a:xfrm>
+            <a:off x="589270" y="4145788"/>
+            <a:ext cx="11013156" cy="361696"/>
           </a:xfrm>
           <a:prstGeom prst="rect">
             <a:avLst/>
@@ -10291,7 +9901,7 @@
       </p:sp>
       <p:sp>
         <p:nvSpPr>
-          <p:cNvPr id="47" name="Text 45"/>
+          <p:cNvPr id="35" name="Text 33"/>
           <p:cNvSpPr/>
           <p:nvPr/>
         </p:nvSpPr>
@@ -10485,8 +10095,8 @@
         </p:nvSpPr>
         <p:spPr>
           <a:xfrm>
-            <a:off x="3782933" y="2433168"/>
-            <a:ext cx="94313" cy="9144"/>
+            <a:off x="1944296" y="2800604"/>
+            <a:ext cx="215148" cy="9144"/>
           </a:xfrm>
           <a:prstGeom prst="line">
             <a:avLst/>
@@ -10508,8 +10118,8 @@
         </p:nvSpPr>
         <p:spPr>
           <a:xfrm>
-            <a:off x="3877246" y="2433168"/>
-            <a:ext cx="9144" cy="1091336"/>
+            <a:off x="2159444" y="2800604"/>
+            <a:ext cx="9144" cy="9144"/>
           </a:xfrm>
           <a:prstGeom prst="line">
             <a:avLst/>
@@ -10531,8 +10141,8 @@
         </p:nvSpPr>
         <p:spPr>
           <a:xfrm>
-            <a:off x="3877246" y="3524504"/>
-            <a:ext cx="94313" cy="9144"/>
+            <a:off x="2159444" y="2800604"/>
+            <a:ext cx="215148" cy="9144"/>
           </a:xfrm>
           <a:prstGeom prst="line">
             <a:avLst/>
@@ -10555,8 +10165,8 @@
         </p:nvSpPr>
         <p:spPr>
           <a:xfrm>
-            <a:off x="4892234" y="3524504"/>
-            <a:ext cx="94313" cy="9144"/>
+            <a:off x="3912498" y="2800604"/>
+            <a:ext cx="215148" cy="9144"/>
           </a:xfrm>
           <a:prstGeom prst="line">
             <a:avLst/>
@@ -10578,7 +10188,7 @@
         </p:nvSpPr>
         <p:spPr>
           <a:xfrm>
-            <a:off x="4986547" y="3524504"/>
+            <a:off x="4127646" y="2800604"/>
             <a:ext cx="9144" cy="9144"/>
           </a:xfrm>
           <a:prstGeom prst="line">
@@ -10601,8 +10211,8 @@
         </p:nvSpPr>
         <p:spPr>
           <a:xfrm>
-            <a:off x="4986547" y="3524504"/>
-            <a:ext cx="94313" cy="9144"/>
+            <a:off x="4127646" y="2800604"/>
+            <a:ext cx="215148" cy="9144"/>
           </a:xfrm>
           <a:prstGeom prst="line">
             <a:avLst/>
@@ -10625,8 +10235,8 @@
         </p:nvSpPr>
         <p:spPr>
           <a:xfrm>
-            <a:off x="6001535" y="3524504"/>
-            <a:ext cx="94313" cy="9144"/>
+            <a:off x="5880700" y="2800604"/>
+            <a:ext cx="215148" cy="9144"/>
           </a:xfrm>
           <a:prstGeom prst="line">
             <a:avLst/>
@@ -10648,7 +10258,7 @@
         </p:nvSpPr>
         <p:spPr>
           <a:xfrm>
-            <a:off x="6095848" y="3524504"/>
+            <a:off x="6095848" y="2800604"/>
             <a:ext cx="9144" cy="9144"/>
           </a:xfrm>
           <a:prstGeom prst="line">
@@ -10671,8 +10281,8 @@
         </p:nvSpPr>
         <p:spPr>
           <a:xfrm>
-            <a:off x="6095848" y="3524504"/>
-            <a:ext cx="94313" cy="9144"/>
+            <a:off x="6095848" y="2800604"/>
+            <a:ext cx="215148" cy="9144"/>
           </a:xfrm>
           <a:prstGeom prst="line">
             <a:avLst/>
@@ -10695,8 +10305,8 @@
         </p:nvSpPr>
         <p:spPr>
           <a:xfrm>
-            <a:off x="7110835" y="3524504"/>
-            <a:ext cx="94313" cy="9144"/>
+            <a:off x="7848902" y="2800604"/>
+            <a:ext cx="215148" cy="9144"/>
           </a:xfrm>
           <a:prstGeom prst="line">
             <a:avLst/>
@@ -10718,7 +10328,7 @@
         </p:nvSpPr>
         <p:spPr>
           <a:xfrm>
-            <a:off x="7205148" y="3524504"/>
+            <a:off x="8064049" y="2800604"/>
             <a:ext cx="9144" cy="9144"/>
           </a:xfrm>
           <a:prstGeom prst="line">
@@ -10741,8 +10351,8 @@
         </p:nvSpPr>
         <p:spPr>
           <a:xfrm>
-            <a:off x="7205148" y="3524504"/>
-            <a:ext cx="94313" cy="9144"/>
+            <a:off x="8064049" y="2800604"/>
+            <a:ext cx="215148" cy="9144"/>
           </a:xfrm>
           <a:prstGeom prst="line">
             <a:avLst/>
@@ -10765,8 +10375,8 @@
         </p:nvSpPr>
         <p:spPr>
           <a:xfrm>
-            <a:off x="8220136" y="3524504"/>
-            <a:ext cx="94313" cy="9144"/>
+            <a:off x="9817104" y="2800604"/>
+            <a:ext cx="215148" cy="9144"/>
           </a:xfrm>
           <a:prstGeom prst="line">
             <a:avLst/>
@@ -10788,7 +10398,7 @@
         </p:nvSpPr>
         <p:spPr>
           <a:xfrm>
-            <a:off x="8314449" y="3524504"/>
+            <a:off x="10032251" y="2800604"/>
             <a:ext cx="9144" cy="9144"/>
           </a:xfrm>
           <a:prstGeom prst="line">
@@ -10811,8 +10421,8 @@
         </p:nvSpPr>
         <p:spPr>
           <a:xfrm>
-            <a:off x="8314449" y="3524504"/>
-            <a:ext cx="94313" cy="9144"/>
+            <a:off x="10032251" y="2800604"/>
+            <a:ext cx="215148" cy="9144"/>
           </a:xfrm>
           <a:prstGeom prst="line">
             <a:avLst/>
@@ -10835,12 +10445,12 @@
         </p:nvSpPr>
         <p:spPr>
           <a:xfrm>
-            <a:off x="2862258" y="2311908"/>
-            <a:ext cx="920675" cy="242519"/>
+            <a:off x="406390" y="2561551"/>
+            <a:ext cx="1537907" cy="478106"/>
           </a:xfrm>
           <a:prstGeom prst="roundRect">
             <a:avLst>
-              <a:gd name="adj" fmla="val 30163"/>
+              <a:gd name="adj" fmla="val 15300"/>
             </a:avLst>
           </a:prstGeom>
           <a:solidFill>
@@ -10862,24 +10472,24 @@
         </p:nvSpPr>
         <p:spPr>
           <a:xfrm>
-            <a:off x="2917122" y="2366772"/>
-            <a:ext cx="810947" cy="132791"/>
-          </a:xfrm>
-          <a:prstGeom prst="rect">
-            <a:avLst/>
-          </a:prstGeom>
-          <a:noFill/>
-          <a:ln/>
-        </p:spPr>
-        <p:txBody>
-          <a:bodyPr wrap="square" rtlCol="0" anchor="ctr"/>
+            <a:off x="479542" y="2616415"/>
+            <a:ext cx="1391603" cy="368378"/>
+          </a:xfrm>
+          <a:prstGeom prst="rect">
+            <a:avLst/>
+          </a:prstGeom>
+          <a:noFill/>
+          <a:ln/>
+        </p:spPr>
+        <p:txBody>
+          <a:bodyPr wrap="square" lIns="0" tIns="0" rIns="0" bIns="0" rtlCol="0" anchor="ctr"/>
           <a:lstStyle/>
           <a:p>
             <a:pPr algn="ctr" indent="0" marL="0">
               <a:buNone/>
             </a:pPr>
             <a:r>
-              <a:rPr lang="en-US" sz="1100" b="1" dirty="0">
+              <a:rPr lang="en-US" sz="1200" b="1" dirty="0">
                 <a:solidFill>
                   <a:srgbClr val="FFFFFF"/>
                 </a:solidFill>
@@ -10889,7 +10499,7 @@
               </a:rPr>
               <a:t>Sorgente DSL</a:t>
             </a:r>
-            <a:endParaRPr lang="en-US" sz="1100" dirty="0"/>
+            <a:endParaRPr lang="en-US" sz="1200" dirty="0"/>
           </a:p>
         </p:txBody>
       </p:sp>
@@ -10901,12 +10511,12 @@
         </p:nvSpPr>
         <p:spPr>
           <a:xfrm>
-            <a:off x="3971559" y="3403244"/>
-            <a:ext cx="920675" cy="242519"/>
+            <a:off x="2374592" y="2561551"/>
+            <a:ext cx="1537907" cy="478106"/>
           </a:xfrm>
           <a:prstGeom prst="roundRect">
             <a:avLst>
-              <a:gd name="adj" fmla="val 30163"/>
+              <a:gd name="adj" fmla="val 15300"/>
             </a:avLst>
           </a:prstGeom>
           <a:solidFill>
@@ -10928,24 +10538,24 @@
         </p:nvSpPr>
         <p:spPr>
           <a:xfrm>
-            <a:off x="4026423" y="3458108"/>
-            <a:ext cx="810947" cy="132791"/>
-          </a:xfrm>
-          <a:prstGeom prst="rect">
-            <a:avLst/>
-          </a:prstGeom>
-          <a:noFill/>
-          <a:ln/>
-        </p:spPr>
-        <p:txBody>
-          <a:bodyPr wrap="square" rtlCol="0" anchor="ctr"/>
+            <a:off x="2447744" y="2616415"/>
+            <a:ext cx="1391603" cy="368378"/>
+          </a:xfrm>
+          <a:prstGeom prst="rect">
+            <a:avLst/>
+          </a:prstGeom>
+          <a:noFill/>
+          <a:ln/>
+        </p:spPr>
+        <p:txBody>
+          <a:bodyPr wrap="square" lIns="0" tIns="0" rIns="0" bIns="0" rtlCol="0" anchor="ctr"/>
           <a:lstStyle/>
           <a:p>
             <a:pPr algn="ctr" indent="0" marL="0">
               <a:buNone/>
             </a:pPr>
             <a:r>
-              <a:rPr lang="en-US" sz="1100" b="1" dirty="0">
+              <a:rPr lang="en-US" sz="1200" b="1" dirty="0">
                 <a:solidFill>
                   <a:srgbClr val="FFFFFF"/>
                 </a:solidFill>
@@ -10955,7 +10565,7 @@
               </a:rPr>
               <a:t>Parser AST</a:t>
             </a:r>
-            <a:endParaRPr lang="en-US" sz="1100" dirty="0"/>
+            <a:endParaRPr lang="en-US" sz="1200" dirty="0"/>
           </a:p>
         </p:txBody>
       </p:sp>
@@ -10967,12 +10577,12 @@
         </p:nvSpPr>
         <p:spPr>
           <a:xfrm>
-            <a:off x="5080860" y="3403244"/>
-            <a:ext cx="920675" cy="242519"/>
+            <a:off x="4342793" y="2561551"/>
+            <a:ext cx="1537907" cy="478106"/>
           </a:xfrm>
           <a:prstGeom prst="roundRect">
             <a:avLst>
-              <a:gd name="adj" fmla="val 30163"/>
+              <a:gd name="adj" fmla="val 15300"/>
             </a:avLst>
           </a:prstGeom>
           <a:solidFill>
@@ -10980,7 +10590,7 @@
           </a:solidFill>
           <a:ln w="25400">
             <a:solidFill>
-              <a:srgbClr val="7B61FF"/>
+              <a:srgbClr val="FFE600"/>
             </a:solidFill>
             <a:prstDash val="solid"/>
           </a:ln>
@@ -10994,24 +10604,24 @@
         </p:nvSpPr>
         <p:spPr>
           <a:xfrm>
-            <a:off x="5135724" y="3458108"/>
-            <a:ext cx="810947" cy="132791"/>
-          </a:xfrm>
-          <a:prstGeom prst="rect">
-            <a:avLst/>
-          </a:prstGeom>
-          <a:noFill/>
-          <a:ln/>
-        </p:spPr>
-        <p:txBody>
-          <a:bodyPr wrap="square" rtlCol="0" anchor="ctr"/>
+            <a:off x="4415945" y="2616415"/>
+            <a:ext cx="1391603" cy="368378"/>
+          </a:xfrm>
+          <a:prstGeom prst="rect">
+            <a:avLst/>
+          </a:prstGeom>
+          <a:noFill/>
+          <a:ln/>
+        </p:spPr>
+        <p:txBody>
+          <a:bodyPr wrap="square" lIns="0" tIns="0" rIns="0" bIns="0" rtlCol="0" anchor="ctr"/>
           <a:lstStyle/>
           <a:p>
             <a:pPr algn="ctr" indent="0" marL="0">
               <a:buNone/>
             </a:pPr>
             <a:r>
-              <a:rPr lang="en-US" sz="1100" b="1" dirty="0">
+              <a:rPr lang="en-US" sz="1200" b="1" dirty="0">
                 <a:solidFill>
                   <a:srgbClr val="FFFFFF"/>
                 </a:solidFill>
@@ -11019,9 +10629,9 @@
                 <a:ea typeface="Trebuchet MS" pitchFamily="34" charset="-122"/>
                 <a:cs typeface="Trebuchet MS" pitchFamily="34" charset="-120"/>
               </a:rPr>
-              <a:t>Design Lint…</a:t>
-            </a:r>
-            <a:endParaRPr lang="en-US" sz="1100" dirty="0"/>
+              <a:t>Design Linter</a:t>
+            </a:r>
+            <a:endParaRPr lang="en-US" sz="1200" dirty="0"/>
           </a:p>
         </p:txBody>
       </p:sp>
@@ -11033,210 +10643,12 @@
         </p:nvSpPr>
         <p:spPr>
           <a:xfrm>
-            <a:off x="6190161" y="3403244"/>
-            <a:ext cx="920675" cy="242519"/>
+            <a:off x="6310995" y="2561551"/>
+            <a:ext cx="1537907" cy="478106"/>
           </a:xfrm>
           <a:prstGeom prst="roundRect">
             <a:avLst>
-              <a:gd name="adj" fmla="val 30163"/>
-            </a:avLst>
-          </a:prstGeom>
-          <a:solidFill>
-            <a:srgbClr val="151522"/>
-          </a:solidFill>
-          <a:ln w="25400">
-            <a:solidFill>
-              <a:srgbClr val="7B61FF"/>
-            </a:solidFill>
-            <a:prstDash val="solid"/>
-          </a:ln>
-        </p:spPr>
-      </p:sp>
-      <p:sp>
-        <p:nvSpPr>
-          <p:cNvPr id="27" name="Text 25"/>
-          <p:cNvSpPr/>
-          <p:nvPr/>
-        </p:nvSpPr>
-        <p:spPr>
-          <a:xfrm>
-            <a:off x="6245025" y="3458108"/>
-            <a:ext cx="810947" cy="132791"/>
-          </a:xfrm>
-          <a:prstGeom prst="rect">
-            <a:avLst/>
-          </a:prstGeom>
-          <a:noFill/>
-          <a:ln/>
-        </p:spPr>
-        <p:txBody>
-          <a:bodyPr wrap="square" rtlCol="0" anchor="ctr"/>
-          <a:lstStyle/>
-          <a:p>
-            <a:pPr algn="ctr" indent="0" marL="0">
-              <a:buNone/>
-            </a:pPr>
-            <a:r>
-              <a:rPr lang="en-US" sz="1100" b="1" dirty="0">
-                <a:solidFill>
-                  <a:srgbClr val="FFFFFF"/>
-                </a:solidFill>
-                <a:latin typeface="Trebuchet MS" pitchFamily="34" charset="0"/>
-                <a:ea typeface="Trebuchet MS" pitchFamily="34" charset="-122"/>
-                <a:cs typeface="Trebuchet MS" pitchFamily="34" charset="-120"/>
-              </a:rPr>
-              <a:t>Theme Engine</a:t>
-            </a:r>
-            <a:endParaRPr lang="en-US" sz="1100" dirty="0"/>
-          </a:p>
-        </p:txBody>
-      </p:sp>
-      <p:sp>
-        <p:nvSpPr>
-          <p:cNvPr id="28" name="Shape 26"/>
-          <p:cNvSpPr/>
-          <p:nvPr/>
-        </p:nvSpPr>
-        <p:spPr>
-          <a:xfrm>
-            <a:off x="7299461" y="3403244"/>
-            <a:ext cx="920675" cy="242519"/>
-          </a:xfrm>
-          <a:prstGeom prst="roundRect">
-            <a:avLst>
-              <a:gd name="adj" fmla="val 30163"/>
-            </a:avLst>
-          </a:prstGeom>
-          <a:solidFill>
-            <a:srgbClr val="151522"/>
-          </a:solidFill>
-          <a:ln w="25400">
-            <a:solidFill>
-              <a:srgbClr val="7B61FF"/>
-            </a:solidFill>
-            <a:prstDash val="solid"/>
-          </a:ln>
-        </p:spPr>
-      </p:sp>
-      <p:sp>
-        <p:nvSpPr>
-          <p:cNvPr id="29" name="Text 27"/>
-          <p:cNvSpPr/>
-          <p:nvPr/>
-        </p:nvSpPr>
-        <p:spPr>
-          <a:xfrm>
-            <a:off x="7354325" y="3458108"/>
-            <a:ext cx="810947" cy="132791"/>
-          </a:xfrm>
-          <a:prstGeom prst="rect">
-            <a:avLst/>
-          </a:prstGeom>
-          <a:noFill/>
-          <a:ln/>
-        </p:spPr>
-        <p:txBody>
-          <a:bodyPr wrap="square" rtlCol="0" anchor="ctr"/>
-          <a:lstStyle/>
-          <a:p>
-            <a:pPr algn="ctr" indent="0" marL="0">
-              <a:buNone/>
-            </a:pPr>
-            <a:r>
-              <a:rPr lang="en-US" sz="1100" b="1" dirty="0">
-                <a:solidFill>
-                  <a:srgbClr val="FFFFFF"/>
-                </a:solidFill>
-                <a:latin typeface="Trebuchet MS" pitchFamily="34" charset="0"/>
-                <a:ea typeface="Trebuchet MS" pitchFamily="34" charset="-122"/>
-                <a:cs typeface="Trebuchet MS" pitchFamily="34" charset="-120"/>
-              </a:rPr>
-              <a:t>Layout Engi…</a:t>
-            </a:r>
-            <a:endParaRPr lang="en-US" sz="1100" dirty="0"/>
-          </a:p>
-        </p:txBody>
-      </p:sp>
-      <p:sp>
-        <p:nvSpPr>
-          <p:cNvPr id="30" name="Shape 28"/>
-          <p:cNvSpPr/>
-          <p:nvPr/>
-        </p:nvSpPr>
-        <p:spPr>
-          <a:xfrm>
-            <a:off x="8408762" y="3403244"/>
-            <a:ext cx="920675" cy="242519"/>
-          </a:xfrm>
-          <a:prstGeom prst="roundRect">
-            <a:avLst>
-              <a:gd name="adj" fmla="val 30163"/>
-            </a:avLst>
-          </a:prstGeom>
-          <a:solidFill>
-            <a:srgbClr val="151522"/>
-          </a:solidFill>
-          <a:ln w="25400">
-            <a:solidFill>
-              <a:srgbClr val="7B61FF"/>
-            </a:solidFill>
-            <a:prstDash val="solid"/>
-          </a:ln>
-        </p:spPr>
-      </p:sp>
-      <p:sp>
-        <p:nvSpPr>
-          <p:cNvPr id="31" name="Text 29"/>
-          <p:cNvSpPr/>
-          <p:nvPr/>
-        </p:nvSpPr>
-        <p:spPr>
-          <a:xfrm>
-            <a:off x="8463626" y="3458108"/>
-            <a:ext cx="810947" cy="132791"/>
-          </a:xfrm>
-          <a:prstGeom prst="rect">
-            <a:avLst/>
-          </a:prstGeom>
-          <a:noFill/>
-          <a:ln/>
-        </p:spPr>
-        <p:txBody>
-          <a:bodyPr wrap="square" rtlCol="0" anchor="ctr"/>
-          <a:lstStyle/>
-          <a:p>
-            <a:pPr algn="ctr" indent="0" marL="0">
-              <a:buNone/>
-            </a:pPr>
-            <a:r>
-              <a:rPr lang="en-US" sz="1100" b="1" dirty="0">
-                <a:solidFill>
-                  <a:srgbClr val="FFFFFF"/>
-                </a:solidFill>
-                <a:latin typeface="Trebuchet MS" pitchFamily="34" charset="0"/>
-                <a:ea typeface="Trebuchet MS" pitchFamily="34" charset="-122"/>
-                <a:cs typeface="Trebuchet MS" pitchFamily="34" charset="-120"/>
-              </a:rPr>
-              <a:t>Renderer Mu…</a:t>
-            </a:r>
-            <a:endParaRPr lang="en-US" sz="1100" dirty="0"/>
-          </a:p>
-        </p:txBody>
-      </p:sp>
-      <p:sp>
-        <p:nvSpPr>
-          <p:cNvPr id="32" name="Shape 30"/>
-          <p:cNvSpPr/>
-          <p:nvPr/>
-        </p:nvSpPr>
-        <p:spPr>
-          <a:xfrm>
-            <a:off x="2862258" y="2675687"/>
-            <a:ext cx="920675" cy="242519"/>
-          </a:xfrm>
-          <a:prstGeom prst="roundRect">
-            <a:avLst>
-              <a:gd name="adj" fmla="val 30163"/>
+              <a:gd name="adj" fmla="val 15300"/>
             </a:avLst>
           </a:prstGeom>
           <a:solidFill>
@@ -11252,30 +10664,30 @@
       </p:sp>
       <p:sp>
         <p:nvSpPr>
-          <p:cNvPr id="33" name="Text 31"/>
-          <p:cNvSpPr/>
-          <p:nvPr/>
-        </p:nvSpPr>
-        <p:spPr>
-          <a:xfrm>
-            <a:off x="2917122" y="2730551"/>
-            <a:ext cx="810947" cy="132791"/>
-          </a:xfrm>
-          <a:prstGeom prst="rect">
-            <a:avLst/>
-          </a:prstGeom>
-          <a:noFill/>
-          <a:ln/>
-        </p:spPr>
-        <p:txBody>
-          <a:bodyPr wrap="square" rtlCol="0" anchor="ctr"/>
+          <p:cNvPr id="27" name="Text 25"/>
+          <p:cNvSpPr/>
+          <p:nvPr/>
+        </p:nvSpPr>
+        <p:spPr>
+          <a:xfrm>
+            <a:off x="6384147" y="2616415"/>
+            <a:ext cx="1391603" cy="368378"/>
+          </a:xfrm>
+          <a:prstGeom prst="rect">
+            <a:avLst/>
+          </a:prstGeom>
+          <a:noFill/>
+          <a:ln/>
+        </p:spPr>
+        <p:txBody>
+          <a:bodyPr wrap="square" lIns="0" tIns="0" rIns="0" bIns="0" rtlCol="0" anchor="ctr"/>
           <a:lstStyle/>
           <a:p>
             <a:pPr algn="ctr" indent="0" marL="0">
               <a:buNone/>
             </a:pPr>
             <a:r>
-              <a:rPr lang="en-US" sz="1100" b="1" dirty="0">
+              <a:rPr lang="en-US" sz="1200" b="1" dirty="0">
                 <a:solidFill>
                   <a:srgbClr val="FFFFFF"/>
                 </a:solidFill>
@@ -11283,158 +10695,26 @@
                 <a:ea typeface="Trebuchet MS" pitchFamily="34" charset="-122"/>
                 <a:cs typeface="Trebuchet MS" pitchFamily="34" charset="-120"/>
               </a:rPr>
-              <a:t>Sorgente</a:t>
-            </a:r>
-            <a:endParaRPr lang="en-US" sz="1100" dirty="0"/>
-          </a:p>
-        </p:txBody>
-      </p:sp>
-      <p:sp>
-        <p:nvSpPr>
-          <p:cNvPr id="34" name="Shape 32"/>
-          <p:cNvSpPr/>
-          <p:nvPr/>
-        </p:nvSpPr>
-        <p:spPr>
-          <a:xfrm>
-            <a:off x="2862258" y="3039466"/>
-            <a:ext cx="920675" cy="242519"/>
+              <a:t>Theme Engine</a:t>
+            </a:r>
+            <a:endParaRPr lang="en-US" sz="1200" dirty="0"/>
+          </a:p>
+        </p:txBody>
+      </p:sp>
+      <p:sp>
+        <p:nvSpPr>
+          <p:cNvPr id="28" name="Shape 26"/>
+          <p:cNvSpPr/>
+          <p:nvPr/>
+        </p:nvSpPr>
+        <p:spPr>
+          <a:xfrm>
+            <a:off x="8279197" y="2561551"/>
+            <a:ext cx="1537907" cy="478106"/>
           </a:xfrm>
           <a:prstGeom prst="roundRect">
             <a:avLst>
-              <a:gd name="adj" fmla="val 30163"/>
-            </a:avLst>
-          </a:prstGeom>
-          <a:solidFill>
-            <a:srgbClr val="151522"/>
-          </a:solidFill>
-          <a:ln w="25400">
-            <a:solidFill>
-              <a:srgbClr val="7B61FF"/>
-            </a:solidFill>
-            <a:prstDash val="solid"/>
-          </a:ln>
-        </p:spPr>
-      </p:sp>
-      <p:sp>
-        <p:nvSpPr>
-          <p:cNvPr id="35" name="Text 33"/>
-          <p:cNvSpPr/>
-          <p:nvPr/>
-        </p:nvSpPr>
-        <p:spPr>
-          <a:xfrm>
-            <a:off x="2917122" y="3094330"/>
-            <a:ext cx="810947" cy="132791"/>
-          </a:xfrm>
-          <a:prstGeom prst="rect">
-            <a:avLst/>
-          </a:prstGeom>
-          <a:noFill/>
-          <a:ln/>
-        </p:spPr>
-        <p:txBody>
-          <a:bodyPr wrap="square" rtlCol="0" anchor="ctr"/>
-          <a:lstStyle/>
-          <a:p>
-            <a:pPr algn="ctr" indent="0" marL="0">
-              <a:buNone/>
-            </a:pPr>
-            <a:r>
-              <a:rPr lang="en-US" sz="1100" b="1" dirty="0">
-                <a:solidFill>
-                  <a:srgbClr val="FFFFFF"/>
-                </a:solidFill>
-                <a:latin typeface="Trebuchet MS" pitchFamily="34" charset="0"/>
-                <a:ea typeface="Trebuchet MS" pitchFamily="34" charset="-122"/>
-                <a:cs typeface="Trebuchet MS" pitchFamily="34" charset="-120"/>
-              </a:rPr>
-              <a:t>Parser</a:t>
-            </a:r>
-            <a:endParaRPr lang="en-US" sz="1100" dirty="0"/>
-          </a:p>
-        </p:txBody>
-      </p:sp>
-      <p:sp>
-        <p:nvSpPr>
-          <p:cNvPr id="36" name="Shape 34"/>
-          <p:cNvSpPr/>
-          <p:nvPr/>
-        </p:nvSpPr>
-        <p:spPr>
-          <a:xfrm>
-            <a:off x="2862258" y="3403244"/>
-            <a:ext cx="920675" cy="242519"/>
-          </a:xfrm>
-          <a:prstGeom prst="roundRect">
-            <a:avLst>
-              <a:gd name="adj" fmla="val 30163"/>
-            </a:avLst>
-          </a:prstGeom>
-          <a:solidFill>
-            <a:srgbClr val="151522"/>
-          </a:solidFill>
-          <a:ln w="25400">
-            <a:solidFill>
-              <a:srgbClr val="FFE600"/>
-            </a:solidFill>
-            <a:prstDash val="solid"/>
-          </a:ln>
-        </p:spPr>
-      </p:sp>
-      <p:sp>
-        <p:nvSpPr>
-          <p:cNvPr id="37" name="Text 35"/>
-          <p:cNvSpPr/>
-          <p:nvPr/>
-        </p:nvSpPr>
-        <p:spPr>
-          <a:xfrm>
-            <a:off x="2917122" y="3458108"/>
-            <a:ext cx="810947" cy="132791"/>
-          </a:xfrm>
-          <a:prstGeom prst="rect">
-            <a:avLst/>
-          </a:prstGeom>
-          <a:noFill/>
-          <a:ln/>
-        </p:spPr>
-        <p:txBody>
-          <a:bodyPr wrap="square" rtlCol="0" anchor="ctr"/>
-          <a:lstStyle/>
-          <a:p>
-            <a:pPr algn="ctr" indent="0" marL="0">
-              <a:buNone/>
-            </a:pPr>
-            <a:r>
-              <a:rPr lang="en-US" sz="1100" b="1" dirty="0">
-                <a:solidFill>
-                  <a:srgbClr val="FFFFFF"/>
-                </a:solidFill>
-                <a:latin typeface="Trebuchet MS" pitchFamily="34" charset="0"/>
-                <a:ea typeface="Trebuchet MS" pitchFamily="34" charset="-122"/>
-                <a:cs typeface="Trebuchet MS" pitchFamily="34" charset="-120"/>
-              </a:rPr>
-              <a:t>Design</a:t>
-            </a:r>
-            <a:endParaRPr lang="en-US" sz="1100" dirty="0"/>
-          </a:p>
-        </p:txBody>
-      </p:sp>
-      <p:sp>
-        <p:nvSpPr>
-          <p:cNvPr id="38" name="Shape 36"/>
-          <p:cNvSpPr/>
-          <p:nvPr/>
-        </p:nvSpPr>
-        <p:spPr>
-          <a:xfrm>
-            <a:off x="2862258" y="3767023"/>
-            <a:ext cx="920675" cy="242519"/>
-          </a:xfrm>
-          <a:prstGeom prst="roundRect">
-            <a:avLst>
-              <a:gd name="adj" fmla="val 30163"/>
+              <a:gd name="adj" fmla="val 15300"/>
             </a:avLst>
           </a:prstGeom>
           <a:solidFill>
@@ -11450,30 +10730,30 @@
       </p:sp>
       <p:sp>
         <p:nvSpPr>
-          <p:cNvPr id="39" name="Text 37"/>
-          <p:cNvSpPr/>
-          <p:nvPr/>
-        </p:nvSpPr>
-        <p:spPr>
-          <a:xfrm>
-            <a:off x="2917122" y="3821887"/>
-            <a:ext cx="810947" cy="132791"/>
-          </a:xfrm>
-          <a:prstGeom prst="rect">
-            <a:avLst/>
-          </a:prstGeom>
-          <a:noFill/>
-          <a:ln/>
-        </p:spPr>
-        <p:txBody>
-          <a:bodyPr wrap="square" rtlCol="0" anchor="ctr"/>
+          <p:cNvPr id="29" name="Text 27"/>
+          <p:cNvSpPr/>
+          <p:nvPr/>
+        </p:nvSpPr>
+        <p:spPr>
+          <a:xfrm>
+            <a:off x="8352349" y="2616415"/>
+            <a:ext cx="1391603" cy="368378"/>
+          </a:xfrm>
+          <a:prstGeom prst="rect">
+            <a:avLst/>
+          </a:prstGeom>
+          <a:noFill/>
+          <a:ln/>
+        </p:spPr>
+        <p:txBody>
+          <a:bodyPr wrap="square" lIns="0" tIns="0" rIns="0" bIns="0" rtlCol="0" anchor="ctr"/>
           <a:lstStyle/>
           <a:p>
             <a:pPr algn="ctr" indent="0" marL="0">
               <a:buNone/>
             </a:pPr>
             <a:r>
-              <a:rPr lang="en-US" sz="1100" b="1" dirty="0">
+              <a:rPr lang="en-US" sz="1200" b="1" dirty="0">
                 <a:solidFill>
                   <a:srgbClr val="FFFFFF"/>
                 </a:solidFill>
@@ -11481,92 +10761,26 @@
                 <a:ea typeface="Trebuchet MS" pitchFamily="34" charset="-122"/>
                 <a:cs typeface="Trebuchet MS" pitchFamily="34" charset="-120"/>
               </a:rPr>
-              <a:t>Theme</a:t>
-            </a:r>
-            <a:endParaRPr lang="en-US" sz="1100" dirty="0"/>
-          </a:p>
-        </p:txBody>
-      </p:sp>
-      <p:sp>
-        <p:nvSpPr>
-          <p:cNvPr id="40" name="Shape 38"/>
-          <p:cNvSpPr/>
-          <p:nvPr/>
-        </p:nvSpPr>
-        <p:spPr>
-          <a:xfrm>
-            <a:off x="2862258" y="4130802"/>
-            <a:ext cx="920675" cy="242519"/>
+              <a:t>Layout Engine</a:t>
+            </a:r>
+            <a:endParaRPr lang="en-US" sz="1200" dirty="0"/>
+          </a:p>
+        </p:txBody>
+      </p:sp>
+      <p:sp>
+        <p:nvSpPr>
+          <p:cNvPr id="30" name="Shape 28"/>
+          <p:cNvSpPr/>
+          <p:nvPr/>
+        </p:nvSpPr>
+        <p:spPr>
+          <a:xfrm>
+            <a:off x="10247399" y="2561551"/>
+            <a:ext cx="1537907" cy="478106"/>
           </a:xfrm>
           <a:prstGeom prst="roundRect">
             <a:avLst>
-              <a:gd name="adj" fmla="val 30163"/>
-            </a:avLst>
-          </a:prstGeom>
-          <a:solidFill>
-            <a:srgbClr val="151522"/>
-          </a:solidFill>
-          <a:ln w="25400">
-            <a:solidFill>
-              <a:srgbClr val="FF2E88"/>
-            </a:solidFill>
-            <a:prstDash val="solid"/>
-          </a:ln>
-        </p:spPr>
-      </p:sp>
-      <p:sp>
-        <p:nvSpPr>
-          <p:cNvPr id="41" name="Text 39"/>
-          <p:cNvSpPr/>
-          <p:nvPr/>
-        </p:nvSpPr>
-        <p:spPr>
-          <a:xfrm>
-            <a:off x="2917122" y="4185666"/>
-            <a:ext cx="810947" cy="132791"/>
-          </a:xfrm>
-          <a:prstGeom prst="rect">
-            <a:avLst/>
-          </a:prstGeom>
-          <a:noFill/>
-          <a:ln/>
-        </p:spPr>
-        <p:txBody>
-          <a:bodyPr wrap="square" rtlCol="0" anchor="ctr"/>
-          <a:lstStyle/>
-          <a:p>
-            <a:pPr algn="ctr" indent="0" marL="0">
-              <a:buNone/>
-            </a:pPr>
-            <a:r>
-              <a:rPr lang="en-US" sz="1100" b="1" dirty="0">
-                <a:solidFill>
-                  <a:srgbClr val="FFFFFF"/>
-                </a:solidFill>
-                <a:latin typeface="Trebuchet MS" pitchFamily="34" charset="0"/>
-                <a:ea typeface="Trebuchet MS" pitchFamily="34" charset="-122"/>
-                <a:cs typeface="Trebuchet MS" pitchFamily="34" charset="-120"/>
-              </a:rPr>
-              <a:t>Layout</a:t>
-            </a:r>
-            <a:endParaRPr lang="en-US" sz="1100" dirty="0"/>
-          </a:p>
-        </p:txBody>
-      </p:sp>
-      <p:sp>
-        <p:nvSpPr>
-          <p:cNvPr id="42" name="Shape 40"/>
-          <p:cNvSpPr/>
-          <p:nvPr/>
-        </p:nvSpPr>
-        <p:spPr>
-          <a:xfrm>
-            <a:off x="2862258" y="4494581"/>
-            <a:ext cx="920675" cy="242519"/>
-          </a:xfrm>
-          <a:prstGeom prst="roundRect">
-            <a:avLst>
-              <a:gd name="adj" fmla="val 30163"/>
+              <a:gd name="adj" fmla="val 15300"/>
             </a:avLst>
           </a:prstGeom>
           <a:solidFill>
@@ -11582,30 +10796,30 @@
       </p:sp>
       <p:sp>
         <p:nvSpPr>
-          <p:cNvPr id="43" name="Text 41"/>
-          <p:cNvSpPr/>
-          <p:nvPr/>
-        </p:nvSpPr>
-        <p:spPr>
-          <a:xfrm>
-            <a:off x="2917122" y="4549445"/>
-            <a:ext cx="810947" cy="132791"/>
-          </a:xfrm>
-          <a:prstGeom prst="rect">
-            <a:avLst/>
-          </a:prstGeom>
-          <a:noFill/>
-          <a:ln/>
-        </p:spPr>
-        <p:txBody>
-          <a:bodyPr wrap="square" rtlCol="0" anchor="ctr"/>
+          <p:cNvPr id="31" name="Text 29"/>
+          <p:cNvSpPr/>
+          <p:nvPr/>
+        </p:nvSpPr>
+        <p:spPr>
+          <a:xfrm>
+            <a:off x="10320551" y="2616415"/>
+            <a:ext cx="1391603" cy="368378"/>
+          </a:xfrm>
+          <a:prstGeom prst="rect">
+            <a:avLst/>
+          </a:prstGeom>
+          <a:noFill/>
+          <a:ln/>
+        </p:spPr>
+        <p:txBody>
+          <a:bodyPr wrap="square" lIns="0" tIns="0" rIns="0" bIns="0" rtlCol="0" anchor="ctr"/>
           <a:lstStyle/>
           <a:p>
             <a:pPr algn="ctr" indent="0" marL="0">
               <a:buNone/>
             </a:pPr>
             <a:r>
-              <a:rPr lang="en-US" sz="1100" b="1" dirty="0">
+              <a:rPr lang="en-US" sz="1200" b="1" dirty="0">
                 <a:solidFill>
                   <a:srgbClr val="FFFFFF"/>
                 </a:solidFill>
@@ -11613,26 +10827,26 @@
                 <a:ea typeface="Trebuchet MS" pitchFamily="34" charset="-122"/>
                 <a:cs typeface="Trebuchet MS" pitchFamily="34" charset="-120"/>
               </a:rPr>
-              <a:t>Renderer</a:t>
-            </a:r>
-            <a:endParaRPr lang="en-US" sz="1100" dirty="0"/>
-          </a:p>
-        </p:txBody>
-      </p:sp>
-      <p:sp>
-        <p:nvSpPr>
-          <p:cNvPr id="44" name="Shape 42"/>
-          <p:cNvSpPr/>
-          <p:nvPr/>
-        </p:nvSpPr>
-        <p:spPr>
-          <a:xfrm>
-            <a:off x="406390" y="4914900"/>
-            <a:ext cx="11378916" cy="831850"/>
+              <a:t>Renderer Multipli</a:t>
+            </a:r>
+            <a:endParaRPr lang="en-US" sz="1200" dirty="0"/>
+          </a:p>
+        </p:txBody>
+      </p:sp>
+      <p:sp>
+        <p:nvSpPr>
+          <p:cNvPr id="32" name="Shape 30"/>
+          <p:cNvSpPr/>
+          <p:nvPr/>
+        </p:nvSpPr>
+        <p:spPr>
+          <a:xfrm>
+            <a:off x="406390" y="3467100"/>
+            <a:ext cx="11378916" cy="965200"/>
           </a:xfrm>
           <a:prstGeom prst="roundRect">
             <a:avLst>
-              <a:gd name="adj" fmla="val 8794"/>
+              <a:gd name="adj" fmla="val 7579"/>
             </a:avLst>
           </a:prstGeom>
           <a:solidFill>
@@ -11648,14 +10862,14 @@
       </p:sp>
       <p:sp>
         <p:nvSpPr>
-          <p:cNvPr id="45" name="Text 43"/>
-          <p:cNvSpPr/>
-          <p:nvPr/>
-        </p:nvSpPr>
-        <p:spPr>
-          <a:xfrm>
-            <a:off x="543550" y="4988052"/>
-            <a:ext cx="11104596" cy="274320"/>
+          <p:cNvPr id="33" name="Text 31"/>
+          <p:cNvSpPr/>
+          <p:nvPr/>
+        </p:nvSpPr>
+        <p:spPr>
+          <a:xfrm>
+            <a:off x="589270" y="3613404"/>
+            <a:ext cx="11013156" cy="274320"/>
           </a:xfrm>
           <a:prstGeom prst="rect">
             <a:avLst/>
@@ -11687,14 +10901,14 @@
       </p:sp>
       <p:sp>
         <p:nvSpPr>
-          <p:cNvPr id="46" name="Text 44"/>
-          <p:cNvSpPr/>
-          <p:nvPr/>
-        </p:nvSpPr>
-        <p:spPr>
-          <a:xfrm>
-            <a:off x="543550" y="5308092"/>
-            <a:ext cx="11104596" cy="365506"/>
+          <p:cNvPr id="34" name="Text 32"/>
+          <p:cNvSpPr/>
+          <p:nvPr/>
+        </p:nvSpPr>
+        <p:spPr>
+          <a:xfrm>
+            <a:off x="589270" y="3942588"/>
+            <a:ext cx="11013156" cy="361696"/>
           </a:xfrm>
           <a:prstGeom prst="rect">
             <a:avLst/>
@@ -11726,7 +10940,7 @@
       </p:sp>
       <p:sp>
         <p:nvSpPr>
-          <p:cNvPr id="47" name="Text 45"/>
+          <p:cNvPr id="35" name="Text 33"/>
           <p:cNvSpPr/>
           <p:nvPr/>
         </p:nvSpPr>
@@ -12666,11 +11880,11 @@
         <p:spPr>
           <a:xfrm>
             <a:off x="406390" y="2019300"/>
-            <a:ext cx="6160616" cy="1905000"/>
+            <a:ext cx="6160616" cy="2476500"/>
           </a:xfrm>
           <a:prstGeom prst="roundRect">
             <a:avLst>
-              <a:gd name="adj" fmla="val 3840"/>
+              <a:gd name="adj" fmla="val 2954"/>
             </a:avLst>
           </a:prstGeom>
           <a:solidFill>
@@ -12767,17 +11981,17 @@
         </p:nvSpPr>
         <p:spPr>
           <a:xfrm>
-            <a:off x="589270" y="2311908"/>
-            <a:ext cx="5794856" cy="1539240"/>
-          </a:xfrm>
-          <a:prstGeom prst="rect">
-            <a:avLst/>
-          </a:prstGeom>
-          <a:noFill/>
-          <a:ln/>
-        </p:spPr>
-        <p:txBody>
-          <a:bodyPr wrap="square" rtlCol="0" anchor="t"/>
+            <a:off x="607558" y="2348484"/>
+            <a:ext cx="5758280" cy="2037588"/>
+          </a:xfrm>
+          <a:prstGeom prst="rect">
+            <a:avLst/>
+          </a:prstGeom>
+          <a:noFill/>
+          <a:ln/>
+        </p:spPr>
+        <p:txBody>
+          <a:bodyPr wrap="square" lIns="0" tIns="0" rIns="0" bIns="0" rtlCol="0" anchor="t"/>
           <a:lstStyle/>
           <a:p>
             <a:pPr indent="0" marL="0">
@@ -14500,11 +13714,11 @@
         <p:spPr>
           <a:xfrm>
             <a:off x="6184745" y="2019300"/>
-            <a:ext cx="5600560" cy="2057400"/>
+            <a:ext cx="5600560" cy="2438400"/>
           </a:xfrm>
           <a:prstGeom prst="roundRect">
             <a:avLst>
-              <a:gd name="adj" fmla="val 3556"/>
+              <a:gd name="adj" fmla="val 3000"/>
             </a:avLst>
           </a:prstGeom>
           <a:solidFill>
@@ -14527,7 +13741,7 @@
         <p:spPr>
           <a:xfrm>
             <a:off x="6203033" y="2055876"/>
-            <a:ext cx="54864" cy="1984248"/>
+            <a:ext cx="54864" cy="2365248"/>
           </a:xfrm>
           <a:prstGeom prst="roundRect">
             <a:avLst>
@@ -14588,11 +13802,11 @@
         <p:spPr>
           <a:xfrm>
             <a:off x="6413340" y="2705100"/>
-            <a:ext cx="5143371" cy="1016000"/>
+            <a:ext cx="5143371" cy="1397000"/>
           </a:xfrm>
           <a:prstGeom prst="roundRect">
             <a:avLst>
-              <a:gd name="adj" fmla="val 7200"/>
+              <a:gd name="adj" fmla="val 5236"/>
             </a:avLst>
           </a:prstGeom>
           <a:solidFill>
@@ -14689,24 +13903,24 @@
         </p:nvSpPr>
         <p:spPr>
           <a:xfrm>
-            <a:off x="6596220" y="2997708"/>
-            <a:ext cx="4777611" cy="650240"/>
-          </a:xfrm>
-          <a:prstGeom prst="rect">
-            <a:avLst/>
-          </a:prstGeom>
-          <a:noFill/>
-          <a:ln/>
-        </p:spPr>
-        <p:txBody>
-          <a:bodyPr wrap="square" rtlCol="0" anchor="t"/>
+            <a:off x="6614508" y="3034284"/>
+            <a:ext cx="4741035" cy="958088"/>
+          </a:xfrm>
+          <a:prstGeom prst="rect">
+            <a:avLst/>
+          </a:prstGeom>
+          <a:noFill/>
+          <a:ln/>
+        </p:spPr>
+        <p:txBody>
+          <a:bodyPr wrap="square" lIns="0" tIns="0" rIns="0" bIns="0" rtlCol="0" anchor="t"/>
           <a:lstStyle/>
           <a:p>
             <a:pPr indent="0" marL="0">
               <a:buNone/>
             </a:pPr>
             <a:r>
-              <a:rPr lang="en-US" sz="1150" dirty="0">
+              <a:rPr lang="en-US" sz="1000" dirty="0">
                 <a:solidFill>
                   <a:srgbClr val="00F0FF"/>
                 </a:solidFill>
@@ -14716,14 +13930,14 @@
               </a:rPr>
               <a:t>[YUM004] Alta densità informativa</a:t>
             </a:r>
-            <a:endParaRPr lang="en-US" sz="1150" dirty="0"/>
+            <a:endParaRPr lang="en-US" sz="1000" dirty="0"/>
           </a:p>
           <a:p>
             <a:pPr indent="0" marL="0">
               <a:buNone/>
             </a:pPr>
             <a:r>
-              <a:rPr lang="en-US" sz="1150" dirty="0">
+              <a:rPr lang="en-US" sz="1000" dirty="0">
                 <a:solidFill>
                   <a:srgbClr val="00F0FF"/>
                 </a:solidFill>
@@ -14733,14 +13947,14 @@
               </a:rPr>
               <a:t>La slide contiene troppi elementi complessi.</a:t>
             </a:r>
-            <a:endParaRPr lang="en-US" sz="1150" dirty="0"/>
+            <a:endParaRPr lang="en-US" sz="1000" dirty="0"/>
           </a:p>
           <a:p>
             <a:pPr indent="0" marL="0">
               <a:buNone/>
             </a:pPr>
             <a:r>
-              <a:rPr lang="en-US" sz="1150" dirty="0">
+              <a:rPr lang="en-US" sz="1000" dirty="0">
                 <a:solidFill>
                   <a:srgbClr val="00F0FF"/>
                 </a:solidFill>
@@ -14750,14 +13964,14 @@
               </a:rPr>
               <a:t>Suggerimento: dividere la slide o usare</a:t>
             </a:r>
-            <a:endParaRPr lang="en-US" sz="1150" dirty="0"/>
+            <a:endParaRPr lang="en-US" sz="1000" dirty="0"/>
           </a:p>
           <a:p>
             <a:pPr indent="0" marL="0">
               <a:buNone/>
             </a:pPr>
             <a:r>
-              <a:rPr lang="en-US" sz="1150" dirty="0">
+              <a:rPr lang="en-US" sz="1000" dirty="0">
                 <a:solidFill>
                   <a:srgbClr val="00F0FF"/>
                 </a:solidFill>
@@ -14767,7 +13981,7 @@
               </a:rPr>
               <a:t>una griglia di metriche.</a:t>
             </a:r>
-            <a:endParaRPr lang="en-US" sz="1150" dirty="0"/>
+            <a:endParaRPr lang="en-US" sz="1000" dirty="0"/>
           </a:p>
         </p:txBody>
       </p:sp>
@@ -14780,11 +13994,11 @@
         <p:spPr>
           <a:xfrm>
             <a:off x="406390" y="5791200"/>
-            <a:ext cx="11378916" cy="654050"/>
+            <a:ext cx="11378916" cy="774700"/>
           </a:xfrm>
           <a:prstGeom prst="roundRect">
             <a:avLst>
-              <a:gd name="adj" fmla="val 11184"/>
+              <a:gd name="adj" fmla="val 9443"/>
             </a:avLst>
           </a:prstGeom>
           <a:solidFill>
@@ -14806,8 +14020,8 @@
         </p:nvSpPr>
         <p:spPr>
           <a:xfrm>
-            <a:off x="543550" y="5864352"/>
-            <a:ext cx="11104596" cy="274320"/>
+            <a:off x="589270" y="5937504"/>
+            <a:ext cx="11013156" cy="274320"/>
           </a:xfrm>
           <a:prstGeom prst="rect">
             <a:avLst/>
@@ -14845,8 +14059,8 @@
         </p:nvSpPr>
         <p:spPr>
           <a:xfrm>
-            <a:off x="543550" y="6184392"/>
-            <a:ext cx="11104596" cy="187706"/>
+            <a:off x="589270" y="6266688"/>
+            <a:ext cx="11013156" cy="182880"/>
           </a:xfrm>
           <a:prstGeom prst="rect">
             <a:avLst/>

</xml_diff>

<commit_message>
fix(layout,html): prevent grid cards from overflowing slide height
Tighten paragraph/list estimates, densify card packing, and equalize row heights so uneven bullet columns stay closed within 16:9.
</commit_message>
<xml_diff>
--- a/presentation.pptx
+++ b/presentation.pptx
@@ -2303,16 +2303,18 @@
         <p:spPr>
           <a:xfrm>
             <a:off x="406390" y="1701800"/>
-            <a:ext cx="11378916" cy="368300"/>
-          </a:xfrm>
-          <a:prstGeom prst="rect">
-            <a:avLst/>
-          </a:prstGeom>
-          <a:noFill/>
-          <a:ln/>
-        </p:spPr>
-        <p:txBody>
-          <a:bodyPr wrap="square" lIns="0" tIns="0" rIns="0" bIns="0" rtlCol="0" anchor="t"/>
+            <a:ext cx="11378916" cy="266700"/>
+          </a:xfrm>
+          <a:prstGeom prst="rect">
+            <a:avLst/>
+          </a:prstGeom>
+          <a:noFill/>
+          <a:ln/>
+        </p:spPr>
+        <p:txBody>
+          <a:bodyPr wrap="square" lIns="0" tIns="0" rIns="0" bIns="0" rtlCol="0" anchor="t">
+            <a:normAutofit/>
+          </a:bodyPr>
           <a:lstStyle/>
           <a:p>
             <a:pPr algn="ctr" indent="0" marL="0">
@@ -2491,11 +2493,11 @@
         <p:spPr>
           <a:xfrm>
             <a:off x="406390" y="2019300"/>
-            <a:ext cx="3674441" cy="2006600"/>
+            <a:ext cx="3725240" cy="1752600"/>
           </a:xfrm>
           <a:prstGeom prst="roundRect">
             <a:avLst>
-              <a:gd name="adj" fmla="val 3646"/>
+              <a:gd name="adj" fmla="val 4174"/>
             </a:avLst>
           </a:prstGeom>
           <a:solidFill>
@@ -2518,7 +2520,7 @@
         <p:spPr>
           <a:xfrm>
             <a:off x="424678" y="2055876"/>
-            <a:ext cx="54864" cy="1933448"/>
+            <a:ext cx="54864" cy="1679448"/>
           </a:xfrm>
           <a:prstGeom prst="roundRect">
             <a:avLst>
@@ -2540,7 +2542,7 @@
         <p:spPr>
           <a:xfrm>
             <a:off x="634990" y="2129028"/>
-            <a:ext cx="3217241" cy="274320"/>
+            <a:ext cx="3268040" cy="274320"/>
           </a:xfrm>
           <a:prstGeom prst="rect">
             <a:avLst/>
@@ -2578,8 +2580,8 @@
         </p:nvSpPr>
         <p:spPr>
           <a:xfrm>
-            <a:off x="634984" y="2705100"/>
-            <a:ext cx="3217253" cy="965200"/>
+            <a:off x="584185" y="2552700"/>
+            <a:ext cx="3369649" cy="965200"/>
           </a:xfrm>
           <a:prstGeom prst="roundRect">
             <a:avLst>
@@ -2605,7 +2607,7 @@
         </p:nvSpPr>
         <p:spPr>
           <a:xfrm>
-            <a:off x="772144" y="2814828"/>
+            <a:off x="721345" y="2662428"/>
             <a:ext cx="91440" cy="91440"/>
           </a:xfrm>
           <a:prstGeom prst="ellipse">
@@ -2630,7 +2632,7 @@
         </p:nvSpPr>
         <p:spPr>
           <a:xfrm>
-            <a:off x="909304" y="2814828"/>
+            <a:off x="858505" y="2662428"/>
             <a:ext cx="91440" cy="91440"/>
           </a:xfrm>
           <a:prstGeom prst="ellipse">
@@ -2655,7 +2657,7 @@
         </p:nvSpPr>
         <p:spPr>
           <a:xfrm>
-            <a:off x="1046464" y="2814828"/>
+            <a:off x="995665" y="2662428"/>
             <a:ext cx="91440" cy="91440"/>
           </a:xfrm>
           <a:prstGeom prst="ellipse">
@@ -2680,8 +2682,8 @@
         </p:nvSpPr>
         <p:spPr>
           <a:xfrm>
-            <a:off x="836152" y="3034284"/>
-            <a:ext cx="2814917" cy="526288"/>
+            <a:off x="785353" y="2881884"/>
+            <a:ext cx="2967313" cy="526288"/>
           </a:xfrm>
           <a:prstGeom prst="rect">
             <a:avLst/>
@@ -2736,12 +2738,12 @@
         </p:nvSpPr>
         <p:spPr>
           <a:xfrm>
-            <a:off x="4258627" y="2019300"/>
-            <a:ext cx="3674441" cy="2006600"/>
+            <a:off x="4233228" y="2019300"/>
+            <a:ext cx="3725240" cy="1752600"/>
           </a:xfrm>
           <a:prstGeom prst="roundRect">
             <a:avLst>
-              <a:gd name="adj" fmla="val 3646"/>
+              <a:gd name="adj" fmla="val 4174"/>
             </a:avLst>
           </a:prstGeom>
           <a:solidFill>
@@ -2763,8 +2765,8 @@
         </p:nvSpPr>
         <p:spPr>
           <a:xfrm>
-            <a:off x="4276915" y="2055876"/>
-            <a:ext cx="54864" cy="1933448"/>
+            <a:off x="4251516" y="2055876"/>
+            <a:ext cx="54864" cy="1679448"/>
           </a:xfrm>
           <a:prstGeom prst="roundRect">
             <a:avLst>
@@ -2785,8 +2787,8 @@
         </p:nvSpPr>
         <p:spPr>
           <a:xfrm>
-            <a:off x="4487227" y="2129028"/>
-            <a:ext cx="3217241" cy="274320"/>
+            <a:off x="4461828" y="2129028"/>
+            <a:ext cx="3268040" cy="274320"/>
           </a:xfrm>
           <a:prstGeom prst="rect">
             <a:avLst/>
@@ -2824,8 +2826,8 @@
         </p:nvSpPr>
         <p:spPr>
           <a:xfrm>
-            <a:off x="4487221" y="2705100"/>
-            <a:ext cx="3217253" cy="965200"/>
+            <a:off x="4411023" y="2552700"/>
+            <a:ext cx="3369649" cy="965200"/>
           </a:xfrm>
           <a:prstGeom prst="roundRect">
             <a:avLst>
@@ -2851,7 +2853,7 @@
         </p:nvSpPr>
         <p:spPr>
           <a:xfrm>
-            <a:off x="4624381" y="2814828"/>
+            <a:off x="4548183" y="2662428"/>
             <a:ext cx="91440" cy="91440"/>
           </a:xfrm>
           <a:prstGeom prst="ellipse">
@@ -2876,7 +2878,7 @@
         </p:nvSpPr>
         <p:spPr>
           <a:xfrm>
-            <a:off x="4761541" y="2814828"/>
+            <a:off x="4685343" y="2662428"/>
             <a:ext cx="91440" cy="91440"/>
           </a:xfrm>
           <a:prstGeom prst="ellipse">
@@ -2901,7 +2903,7 @@
         </p:nvSpPr>
         <p:spPr>
           <a:xfrm>
-            <a:off x="4898701" y="2814828"/>
+            <a:off x="4822503" y="2662428"/>
             <a:ext cx="91440" cy="91440"/>
           </a:xfrm>
           <a:prstGeom prst="ellipse">
@@ -2926,8 +2928,8 @@
         </p:nvSpPr>
         <p:spPr>
           <a:xfrm>
-            <a:off x="4688389" y="3034284"/>
-            <a:ext cx="2814917" cy="526288"/>
+            <a:off x="4612191" y="2881884"/>
+            <a:ext cx="2967313" cy="526288"/>
           </a:xfrm>
           <a:prstGeom prst="rect">
             <a:avLst/>
@@ -2982,12 +2984,12 @@
         </p:nvSpPr>
         <p:spPr>
           <a:xfrm>
-            <a:off x="8110864" y="2019300"/>
-            <a:ext cx="3674441" cy="2006600"/>
+            <a:off x="8060065" y="2019300"/>
+            <a:ext cx="3725240" cy="1752600"/>
           </a:xfrm>
           <a:prstGeom prst="roundRect">
             <a:avLst>
-              <a:gd name="adj" fmla="val 3646"/>
+              <a:gd name="adj" fmla="val 4174"/>
             </a:avLst>
           </a:prstGeom>
           <a:solidFill>
@@ -3009,8 +3011,8 @@
         </p:nvSpPr>
         <p:spPr>
           <a:xfrm>
-            <a:off x="8129152" y="2055876"/>
-            <a:ext cx="54864" cy="1933448"/>
+            <a:off x="8078353" y="2055876"/>
+            <a:ext cx="54864" cy="1679448"/>
           </a:xfrm>
           <a:prstGeom prst="roundRect">
             <a:avLst>
@@ -3031,8 +3033,8 @@
         </p:nvSpPr>
         <p:spPr>
           <a:xfrm>
-            <a:off x="8339464" y="2129028"/>
-            <a:ext cx="3217241" cy="274320"/>
+            <a:off x="8288665" y="2129028"/>
+            <a:ext cx="3268040" cy="274320"/>
           </a:xfrm>
           <a:prstGeom prst="rect">
             <a:avLst/>
@@ -3070,8 +3072,8 @@
         </p:nvSpPr>
         <p:spPr>
           <a:xfrm>
-            <a:off x="8339458" y="2705100"/>
-            <a:ext cx="3217253" cy="965200"/>
+            <a:off x="8237861" y="2552700"/>
+            <a:ext cx="3369649" cy="965200"/>
           </a:xfrm>
           <a:prstGeom prst="roundRect">
             <a:avLst>
@@ -3097,7 +3099,7 @@
         </p:nvSpPr>
         <p:spPr>
           <a:xfrm>
-            <a:off x="8476618" y="2814828"/>
+            <a:off x="8375021" y="2662428"/>
             <a:ext cx="91440" cy="91440"/>
           </a:xfrm>
           <a:prstGeom prst="ellipse">
@@ -3122,7 +3124,7 @@
         </p:nvSpPr>
         <p:spPr>
           <a:xfrm>
-            <a:off x="8613778" y="2814828"/>
+            <a:off x="8512181" y="2662428"/>
             <a:ext cx="91440" cy="91440"/>
           </a:xfrm>
           <a:prstGeom prst="ellipse">
@@ -3147,7 +3149,7 @@
         </p:nvSpPr>
         <p:spPr>
           <a:xfrm>
-            <a:off x="8750938" y="2814828"/>
+            <a:off x="8649341" y="2662428"/>
             <a:ext cx="91440" cy="91440"/>
           </a:xfrm>
           <a:prstGeom prst="ellipse">
@@ -3172,8 +3174,8 @@
         </p:nvSpPr>
         <p:spPr>
           <a:xfrm>
-            <a:off x="8540626" y="3034284"/>
-            <a:ext cx="2814917" cy="526288"/>
+            <a:off x="8439029" y="2881884"/>
+            <a:ext cx="2967313" cy="526288"/>
           </a:xfrm>
           <a:prstGeom prst="rect">
             <a:avLst/>
@@ -3228,7 +3230,7 @@
         </p:nvSpPr>
         <p:spPr>
           <a:xfrm>
-            <a:off x="406390" y="4381500"/>
+            <a:off x="406390" y="3949700"/>
             <a:ext cx="11378916" cy="774700"/>
           </a:xfrm>
           <a:prstGeom prst="roundRect">
@@ -3255,7 +3257,7 @@
         </p:nvSpPr>
         <p:spPr>
           <a:xfrm>
-            <a:off x="589270" y="4527804"/>
+            <a:off x="589270" y="4096004"/>
             <a:ext cx="11013156" cy="274320"/>
           </a:xfrm>
           <a:prstGeom prst="rect">
@@ -3294,7 +3296,7 @@
         </p:nvSpPr>
         <p:spPr>
           <a:xfrm>
-            <a:off x="589270" y="4856988"/>
+            <a:off x="589270" y="4425188"/>
             <a:ext cx="11013156" cy="182880"/>
           </a:xfrm>
           <a:prstGeom prst="rect">
@@ -3483,11 +3485,11 @@
         <p:spPr>
           <a:xfrm>
             <a:off x="406390" y="2019300"/>
-            <a:ext cx="5460858" cy="4089400"/>
+            <a:ext cx="5460858" cy="2463800"/>
           </a:xfrm>
           <a:prstGeom prst="roundRect">
             <a:avLst>
-              <a:gd name="adj" fmla="val 2236"/>
+              <a:gd name="adj" fmla="val 3711"/>
             </a:avLst>
           </a:prstGeom>
           <a:solidFill>
@@ -3549,11 +3551,11 @@
         <p:spPr>
           <a:xfrm>
             <a:off x="6324448" y="2019300"/>
-            <a:ext cx="5460858" cy="4089400"/>
+            <a:ext cx="5460858" cy="2463800"/>
           </a:xfrm>
           <a:prstGeom prst="roundRect">
             <a:avLst>
-              <a:gd name="adj" fmla="val 2236"/>
+              <a:gd name="adj" fmla="val 3711"/>
             </a:avLst>
           </a:prstGeom>
           <a:solidFill>
@@ -3614,7 +3616,7 @@
         </p:nvSpPr>
         <p:spPr>
           <a:xfrm>
-            <a:off x="5903824" y="3871976"/>
+            <a:off x="5903824" y="3059176"/>
             <a:ext cx="384048" cy="384048"/>
           </a:xfrm>
           <a:prstGeom prst="ellipse">
@@ -3639,7 +3641,7 @@
         </p:nvSpPr>
         <p:spPr>
           <a:xfrm>
-            <a:off x="5903824" y="3871976"/>
+            <a:off x="5903824" y="3059176"/>
             <a:ext cx="384048" cy="384048"/>
           </a:xfrm>
           <a:prstGeom prst="rect">
@@ -3745,16 +3747,18 @@
         <p:spPr>
           <a:xfrm>
             <a:off x="584185" y="2971800"/>
-            <a:ext cx="5156071" cy="673100"/>
-          </a:xfrm>
-          <a:prstGeom prst="rect">
-            <a:avLst/>
-          </a:prstGeom>
-          <a:noFill/>
-          <a:ln/>
-        </p:spPr>
-        <p:txBody>
-          <a:bodyPr wrap="square" lIns="0" tIns="0" rIns="0" bIns="0" rtlCol="0" anchor="t"/>
+            <a:ext cx="5156071" cy="266700"/>
+          </a:xfrm>
+          <a:prstGeom prst="rect">
+            <a:avLst/>
+          </a:prstGeom>
+          <a:noFill/>
+          <a:ln/>
+        </p:spPr>
+        <p:txBody>
+          <a:bodyPr wrap="square" lIns="0" tIns="0" rIns="0" bIns="0" rtlCol="0" anchor="t">
+            <a:normAutofit/>
+          </a:bodyPr>
           <a:lstStyle/>
           <a:p>
             <a:pPr algn="l" indent="0" marL="0">
@@ -3783,17 +3787,19 @@
         </p:nvSpPr>
         <p:spPr>
           <a:xfrm>
-            <a:off x="584185" y="3733800"/>
-            <a:ext cx="5156071" cy="673100"/>
-          </a:xfrm>
-          <a:prstGeom prst="rect">
-            <a:avLst/>
-          </a:prstGeom>
-          <a:noFill/>
-          <a:ln/>
-        </p:spPr>
-        <p:txBody>
-          <a:bodyPr wrap="square" lIns="0" tIns="0" rIns="0" bIns="0" rtlCol="0" anchor="t"/>
+            <a:off x="584185" y="3327400"/>
+            <a:ext cx="5156071" cy="266700"/>
+          </a:xfrm>
+          <a:prstGeom prst="rect">
+            <a:avLst/>
+          </a:prstGeom>
+          <a:noFill/>
+          <a:ln/>
+        </p:spPr>
+        <p:txBody>
+          <a:bodyPr wrap="square" lIns="0" tIns="0" rIns="0" bIns="0" rtlCol="0" anchor="t">
+            <a:normAutofit/>
+          </a:bodyPr>
           <a:lstStyle/>
           <a:p>
             <a:pPr algn="l" indent="0" marL="0">
@@ -3822,17 +3828,19 @@
         </p:nvSpPr>
         <p:spPr>
           <a:xfrm>
-            <a:off x="584185" y="4495800"/>
-            <a:ext cx="5156071" cy="673100"/>
-          </a:xfrm>
-          <a:prstGeom prst="rect">
-            <a:avLst/>
-          </a:prstGeom>
-          <a:noFill/>
-          <a:ln/>
-        </p:spPr>
-        <p:txBody>
-          <a:bodyPr wrap="square" lIns="0" tIns="0" rIns="0" bIns="0" rtlCol="0" anchor="t"/>
+            <a:off x="584185" y="3683000"/>
+            <a:ext cx="5156071" cy="266700"/>
+          </a:xfrm>
+          <a:prstGeom prst="rect">
+            <a:avLst/>
+          </a:prstGeom>
+          <a:noFill/>
+          <a:ln/>
+        </p:spPr>
+        <p:txBody>
+          <a:bodyPr wrap="square" lIns="0" tIns="0" rIns="0" bIns="0" rtlCol="0" anchor="t">
+            <a:normAutofit/>
+          </a:bodyPr>
           <a:lstStyle/>
           <a:p>
             <a:pPr algn="l" indent="0" marL="0">
@@ -3861,17 +3869,19 @@
         </p:nvSpPr>
         <p:spPr>
           <a:xfrm>
-            <a:off x="584185" y="5257800"/>
-            <a:ext cx="5156071" cy="368300"/>
-          </a:xfrm>
-          <a:prstGeom prst="rect">
-            <a:avLst/>
-          </a:prstGeom>
-          <a:noFill/>
-          <a:ln/>
-        </p:spPr>
-        <p:txBody>
-          <a:bodyPr wrap="square" lIns="0" tIns="0" rIns="0" bIns="0" rtlCol="0" anchor="t"/>
+            <a:off x="584185" y="4038600"/>
+            <a:ext cx="5156071" cy="266700"/>
+          </a:xfrm>
+          <a:prstGeom prst="rect">
+            <a:avLst/>
+          </a:prstGeom>
+          <a:noFill/>
+          <a:ln/>
+        </p:spPr>
+        <p:txBody>
+          <a:bodyPr wrap="square" lIns="0" tIns="0" rIns="0" bIns="0" rtlCol="0" anchor="t">
+            <a:normAutofit/>
+          </a:bodyPr>
           <a:lstStyle/>
           <a:p>
             <a:pPr algn="l" indent="0" marL="0">
@@ -3967,16 +3977,18 @@
         <p:spPr>
           <a:xfrm>
             <a:off x="6451439" y="2971800"/>
-            <a:ext cx="5156071" cy="673100"/>
-          </a:xfrm>
-          <a:prstGeom prst="rect">
-            <a:avLst/>
-          </a:prstGeom>
-          <a:noFill/>
-          <a:ln/>
-        </p:spPr>
-        <p:txBody>
-          <a:bodyPr wrap="square" lIns="0" tIns="0" rIns="0" bIns="0" rtlCol="0" anchor="t"/>
+            <a:ext cx="5156071" cy="266700"/>
+          </a:xfrm>
+          <a:prstGeom prst="rect">
+            <a:avLst/>
+          </a:prstGeom>
+          <a:noFill/>
+          <a:ln/>
+        </p:spPr>
+        <p:txBody>
+          <a:bodyPr wrap="square" lIns="0" tIns="0" rIns="0" bIns="0" rtlCol="0" anchor="t">
+            <a:normAutofit/>
+          </a:bodyPr>
           <a:lstStyle/>
           <a:p>
             <a:pPr algn="l" indent="0" marL="0">
@@ -4005,17 +4017,19 @@
         </p:nvSpPr>
         <p:spPr>
           <a:xfrm>
-            <a:off x="6451439" y="3733800"/>
-            <a:ext cx="5156071" cy="673100"/>
-          </a:xfrm>
-          <a:prstGeom prst="rect">
-            <a:avLst/>
-          </a:prstGeom>
-          <a:noFill/>
-          <a:ln/>
-        </p:spPr>
-        <p:txBody>
-          <a:bodyPr wrap="square" lIns="0" tIns="0" rIns="0" bIns="0" rtlCol="0" anchor="t"/>
+            <a:off x="6451439" y="3327400"/>
+            <a:ext cx="5156071" cy="266700"/>
+          </a:xfrm>
+          <a:prstGeom prst="rect">
+            <a:avLst/>
+          </a:prstGeom>
+          <a:noFill/>
+          <a:ln/>
+        </p:spPr>
+        <p:txBody>
+          <a:bodyPr wrap="square" lIns="0" tIns="0" rIns="0" bIns="0" rtlCol="0" anchor="t">
+            <a:normAutofit/>
+          </a:bodyPr>
           <a:lstStyle/>
           <a:p>
             <a:pPr algn="l" indent="0" marL="0">
@@ -4044,17 +4058,19 @@
         </p:nvSpPr>
         <p:spPr>
           <a:xfrm>
-            <a:off x="6451439" y="4495800"/>
-            <a:ext cx="5156071" cy="673100"/>
-          </a:xfrm>
-          <a:prstGeom prst="rect">
-            <a:avLst/>
-          </a:prstGeom>
-          <a:noFill/>
-          <a:ln/>
-        </p:spPr>
-        <p:txBody>
-          <a:bodyPr wrap="square" lIns="0" tIns="0" rIns="0" bIns="0" rtlCol="0" anchor="t"/>
+            <a:off x="6451439" y="3683000"/>
+            <a:ext cx="5156071" cy="266700"/>
+          </a:xfrm>
+          <a:prstGeom prst="rect">
+            <a:avLst/>
+          </a:prstGeom>
+          <a:noFill/>
+          <a:ln/>
+        </p:spPr>
+        <p:txBody>
+          <a:bodyPr wrap="square" lIns="0" tIns="0" rIns="0" bIns="0" rtlCol="0" anchor="t">
+            <a:normAutofit/>
+          </a:bodyPr>
           <a:lstStyle/>
           <a:p>
             <a:pPr algn="l" indent="0" marL="0">
@@ -4083,17 +4099,19 @@
         </p:nvSpPr>
         <p:spPr>
           <a:xfrm>
-            <a:off x="6451439" y="5257800"/>
-            <a:ext cx="5156071" cy="673100"/>
-          </a:xfrm>
-          <a:prstGeom prst="rect">
-            <a:avLst/>
-          </a:prstGeom>
-          <a:noFill/>
-          <a:ln/>
-        </p:spPr>
-        <p:txBody>
-          <a:bodyPr wrap="square" lIns="0" tIns="0" rIns="0" bIns="0" rtlCol="0" anchor="t"/>
+            <a:off x="6451439" y="4038600"/>
+            <a:ext cx="5156071" cy="266700"/>
+          </a:xfrm>
+          <a:prstGeom prst="rect">
+            <a:avLst/>
+          </a:prstGeom>
+          <a:noFill/>
+          <a:ln/>
+        </p:spPr>
+        <p:txBody>
+          <a:bodyPr wrap="square" lIns="0" tIns="0" rIns="0" bIns="0" rtlCol="0" anchor="t">
+            <a:normAutofit/>
+          </a:bodyPr>
           <a:lstStyle/>
           <a:p>
             <a:pPr algn="l" indent="0" marL="0">
@@ -4272,11 +4290,11 @@
         <p:spPr>
           <a:xfrm>
             <a:off x="406390" y="2019300"/>
-            <a:ext cx="3674441" cy="2019300"/>
+            <a:ext cx="3725240" cy="1270000"/>
           </a:xfrm>
           <a:prstGeom prst="roundRect">
             <a:avLst>
-              <a:gd name="adj" fmla="val 3623"/>
+              <a:gd name="adj" fmla="val 5760"/>
             </a:avLst>
           </a:prstGeom>
           <a:solidFill>
@@ -4299,7 +4317,7 @@
         <p:spPr>
           <a:xfrm>
             <a:off x="424678" y="2055876"/>
-            <a:ext cx="54864" cy="1946148"/>
+            <a:ext cx="54864" cy="1196848"/>
           </a:xfrm>
           <a:prstGeom prst="roundRect">
             <a:avLst>
@@ -4321,7 +4339,7 @@
         <p:spPr>
           <a:xfrm>
             <a:off x="634990" y="2129028"/>
-            <a:ext cx="3217241" cy="274320"/>
+            <a:ext cx="3268040" cy="274320"/>
           </a:xfrm>
           <a:prstGeom prst="rect">
             <a:avLst/>
@@ -4359,8 +4377,8 @@
         </p:nvSpPr>
         <p:spPr>
           <a:xfrm>
-            <a:off x="634984" y="2705100"/>
-            <a:ext cx="3217253" cy="977900"/>
+            <a:off x="584185" y="2552700"/>
+            <a:ext cx="3369649" cy="482600"/>
           </a:xfrm>
           <a:prstGeom prst="rect">
             <a:avLst/>
@@ -4398,12 +4416,12 @@
         </p:nvSpPr>
         <p:spPr>
           <a:xfrm>
-            <a:off x="4258627" y="2019300"/>
-            <a:ext cx="3674441" cy="2019300"/>
+            <a:off x="4233228" y="2019300"/>
+            <a:ext cx="3725240" cy="1270000"/>
           </a:xfrm>
           <a:prstGeom prst="roundRect">
             <a:avLst>
-              <a:gd name="adj" fmla="val 3623"/>
+              <a:gd name="adj" fmla="val 5760"/>
             </a:avLst>
           </a:prstGeom>
           <a:solidFill>
@@ -4425,8 +4443,8 @@
         </p:nvSpPr>
         <p:spPr>
           <a:xfrm>
-            <a:off x="4276915" y="2055876"/>
-            <a:ext cx="54864" cy="1946148"/>
+            <a:off x="4251516" y="2055876"/>
+            <a:ext cx="54864" cy="1196848"/>
           </a:xfrm>
           <a:prstGeom prst="roundRect">
             <a:avLst>
@@ -4447,8 +4465,8 @@
         </p:nvSpPr>
         <p:spPr>
           <a:xfrm>
-            <a:off x="4487227" y="2129028"/>
-            <a:ext cx="3217241" cy="274320"/>
+            <a:off x="4461828" y="2129028"/>
+            <a:ext cx="3268040" cy="274320"/>
           </a:xfrm>
           <a:prstGeom prst="rect">
             <a:avLst/>
@@ -4486,8 +4504,8 @@
         </p:nvSpPr>
         <p:spPr>
           <a:xfrm>
-            <a:off x="4487221" y="2705100"/>
-            <a:ext cx="3217253" cy="977900"/>
+            <a:off x="4411023" y="2552700"/>
+            <a:ext cx="3369649" cy="482600"/>
           </a:xfrm>
           <a:prstGeom prst="rect">
             <a:avLst/>
@@ -4525,12 +4543,12 @@
         </p:nvSpPr>
         <p:spPr>
           <a:xfrm>
-            <a:off x="8110864" y="2019300"/>
-            <a:ext cx="3674441" cy="2019300"/>
+            <a:off x="8060065" y="2019300"/>
+            <a:ext cx="3725240" cy="1270000"/>
           </a:xfrm>
           <a:prstGeom prst="roundRect">
             <a:avLst>
-              <a:gd name="adj" fmla="val 3623"/>
+              <a:gd name="adj" fmla="val 5760"/>
             </a:avLst>
           </a:prstGeom>
           <a:solidFill>
@@ -4552,8 +4570,8 @@
         </p:nvSpPr>
         <p:spPr>
           <a:xfrm>
-            <a:off x="8129152" y="2055876"/>
-            <a:ext cx="54864" cy="1946148"/>
+            <a:off x="8078353" y="2055876"/>
+            <a:ext cx="54864" cy="1196848"/>
           </a:xfrm>
           <a:prstGeom prst="roundRect">
             <a:avLst>
@@ -4574,8 +4592,8 @@
         </p:nvSpPr>
         <p:spPr>
           <a:xfrm>
-            <a:off x="8339464" y="2129028"/>
-            <a:ext cx="3217241" cy="274320"/>
+            <a:off x="8288665" y="2129028"/>
+            <a:ext cx="3268040" cy="274320"/>
           </a:xfrm>
           <a:prstGeom prst="rect">
             <a:avLst/>
@@ -4613,8 +4631,8 @@
         </p:nvSpPr>
         <p:spPr>
           <a:xfrm>
-            <a:off x="8339458" y="2705100"/>
-            <a:ext cx="3217253" cy="977900"/>
+            <a:off x="8237861" y="2552700"/>
+            <a:ext cx="3369649" cy="482600"/>
           </a:xfrm>
           <a:prstGeom prst="rect">
             <a:avLst/>
@@ -4652,12 +4670,12 @@
         </p:nvSpPr>
         <p:spPr>
           <a:xfrm>
-            <a:off x="406390" y="4216400"/>
-            <a:ext cx="3674441" cy="2019300"/>
+            <a:off x="406390" y="3390900"/>
+            <a:ext cx="3725240" cy="1270000"/>
           </a:xfrm>
           <a:prstGeom prst="roundRect">
             <a:avLst>
-              <a:gd name="adj" fmla="val 3623"/>
+              <a:gd name="adj" fmla="val 5760"/>
             </a:avLst>
           </a:prstGeom>
           <a:solidFill>
@@ -4679,8 +4697,8 @@
         </p:nvSpPr>
         <p:spPr>
           <a:xfrm>
-            <a:off x="424678" y="4252976"/>
-            <a:ext cx="54864" cy="1946148"/>
+            <a:off x="424678" y="3427476"/>
+            <a:ext cx="54864" cy="1196848"/>
           </a:xfrm>
           <a:prstGeom prst="roundRect">
             <a:avLst>
@@ -4701,8 +4719,8 @@
         </p:nvSpPr>
         <p:spPr>
           <a:xfrm>
-            <a:off x="634990" y="4326128"/>
-            <a:ext cx="3217241" cy="274320"/>
+            <a:off x="634990" y="3500628"/>
+            <a:ext cx="3268040" cy="274320"/>
           </a:xfrm>
           <a:prstGeom prst="rect">
             <a:avLst/>
@@ -4740,8 +4758,8 @@
         </p:nvSpPr>
         <p:spPr>
           <a:xfrm>
-            <a:off x="634984" y="4902200"/>
-            <a:ext cx="3217253" cy="977900"/>
+            <a:off x="584185" y="3924300"/>
+            <a:ext cx="3369649" cy="482600"/>
           </a:xfrm>
           <a:prstGeom prst="rect">
             <a:avLst/>
@@ -4779,12 +4797,12 @@
         </p:nvSpPr>
         <p:spPr>
           <a:xfrm>
-            <a:off x="4258627" y="4216400"/>
-            <a:ext cx="3674441" cy="2019300"/>
+            <a:off x="4233228" y="3390900"/>
+            <a:ext cx="3725240" cy="1270000"/>
           </a:xfrm>
           <a:prstGeom prst="roundRect">
             <a:avLst>
-              <a:gd name="adj" fmla="val 3623"/>
+              <a:gd name="adj" fmla="val 5760"/>
             </a:avLst>
           </a:prstGeom>
           <a:solidFill>
@@ -4806,8 +4824,8 @@
         </p:nvSpPr>
         <p:spPr>
           <a:xfrm>
-            <a:off x="4276915" y="4252976"/>
-            <a:ext cx="54864" cy="1946148"/>
+            <a:off x="4251516" y="3427476"/>
+            <a:ext cx="54864" cy="1196848"/>
           </a:xfrm>
           <a:prstGeom prst="roundRect">
             <a:avLst>
@@ -4828,8 +4846,8 @@
         </p:nvSpPr>
         <p:spPr>
           <a:xfrm>
-            <a:off x="4487227" y="4326128"/>
-            <a:ext cx="3217241" cy="274320"/>
+            <a:off x="4461828" y="3500628"/>
+            <a:ext cx="3268040" cy="274320"/>
           </a:xfrm>
           <a:prstGeom prst="rect">
             <a:avLst/>
@@ -4867,8 +4885,8 @@
         </p:nvSpPr>
         <p:spPr>
           <a:xfrm>
-            <a:off x="4487221" y="4902200"/>
-            <a:ext cx="3217253" cy="977900"/>
+            <a:off x="4411023" y="3924300"/>
+            <a:ext cx="3369649" cy="482600"/>
           </a:xfrm>
           <a:prstGeom prst="rect">
             <a:avLst/>
@@ -4906,12 +4924,12 @@
         </p:nvSpPr>
         <p:spPr>
           <a:xfrm>
-            <a:off x="8110864" y="4216400"/>
-            <a:ext cx="3674441" cy="2019300"/>
+            <a:off x="8060065" y="3390900"/>
+            <a:ext cx="3725240" cy="1270000"/>
           </a:xfrm>
           <a:prstGeom prst="roundRect">
             <a:avLst>
-              <a:gd name="adj" fmla="val 3623"/>
+              <a:gd name="adj" fmla="val 5760"/>
             </a:avLst>
           </a:prstGeom>
           <a:solidFill>
@@ -4933,8 +4951,8 @@
         </p:nvSpPr>
         <p:spPr>
           <a:xfrm>
-            <a:off x="8129152" y="4252976"/>
-            <a:ext cx="54864" cy="1946148"/>
+            <a:off x="8078353" y="3427476"/>
+            <a:ext cx="54864" cy="1196848"/>
           </a:xfrm>
           <a:prstGeom prst="roundRect">
             <a:avLst>
@@ -4955,8 +4973,8 @@
         </p:nvSpPr>
         <p:spPr>
           <a:xfrm>
-            <a:off x="8339464" y="4326128"/>
-            <a:ext cx="3217241" cy="274320"/>
+            <a:off x="8288665" y="3500628"/>
+            <a:ext cx="3268040" cy="274320"/>
           </a:xfrm>
           <a:prstGeom prst="rect">
             <a:avLst/>
@@ -4994,8 +5012,8 @@
         </p:nvSpPr>
         <p:spPr>
           <a:xfrm>
-            <a:off x="8339458" y="4902200"/>
-            <a:ext cx="3217253" cy="977900"/>
+            <a:off x="8237861" y="3924300"/>
+            <a:ext cx="3369649" cy="482600"/>
           </a:xfrm>
           <a:prstGeom prst="rect">
             <a:avLst/>
@@ -5183,11 +5201,11 @@
         <p:spPr>
           <a:xfrm>
             <a:off x="406390" y="2019300"/>
-            <a:ext cx="5600560" cy="1803400"/>
+            <a:ext cx="5600560" cy="1549400"/>
           </a:xfrm>
           <a:prstGeom prst="roundRect">
             <a:avLst>
-              <a:gd name="adj" fmla="val 4056"/>
+              <a:gd name="adj" fmla="val 4721"/>
             </a:avLst>
           </a:prstGeom>
           <a:solidFill>
@@ -5210,7 +5228,7 @@
         <p:spPr>
           <a:xfrm>
             <a:off x="424678" y="2055876"/>
-            <a:ext cx="54864" cy="1730248"/>
+            <a:ext cx="54864" cy="1476248"/>
           </a:xfrm>
           <a:prstGeom prst="roundRect">
             <a:avLst>
@@ -5270,8 +5288,8 @@
         </p:nvSpPr>
         <p:spPr>
           <a:xfrm>
-            <a:off x="634984" y="2705100"/>
-            <a:ext cx="5143371" cy="762000"/>
+            <a:off x="584185" y="2552700"/>
+            <a:ext cx="5244969" cy="762000"/>
           </a:xfrm>
           <a:prstGeom prst="roundRect">
             <a:avLst>
@@ -5297,7 +5315,7 @@
         </p:nvSpPr>
         <p:spPr>
           <a:xfrm>
-            <a:off x="772144" y="2814828"/>
+            <a:off x="721345" y="2662428"/>
             <a:ext cx="91440" cy="91440"/>
           </a:xfrm>
           <a:prstGeom prst="ellipse">
@@ -5322,7 +5340,7 @@
         </p:nvSpPr>
         <p:spPr>
           <a:xfrm>
-            <a:off x="909304" y="2814828"/>
+            <a:off x="858505" y="2662428"/>
             <a:ext cx="91440" cy="91440"/>
           </a:xfrm>
           <a:prstGeom prst="ellipse">
@@ -5347,7 +5365,7 @@
         </p:nvSpPr>
         <p:spPr>
           <a:xfrm>
-            <a:off x="1046464" y="2814828"/>
+            <a:off x="995665" y="2662428"/>
             <a:ext cx="91440" cy="91440"/>
           </a:xfrm>
           <a:prstGeom prst="ellipse">
@@ -5372,8 +5390,8 @@
         </p:nvSpPr>
         <p:spPr>
           <a:xfrm>
-            <a:off x="836152" y="3034284"/>
-            <a:ext cx="4741035" cy="323088"/>
+            <a:off x="785353" y="2881884"/>
+            <a:ext cx="4842633" cy="323088"/>
           </a:xfrm>
           <a:prstGeom prst="rect">
             <a:avLst/>
@@ -5411,17 +5429,19 @@
         </p:nvSpPr>
         <p:spPr>
           <a:xfrm>
-            <a:off x="406390" y="4000500"/>
-            <a:ext cx="5600560" cy="673100"/>
-          </a:xfrm>
-          <a:prstGeom prst="rect">
-            <a:avLst/>
-          </a:prstGeom>
-          <a:noFill/>
-          <a:ln/>
-        </p:spPr>
-        <p:txBody>
-          <a:bodyPr wrap="square" lIns="0" tIns="0" rIns="0" bIns="0" rtlCol="0" anchor="t"/>
+            <a:off x="406390" y="3746500"/>
+            <a:ext cx="5600560" cy="266700"/>
+          </a:xfrm>
+          <a:prstGeom prst="rect">
+            <a:avLst/>
+          </a:prstGeom>
+          <a:noFill/>
+          <a:ln/>
+        </p:spPr>
+        <p:txBody>
+          <a:bodyPr wrap="square" lIns="0" tIns="0" rIns="0" bIns="0" rtlCol="0" anchor="t">
+            <a:normAutofit/>
+          </a:bodyPr>
           <a:lstStyle/>
           <a:p>
             <a:pPr algn="l" indent="0" marL="0">
@@ -5451,11 +5471,11 @@
         <p:spPr>
           <a:xfrm>
             <a:off x="6184745" y="2019300"/>
-            <a:ext cx="5600560" cy="1803400"/>
+            <a:ext cx="5600560" cy="1549400"/>
           </a:xfrm>
           <a:prstGeom prst="roundRect">
             <a:avLst>
-              <a:gd name="adj" fmla="val 4056"/>
+              <a:gd name="adj" fmla="val 4721"/>
             </a:avLst>
           </a:prstGeom>
           <a:solidFill>
@@ -5478,7 +5498,7 @@
         <p:spPr>
           <a:xfrm>
             <a:off x="6203033" y="2055876"/>
-            <a:ext cx="54864" cy="1730248"/>
+            <a:ext cx="54864" cy="1476248"/>
           </a:xfrm>
           <a:prstGeom prst="roundRect">
             <a:avLst>
@@ -5538,8 +5558,8 @@
         </p:nvSpPr>
         <p:spPr>
           <a:xfrm>
-            <a:off x="6413340" y="2705100"/>
-            <a:ext cx="5143371" cy="762000"/>
+            <a:off x="6362541" y="2552700"/>
+            <a:ext cx="5244969" cy="762000"/>
           </a:xfrm>
           <a:prstGeom prst="roundRect">
             <a:avLst>
@@ -5565,7 +5585,7 @@
         </p:nvSpPr>
         <p:spPr>
           <a:xfrm>
-            <a:off x="6550500" y="2814828"/>
+            <a:off x="6499701" y="2662428"/>
             <a:ext cx="91440" cy="91440"/>
           </a:xfrm>
           <a:prstGeom prst="ellipse">
@@ -5590,7 +5610,7 @@
         </p:nvSpPr>
         <p:spPr>
           <a:xfrm>
-            <a:off x="6687660" y="2814828"/>
+            <a:off x="6636861" y="2662428"/>
             <a:ext cx="91440" cy="91440"/>
           </a:xfrm>
           <a:prstGeom prst="ellipse">
@@ -5615,7 +5635,7 @@
         </p:nvSpPr>
         <p:spPr>
           <a:xfrm>
-            <a:off x="6824820" y="2814828"/>
+            <a:off x="6774021" y="2662428"/>
             <a:ext cx="91440" cy="91440"/>
           </a:xfrm>
           <a:prstGeom prst="ellipse">
@@ -5640,8 +5660,8 @@
         </p:nvSpPr>
         <p:spPr>
           <a:xfrm>
-            <a:off x="6614508" y="3034284"/>
-            <a:ext cx="4741035" cy="323088"/>
+            <a:off x="6563709" y="2881884"/>
+            <a:ext cx="4842633" cy="323088"/>
           </a:xfrm>
           <a:prstGeom prst="rect">
             <a:avLst/>
@@ -5679,17 +5699,19 @@
         </p:nvSpPr>
         <p:spPr>
           <a:xfrm>
-            <a:off x="6184745" y="4000500"/>
-            <a:ext cx="5600560" cy="673100"/>
-          </a:xfrm>
-          <a:prstGeom prst="rect">
-            <a:avLst/>
-          </a:prstGeom>
-          <a:noFill/>
-          <a:ln/>
-        </p:spPr>
-        <p:txBody>
-          <a:bodyPr wrap="square" lIns="0" tIns="0" rIns="0" bIns="0" rtlCol="0" anchor="t"/>
+            <a:off x="6184745" y="3746500"/>
+            <a:ext cx="5600560" cy="266700"/>
+          </a:xfrm>
+          <a:prstGeom prst="rect">
+            <a:avLst/>
+          </a:prstGeom>
+          <a:noFill/>
+          <a:ln/>
+        </p:spPr>
+        <p:txBody>
+          <a:bodyPr wrap="square" lIns="0" tIns="0" rIns="0" bIns="0" rtlCol="0" anchor="t">
+            <a:normAutofit/>
+          </a:bodyPr>
           <a:lstStyle/>
           <a:p>
             <a:pPr algn="l" indent="0" marL="0">
@@ -5718,7 +5740,7 @@
         </p:nvSpPr>
         <p:spPr>
           <a:xfrm>
-            <a:off x="406390" y="4851400"/>
+            <a:off x="406390" y="4191000"/>
             <a:ext cx="11378916" cy="965200"/>
           </a:xfrm>
           <a:prstGeom prst="roundRect">
@@ -5745,7 +5767,7 @@
         </p:nvSpPr>
         <p:spPr>
           <a:xfrm>
-            <a:off x="589270" y="4997704"/>
+            <a:off x="589270" y="4337304"/>
             <a:ext cx="11013156" cy="274320"/>
           </a:xfrm>
           <a:prstGeom prst="rect">
@@ -5784,7 +5806,7 @@
         </p:nvSpPr>
         <p:spPr>
           <a:xfrm>
-            <a:off x="589270" y="5326888"/>
+            <a:off x="589270" y="4666488"/>
             <a:ext cx="11013156" cy="361696"/>
           </a:xfrm>
           <a:prstGeom prst="rect">
@@ -5973,11 +5995,11 @@
         <p:spPr>
           <a:xfrm>
             <a:off x="406390" y="2019300"/>
-            <a:ext cx="3674441" cy="5118100"/>
+            <a:ext cx="3725240" cy="2120900"/>
           </a:xfrm>
           <a:prstGeom prst="roundRect">
             <a:avLst>
-              <a:gd name="adj" fmla="val 1991"/>
+              <a:gd name="adj" fmla="val 3449"/>
             </a:avLst>
           </a:prstGeom>
           <a:solidFill>
@@ -6000,7 +6022,7 @@
         <p:spPr>
           <a:xfrm>
             <a:off x="424678" y="2055876"/>
-            <a:ext cx="54864" cy="5044948"/>
+            <a:ext cx="54864" cy="2047748"/>
           </a:xfrm>
           <a:prstGeom prst="roundRect">
             <a:avLst>
@@ -6022,7 +6044,7 @@
         <p:spPr>
           <a:xfrm>
             <a:off x="634990" y="2129028"/>
-            <a:ext cx="3217241" cy="274320"/>
+            <a:ext cx="3268040" cy="274320"/>
           </a:xfrm>
           <a:prstGeom prst="rect">
             <a:avLst/>
@@ -6060,8 +6082,8 @@
         </p:nvSpPr>
         <p:spPr>
           <a:xfrm>
-            <a:off x="634984" y="2705100"/>
-            <a:ext cx="3217253" cy="673100"/>
+            <a:off x="584185" y="2552700"/>
+            <a:ext cx="3369649" cy="1333500"/>
           </a:xfrm>
           <a:prstGeom prst="rect">
             <a:avLst/>
@@ -6073,11 +6095,15 @@
           <a:bodyPr wrap="square" lIns="0" tIns="0" rIns="0" bIns="0" rtlCol="0" anchor="t"/>
           <a:lstStyle/>
           <a:p>
-            <a:pPr algn="l" indent="0" marL="0">
-              <a:buNone/>
-            </a:pPr>
-            <a:r>
-              <a:rPr lang="en-US" sz="1300" dirty="0">
+            <a:pPr marL="342900" indent="-342900">
+              <a:spcAft>
+                <a:spcPts val="400"/>
+              </a:spcAft>
+              <a:buSzPct val="100000"/>
+              <a:buChar char="•"/>
+            </a:pPr>
+            <a:r>
+              <a:rPr lang="en-US" sz="1250" dirty="0">
                 <a:solidFill>
                   <a:srgbClr val="FFFFFF"/>
                 </a:solidFill>
@@ -6085,38 +6111,20 @@
                 <a:ea typeface="Segoe UI" pitchFamily="34" charset="-122"/>
                 <a:cs typeface="Segoe UI" pitchFamily="34" charset="-120"/>
               </a:rPr>
-              <a:t>• Sorgente 100% versionabile con Git</a:t>
-            </a:r>
-            <a:endParaRPr lang="en-US" sz="1300" dirty="0"/>
-          </a:p>
-        </p:txBody>
-      </p:sp>
-      <p:sp>
-        <p:nvSpPr>
-          <p:cNvPr id="8" name="Text 6"/>
-          <p:cNvSpPr/>
-          <p:nvPr/>
-        </p:nvSpPr>
-        <p:spPr>
-          <a:xfrm>
-            <a:off x="634984" y="3556000"/>
-            <a:ext cx="3217253" cy="673100"/>
-          </a:xfrm>
-          <a:prstGeom prst="rect">
-            <a:avLst/>
-          </a:prstGeom>
-          <a:noFill/>
-          <a:ln/>
-        </p:spPr>
-        <p:txBody>
-          <a:bodyPr wrap="square" lIns="0" tIns="0" rIns="0" bIns="0" rtlCol="0" anchor="t"/>
-          <a:lstStyle/>
-          <a:p>
-            <a:pPr algn="l" indent="0" marL="0">
-              <a:buNone/>
-            </a:pPr>
-            <a:r>
-              <a:rPr lang="en-US" sz="1300" dirty="0">
+              <a:t>Sorgente 100% versionabile con Git</a:t>
+            </a:r>
+            <a:endParaRPr lang="en-US" sz="1250" dirty="0"/>
+          </a:p>
+          <a:p>
+            <a:pPr marL="342900" indent="-342900">
+              <a:spcAft>
+                <a:spcPts val="400"/>
+              </a:spcAft>
+              <a:buSzPct val="100000"/>
+              <a:buChar char="•"/>
+            </a:pPr>
+            <a:r>
+              <a:rPr lang="en-US" sz="1250" dirty="0">
                 <a:solidFill>
                   <a:srgbClr val="FFFFFF"/>
                 </a:solidFill>
@@ -6124,38 +6132,20 @@
                 <a:ea typeface="Segoe UI" pitchFamily="34" charset="-122"/>
                 <a:cs typeface="Segoe UI" pitchFamily="34" charset="-120"/>
               </a:rPr>
-              <a:t>• Tre output compilati da un unico file</a:t>
-            </a:r>
-            <a:endParaRPr lang="en-US" sz="1300" dirty="0"/>
-          </a:p>
-        </p:txBody>
-      </p:sp>
-      <p:sp>
-        <p:nvSpPr>
-          <p:cNvPr id="9" name="Text 7"/>
-          <p:cNvSpPr/>
-          <p:nvPr/>
-        </p:nvSpPr>
-        <p:spPr>
-          <a:xfrm>
-            <a:off x="634984" y="4406900"/>
-            <a:ext cx="3217253" cy="673100"/>
-          </a:xfrm>
-          <a:prstGeom prst="rect">
-            <a:avLst/>
-          </a:prstGeom>
-          <a:noFill/>
-          <a:ln/>
-        </p:spPr>
-        <p:txBody>
-          <a:bodyPr wrap="square" lIns="0" tIns="0" rIns="0" bIns="0" rtlCol="0" anchor="t"/>
-          <a:lstStyle/>
-          <a:p>
-            <a:pPr algn="l" indent="0" marL="0">
-              <a:buNone/>
-            </a:pPr>
-            <a:r>
-              <a:rPr lang="en-US" sz="1300" dirty="0">
+              <a:t>Tre output compilati da un unico file</a:t>
+            </a:r>
+            <a:endParaRPr lang="en-US" sz="1250" dirty="0"/>
+          </a:p>
+          <a:p>
+            <a:pPr marL="342900" indent="-342900">
+              <a:spcAft>
+                <a:spcPts val="400"/>
+              </a:spcAft>
+              <a:buSzPct val="100000"/>
+              <a:buChar char="•"/>
+            </a:pPr>
+            <a:r>
+              <a:rPr lang="en-US" sz="1250" dirty="0">
                 <a:solidFill>
                   <a:srgbClr val="FFFFFF"/>
                 </a:solidFill>
@@ -6163,38 +6153,20 @@
                 <a:ea typeface="Segoe UI" pitchFamily="34" charset="-122"/>
                 <a:cs typeface="Segoe UI" pitchFamily="34" charset="-120"/>
               </a:rPr>
-              <a:t>• Layout e gerarchia visiva garantiti</a:t>
-            </a:r>
-            <a:endParaRPr lang="en-US" sz="1300" dirty="0"/>
-          </a:p>
-        </p:txBody>
-      </p:sp>
-      <p:sp>
-        <p:nvSpPr>
-          <p:cNvPr id="10" name="Text 8"/>
-          <p:cNvSpPr/>
-          <p:nvPr/>
-        </p:nvSpPr>
-        <p:spPr>
-          <a:xfrm>
-            <a:off x="634984" y="5257800"/>
-            <a:ext cx="3217253" cy="673100"/>
-          </a:xfrm>
-          <a:prstGeom prst="rect">
-            <a:avLst/>
-          </a:prstGeom>
-          <a:noFill/>
-          <a:ln/>
-        </p:spPr>
-        <p:txBody>
-          <a:bodyPr wrap="square" lIns="0" tIns="0" rIns="0" bIns="0" rtlCol="0" anchor="t"/>
-          <a:lstStyle/>
-          <a:p>
-            <a:pPr algn="l" indent="0" marL="0">
-              <a:buNone/>
-            </a:pPr>
-            <a:r>
-              <a:rPr lang="en-US" sz="1300" dirty="0">
+              <a:t>Layout e gerarchia visiva garantiti</a:t>
+            </a:r>
+            <a:endParaRPr lang="en-US" sz="1250" dirty="0"/>
+          </a:p>
+          <a:p>
+            <a:pPr marL="342900" indent="-342900">
+              <a:spcAft>
+                <a:spcPts val="400"/>
+              </a:spcAft>
+              <a:buSzPct val="100000"/>
+              <a:buChar char="•"/>
+            </a:pPr>
+            <a:r>
+              <a:rPr lang="en-US" sz="1250" dirty="0">
                 <a:solidFill>
                   <a:srgbClr val="FFFFFF"/>
                 </a:solidFill>
@@ -6202,38 +6174,20 @@
                 <a:ea typeface="Segoe UI" pitchFamily="34" charset="-122"/>
                 <a:cs typeface="Segoe UI" pitchFamily="34" charset="-120"/>
               </a:rPr>
-              <a:t>• Linter automatico per design e WCAG</a:t>
-            </a:r>
-            <a:endParaRPr lang="en-US" sz="1300" dirty="0"/>
-          </a:p>
-        </p:txBody>
-      </p:sp>
-      <p:sp>
-        <p:nvSpPr>
-          <p:cNvPr id="11" name="Text 9"/>
-          <p:cNvSpPr/>
-          <p:nvPr/>
-        </p:nvSpPr>
-        <p:spPr>
-          <a:xfrm>
-            <a:off x="634984" y="6108700"/>
-            <a:ext cx="3217253" cy="673100"/>
-          </a:xfrm>
-          <a:prstGeom prst="rect">
-            <a:avLst/>
-          </a:prstGeom>
-          <a:noFill/>
-          <a:ln/>
-        </p:spPr>
-        <p:txBody>
-          <a:bodyPr wrap="square" lIns="0" tIns="0" rIns="0" bIns="0" rtlCol="0" anchor="t"/>
-          <a:lstStyle/>
-          <a:p>
-            <a:pPr algn="l" indent="0" marL="0">
-              <a:buNone/>
-            </a:pPr>
-            <a:r>
-              <a:rPr lang="en-US" sz="1300" dirty="0">
+              <a:t>Linter automatico per design e WCAG</a:t>
+            </a:r>
+            <a:endParaRPr lang="en-US" sz="1250" dirty="0"/>
+          </a:p>
+          <a:p>
+            <a:pPr marL="342900" indent="-342900">
+              <a:spcAft>
+                <a:spcPts val="400"/>
+              </a:spcAft>
+              <a:buSzPct val="100000"/>
+              <a:buChar char="•"/>
+            </a:pPr>
+            <a:r>
+              <a:rPr lang="en-US" sz="1250" dirty="0">
                 <a:solidFill>
                   <a:srgbClr val="FFFFFF"/>
                 </a:solidFill>
@@ -6241,26 +6195,26 @@
                 <a:ea typeface="Segoe UI" pitchFamily="34" charset="-122"/>
                 <a:cs typeface="Segoe UI" pitchFamily="34" charset="-120"/>
               </a:rPr>
-              <a:t>• Integrazione nativa con workflow AI</a:t>
-            </a:r>
-            <a:endParaRPr lang="en-US" sz="1300" dirty="0"/>
-          </a:p>
-        </p:txBody>
-      </p:sp>
-      <p:sp>
-        <p:nvSpPr>
-          <p:cNvPr id="12" name="Shape 10"/>
-          <p:cNvSpPr/>
-          <p:nvPr/>
-        </p:nvSpPr>
-        <p:spPr>
-          <a:xfrm>
-            <a:off x="4258627" y="2019300"/>
-            <a:ext cx="3674441" cy="4267200"/>
+              <a:t>Integrazione nativa con workflow AI</a:t>
+            </a:r>
+            <a:endParaRPr lang="en-US" sz="1250" dirty="0"/>
+          </a:p>
+        </p:txBody>
+      </p:sp>
+      <p:sp>
+        <p:nvSpPr>
+          <p:cNvPr id="8" name="Shape 6"/>
+          <p:cNvSpPr/>
+          <p:nvPr/>
+        </p:nvSpPr>
+        <p:spPr>
+          <a:xfrm>
+            <a:off x="4233228" y="2019300"/>
+            <a:ext cx="3725240" cy="2120900"/>
           </a:xfrm>
           <a:prstGeom prst="roundRect">
             <a:avLst>
-              <a:gd name="adj" fmla="val 1991"/>
+              <a:gd name="adj" fmla="val 3449"/>
             </a:avLst>
           </a:prstGeom>
           <a:solidFill>
@@ -6276,14 +6230,14 @@
       </p:sp>
       <p:sp>
         <p:nvSpPr>
-          <p:cNvPr id="13" name="Shape 11"/>
-          <p:cNvSpPr/>
-          <p:nvPr/>
-        </p:nvSpPr>
-        <p:spPr>
-          <a:xfrm>
-            <a:off x="4276915" y="2055876"/>
-            <a:ext cx="54864" cy="4194048"/>
+          <p:cNvPr id="9" name="Shape 7"/>
+          <p:cNvSpPr/>
+          <p:nvPr/>
+        </p:nvSpPr>
+        <p:spPr>
+          <a:xfrm>
+            <a:off x="4251516" y="2055876"/>
+            <a:ext cx="54864" cy="2047748"/>
           </a:xfrm>
           <a:prstGeom prst="roundRect">
             <a:avLst>
@@ -6298,14 +6252,14 @@
       </p:sp>
       <p:sp>
         <p:nvSpPr>
-          <p:cNvPr id="14" name="Text 12"/>
-          <p:cNvSpPr/>
-          <p:nvPr/>
-        </p:nvSpPr>
-        <p:spPr>
-          <a:xfrm>
-            <a:off x="4487227" y="2129028"/>
-            <a:ext cx="3217241" cy="274320"/>
+          <p:cNvPr id="10" name="Text 8"/>
+          <p:cNvSpPr/>
+          <p:nvPr/>
+        </p:nvSpPr>
+        <p:spPr>
+          <a:xfrm>
+            <a:off x="4461828" y="2129028"/>
+            <a:ext cx="3268040" cy="274320"/>
           </a:xfrm>
           <a:prstGeom prst="rect">
             <a:avLst/>
@@ -6337,14 +6291,14 @@
       </p:sp>
       <p:sp>
         <p:nvSpPr>
-          <p:cNvPr id="15" name="Text 13"/>
-          <p:cNvSpPr/>
-          <p:nvPr/>
-        </p:nvSpPr>
-        <p:spPr>
-          <a:xfrm>
-            <a:off x="4487221" y="2705100"/>
-            <a:ext cx="3217253" cy="673100"/>
+          <p:cNvPr id="11" name="Text 9"/>
+          <p:cNvSpPr/>
+          <p:nvPr/>
+        </p:nvSpPr>
+        <p:spPr>
+          <a:xfrm>
+            <a:off x="4411023" y="2552700"/>
+            <a:ext cx="3369649" cy="1066800"/>
           </a:xfrm>
           <a:prstGeom prst="rect">
             <a:avLst/>
@@ -6356,11 +6310,15 @@
           <a:bodyPr wrap="square" lIns="0" tIns="0" rIns="0" bIns="0" rtlCol="0" anchor="t"/>
           <a:lstStyle/>
           <a:p>
-            <a:pPr algn="l" indent="0" marL="0">
-              <a:buNone/>
-            </a:pPr>
-            <a:r>
-              <a:rPr lang="en-US" sz="1300" dirty="0">
+            <a:pPr marL="342900" indent="-342900">
+              <a:spcAft>
+                <a:spcPts val="400"/>
+              </a:spcAft>
+              <a:buSzPct val="100000"/>
+              <a:buChar char="•"/>
+            </a:pPr>
+            <a:r>
+              <a:rPr lang="en-US" sz="1250" dirty="0">
                 <a:solidFill>
                   <a:srgbClr val="FFFFFF"/>
                 </a:solidFill>
@@ -6368,38 +6326,20 @@
                 <a:ea typeface="Segoe UI" pitchFamily="34" charset="-122"/>
                 <a:cs typeface="Segoe UI" pitchFamily="34" charset="-120"/>
               </a:rPr>
-              <a:t>• Parità totale di rendering su edge case</a:t>
-            </a:r>
-            <a:endParaRPr lang="en-US" sz="1300" dirty="0"/>
-          </a:p>
-        </p:txBody>
-      </p:sp>
-      <p:sp>
-        <p:nvSpPr>
-          <p:cNvPr id="16" name="Text 14"/>
-          <p:cNvSpPr/>
-          <p:nvPr/>
-        </p:nvSpPr>
-        <p:spPr>
-          <a:xfrm>
-            <a:off x="4487221" y="3556000"/>
-            <a:ext cx="3217253" cy="673100"/>
-          </a:xfrm>
-          <a:prstGeom prst="rect">
-            <a:avLst/>
-          </a:prstGeom>
-          <a:noFill/>
-          <a:ln/>
-        </p:spPr>
-        <p:txBody>
-          <a:bodyPr wrap="square" lIns="0" tIns="0" rIns="0" bIns="0" rtlCol="0" anchor="t"/>
-          <a:lstStyle/>
-          <a:p>
-            <a:pPr algn="l" indent="0" marL="0">
-              <a:buNone/>
-            </a:pPr>
-            <a:r>
-              <a:rPr lang="en-US" sz="1300" dirty="0">
+              <a:t>Parità totale di rendering su edge case</a:t>
+            </a:r>
+            <a:endParaRPr lang="en-US" sz="1250" dirty="0"/>
+          </a:p>
+          <a:p>
+            <a:pPr marL="342900" indent="-342900">
+              <a:spcAft>
+                <a:spcPts val="400"/>
+              </a:spcAft>
+              <a:buSzPct val="100000"/>
+              <a:buChar char="•"/>
+            </a:pPr>
+            <a:r>
+              <a:rPr lang="en-US" sz="1250" dirty="0">
                 <a:solidFill>
                   <a:srgbClr val="FFFFFF"/>
                 </a:solidFill>
@@ -6407,38 +6347,20 @@
                 <a:ea typeface="Segoe UI" pitchFamily="34" charset="-122"/>
                 <a:cs typeface="Segoe UI" pitchFamily="34" charset="-120"/>
               </a:rPr>
-              <a:t>• Estensione della copertura dei test</a:t>
-            </a:r>
-            <a:endParaRPr lang="en-US" sz="1300" dirty="0"/>
-          </a:p>
-        </p:txBody>
-      </p:sp>
-      <p:sp>
-        <p:nvSpPr>
-          <p:cNvPr id="17" name="Text 15"/>
-          <p:cNvSpPr/>
-          <p:nvPr/>
-        </p:nvSpPr>
-        <p:spPr>
-          <a:xfrm>
-            <a:off x="4487221" y="4406900"/>
-            <a:ext cx="3217253" cy="673100"/>
-          </a:xfrm>
-          <a:prstGeom prst="rect">
-            <a:avLst/>
-          </a:prstGeom>
-          <a:noFill/>
-          <a:ln/>
-        </p:spPr>
-        <p:txBody>
-          <a:bodyPr wrap="square" lIns="0" tIns="0" rIns="0" bIns="0" rtlCol="0" anchor="t"/>
-          <a:lstStyle/>
-          <a:p>
-            <a:pPr algn="l" indent="0" marL="0">
-              <a:buNone/>
-            </a:pPr>
-            <a:r>
-              <a:rPr lang="en-US" sz="1300" dirty="0">
+              <a:t>Estensione della copertura dei test</a:t>
+            </a:r>
+            <a:endParaRPr lang="en-US" sz="1250" dirty="0"/>
+          </a:p>
+          <a:p>
+            <a:pPr marL="342900" indent="-342900">
+              <a:spcAft>
+                <a:spcPts val="400"/>
+              </a:spcAft>
+              <a:buSzPct val="100000"/>
+              <a:buChar char="•"/>
+            </a:pPr>
+            <a:r>
+              <a:rPr lang="en-US" sz="1250" dirty="0">
                 <a:solidFill>
                   <a:srgbClr val="FFFFFF"/>
                 </a:solidFill>
@@ -6446,38 +6368,20 @@
                 <a:ea typeface="Segoe UI" pitchFamily="34" charset="-122"/>
                 <a:cs typeface="Segoe UI" pitchFamily="34" charset="-120"/>
               </a:rPr>
-              <a:t>• Supporto a font e asset esterni complessi</a:t>
-            </a:r>
-            <a:endParaRPr lang="en-US" sz="1300" dirty="0"/>
-          </a:p>
-        </p:txBody>
-      </p:sp>
-      <p:sp>
-        <p:nvSpPr>
-          <p:cNvPr id="18" name="Text 16"/>
-          <p:cNvSpPr/>
-          <p:nvPr/>
-        </p:nvSpPr>
-        <p:spPr>
-          <a:xfrm>
-            <a:off x="4487221" y="5257800"/>
-            <a:ext cx="3217253" cy="673100"/>
-          </a:xfrm>
-          <a:prstGeom prst="rect">
-            <a:avLst/>
-          </a:prstGeom>
-          <a:noFill/>
-          <a:ln/>
-        </p:spPr>
-        <p:txBody>
-          <a:bodyPr wrap="square" lIns="0" tIns="0" rIns="0" bIns="0" rtlCol="0" anchor="t"/>
-          <a:lstStyle/>
-          <a:p>
-            <a:pPr algn="l" indent="0" marL="0">
-              <a:buNone/>
-            </a:pPr>
-            <a:r>
-              <a:rPr lang="en-US" sz="1300" dirty="0">
+              <a:t>Supporto a font e asset esterni complessi</a:t>
+            </a:r>
+            <a:endParaRPr lang="en-US" sz="1250" dirty="0"/>
+          </a:p>
+          <a:p>
+            <a:pPr marL="342900" indent="-342900">
+              <a:spcAft>
+                <a:spcPts val="400"/>
+              </a:spcAft>
+              <a:buSzPct val="100000"/>
+              <a:buChar char="•"/>
+            </a:pPr>
+            <a:r>
+              <a:rPr lang="en-US" sz="1250" dirty="0">
                 <a:solidFill>
                   <a:srgbClr val="FFFFFF"/>
                 </a:solidFill>
@@ -6485,26 +6389,26 @@
                 <a:ea typeface="Segoe UI" pitchFamily="34" charset="-122"/>
                 <a:cs typeface="Segoe UI" pitchFamily="34" charset="-120"/>
               </a:rPr>
-              <a:t>• Documentazione di scenari avanzati</a:t>
-            </a:r>
-            <a:endParaRPr lang="en-US" sz="1300" dirty="0"/>
-          </a:p>
-        </p:txBody>
-      </p:sp>
-      <p:sp>
-        <p:nvSpPr>
-          <p:cNvPr id="19" name="Shape 17"/>
-          <p:cNvSpPr/>
-          <p:nvPr/>
-        </p:nvSpPr>
-        <p:spPr>
-          <a:xfrm>
-            <a:off x="8110864" y="2019300"/>
-            <a:ext cx="3674441" cy="4267200"/>
+              <a:t>Documentazione di scenari avanzati</a:t>
+            </a:r>
+            <a:endParaRPr lang="en-US" sz="1250" dirty="0"/>
+          </a:p>
+        </p:txBody>
+      </p:sp>
+      <p:sp>
+        <p:nvSpPr>
+          <p:cNvPr id="12" name="Shape 10"/>
+          <p:cNvSpPr/>
+          <p:nvPr/>
+        </p:nvSpPr>
+        <p:spPr>
+          <a:xfrm>
+            <a:off x="8060065" y="2019300"/>
+            <a:ext cx="3725240" cy="2120900"/>
           </a:xfrm>
           <a:prstGeom prst="roundRect">
             <a:avLst>
-              <a:gd name="adj" fmla="val 1991"/>
+              <a:gd name="adj" fmla="val 3449"/>
             </a:avLst>
           </a:prstGeom>
           <a:solidFill>
@@ -6520,14 +6424,14 @@
       </p:sp>
       <p:sp>
         <p:nvSpPr>
-          <p:cNvPr id="20" name="Shape 18"/>
-          <p:cNvSpPr/>
-          <p:nvPr/>
-        </p:nvSpPr>
-        <p:spPr>
-          <a:xfrm>
-            <a:off x="8129152" y="2055876"/>
-            <a:ext cx="54864" cy="4194048"/>
+          <p:cNvPr id="13" name="Shape 11"/>
+          <p:cNvSpPr/>
+          <p:nvPr/>
+        </p:nvSpPr>
+        <p:spPr>
+          <a:xfrm>
+            <a:off x="8078353" y="2055876"/>
+            <a:ext cx="54864" cy="2047748"/>
           </a:xfrm>
           <a:prstGeom prst="roundRect">
             <a:avLst>
@@ -6542,14 +6446,14 @@
       </p:sp>
       <p:sp>
         <p:nvSpPr>
-          <p:cNvPr id="21" name="Text 19"/>
-          <p:cNvSpPr/>
-          <p:nvPr/>
-        </p:nvSpPr>
-        <p:spPr>
-          <a:xfrm>
-            <a:off x="8339464" y="2129028"/>
-            <a:ext cx="3217241" cy="274320"/>
+          <p:cNvPr id="14" name="Text 12"/>
+          <p:cNvSpPr/>
+          <p:nvPr/>
+        </p:nvSpPr>
+        <p:spPr>
+          <a:xfrm>
+            <a:off x="8288665" y="2129028"/>
+            <a:ext cx="3268040" cy="274320"/>
           </a:xfrm>
           <a:prstGeom prst="rect">
             <a:avLst/>
@@ -6581,14 +6485,14 @@
       </p:sp>
       <p:sp>
         <p:nvSpPr>
-          <p:cNvPr id="22" name="Text 20"/>
-          <p:cNvSpPr/>
-          <p:nvPr/>
-        </p:nvSpPr>
-        <p:spPr>
-          <a:xfrm>
-            <a:off x="8339458" y="2705100"/>
-            <a:ext cx="3217253" cy="673100"/>
+          <p:cNvPr id="15" name="Text 13"/>
+          <p:cNvSpPr/>
+          <p:nvPr/>
+        </p:nvSpPr>
+        <p:spPr>
+          <a:xfrm>
+            <a:off x="8237861" y="2552700"/>
+            <a:ext cx="3369649" cy="1066800"/>
           </a:xfrm>
           <a:prstGeom prst="rect">
             <a:avLst/>
@@ -6600,11 +6504,15 @@
           <a:bodyPr wrap="square" lIns="0" tIns="0" rIns="0" bIns="0" rtlCol="0" anchor="t"/>
           <a:lstStyle/>
           <a:p>
-            <a:pPr algn="l" indent="0" marL="0">
-              <a:buNone/>
-            </a:pPr>
-            <a:r>
-              <a:rPr lang="en-US" sz="1300" dirty="0">
+            <a:pPr marL="342900" indent="-342900">
+              <a:spcAft>
+                <a:spcPts val="400"/>
+              </a:spcAft>
+              <a:buSzPct val="100000"/>
+              <a:buChar char="•"/>
+            </a:pPr>
+            <a:r>
+              <a:rPr lang="en-US" sz="1250" dirty="0">
                 <a:solidFill>
                   <a:srgbClr val="FFFFFF"/>
                 </a:solidFill>
@@ -6612,38 +6520,20 @@
                 <a:ea typeface="Segoe UI" pitchFamily="34" charset="-122"/>
                 <a:cs typeface="Segoe UI" pitchFamily="34" charset="-120"/>
               </a:rPr>
-              <a:t>• Editor visuale WYSIWYG bidirezionale</a:t>
-            </a:r>
-            <a:endParaRPr lang="en-US" sz="1300" dirty="0"/>
-          </a:p>
-        </p:txBody>
-      </p:sp>
-      <p:sp>
-        <p:nvSpPr>
-          <p:cNvPr id="23" name="Text 21"/>
-          <p:cNvSpPr/>
-          <p:nvPr/>
-        </p:nvSpPr>
-        <p:spPr>
-          <a:xfrm>
-            <a:off x="8339458" y="3556000"/>
-            <a:ext cx="3217253" cy="673100"/>
-          </a:xfrm>
-          <a:prstGeom prst="rect">
-            <a:avLst/>
-          </a:prstGeom>
-          <a:noFill/>
-          <a:ln/>
-        </p:spPr>
-        <p:txBody>
-          <a:bodyPr wrap="square" lIns="0" tIns="0" rIns="0" bIns="0" rtlCol="0" anchor="t"/>
-          <a:lstStyle/>
-          <a:p>
-            <a:pPr algn="l" indent="0" marL="0">
-              <a:buNone/>
-            </a:pPr>
-            <a:r>
-              <a:rPr lang="en-US" sz="1300" dirty="0">
+              <a:t>Editor visuale WYSIWYG bidirezionale</a:t>
+            </a:r>
+            <a:endParaRPr lang="en-US" sz="1250" dirty="0"/>
+          </a:p>
+          <a:p>
+            <a:pPr marL="342900" indent="-342900">
+              <a:spcAft>
+                <a:spcPts val="400"/>
+              </a:spcAft>
+              <a:buSzPct val="100000"/>
+              <a:buChar char="•"/>
+            </a:pPr>
+            <a:r>
+              <a:rPr lang="en-US" sz="1250" dirty="0">
                 <a:solidFill>
                   <a:srgbClr val="FFFFFF"/>
                 </a:solidFill>
@@ -6651,38 +6541,20 @@
                 <a:ea typeface="Segoe UI" pitchFamily="34" charset="-122"/>
                 <a:cs typeface="Segoe UI" pitchFamily="34" charset="-120"/>
               </a:rPr>
-              <a:t>• Collaborazione in tempo reale su browser</a:t>
-            </a:r>
-            <a:endParaRPr lang="en-US" sz="1300" dirty="0"/>
-          </a:p>
-        </p:txBody>
-      </p:sp>
-      <p:sp>
-        <p:nvSpPr>
-          <p:cNvPr id="24" name="Text 22"/>
-          <p:cNvSpPr/>
-          <p:nvPr/>
-        </p:nvSpPr>
-        <p:spPr>
-          <a:xfrm>
-            <a:off x="8339458" y="4406900"/>
-            <a:ext cx="3217253" cy="673100"/>
-          </a:xfrm>
-          <a:prstGeom prst="rect">
-            <a:avLst/>
-          </a:prstGeom>
-          <a:noFill/>
-          <a:ln/>
-        </p:spPr>
-        <p:txBody>
-          <a:bodyPr wrap="square" lIns="0" tIns="0" rIns="0" bIns="0" rtlCol="0" anchor="t"/>
-          <a:lstStyle/>
-          <a:p>
-            <a:pPr algn="l" indent="0" marL="0">
-              <a:buNone/>
-            </a:pPr>
-            <a:r>
-              <a:rPr lang="en-US" sz="1300" dirty="0">
+              <a:t>Collaborazione in tempo reale su browser</a:t>
+            </a:r>
+            <a:endParaRPr lang="en-US" sz="1250" dirty="0"/>
+          </a:p>
+          <a:p>
+            <a:pPr marL="342900" indent="-342900">
+              <a:spcAft>
+                <a:spcPts val="400"/>
+              </a:spcAft>
+              <a:buSzPct val="100000"/>
+              <a:buChar char="•"/>
+            </a:pPr>
+            <a:r>
+              <a:rPr lang="en-US" sz="1250" dirty="0">
                 <a:solidFill>
                   <a:srgbClr val="FFFFFF"/>
                 </a:solidFill>
@@ -6690,38 +6562,20 @@
                 <a:ea typeface="Segoe UI" pitchFamily="34" charset="-122"/>
                 <a:cs typeface="Segoe UI" pitchFamily="34" charset="-120"/>
               </a:rPr>
-              <a:t>• Integrazione con modelli LLM in locale</a:t>
-            </a:r>
-            <a:endParaRPr lang="en-US" sz="1300" dirty="0"/>
-          </a:p>
-        </p:txBody>
-      </p:sp>
-      <p:sp>
-        <p:nvSpPr>
-          <p:cNvPr id="25" name="Text 23"/>
-          <p:cNvSpPr/>
-          <p:nvPr/>
-        </p:nvSpPr>
-        <p:spPr>
-          <a:xfrm>
-            <a:off x="8339458" y="5257800"/>
-            <a:ext cx="3217253" cy="673100"/>
-          </a:xfrm>
-          <a:prstGeom prst="rect">
-            <a:avLst/>
-          </a:prstGeom>
-          <a:noFill/>
-          <a:ln/>
-        </p:spPr>
-        <p:txBody>
-          <a:bodyPr wrap="square" lIns="0" tIns="0" rIns="0" bIns="0" rtlCol="0" anchor="t"/>
-          <a:lstStyle/>
-          <a:p>
-            <a:pPr algn="l" indent="0" marL="0">
-              <a:buNone/>
-            </a:pPr>
-            <a:r>
-              <a:rPr lang="en-US" sz="1300" dirty="0">
+              <a:t>Integrazione con modelli LLM in locale</a:t>
+            </a:r>
+            <a:endParaRPr lang="en-US" sz="1250" dirty="0"/>
+          </a:p>
+          <a:p>
+            <a:pPr marL="342900" indent="-342900">
+              <a:spcAft>
+                <a:spcPts val="400"/>
+              </a:spcAft>
+              <a:buSzPct val="100000"/>
+              <a:buChar char="•"/>
+            </a:pPr>
+            <a:r>
+              <a:rPr lang="en-US" sz="1250" dirty="0">
                 <a:solidFill>
                   <a:srgbClr val="FFFFFF"/>
                 </a:solidFill>
@@ -6729,15 +6583,15 @@
                 <a:ea typeface="Segoe UI" pitchFamily="34" charset="-122"/>
                 <a:cs typeface="Segoe UI" pitchFamily="34" charset="-120"/>
               </a:rPr>
-              <a:t>• Plugin per VS Code ed estensioni IDE</a:t>
-            </a:r>
-            <a:endParaRPr lang="en-US" sz="1300" dirty="0"/>
-          </a:p>
-        </p:txBody>
-      </p:sp>
-      <p:sp>
-        <p:nvSpPr>
-          <p:cNvPr id="26" name="Text 24"/>
+              <a:t>Plugin per VS Code ed estensioni IDE</a:t>
+            </a:r>
+            <a:endParaRPr lang="en-US" sz="1250" dirty="0"/>
+          </a:p>
+        </p:txBody>
+      </p:sp>
+      <p:sp>
+        <p:nvSpPr>
+          <p:cNvPr id="16" name="Text 14"/>
           <p:cNvSpPr/>
           <p:nvPr/>
         </p:nvSpPr>
@@ -6959,11 +6813,11 @@
         <p:spPr>
           <a:xfrm>
             <a:off x="406390" y="1701800"/>
-            <a:ext cx="3674441" cy="2019300"/>
+            <a:ext cx="3725240" cy="1270000"/>
           </a:xfrm>
           <a:prstGeom prst="roundRect">
             <a:avLst>
-              <a:gd name="adj" fmla="val 3623"/>
+              <a:gd name="adj" fmla="val 5760"/>
             </a:avLst>
           </a:prstGeom>
           <a:solidFill>
@@ -6986,7 +6840,7 @@
         <p:spPr>
           <a:xfrm>
             <a:off x="424678" y="1738376"/>
-            <a:ext cx="54864" cy="1946148"/>
+            <a:ext cx="54864" cy="1196848"/>
           </a:xfrm>
           <a:prstGeom prst="roundRect">
             <a:avLst>
@@ -7008,7 +6862,7 @@
         <p:spPr>
           <a:xfrm>
             <a:off x="634990" y="1811528"/>
-            <a:ext cx="3217241" cy="274320"/>
+            <a:ext cx="3268040" cy="274320"/>
           </a:xfrm>
           <a:prstGeom prst="rect">
             <a:avLst/>
@@ -7046,8 +6900,8 @@
         </p:nvSpPr>
         <p:spPr>
           <a:xfrm>
-            <a:off x="634984" y="2387600"/>
-            <a:ext cx="3217253" cy="977900"/>
+            <a:off x="584185" y="2235200"/>
+            <a:ext cx="3369649" cy="482600"/>
           </a:xfrm>
           <a:prstGeom prst="rect">
             <a:avLst/>
@@ -7085,12 +6939,12 @@
         </p:nvSpPr>
         <p:spPr>
           <a:xfrm>
-            <a:off x="4258627" y="1701800"/>
-            <a:ext cx="3674441" cy="2019300"/>
+            <a:off x="4233228" y="1701800"/>
+            <a:ext cx="3725240" cy="1270000"/>
           </a:xfrm>
           <a:prstGeom prst="roundRect">
             <a:avLst>
-              <a:gd name="adj" fmla="val 3623"/>
+              <a:gd name="adj" fmla="val 5760"/>
             </a:avLst>
           </a:prstGeom>
           <a:solidFill>
@@ -7112,8 +6966,8 @@
         </p:nvSpPr>
         <p:spPr>
           <a:xfrm>
-            <a:off x="4276915" y="1738376"/>
-            <a:ext cx="54864" cy="1946148"/>
+            <a:off x="4251516" y="1738376"/>
+            <a:ext cx="54864" cy="1196848"/>
           </a:xfrm>
           <a:prstGeom prst="roundRect">
             <a:avLst>
@@ -7134,8 +6988,8 @@
         </p:nvSpPr>
         <p:spPr>
           <a:xfrm>
-            <a:off x="4487227" y="1811528"/>
-            <a:ext cx="3217241" cy="274320"/>
+            <a:off x="4461828" y="1811528"/>
+            <a:ext cx="3268040" cy="274320"/>
           </a:xfrm>
           <a:prstGeom prst="rect">
             <a:avLst/>
@@ -7173,8 +7027,8 @@
         </p:nvSpPr>
         <p:spPr>
           <a:xfrm>
-            <a:off x="4487221" y="2387600"/>
-            <a:ext cx="3217253" cy="977900"/>
+            <a:off x="4411023" y="2235200"/>
+            <a:ext cx="3369649" cy="482600"/>
           </a:xfrm>
           <a:prstGeom prst="rect">
             <a:avLst/>
@@ -7212,12 +7066,12 @@
         </p:nvSpPr>
         <p:spPr>
           <a:xfrm>
-            <a:off x="8110864" y="1701800"/>
-            <a:ext cx="3674441" cy="2019300"/>
+            <a:off x="8060065" y="1701800"/>
+            <a:ext cx="3725240" cy="1270000"/>
           </a:xfrm>
           <a:prstGeom prst="roundRect">
             <a:avLst>
-              <a:gd name="adj" fmla="val 3623"/>
+              <a:gd name="adj" fmla="val 5760"/>
             </a:avLst>
           </a:prstGeom>
           <a:solidFill>
@@ -7239,8 +7093,8 @@
         </p:nvSpPr>
         <p:spPr>
           <a:xfrm>
-            <a:off x="8129152" y="1738376"/>
-            <a:ext cx="54864" cy="1946148"/>
+            <a:off x="8078353" y="1738376"/>
+            <a:ext cx="54864" cy="1196848"/>
           </a:xfrm>
           <a:prstGeom prst="roundRect">
             <a:avLst>
@@ -7261,8 +7115,8 @@
         </p:nvSpPr>
         <p:spPr>
           <a:xfrm>
-            <a:off x="8339464" y="1811528"/>
-            <a:ext cx="3217241" cy="274320"/>
+            <a:off x="8288665" y="1811528"/>
+            <a:ext cx="3268040" cy="274320"/>
           </a:xfrm>
           <a:prstGeom prst="rect">
             <a:avLst/>
@@ -7300,8 +7154,8 @@
         </p:nvSpPr>
         <p:spPr>
           <a:xfrm>
-            <a:off x="8339458" y="2387600"/>
-            <a:ext cx="3217253" cy="977900"/>
+            <a:off x="8237861" y="2235200"/>
+            <a:ext cx="3369649" cy="482600"/>
           </a:xfrm>
           <a:prstGeom prst="rect">
             <a:avLst/>
@@ -7339,7 +7193,7 @@
         </p:nvSpPr>
         <p:spPr>
           <a:xfrm>
-            <a:off x="406390" y="4076700"/>
+            <a:off x="406390" y="3149600"/>
             <a:ext cx="11378916" cy="774700"/>
           </a:xfrm>
           <a:prstGeom prst="roundRect">
@@ -7366,7 +7220,7 @@
         </p:nvSpPr>
         <p:spPr>
           <a:xfrm>
-            <a:off x="589270" y="4223004"/>
+            <a:off x="589270" y="3295904"/>
             <a:ext cx="11013156" cy="274320"/>
           </a:xfrm>
           <a:prstGeom prst="rect">
@@ -7405,7 +7259,7 @@
         </p:nvSpPr>
         <p:spPr>
           <a:xfrm>
-            <a:off x="589270" y="4552188"/>
+            <a:off x="589270" y="3625088"/>
             <a:ext cx="11013156" cy="182880"/>
           </a:xfrm>
           <a:prstGeom prst="rect">
@@ -7594,11 +7448,11 @@
         <p:spPr>
           <a:xfrm>
             <a:off x="406390" y="2019300"/>
-            <a:ext cx="5460858" cy="3479800"/>
+            <a:ext cx="5460858" cy="2463800"/>
           </a:xfrm>
           <a:prstGeom prst="roundRect">
             <a:avLst>
-              <a:gd name="adj" fmla="val 2628"/>
+              <a:gd name="adj" fmla="val 3711"/>
             </a:avLst>
           </a:prstGeom>
           <a:solidFill>
@@ -7660,11 +7514,11 @@
         <p:spPr>
           <a:xfrm>
             <a:off x="6324448" y="2019300"/>
-            <a:ext cx="5460858" cy="3479800"/>
+            <a:ext cx="5460858" cy="2463800"/>
           </a:xfrm>
           <a:prstGeom prst="roundRect">
             <a:avLst>
-              <a:gd name="adj" fmla="val 2628"/>
+              <a:gd name="adj" fmla="val 3711"/>
             </a:avLst>
           </a:prstGeom>
           <a:solidFill>
@@ -7725,7 +7579,7 @@
         </p:nvSpPr>
         <p:spPr>
           <a:xfrm>
-            <a:off x="5903824" y="3567176"/>
+            <a:off x="5903824" y="3059176"/>
             <a:ext cx="384048" cy="384048"/>
           </a:xfrm>
           <a:prstGeom prst="ellipse">
@@ -7750,7 +7604,7 @@
         </p:nvSpPr>
         <p:spPr>
           <a:xfrm>
-            <a:off x="5903824" y="3567176"/>
+            <a:off x="5903824" y="3059176"/>
             <a:ext cx="384048" cy="384048"/>
           </a:xfrm>
           <a:prstGeom prst="rect">
@@ -7856,16 +7710,18 @@
         <p:spPr>
           <a:xfrm>
             <a:off x="584185" y="2971800"/>
-            <a:ext cx="5156071" cy="368300"/>
-          </a:xfrm>
-          <a:prstGeom prst="rect">
-            <a:avLst/>
-          </a:prstGeom>
-          <a:noFill/>
-          <a:ln/>
-        </p:spPr>
-        <p:txBody>
-          <a:bodyPr wrap="square" lIns="0" tIns="0" rIns="0" bIns="0" rtlCol="0" anchor="t"/>
+            <a:ext cx="5156071" cy="266700"/>
+          </a:xfrm>
+          <a:prstGeom prst="rect">
+            <a:avLst/>
+          </a:prstGeom>
+          <a:noFill/>
+          <a:ln/>
+        </p:spPr>
+        <p:txBody>
+          <a:bodyPr wrap="square" lIns="0" tIns="0" rIns="0" bIns="0" rtlCol="0" anchor="t">
+            <a:normAutofit/>
+          </a:bodyPr>
           <a:lstStyle/>
           <a:p>
             <a:pPr algn="l" indent="0" marL="0">
@@ -7894,17 +7750,19 @@
         </p:nvSpPr>
         <p:spPr>
           <a:xfrm>
-            <a:off x="584185" y="3429000"/>
-            <a:ext cx="5156071" cy="673100"/>
-          </a:xfrm>
-          <a:prstGeom prst="rect">
-            <a:avLst/>
-          </a:prstGeom>
-          <a:noFill/>
-          <a:ln/>
-        </p:spPr>
-        <p:txBody>
-          <a:bodyPr wrap="square" lIns="0" tIns="0" rIns="0" bIns="0" rtlCol="0" anchor="t"/>
+            <a:off x="584185" y="3327400"/>
+            <a:ext cx="5156071" cy="266700"/>
+          </a:xfrm>
+          <a:prstGeom prst="rect">
+            <a:avLst/>
+          </a:prstGeom>
+          <a:noFill/>
+          <a:ln/>
+        </p:spPr>
+        <p:txBody>
+          <a:bodyPr wrap="square" lIns="0" tIns="0" rIns="0" bIns="0" rtlCol="0" anchor="t">
+            <a:normAutofit/>
+          </a:bodyPr>
           <a:lstStyle/>
           <a:p>
             <a:pPr algn="l" indent="0" marL="0">
@@ -7933,17 +7791,19 @@
         </p:nvSpPr>
         <p:spPr>
           <a:xfrm>
-            <a:off x="584185" y="4191000"/>
-            <a:ext cx="5156071" cy="368300"/>
-          </a:xfrm>
-          <a:prstGeom prst="rect">
-            <a:avLst/>
-          </a:prstGeom>
-          <a:noFill/>
-          <a:ln/>
-        </p:spPr>
-        <p:txBody>
-          <a:bodyPr wrap="square" lIns="0" tIns="0" rIns="0" bIns="0" rtlCol="0" anchor="t"/>
+            <a:off x="584185" y="3683000"/>
+            <a:ext cx="5156071" cy="266700"/>
+          </a:xfrm>
+          <a:prstGeom prst="rect">
+            <a:avLst/>
+          </a:prstGeom>
+          <a:noFill/>
+          <a:ln/>
+        </p:spPr>
+        <p:txBody>
+          <a:bodyPr wrap="square" lIns="0" tIns="0" rIns="0" bIns="0" rtlCol="0" anchor="t">
+            <a:normAutofit/>
+          </a:bodyPr>
           <a:lstStyle/>
           <a:p>
             <a:pPr algn="l" indent="0" marL="0">
@@ -7972,17 +7832,19 @@
         </p:nvSpPr>
         <p:spPr>
           <a:xfrm>
-            <a:off x="584185" y="4648200"/>
-            <a:ext cx="5156071" cy="673100"/>
-          </a:xfrm>
-          <a:prstGeom prst="rect">
-            <a:avLst/>
-          </a:prstGeom>
-          <a:noFill/>
-          <a:ln/>
-        </p:spPr>
-        <p:txBody>
-          <a:bodyPr wrap="square" lIns="0" tIns="0" rIns="0" bIns="0" rtlCol="0" anchor="t"/>
+            <a:off x="584185" y="4038600"/>
+            <a:ext cx="5156071" cy="266700"/>
+          </a:xfrm>
+          <a:prstGeom prst="rect">
+            <a:avLst/>
+          </a:prstGeom>
+          <a:noFill/>
+          <a:ln/>
+        </p:spPr>
+        <p:txBody>
+          <a:bodyPr wrap="square" lIns="0" tIns="0" rIns="0" bIns="0" rtlCol="0" anchor="t">
+            <a:normAutofit/>
+          </a:bodyPr>
           <a:lstStyle/>
           <a:p>
             <a:pPr algn="l" indent="0" marL="0">
@@ -8078,16 +7940,18 @@
         <p:spPr>
           <a:xfrm>
             <a:off x="6451439" y="2971800"/>
-            <a:ext cx="5156071" cy="673100"/>
-          </a:xfrm>
-          <a:prstGeom prst="rect">
-            <a:avLst/>
-          </a:prstGeom>
-          <a:noFill/>
-          <a:ln/>
-        </p:spPr>
-        <p:txBody>
-          <a:bodyPr wrap="square" lIns="0" tIns="0" rIns="0" bIns="0" rtlCol="0" anchor="t"/>
+            <a:ext cx="5156071" cy="266700"/>
+          </a:xfrm>
+          <a:prstGeom prst="rect">
+            <a:avLst/>
+          </a:prstGeom>
+          <a:noFill/>
+          <a:ln/>
+        </p:spPr>
+        <p:txBody>
+          <a:bodyPr wrap="square" lIns="0" tIns="0" rIns="0" bIns="0" rtlCol="0" anchor="t">
+            <a:normAutofit/>
+          </a:bodyPr>
           <a:lstStyle/>
           <a:p>
             <a:pPr algn="l" indent="0" marL="0">
@@ -8116,17 +7980,19 @@
         </p:nvSpPr>
         <p:spPr>
           <a:xfrm>
-            <a:off x="6451439" y="3733800"/>
-            <a:ext cx="5156071" cy="368300"/>
-          </a:xfrm>
-          <a:prstGeom prst="rect">
-            <a:avLst/>
-          </a:prstGeom>
-          <a:noFill/>
-          <a:ln/>
-        </p:spPr>
-        <p:txBody>
-          <a:bodyPr wrap="square" lIns="0" tIns="0" rIns="0" bIns="0" rtlCol="0" anchor="t"/>
+            <a:off x="6451439" y="3327400"/>
+            <a:ext cx="5156071" cy="266700"/>
+          </a:xfrm>
+          <a:prstGeom prst="rect">
+            <a:avLst/>
+          </a:prstGeom>
+          <a:noFill/>
+          <a:ln/>
+        </p:spPr>
+        <p:txBody>
+          <a:bodyPr wrap="square" lIns="0" tIns="0" rIns="0" bIns="0" rtlCol="0" anchor="t">
+            <a:normAutofit/>
+          </a:bodyPr>
           <a:lstStyle/>
           <a:p>
             <a:pPr algn="l" indent="0" marL="0">
@@ -8155,17 +8021,19 @@
         </p:nvSpPr>
         <p:spPr>
           <a:xfrm>
-            <a:off x="6451439" y="4191000"/>
-            <a:ext cx="5156071" cy="673100"/>
-          </a:xfrm>
-          <a:prstGeom prst="rect">
-            <a:avLst/>
-          </a:prstGeom>
-          <a:noFill/>
-          <a:ln/>
-        </p:spPr>
-        <p:txBody>
-          <a:bodyPr wrap="square" lIns="0" tIns="0" rIns="0" bIns="0" rtlCol="0" anchor="t"/>
+            <a:off x="6451439" y="3683000"/>
+            <a:ext cx="5156071" cy="266700"/>
+          </a:xfrm>
+          <a:prstGeom prst="rect">
+            <a:avLst/>
+          </a:prstGeom>
+          <a:noFill/>
+          <a:ln/>
+        </p:spPr>
+        <p:txBody>
+          <a:bodyPr wrap="square" lIns="0" tIns="0" rIns="0" bIns="0" rtlCol="0" anchor="t">
+            <a:normAutofit/>
+          </a:bodyPr>
           <a:lstStyle/>
           <a:p>
             <a:pPr algn="l" indent="0" marL="0">
@@ -8194,17 +8062,19 @@
         </p:nvSpPr>
         <p:spPr>
           <a:xfrm>
-            <a:off x="6451439" y="4953000"/>
-            <a:ext cx="5156071" cy="368300"/>
-          </a:xfrm>
-          <a:prstGeom prst="rect">
-            <a:avLst/>
-          </a:prstGeom>
-          <a:noFill/>
-          <a:ln/>
-        </p:spPr>
-        <p:txBody>
-          <a:bodyPr wrap="square" lIns="0" tIns="0" rIns="0" bIns="0" rtlCol="0" anchor="t"/>
+            <a:off x="6451439" y="4038600"/>
+            <a:ext cx="5156071" cy="266700"/>
+          </a:xfrm>
+          <a:prstGeom prst="rect">
+            <a:avLst/>
+          </a:prstGeom>
+          <a:noFill/>
+          <a:ln/>
+        </p:spPr>
+        <p:txBody>
+          <a:bodyPr wrap="square" lIns="0" tIns="0" rIns="0" bIns="0" rtlCol="0" anchor="t">
+            <a:normAutofit/>
+          </a:bodyPr>
           <a:lstStyle/>
           <a:p>
             <a:pPr algn="l" indent="0" marL="0">
@@ -8383,11 +8253,11 @@
         <p:spPr>
           <a:xfrm>
             <a:off x="406390" y="2019300"/>
-            <a:ext cx="3674441" cy="2628900"/>
+            <a:ext cx="3725240" cy="1485900"/>
           </a:xfrm>
           <a:prstGeom prst="roundRect">
             <a:avLst>
-              <a:gd name="adj" fmla="val 2783"/>
+              <a:gd name="adj" fmla="val 4923"/>
             </a:avLst>
           </a:prstGeom>
           <a:solidFill>
@@ -8410,7 +8280,7 @@
         <p:spPr>
           <a:xfrm>
             <a:off x="424678" y="2055876"/>
-            <a:ext cx="54864" cy="2555748"/>
+            <a:ext cx="54864" cy="1412748"/>
           </a:xfrm>
           <a:prstGeom prst="roundRect">
             <a:avLst>
@@ -8432,7 +8302,7 @@
         <p:spPr>
           <a:xfrm>
             <a:off x="634990" y="2129028"/>
-            <a:ext cx="3217241" cy="274320"/>
+            <a:ext cx="3268040" cy="274320"/>
           </a:xfrm>
           <a:prstGeom prst="rect">
             <a:avLst/>
@@ -8470,8 +8340,8 @@
         </p:nvSpPr>
         <p:spPr>
           <a:xfrm>
-            <a:off x="634984" y="2705100"/>
-            <a:ext cx="3217253" cy="1587500"/>
+            <a:off x="584185" y="2552700"/>
+            <a:ext cx="3369649" cy="698500"/>
           </a:xfrm>
           <a:prstGeom prst="rect">
             <a:avLst/>
@@ -8509,12 +8379,12 @@
         </p:nvSpPr>
         <p:spPr>
           <a:xfrm>
-            <a:off x="4258627" y="2019300"/>
-            <a:ext cx="3674441" cy="2324100"/>
+            <a:off x="4233228" y="2019300"/>
+            <a:ext cx="3725240" cy="1485900"/>
           </a:xfrm>
           <a:prstGeom prst="roundRect">
             <a:avLst>
-              <a:gd name="adj" fmla="val 3148"/>
+              <a:gd name="adj" fmla="val 4923"/>
             </a:avLst>
           </a:prstGeom>
           <a:solidFill>
@@ -8536,8 +8406,8 @@
         </p:nvSpPr>
         <p:spPr>
           <a:xfrm>
-            <a:off x="4276915" y="2055876"/>
-            <a:ext cx="54864" cy="2250948"/>
+            <a:off x="4251516" y="2055876"/>
+            <a:ext cx="54864" cy="1412748"/>
           </a:xfrm>
           <a:prstGeom prst="roundRect">
             <a:avLst>
@@ -8558,8 +8428,8 @@
         </p:nvSpPr>
         <p:spPr>
           <a:xfrm>
-            <a:off x="4487227" y="2129028"/>
-            <a:ext cx="3217241" cy="274320"/>
+            <a:off x="4461828" y="2129028"/>
+            <a:ext cx="3268040" cy="274320"/>
           </a:xfrm>
           <a:prstGeom prst="rect">
             <a:avLst/>
@@ -8597,8 +8467,8 @@
         </p:nvSpPr>
         <p:spPr>
           <a:xfrm>
-            <a:off x="4487221" y="2705100"/>
-            <a:ext cx="3217253" cy="1282700"/>
+            <a:off x="4411023" y="2552700"/>
+            <a:ext cx="3369649" cy="482600"/>
           </a:xfrm>
           <a:prstGeom prst="rect">
             <a:avLst/>
@@ -8636,12 +8506,12 @@
         </p:nvSpPr>
         <p:spPr>
           <a:xfrm>
-            <a:off x="8110864" y="2019300"/>
-            <a:ext cx="3674441" cy="2324100"/>
+            <a:off x="8060065" y="2019300"/>
+            <a:ext cx="3725240" cy="1485900"/>
           </a:xfrm>
           <a:prstGeom prst="roundRect">
             <a:avLst>
-              <a:gd name="adj" fmla="val 3148"/>
+              <a:gd name="adj" fmla="val 4923"/>
             </a:avLst>
           </a:prstGeom>
           <a:solidFill>
@@ -8663,8 +8533,8 @@
         </p:nvSpPr>
         <p:spPr>
           <a:xfrm>
-            <a:off x="8129152" y="2055876"/>
-            <a:ext cx="54864" cy="2250948"/>
+            <a:off x="8078353" y="2055876"/>
+            <a:ext cx="54864" cy="1412748"/>
           </a:xfrm>
           <a:prstGeom prst="roundRect">
             <a:avLst>
@@ -8685,8 +8555,8 @@
         </p:nvSpPr>
         <p:spPr>
           <a:xfrm>
-            <a:off x="8339464" y="2129028"/>
-            <a:ext cx="3217241" cy="274320"/>
+            <a:off x="8288665" y="2129028"/>
+            <a:ext cx="3268040" cy="274320"/>
           </a:xfrm>
           <a:prstGeom prst="rect">
             <a:avLst/>
@@ -8724,8 +8594,8 @@
         </p:nvSpPr>
         <p:spPr>
           <a:xfrm>
-            <a:off x="8339458" y="2705100"/>
-            <a:ext cx="3217253" cy="1282700"/>
+            <a:off x="8237861" y="2552700"/>
+            <a:ext cx="3369649" cy="482600"/>
           </a:xfrm>
           <a:prstGeom prst="rect">
             <a:avLst/>
@@ -8763,7 +8633,7 @@
         </p:nvSpPr>
         <p:spPr>
           <a:xfrm>
-            <a:off x="406390" y="5003800"/>
+            <a:off x="406390" y="3683000"/>
             <a:ext cx="11378916" cy="965200"/>
           </a:xfrm>
           <a:prstGeom prst="roundRect">
@@ -8790,7 +8660,7 @@
         </p:nvSpPr>
         <p:spPr>
           <a:xfrm>
-            <a:off x="589270" y="5150104"/>
+            <a:off x="589270" y="3829304"/>
             <a:ext cx="11013156" cy="274320"/>
           </a:xfrm>
           <a:prstGeom prst="rect">
@@ -8829,7 +8699,7 @@
         </p:nvSpPr>
         <p:spPr>
           <a:xfrm>
-            <a:off x="589270" y="5479288"/>
+            <a:off x="589270" y="4158488"/>
             <a:ext cx="11013156" cy="361696"/>
           </a:xfrm>
           <a:prstGeom prst="rect">
@@ -11096,11 +10966,11 @@
         <p:spPr>
           <a:xfrm>
             <a:off x="406390" y="2019300"/>
-            <a:ext cx="5600560" cy="4051300"/>
+            <a:ext cx="5600560" cy="2870200"/>
           </a:xfrm>
           <a:prstGeom prst="roundRect">
             <a:avLst>
-              <a:gd name="adj" fmla="val 1806"/>
+              <a:gd name="adj" fmla="val 2549"/>
             </a:avLst>
           </a:prstGeom>
           <a:solidFill>
@@ -11123,7 +10993,7 @@
         <p:spPr>
           <a:xfrm>
             <a:off x="424678" y="2055876"/>
-            <a:ext cx="54864" cy="3978148"/>
+            <a:ext cx="54864" cy="2797048"/>
           </a:xfrm>
           <a:prstGeom prst="roundRect">
             <a:avLst>
@@ -11183,8 +11053,8 @@
         </p:nvSpPr>
         <p:spPr>
           <a:xfrm>
-            <a:off x="634984" y="2705100"/>
-            <a:ext cx="5143371" cy="977900"/>
+            <a:off x="584185" y="2552700"/>
+            <a:ext cx="5244969" cy="482600"/>
           </a:xfrm>
           <a:prstGeom prst="rect">
             <a:avLst/>
@@ -11222,7 +11092,7 @@
         </p:nvSpPr>
         <p:spPr>
           <a:xfrm>
-            <a:off x="2530014" y="3860800"/>
+            <a:off x="2530014" y="3105150"/>
             <a:ext cx="1353312" cy="330200"/>
           </a:xfrm>
           <a:prstGeom prst="roundRect">
@@ -11249,7 +11119,7 @@
         </p:nvSpPr>
         <p:spPr>
           <a:xfrm>
-            <a:off x="2530014" y="3860800"/>
+            <a:off x="2530014" y="3105150"/>
             <a:ext cx="1353312" cy="330200"/>
           </a:xfrm>
           <a:prstGeom prst="rect">
@@ -11288,7 +11158,7 @@
         </p:nvSpPr>
         <p:spPr>
           <a:xfrm>
-            <a:off x="2580306" y="4368800"/>
+            <a:off x="2580306" y="3505200"/>
             <a:ext cx="1252728" cy="330200"/>
           </a:xfrm>
           <a:prstGeom prst="roundRect">
@@ -11315,7 +11185,7 @@
         </p:nvSpPr>
         <p:spPr>
           <a:xfrm>
-            <a:off x="2580306" y="4368800"/>
+            <a:off x="2580306" y="3505200"/>
             <a:ext cx="1252728" cy="330200"/>
           </a:xfrm>
           <a:prstGeom prst="rect">
@@ -11354,7 +11224,7 @@
         </p:nvSpPr>
         <p:spPr>
           <a:xfrm>
-            <a:off x="2479722" y="4876800"/>
+            <a:off x="2479722" y="3905250"/>
             <a:ext cx="1453896" cy="330200"/>
           </a:xfrm>
           <a:prstGeom prst="roundRect">
@@ -11381,7 +11251,7 @@
         </p:nvSpPr>
         <p:spPr>
           <a:xfrm>
-            <a:off x="2479722" y="4876800"/>
+            <a:off x="2479722" y="3905250"/>
             <a:ext cx="1453896" cy="330200"/>
           </a:xfrm>
           <a:prstGeom prst="rect">
@@ -11420,7 +11290,7 @@
         </p:nvSpPr>
         <p:spPr>
           <a:xfrm>
-            <a:off x="2658030" y="5384800"/>
+            <a:off x="2658030" y="4305300"/>
             <a:ext cx="1097280" cy="330200"/>
           </a:xfrm>
           <a:prstGeom prst="roundRect">
@@ -11447,7 +11317,7 @@
         </p:nvSpPr>
         <p:spPr>
           <a:xfrm>
-            <a:off x="2658030" y="5384800"/>
+            <a:off x="2658030" y="4305300"/>
             <a:ext cx="1097280" cy="330200"/>
           </a:xfrm>
           <a:prstGeom prst="rect">
@@ -11487,11 +11357,11 @@
         <p:spPr>
           <a:xfrm>
             <a:off x="6184745" y="2019300"/>
-            <a:ext cx="5600560" cy="3962400"/>
+            <a:ext cx="5600560" cy="2063750"/>
           </a:xfrm>
           <a:prstGeom prst="roundRect">
             <a:avLst>
-              <a:gd name="adj" fmla="val 1846"/>
+              <a:gd name="adj" fmla="val 3545"/>
             </a:avLst>
           </a:prstGeom>
           <a:solidFill>
@@ -11514,7 +11384,7 @@
         <p:spPr>
           <a:xfrm>
             <a:off x="6203033" y="2055876"/>
-            <a:ext cx="54864" cy="3889248"/>
+            <a:ext cx="54864" cy="1990598"/>
           </a:xfrm>
           <a:prstGeom prst="roundRect">
             <a:avLst>
@@ -11574,17 +11444,19 @@
         </p:nvSpPr>
         <p:spPr>
           <a:xfrm>
-            <a:off x="6413340" y="2705100"/>
-            <a:ext cx="5143371" cy="673100"/>
-          </a:xfrm>
-          <a:prstGeom prst="rect">
-            <a:avLst/>
-          </a:prstGeom>
-          <a:noFill/>
-          <a:ln/>
-        </p:spPr>
-        <p:txBody>
-          <a:bodyPr wrap="square" lIns="0" tIns="0" rIns="0" bIns="0" rtlCol="0" anchor="t"/>
+            <a:off x="6362541" y="2552700"/>
+            <a:ext cx="5244969" cy="266700"/>
+          </a:xfrm>
+          <a:prstGeom prst="rect">
+            <a:avLst/>
+          </a:prstGeom>
+          <a:noFill/>
+          <a:ln/>
+        </p:spPr>
+        <p:txBody>
+          <a:bodyPr wrap="square" lIns="0" tIns="0" rIns="0" bIns="0" rtlCol="0" anchor="t">
+            <a:normAutofit/>
+          </a:bodyPr>
           <a:lstStyle/>
           <a:p>
             <a:pPr algn="l" indent="0" marL="0">
@@ -11613,17 +11485,19 @@
         </p:nvSpPr>
         <p:spPr>
           <a:xfrm>
-            <a:off x="6413340" y="3556000"/>
-            <a:ext cx="5143371" cy="673100"/>
-          </a:xfrm>
-          <a:prstGeom prst="rect">
-            <a:avLst/>
-          </a:prstGeom>
-          <a:noFill/>
-          <a:ln/>
-        </p:spPr>
-        <p:txBody>
-          <a:bodyPr wrap="square" lIns="0" tIns="0" rIns="0" bIns="0" rtlCol="0" anchor="t"/>
+            <a:off x="6362541" y="2889250"/>
+            <a:ext cx="5244969" cy="266700"/>
+          </a:xfrm>
+          <a:prstGeom prst="rect">
+            <a:avLst/>
+          </a:prstGeom>
+          <a:noFill/>
+          <a:ln/>
+        </p:spPr>
+        <p:txBody>
+          <a:bodyPr wrap="square" lIns="0" tIns="0" rIns="0" bIns="0" rtlCol="0" anchor="t">
+            <a:normAutofit/>
+          </a:bodyPr>
           <a:lstStyle/>
           <a:p>
             <a:pPr algn="l" indent="0" marL="0">
@@ -11652,17 +11526,19 @@
         </p:nvSpPr>
         <p:spPr>
           <a:xfrm>
-            <a:off x="6413340" y="4406900"/>
-            <a:ext cx="5143371" cy="673100"/>
-          </a:xfrm>
-          <a:prstGeom prst="rect">
-            <a:avLst/>
-          </a:prstGeom>
-          <a:noFill/>
-          <a:ln/>
-        </p:spPr>
-        <p:txBody>
-          <a:bodyPr wrap="square" lIns="0" tIns="0" rIns="0" bIns="0" rtlCol="0" anchor="t"/>
+            <a:off x="6362541" y="3225800"/>
+            <a:ext cx="5244969" cy="266700"/>
+          </a:xfrm>
+          <a:prstGeom prst="rect">
+            <a:avLst/>
+          </a:prstGeom>
+          <a:noFill/>
+          <a:ln/>
+        </p:spPr>
+        <p:txBody>
+          <a:bodyPr wrap="square" lIns="0" tIns="0" rIns="0" bIns="0" rtlCol="0" anchor="t">
+            <a:normAutofit/>
+          </a:bodyPr>
           <a:lstStyle/>
           <a:p>
             <a:pPr algn="l" indent="0" marL="0">
@@ -11691,17 +11567,19 @@
         </p:nvSpPr>
         <p:spPr>
           <a:xfrm>
-            <a:off x="6413340" y="5257800"/>
-            <a:ext cx="5143371" cy="368300"/>
-          </a:xfrm>
-          <a:prstGeom prst="rect">
-            <a:avLst/>
-          </a:prstGeom>
-          <a:noFill/>
-          <a:ln/>
-        </p:spPr>
-        <p:txBody>
-          <a:bodyPr wrap="square" lIns="0" tIns="0" rIns="0" bIns="0" rtlCol="0" anchor="t"/>
+            <a:off x="6362541" y="3562350"/>
+            <a:ext cx="5244969" cy="266700"/>
+          </a:xfrm>
+          <a:prstGeom prst="rect">
+            <a:avLst/>
+          </a:prstGeom>
+          <a:noFill/>
+          <a:ln/>
+        </p:spPr>
+        <p:txBody>
+          <a:bodyPr wrap="square" lIns="0" tIns="0" rIns="0" bIns="0" rtlCol="0" anchor="t">
+            <a:normAutofit/>
+          </a:bodyPr>
           <a:lstStyle/>
           <a:p>
             <a:pPr algn="l" indent="0" marL="0">
@@ -12157,11 +12035,11 @@
         <p:spPr>
           <a:xfrm>
             <a:off x="6744801" y="2019300"/>
-            <a:ext cx="5040504" cy="4267200"/>
+            <a:ext cx="5040504" cy="2063750"/>
           </a:xfrm>
           <a:prstGeom prst="roundRect">
             <a:avLst>
-              <a:gd name="adj" fmla="val 1714"/>
+              <a:gd name="adj" fmla="val 3545"/>
             </a:avLst>
           </a:prstGeom>
           <a:solidFill>
@@ -12184,7 +12062,7 @@
         <p:spPr>
           <a:xfrm>
             <a:off x="6763089" y="2055876"/>
-            <a:ext cx="54864" cy="4194048"/>
+            <a:ext cx="54864" cy="1990598"/>
           </a:xfrm>
           <a:prstGeom prst="roundRect">
             <a:avLst>
@@ -12244,17 +12122,19 @@
         </p:nvSpPr>
         <p:spPr>
           <a:xfrm>
-            <a:off x="6973396" y="2705100"/>
-            <a:ext cx="4583315" cy="673100"/>
-          </a:xfrm>
-          <a:prstGeom prst="rect">
-            <a:avLst/>
-          </a:prstGeom>
-          <a:noFill/>
-          <a:ln/>
-        </p:spPr>
-        <p:txBody>
-          <a:bodyPr wrap="square" lIns="0" tIns="0" rIns="0" bIns="0" rtlCol="0" anchor="t"/>
+            <a:off x="6922597" y="2552700"/>
+            <a:ext cx="4684913" cy="266700"/>
+          </a:xfrm>
+          <a:prstGeom prst="rect">
+            <a:avLst/>
+          </a:prstGeom>
+          <a:noFill/>
+          <a:ln/>
+        </p:spPr>
+        <p:txBody>
+          <a:bodyPr wrap="square" lIns="0" tIns="0" rIns="0" bIns="0" rtlCol="0" anchor="t">
+            <a:normAutofit/>
+          </a:bodyPr>
           <a:lstStyle/>
           <a:p>
             <a:pPr algn="l" indent="0" marL="0">
@@ -12283,17 +12163,19 @@
         </p:nvSpPr>
         <p:spPr>
           <a:xfrm>
-            <a:off x="6973396" y="3556000"/>
-            <a:ext cx="4583315" cy="673100"/>
-          </a:xfrm>
-          <a:prstGeom prst="rect">
-            <a:avLst/>
-          </a:prstGeom>
-          <a:noFill/>
-          <a:ln/>
-        </p:spPr>
-        <p:txBody>
-          <a:bodyPr wrap="square" lIns="0" tIns="0" rIns="0" bIns="0" rtlCol="0" anchor="t"/>
+            <a:off x="6922597" y="2889250"/>
+            <a:ext cx="4684913" cy="266700"/>
+          </a:xfrm>
+          <a:prstGeom prst="rect">
+            <a:avLst/>
+          </a:prstGeom>
+          <a:noFill/>
+          <a:ln/>
+        </p:spPr>
+        <p:txBody>
+          <a:bodyPr wrap="square" lIns="0" tIns="0" rIns="0" bIns="0" rtlCol="0" anchor="t">
+            <a:normAutofit/>
+          </a:bodyPr>
           <a:lstStyle/>
           <a:p>
             <a:pPr algn="l" indent="0" marL="0">
@@ -12322,17 +12204,19 @@
         </p:nvSpPr>
         <p:spPr>
           <a:xfrm>
-            <a:off x="6973396" y="4406900"/>
-            <a:ext cx="4583315" cy="673100"/>
-          </a:xfrm>
-          <a:prstGeom prst="rect">
-            <a:avLst/>
-          </a:prstGeom>
-          <a:noFill/>
-          <a:ln/>
-        </p:spPr>
-        <p:txBody>
-          <a:bodyPr wrap="square" lIns="0" tIns="0" rIns="0" bIns="0" rtlCol="0" anchor="t"/>
+            <a:off x="6922597" y="3225800"/>
+            <a:ext cx="4684913" cy="266700"/>
+          </a:xfrm>
+          <a:prstGeom prst="rect">
+            <a:avLst/>
+          </a:prstGeom>
+          <a:noFill/>
+          <a:ln/>
+        </p:spPr>
+        <p:txBody>
+          <a:bodyPr wrap="square" lIns="0" tIns="0" rIns="0" bIns="0" rtlCol="0" anchor="t">
+            <a:normAutofit/>
+          </a:bodyPr>
           <a:lstStyle/>
           <a:p>
             <a:pPr algn="l" indent="0" marL="0">
@@ -12361,17 +12245,19 @@
         </p:nvSpPr>
         <p:spPr>
           <a:xfrm>
-            <a:off x="6973396" y="5257800"/>
-            <a:ext cx="4583315" cy="673100"/>
-          </a:xfrm>
-          <a:prstGeom prst="rect">
-            <a:avLst/>
-          </a:prstGeom>
-          <a:noFill/>
-          <a:ln/>
-        </p:spPr>
-        <p:txBody>
-          <a:bodyPr wrap="square" lIns="0" tIns="0" rIns="0" bIns="0" rtlCol="0" anchor="t"/>
+            <a:off x="6922597" y="3562350"/>
+            <a:ext cx="4684913" cy="266700"/>
+          </a:xfrm>
+          <a:prstGeom prst="rect">
+            <a:avLst/>
+          </a:prstGeom>
+          <a:noFill/>
+          <a:ln/>
+        </p:spPr>
+        <p:txBody>
+          <a:bodyPr wrap="square" lIns="0" tIns="0" rIns="0" bIns="0" rtlCol="0" anchor="t">
+            <a:normAutofit/>
+          </a:bodyPr>
           <a:lstStyle/>
           <a:p>
             <a:pPr algn="l" indent="0" marL="0">
@@ -12550,11 +12436,11 @@
         <p:spPr>
           <a:xfrm>
             <a:off x="406390" y="2019300"/>
-            <a:ext cx="3674441" cy="4267200"/>
+            <a:ext cx="3725240" cy="2063750"/>
           </a:xfrm>
           <a:prstGeom prst="roundRect">
             <a:avLst>
-              <a:gd name="adj" fmla="val 1991"/>
+              <a:gd name="adj" fmla="val 3545"/>
             </a:avLst>
           </a:prstGeom>
           <a:solidFill>
@@ -12577,7 +12463,7 @@
         <p:spPr>
           <a:xfrm>
             <a:off x="424678" y="2055876"/>
-            <a:ext cx="54864" cy="4194048"/>
+            <a:ext cx="54864" cy="1990598"/>
           </a:xfrm>
           <a:prstGeom prst="roundRect">
             <a:avLst>
@@ -12599,7 +12485,7 @@
         <p:spPr>
           <a:xfrm>
             <a:off x="634990" y="2129028"/>
-            <a:ext cx="3217241" cy="274320"/>
+            <a:ext cx="3268040" cy="274320"/>
           </a:xfrm>
           <a:prstGeom prst="rect">
             <a:avLst/>
@@ -12637,17 +12523,19 @@
         </p:nvSpPr>
         <p:spPr>
           <a:xfrm>
-            <a:off x="634984" y="2705100"/>
-            <a:ext cx="3217253" cy="673100"/>
-          </a:xfrm>
-          <a:prstGeom prst="rect">
-            <a:avLst/>
-          </a:prstGeom>
-          <a:noFill/>
-          <a:ln/>
-        </p:spPr>
-        <p:txBody>
-          <a:bodyPr wrap="square" lIns="0" tIns="0" rIns="0" bIns="0" rtlCol="0" anchor="t"/>
+            <a:off x="584185" y="2552700"/>
+            <a:ext cx="3369649" cy="266700"/>
+          </a:xfrm>
+          <a:prstGeom prst="rect">
+            <a:avLst/>
+          </a:prstGeom>
+          <a:noFill/>
+          <a:ln/>
+        </p:spPr>
+        <p:txBody>
+          <a:bodyPr wrap="square" lIns="0" tIns="0" rIns="0" bIns="0" rtlCol="0" anchor="t">
+            <a:normAutofit/>
+          </a:bodyPr>
           <a:lstStyle/>
           <a:p>
             <a:pPr algn="l" indent="0" marL="0">
@@ -12676,17 +12564,19 @@
         </p:nvSpPr>
         <p:spPr>
           <a:xfrm>
-            <a:off x="634984" y="3556000"/>
-            <a:ext cx="3217253" cy="673100"/>
-          </a:xfrm>
-          <a:prstGeom prst="rect">
-            <a:avLst/>
-          </a:prstGeom>
-          <a:noFill/>
-          <a:ln/>
-        </p:spPr>
-        <p:txBody>
-          <a:bodyPr wrap="square" lIns="0" tIns="0" rIns="0" bIns="0" rtlCol="0" anchor="t"/>
+            <a:off x="584185" y="2889250"/>
+            <a:ext cx="3369649" cy="266700"/>
+          </a:xfrm>
+          <a:prstGeom prst="rect">
+            <a:avLst/>
+          </a:prstGeom>
+          <a:noFill/>
+          <a:ln/>
+        </p:spPr>
+        <p:txBody>
+          <a:bodyPr wrap="square" lIns="0" tIns="0" rIns="0" bIns="0" rtlCol="0" anchor="t">
+            <a:normAutofit/>
+          </a:bodyPr>
           <a:lstStyle/>
           <a:p>
             <a:pPr algn="l" indent="0" marL="0">
@@ -12715,17 +12605,19 @@
         </p:nvSpPr>
         <p:spPr>
           <a:xfrm>
-            <a:off x="634984" y="4406900"/>
-            <a:ext cx="3217253" cy="673100"/>
-          </a:xfrm>
-          <a:prstGeom prst="rect">
-            <a:avLst/>
-          </a:prstGeom>
-          <a:noFill/>
-          <a:ln/>
-        </p:spPr>
-        <p:txBody>
-          <a:bodyPr wrap="square" lIns="0" tIns="0" rIns="0" bIns="0" rtlCol="0" anchor="t"/>
+            <a:off x="584185" y="3225800"/>
+            <a:ext cx="3369649" cy="266700"/>
+          </a:xfrm>
+          <a:prstGeom prst="rect">
+            <a:avLst/>
+          </a:prstGeom>
+          <a:noFill/>
+          <a:ln/>
+        </p:spPr>
+        <p:txBody>
+          <a:bodyPr wrap="square" lIns="0" tIns="0" rIns="0" bIns="0" rtlCol="0" anchor="t">
+            <a:normAutofit/>
+          </a:bodyPr>
           <a:lstStyle/>
           <a:p>
             <a:pPr algn="l" indent="0" marL="0">
@@ -12754,17 +12646,19 @@
         </p:nvSpPr>
         <p:spPr>
           <a:xfrm>
-            <a:off x="634984" y="5257800"/>
-            <a:ext cx="3217253" cy="673100"/>
-          </a:xfrm>
-          <a:prstGeom prst="rect">
-            <a:avLst/>
-          </a:prstGeom>
-          <a:noFill/>
-          <a:ln/>
-        </p:spPr>
-        <p:txBody>
-          <a:bodyPr wrap="square" lIns="0" tIns="0" rIns="0" bIns="0" rtlCol="0" anchor="t"/>
+            <a:off x="584185" y="3562350"/>
+            <a:ext cx="3369649" cy="266700"/>
+          </a:xfrm>
+          <a:prstGeom prst="rect">
+            <a:avLst/>
+          </a:prstGeom>
+          <a:noFill/>
+          <a:ln/>
+        </p:spPr>
+        <p:txBody>
+          <a:bodyPr wrap="square" lIns="0" tIns="0" rIns="0" bIns="0" rtlCol="0" anchor="t">
+            <a:normAutofit/>
+          </a:bodyPr>
           <a:lstStyle/>
           <a:p>
             <a:pPr algn="l" indent="0" marL="0">
@@ -12793,12 +12687,12 @@
         </p:nvSpPr>
         <p:spPr>
           <a:xfrm>
-            <a:off x="4258627" y="2019300"/>
-            <a:ext cx="3674441" cy="4267200"/>
+            <a:off x="4233228" y="2019300"/>
+            <a:ext cx="3725240" cy="2063750"/>
           </a:xfrm>
           <a:prstGeom prst="roundRect">
             <a:avLst>
-              <a:gd name="adj" fmla="val 1991"/>
+              <a:gd name="adj" fmla="val 3545"/>
             </a:avLst>
           </a:prstGeom>
           <a:solidFill>
@@ -12820,8 +12714,8 @@
         </p:nvSpPr>
         <p:spPr>
           <a:xfrm>
-            <a:off x="4276915" y="2055876"/>
-            <a:ext cx="54864" cy="4194048"/>
+            <a:off x="4251516" y="2055876"/>
+            <a:ext cx="54864" cy="1990598"/>
           </a:xfrm>
           <a:prstGeom prst="roundRect">
             <a:avLst>
@@ -12842,8 +12736,8 @@
         </p:nvSpPr>
         <p:spPr>
           <a:xfrm>
-            <a:off x="4487227" y="2129028"/>
-            <a:ext cx="3217241" cy="274320"/>
+            <a:off x="4461828" y="2129028"/>
+            <a:ext cx="3268040" cy="274320"/>
           </a:xfrm>
           <a:prstGeom prst="rect">
             <a:avLst/>
@@ -12881,17 +12775,19 @@
         </p:nvSpPr>
         <p:spPr>
           <a:xfrm>
-            <a:off x="4487221" y="2705100"/>
-            <a:ext cx="3217253" cy="673100"/>
-          </a:xfrm>
-          <a:prstGeom prst="rect">
-            <a:avLst/>
-          </a:prstGeom>
-          <a:noFill/>
-          <a:ln/>
-        </p:spPr>
-        <p:txBody>
-          <a:bodyPr wrap="square" lIns="0" tIns="0" rIns="0" bIns="0" rtlCol="0" anchor="t"/>
+            <a:off x="4411023" y="2552700"/>
+            <a:ext cx="3369649" cy="266700"/>
+          </a:xfrm>
+          <a:prstGeom prst="rect">
+            <a:avLst/>
+          </a:prstGeom>
+          <a:noFill/>
+          <a:ln/>
+        </p:spPr>
+        <p:txBody>
+          <a:bodyPr wrap="square" lIns="0" tIns="0" rIns="0" bIns="0" rtlCol="0" anchor="t">
+            <a:normAutofit/>
+          </a:bodyPr>
           <a:lstStyle/>
           <a:p>
             <a:pPr algn="l" indent="0" marL="0">
@@ -12920,17 +12816,19 @@
         </p:nvSpPr>
         <p:spPr>
           <a:xfrm>
-            <a:off x="4487221" y="3556000"/>
-            <a:ext cx="3217253" cy="673100"/>
-          </a:xfrm>
-          <a:prstGeom prst="rect">
-            <a:avLst/>
-          </a:prstGeom>
-          <a:noFill/>
-          <a:ln/>
-        </p:spPr>
-        <p:txBody>
-          <a:bodyPr wrap="square" lIns="0" tIns="0" rIns="0" bIns="0" rtlCol="0" anchor="t"/>
+            <a:off x="4411023" y="2889250"/>
+            <a:ext cx="3369649" cy="266700"/>
+          </a:xfrm>
+          <a:prstGeom prst="rect">
+            <a:avLst/>
+          </a:prstGeom>
+          <a:noFill/>
+          <a:ln/>
+        </p:spPr>
+        <p:txBody>
+          <a:bodyPr wrap="square" lIns="0" tIns="0" rIns="0" bIns="0" rtlCol="0" anchor="t">
+            <a:normAutofit/>
+          </a:bodyPr>
           <a:lstStyle/>
           <a:p>
             <a:pPr algn="l" indent="0" marL="0">
@@ -12959,17 +12857,19 @@
         </p:nvSpPr>
         <p:spPr>
           <a:xfrm>
-            <a:off x="4487221" y="4406900"/>
-            <a:ext cx="3217253" cy="673100"/>
-          </a:xfrm>
-          <a:prstGeom prst="rect">
-            <a:avLst/>
-          </a:prstGeom>
-          <a:noFill/>
-          <a:ln/>
-        </p:spPr>
-        <p:txBody>
-          <a:bodyPr wrap="square" lIns="0" tIns="0" rIns="0" bIns="0" rtlCol="0" anchor="t"/>
+            <a:off x="4411023" y="3225800"/>
+            <a:ext cx="3369649" cy="266700"/>
+          </a:xfrm>
+          <a:prstGeom prst="rect">
+            <a:avLst/>
+          </a:prstGeom>
+          <a:noFill/>
+          <a:ln/>
+        </p:spPr>
+        <p:txBody>
+          <a:bodyPr wrap="square" lIns="0" tIns="0" rIns="0" bIns="0" rtlCol="0" anchor="t">
+            <a:normAutofit/>
+          </a:bodyPr>
           <a:lstStyle/>
           <a:p>
             <a:pPr algn="l" indent="0" marL="0">
@@ -12998,17 +12898,19 @@
         </p:nvSpPr>
         <p:spPr>
           <a:xfrm>
-            <a:off x="4487221" y="5257800"/>
-            <a:ext cx="3217253" cy="673100"/>
-          </a:xfrm>
-          <a:prstGeom prst="rect">
-            <a:avLst/>
-          </a:prstGeom>
-          <a:noFill/>
-          <a:ln/>
-        </p:spPr>
-        <p:txBody>
-          <a:bodyPr wrap="square" lIns="0" tIns="0" rIns="0" bIns="0" rtlCol="0" anchor="t"/>
+            <a:off x="4411023" y="3562350"/>
+            <a:ext cx="3369649" cy="266700"/>
+          </a:xfrm>
+          <a:prstGeom prst="rect">
+            <a:avLst/>
+          </a:prstGeom>
+          <a:noFill/>
+          <a:ln/>
+        </p:spPr>
+        <p:txBody>
+          <a:bodyPr wrap="square" lIns="0" tIns="0" rIns="0" bIns="0" rtlCol="0" anchor="t">
+            <a:normAutofit/>
+          </a:bodyPr>
           <a:lstStyle/>
           <a:p>
             <a:pPr algn="l" indent="0" marL="0">
@@ -13037,12 +12939,12 @@
         </p:nvSpPr>
         <p:spPr>
           <a:xfrm>
-            <a:off x="8110864" y="2019300"/>
-            <a:ext cx="3674441" cy="4267200"/>
+            <a:off x="8060065" y="2019300"/>
+            <a:ext cx="3725240" cy="2063750"/>
           </a:xfrm>
           <a:prstGeom prst="roundRect">
             <a:avLst>
-              <a:gd name="adj" fmla="val 1991"/>
+              <a:gd name="adj" fmla="val 3545"/>
             </a:avLst>
           </a:prstGeom>
           <a:solidFill>
@@ -13064,8 +12966,8 @@
         </p:nvSpPr>
         <p:spPr>
           <a:xfrm>
-            <a:off x="8129152" y="2055876"/>
-            <a:ext cx="54864" cy="4194048"/>
+            <a:off x="8078353" y="2055876"/>
+            <a:ext cx="54864" cy="1990598"/>
           </a:xfrm>
           <a:prstGeom prst="roundRect">
             <a:avLst>
@@ -13086,8 +12988,8 @@
         </p:nvSpPr>
         <p:spPr>
           <a:xfrm>
-            <a:off x="8339464" y="2129028"/>
-            <a:ext cx="3217241" cy="274320"/>
+            <a:off x="8288665" y="2129028"/>
+            <a:ext cx="3268040" cy="274320"/>
           </a:xfrm>
           <a:prstGeom prst="rect">
             <a:avLst/>
@@ -13125,17 +13027,19 @@
         </p:nvSpPr>
         <p:spPr>
           <a:xfrm>
-            <a:off x="8339458" y="2705100"/>
-            <a:ext cx="3217253" cy="673100"/>
-          </a:xfrm>
-          <a:prstGeom prst="rect">
-            <a:avLst/>
-          </a:prstGeom>
-          <a:noFill/>
-          <a:ln/>
-        </p:spPr>
-        <p:txBody>
-          <a:bodyPr wrap="square" lIns="0" tIns="0" rIns="0" bIns="0" rtlCol="0" anchor="t"/>
+            <a:off x="8237861" y="2552700"/>
+            <a:ext cx="3369649" cy="266700"/>
+          </a:xfrm>
+          <a:prstGeom prst="rect">
+            <a:avLst/>
+          </a:prstGeom>
+          <a:noFill/>
+          <a:ln/>
+        </p:spPr>
+        <p:txBody>
+          <a:bodyPr wrap="square" lIns="0" tIns="0" rIns="0" bIns="0" rtlCol="0" anchor="t">
+            <a:normAutofit/>
+          </a:bodyPr>
           <a:lstStyle/>
           <a:p>
             <a:pPr algn="l" indent="0" marL="0">
@@ -13164,17 +13068,19 @@
         </p:nvSpPr>
         <p:spPr>
           <a:xfrm>
-            <a:off x="8339458" y="3556000"/>
-            <a:ext cx="3217253" cy="673100"/>
-          </a:xfrm>
-          <a:prstGeom prst="rect">
-            <a:avLst/>
-          </a:prstGeom>
-          <a:noFill/>
-          <a:ln/>
-        </p:spPr>
-        <p:txBody>
-          <a:bodyPr wrap="square" lIns="0" tIns="0" rIns="0" bIns="0" rtlCol="0" anchor="t"/>
+            <a:off x="8237861" y="2889250"/>
+            <a:ext cx="3369649" cy="266700"/>
+          </a:xfrm>
+          <a:prstGeom prst="rect">
+            <a:avLst/>
+          </a:prstGeom>
+          <a:noFill/>
+          <a:ln/>
+        </p:spPr>
+        <p:txBody>
+          <a:bodyPr wrap="square" lIns="0" tIns="0" rIns="0" bIns="0" rtlCol="0" anchor="t">
+            <a:normAutofit/>
+          </a:bodyPr>
           <a:lstStyle/>
           <a:p>
             <a:pPr algn="l" indent="0" marL="0">
@@ -13203,17 +13109,19 @@
         </p:nvSpPr>
         <p:spPr>
           <a:xfrm>
-            <a:off x="8339458" y="4406900"/>
-            <a:ext cx="3217253" cy="673100"/>
-          </a:xfrm>
-          <a:prstGeom prst="rect">
-            <a:avLst/>
-          </a:prstGeom>
-          <a:noFill/>
-          <a:ln/>
-        </p:spPr>
-        <p:txBody>
-          <a:bodyPr wrap="square" lIns="0" tIns="0" rIns="0" bIns="0" rtlCol="0" anchor="t"/>
+            <a:off x="8237861" y="3225800"/>
+            <a:ext cx="3369649" cy="266700"/>
+          </a:xfrm>
+          <a:prstGeom prst="rect">
+            <a:avLst/>
+          </a:prstGeom>
+          <a:noFill/>
+          <a:ln/>
+        </p:spPr>
+        <p:txBody>
+          <a:bodyPr wrap="square" lIns="0" tIns="0" rIns="0" bIns="0" rtlCol="0" anchor="t">
+            <a:normAutofit/>
+          </a:bodyPr>
           <a:lstStyle/>
           <a:p>
             <a:pPr algn="l" indent="0" marL="0">
@@ -13242,17 +13150,19 @@
         </p:nvSpPr>
         <p:spPr>
           <a:xfrm>
-            <a:off x="8339458" y="5257800"/>
-            <a:ext cx="3217253" cy="673100"/>
-          </a:xfrm>
-          <a:prstGeom prst="rect">
-            <a:avLst/>
-          </a:prstGeom>
-          <a:noFill/>
-          <a:ln/>
-        </p:spPr>
-        <p:txBody>
-          <a:bodyPr wrap="square" lIns="0" tIns="0" rIns="0" bIns="0" rtlCol="0" anchor="t"/>
+            <a:off x="8237861" y="3562350"/>
+            <a:ext cx="3369649" cy="266700"/>
+          </a:xfrm>
+          <a:prstGeom prst="rect">
+            <a:avLst/>
+          </a:prstGeom>
+          <a:noFill/>
+          <a:ln/>
+        </p:spPr>
+        <p:txBody>
+          <a:bodyPr wrap="square" lIns="0" tIns="0" rIns="0" bIns="0" rtlCol="0" anchor="t">
+            <a:normAutofit/>
+          </a:bodyPr>
           <a:lstStyle/>
           <a:p>
             <a:pPr algn="l" indent="0" marL="0">
@@ -13431,11 +13341,11 @@
         <p:spPr>
           <a:xfrm>
             <a:off x="406390" y="2019300"/>
-            <a:ext cx="5600560" cy="3594100"/>
+            <a:ext cx="5600560" cy="2400300"/>
           </a:xfrm>
           <a:prstGeom prst="roundRect">
             <a:avLst>
-              <a:gd name="adj" fmla="val 2035"/>
+              <a:gd name="adj" fmla="val 3048"/>
             </a:avLst>
           </a:prstGeom>
           <a:solidFill>
@@ -13458,7 +13368,7 @@
         <p:spPr>
           <a:xfrm>
             <a:off x="424678" y="2055876"/>
-            <a:ext cx="54864" cy="3520948"/>
+            <a:ext cx="54864" cy="2327148"/>
           </a:xfrm>
           <a:prstGeom prst="roundRect">
             <a:avLst>
@@ -13518,17 +13428,19 @@
         </p:nvSpPr>
         <p:spPr>
           <a:xfrm>
-            <a:off x="634984" y="2705100"/>
-            <a:ext cx="5143371" cy="368300"/>
-          </a:xfrm>
-          <a:prstGeom prst="rect">
-            <a:avLst/>
-          </a:prstGeom>
-          <a:noFill/>
-          <a:ln/>
-        </p:spPr>
-        <p:txBody>
-          <a:bodyPr wrap="square" lIns="0" tIns="0" rIns="0" bIns="0" rtlCol="0" anchor="t"/>
+            <a:off x="584185" y="2552700"/>
+            <a:ext cx="5244969" cy="266700"/>
+          </a:xfrm>
+          <a:prstGeom prst="rect">
+            <a:avLst/>
+          </a:prstGeom>
+          <a:noFill/>
+          <a:ln/>
+        </p:spPr>
+        <p:txBody>
+          <a:bodyPr wrap="square" lIns="0" tIns="0" rIns="0" bIns="0" rtlCol="0" anchor="t">
+            <a:normAutofit/>
+          </a:bodyPr>
           <a:lstStyle/>
           <a:p>
             <a:pPr algn="l" indent="0" marL="0">
@@ -13557,17 +13469,19 @@
         </p:nvSpPr>
         <p:spPr>
           <a:xfrm>
-            <a:off x="634984" y="3251200"/>
-            <a:ext cx="5143371" cy="368300"/>
-          </a:xfrm>
-          <a:prstGeom prst="rect">
-            <a:avLst/>
-          </a:prstGeom>
-          <a:noFill/>
-          <a:ln/>
-        </p:spPr>
-        <p:txBody>
-          <a:bodyPr wrap="square" lIns="0" tIns="0" rIns="0" bIns="0" rtlCol="0" anchor="t"/>
+            <a:off x="584185" y="2889250"/>
+            <a:ext cx="5244969" cy="266700"/>
+          </a:xfrm>
+          <a:prstGeom prst="rect">
+            <a:avLst/>
+          </a:prstGeom>
+          <a:noFill/>
+          <a:ln/>
+        </p:spPr>
+        <p:txBody>
+          <a:bodyPr wrap="square" lIns="0" tIns="0" rIns="0" bIns="0" rtlCol="0" anchor="t">
+            <a:normAutofit/>
+          </a:bodyPr>
           <a:lstStyle/>
           <a:p>
             <a:pPr algn="l" indent="0" marL="0">
@@ -13596,17 +13510,19 @@
         </p:nvSpPr>
         <p:spPr>
           <a:xfrm>
-            <a:off x="634984" y="3797300"/>
-            <a:ext cx="5143371" cy="368300"/>
-          </a:xfrm>
-          <a:prstGeom prst="rect">
-            <a:avLst/>
-          </a:prstGeom>
-          <a:noFill/>
-          <a:ln/>
-        </p:spPr>
-        <p:txBody>
-          <a:bodyPr wrap="square" lIns="0" tIns="0" rIns="0" bIns="0" rtlCol="0" anchor="t"/>
+            <a:off x="584185" y="3225800"/>
+            <a:ext cx="5244969" cy="266700"/>
+          </a:xfrm>
+          <a:prstGeom prst="rect">
+            <a:avLst/>
+          </a:prstGeom>
+          <a:noFill/>
+          <a:ln/>
+        </p:spPr>
+        <p:txBody>
+          <a:bodyPr wrap="square" lIns="0" tIns="0" rIns="0" bIns="0" rtlCol="0" anchor="t">
+            <a:normAutofit/>
+          </a:bodyPr>
           <a:lstStyle/>
           <a:p>
             <a:pPr algn="l" indent="0" marL="0">
@@ -13635,17 +13551,19 @@
         </p:nvSpPr>
         <p:spPr>
           <a:xfrm>
-            <a:off x="634984" y="4343400"/>
-            <a:ext cx="5143371" cy="368300"/>
-          </a:xfrm>
-          <a:prstGeom prst="rect">
-            <a:avLst/>
-          </a:prstGeom>
-          <a:noFill/>
-          <a:ln/>
-        </p:spPr>
-        <p:txBody>
-          <a:bodyPr wrap="square" lIns="0" tIns="0" rIns="0" bIns="0" rtlCol="0" anchor="t"/>
+            <a:off x="584185" y="3562350"/>
+            <a:ext cx="5244969" cy="266700"/>
+          </a:xfrm>
+          <a:prstGeom prst="rect">
+            <a:avLst/>
+          </a:prstGeom>
+          <a:noFill/>
+          <a:ln/>
+        </p:spPr>
+        <p:txBody>
+          <a:bodyPr wrap="square" lIns="0" tIns="0" rIns="0" bIns="0" rtlCol="0" anchor="t">
+            <a:normAutofit/>
+          </a:bodyPr>
           <a:lstStyle/>
           <a:p>
             <a:pPr algn="l" indent="0" marL="0">
@@ -13674,17 +13592,19 @@
         </p:nvSpPr>
         <p:spPr>
           <a:xfrm>
-            <a:off x="634984" y="4889500"/>
-            <a:ext cx="5143371" cy="368300"/>
-          </a:xfrm>
-          <a:prstGeom prst="rect">
-            <a:avLst/>
-          </a:prstGeom>
-          <a:noFill/>
-          <a:ln/>
-        </p:spPr>
-        <p:txBody>
-          <a:bodyPr wrap="square" lIns="0" tIns="0" rIns="0" bIns="0" rtlCol="0" anchor="t"/>
+            <a:off x="584185" y="3898900"/>
+            <a:ext cx="5244969" cy="266700"/>
+          </a:xfrm>
+          <a:prstGeom prst="rect">
+            <a:avLst/>
+          </a:prstGeom>
+          <a:noFill/>
+          <a:ln/>
+        </p:spPr>
+        <p:txBody>
+          <a:bodyPr wrap="square" lIns="0" tIns="0" rIns="0" bIns="0" rtlCol="0" anchor="t">
+            <a:normAutofit/>
+          </a:bodyPr>
           <a:lstStyle/>
           <a:p>
             <a:pPr algn="l" indent="0" marL="0">
@@ -13714,11 +13634,11 @@
         <p:spPr>
           <a:xfrm>
             <a:off x="6184745" y="2019300"/>
-            <a:ext cx="5600560" cy="2438400"/>
+            <a:ext cx="5600560" cy="2184400"/>
           </a:xfrm>
           <a:prstGeom prst="roundRect">
             <a:avLst>
-              <a:gd name="adj" fmla="val 3000"/>
+              <a:gd name="adj" fmla="val 3349"/>
             </a:avLst>
           </a:prstGeom>
           <a:solidFill>
@@ -13741,7 +13661,7 @@
         <p:spPr>
           <a:xfrm>
             <a:off x="6203033" y="2055876"/>
-            <a:ext cx="54864" cy="2365248"/>
+            <a:ext cx="54864" cy="2111248"/>
           </a:xfrm>
           <a:prstGeom prst="roundRect">
             <a:avLst>
@@ -13801,8 +13721,8 @@
         </p:nvSpPr>
         <p:spPr>
           <a:xfrm>
-            <a:off x="6413340" y="2705100"/>
-            <a:ext cx="5143371" cy="1397000"/>
+            <a:off x="6362541" y="2552700"/>
+            <a:ext cx="5244969" cy="1397000"/>
           </a:xfrm>
           <a:prstGeom prst="roundRect">
             <a:avLst>
@@ -13828,7 +13748,7 @@
         </p:nvSpPr>
         <p:spPr>
           <a:xfrm>
-            <a:off x="6550500" y="2814828"/>
+            <a:off x="6499701" y="2662428"/>
             <a:ext cx="91440" cy="91440"/>
           </a:xfrm>
           <a:prstGeom prst="ellipse">
@@ -13853,7 +13773,7 @@
         </p:nvSpPr>
         <p:spPr>
           <a:xfrm>
-            <a:off x="6687660" y="2814828"/>
+            <a:off x="6636861" y="2662428"/>
             <a:ext cx="91440" cy="91440"/>
           </a:xfrm>
           <a:prstGeom prst="ellipse">
@@ -13878,7 +13798,7 @@
         </p:nvSpPr>
         <p:spPr>
           <a:xfrm>
-            <a:off x="6824820" y="2814828"/>
+            <a:off x="6774021" y="2662428"/>
             <a:ext cx="91440" cy="91440"/>
           </a:xfrm>
           <a:prstGeom prst="ellipse">
@@ -13903,8 +13823,8 @@
         </p:nvSpPr>
         <p:spPr>
           <a:xfrm>
-            <a:off x="6614508" y="3034284"/>
-            <a:ext cx="4741035" cy="958088"/>
+            <a:off x="6563709" y="2881884"/>
+            <a:ext cx="4842633" cy="958088"/>
           </a:xfrm>
           <a:prstGeom prst="rect">
             <a:avLst/>
@@ -13993,7 +13913,7 @@
         </p:nvSpPr>
         <p:spPr>
           <a:xfrm>
-            <a:off x="406390" y="5791200"/>
+            <a:off x="406390" y="4597400"/>
             <a:ext cx="11378916" cy="774700"/>
           </a:xfrm>
           <a:prstGeom prst="roundRect">
@@ -14020,7 +13940,7 @@
         </p:nvSpPr>
         <p:spPr>
           <a:xfrm>
-            <a:off x="589270" y="5937504"/>
+            <a:off x="589270" y="4743704"/>
             <a:ext cx="11013156" cy="274320"/>
           </a:xfrm>
           <a:prstGeom prst="rect">
@@ -14059,7 +13979,7 @@
         </p:nvSpPr>
         <p:spPr>
           <a:xfrm>
-            <a:off x="589270" y="6266688"/>
+            <a:off x="589270" y="5072888"/>
             <a:ext cx="11013156" cy="182880"/>
           </a:xfrm>
           <a:prstGeom prst="rect">

</xml_diff>